<commit_message>
Release guided workload contract
</commit_message>
<xml_diff>
--- a/artifacts/AI_BUILD_CREW_COST_CONTRACT_VIDEO_REVIEW.pptx
+++ b/artifacts/AI_BUILD_CREW_COST_CONTRACT_VIDEO_REVIEW.pptx
@@ -2,20 +2,20 @@
 <file path=ppt/presentation.xml><?xml version="1.0" encoding="utf-8"?>
 <p:presentation xmlns:p="http://schemas.openxmlformats.org/presentationml/2006/main">
   <p:sldMasterIdLst>
-    <p:sldMasterId xmlns:r="http://schemas.openxmlformats.org/officeDocument/2006/relationships" id="2147483648" r:id="R588455171fff4533"/>
+    <p:sldMasterId xmlns:r="http://schemas.openxmlformats.org/officeDocument/2006/relationships" id="2147483648" r:id="R0dbf89d702e84697"/>
   </p:sldMasterIdLst>
   <p:notesMasterIdLst>
-    <p:notesMasterId xmlns:r="http://schemas.openxmlformats.org/officeDocument/2006/relationships" r:id="R6cdc42dff1984367"/>
+    <p:notesMasterId xmlns:r="http://schemas.openxmlformats.org/officeDocument/2006/relationships" r:id="R0ccfb24263334d26"/>
   </p:notesMasterIdLst>
   <p:sldIdLst>
-    <p:sldId xmlns:r="http://schemas.openxmlformats.org/officeDocument/2006/relationships" id="256" r:id="R47c30c0348564fbc"/>
-    <p:sldId xmlns:r="http://schemas.openxmlformats.org/officeDocument/2006/relationships" id="257" r:id="Re0a41d06bb16403d"/>
-    <p:sldId xmlns:r="http://schemas.openxmlformats.org/officeDocument/2006/relationships" id="258" r:id="R72353bebc7354cd9"/>
-    <p:sldId xmlns:r="http://schemas.openxmlformats.org/officeDocument/2006/relationships" id="259" r:id="Rab6ba5ae97f342ed"/>
-    <p:sldId xmlns:r="http://schemas.openxmlformats.org/officeDocument/2006/relationships" id="260" r:id="R2ba78cf770ed4300"/>
-    <p:sldId xmlns:r="http://schemas.openxmlformats.org/officeDocument/2006/relationships" id="261" r:id="R2d927501a20e428c"/>
-    <p:sldId xmlns:r="http://schemas.openxmlformats.org/officeDocument/2006/relationships" id="262" r:id="R9244d64433344d9d"/>
-    <p:sldId xmlns:r="http://schemas.openxmlformats.org/officeDocument/2006/relationships" id="263" r:id="R3071bf408c4c4eab"/>
+    <p:sldId xmlns:r="http://schemas.openxmlformats.org/officeDocument/2006/relationships" id="256" r:id="R5d8d3ec7a986444a"/>
+    <p:sldId xmlns:r="http://schemas.openxmlformats.org/officeDocument/2006/relationships" id="257" r:id="R6adb5c2113854b0b"/>
+    <p:sldId xmlns:r="http://schemas.openxmlformats.org/officeDocument/2006/relationships" id="258" r:id="R4781dc3035e14b8d"/>
+    <p:sldId xmlns:r="http://schemas.openxmlformats.org/officeDocument/2006/relationships" id="259" r:id="Rd7a34f714822490d"/>
+    <p:sldId xmlns:r="http://schemas.openxmlformats.org/officeDocument/2006/relationships" id="260" r:id="Rb5027c57c1a04217"/>
+    <p:sldId xmlns:r="http://schemas.openxmlformats.org/officeDocument/2006/relationships" id="261" r:id="Rb458509aa2d94d34"/>
+    <p:sldId xmlns:r="http://schemas.openxmlformats.org/officeDocument/2006/relationships" id="262" r:id="Rb789cfdf956847e6"/>
+    <p:sldId xmlns:r="http://schemas.openxmlformats.org/officeDocument/2006/relationships" id="263" r:id="Rb326b6b2d1c543ad"/>
   </p:sldIdLst>
   <p:sldSz cx="12192000" cy="6858000"/>
   <p:notesSz cx="6858000" cy="9144000"/>
@@ -634,7 +634,7 @@
           <a:lstStyle xmlns:a="http://schemas.openxmlformats.org/drawingml/2006/main"/>
           <a:p xmlns:a="http://schemas.openxmlformats.org/drawingml/2006/main">
             <a:r>
-              <a:t>The first user is a product person building an AI-powered application, agent, or tool without a dedicated AI architect or FinOps partner. They understand the user problem and business constraints, but should not need to know token math, cache policy, or model architecture to begin. Their job is straightforward: forecast the likely cost, see where the estimate is uncertain, and understand what changes if they choose another model.</a:t>
+              <a:t>The persona is not the problem statement. The persona is a product builder who owns a go or no-go decision without dedicated AI architecture or FinOps support. The JTBD is situational: when deciding whether and how to build an AI product, help confirm the workload, model starting point, and cost distribution, so the builder can prototype, budget, test, or stop before committing. That separates who we serve, what breaks, and what progress they hire the product to make.</a:t>
             </a:r>
           </a:p>
           <a:p xmlns:a="http://schemas.openxmlformats.org/drawingml/2006/main">
@@ -649,7 +649,7 @@
           </a:p>
           <a:p xmlns:a="http://schemas.openxmlformats.org/drawingml/2006/main">
             <a:r>
-              <a:t>- AI Build Crew Agentic AI PRD, specific-user and job-to-be-done rows, August 9, 2026</a:t>
+              <a:t>- AI Build Crew Agentic AI PRD, specific-user, problem, and JTBD rows, August 9, 2026</a:t>
             </a:r>
           </a:p>
         </p:txBody>
@@ -719,7 +719,7 @@
           <a:lstStyle xmlns:a="http://schemas.openxmlformats.org/drawingml/2006/main"/>
           <a:p xmlns:a="http://schemas.openxmlformats.org/drawingml/2006/main">
             <a:r>
-              <a:t>The experience starts with the idea, then asks the technical questions. The description remains context; it never silently becomes a decision fact. The user can take the guide, enter known usage, or load a safe example. Before calculation, they review what is known, assumed, or unknown. In the current prototype the content stays in browser memory, is not sent to a model or application database, and clears on refresh.</a:t>
+              <a:t>The experience starts with the idea, then asks the minimum questions required by the cost contract. Format is multi-select because a single task may require text plus images or other combinations. The builder never enters output tokens. If they do not know the number of AI steps, a deterministic Workflow Architect rule proposes primary and checker steps based on job, consequence, data boundary, and regulation; that suggestion remains visible and editable. The optional ceiling is a constraint only, never an assumed maximum cost.</a:t>
             </a:r>
           </a:p>
           <a:p xmlns:a="http://schemas.openxmlformats.org/drawingml/2006/main">
@@ -734,12 +734,12 @@
           </a:p>
           <a:p xmlns:a="http://schemas.openxmlformats.org/drawingml/2006/main">
             <a:r>
-              <a:t>- AI Build Crew Agentic AI PRD, workflow and memory rows, August 9, 2026</a:t>
-            </a:r>
-          </a:p>
-          <a:p xmlns:a="http://schemas.openxmlformats.org/drawingml/2006/main">
-            <a:r>
-              <a:t>- AI Build Crew application source, release candidate v0.2.0-rc.3</a:t>
+              <a:t>- AI Build Crew Agentic AI PRD, workflow, context, and output rows, August 9, 2026</a:t>
+            </a:r>
+          </a:p>
+          <a:p xmlns:a="http://schemas.openxmlformats.org/drawingml/2006/main">
+            <a:r>
+              <a:t>- AI Build Crew application source, decision engine v1.4.0</a:t>
             </a:r>
           </a:p>
         </p:txBody>
@@ -809,7 +809,7 @@
           <a:lstStyle xmlns:a="http://schemas.openxmlformats.org/drawingml/2006/main"/>
           <a:p xmlns:a="http://schemas.openxmlformats.org/drawingml/2006/main">
             <a:r>
-              <a:t>This frozen product-analysis example uses one thousand completed tasks per day, twenty-four hundred input tokens, a detailed result, one primary step, and one checker. The user never enters output tokens. Terra's planning profile produces six hundred, twelve hundred, and twenty-two hundred fifty output tokens per primary call across the three scenarios, with retry multipliers from one to one point five. The chart reports 2.32, 4.08, and 8.56 cents per completed task using the official August 9 Terra token prices. Published prices are dated facts; behavior profiles are heuristics, not invoices.</a:t>
+              <a:t>This product-analysis example uses one thousand completed tasks per day, twenty-four hundred input tokens, a detailed result, and the visible recommendation of two primary steps plus one checker. The user never enters output tokens. Terra's profile produces six hundred, twelve hundred, and twenty-two hundred fifty output tokens per primary call, with retry multipliers from one to one point five. The chart reports 3.71, 6.72, and 14.36 cents per completed task. Terra wins because Product Analysis plus Medium consequence requires tier two; Classification plus Low tests Luna, while Complex Reasoning or High consequence tests Sol. Volume changes cost, not the required quality tier.</a:t>
             </a:r>
           </a:p>
           <a:p xmlns:a="http://schemas.openxmlformats.org/drawingml/2006/main">
@@ -839,7 +839,7 @@
           </a:p>
           <a:p xmlns:a="http://schemas.openxmlformats.org/drawingml/2006/main">
             <a:r>
-              <a:t>- AI Build Crew decision engine v1.3.0</a:t>
+              <a:t>- AI Build Crew decision engine v1.4.0</a:t>
             </a:r>
           </a:p>
         </p:txBody>
@@ -909,7 +909,7 @@
           <a:lstStyle xmlns:a="http://schemas.openxmlformats.org/drawingml/2006/main"/>
           <a:p xmlns:a="http://schemas.openxmlformats.org/drawingml/2006/main">
             <a:r>
-              <a:t>The correction becomes hard through a specialist workflow. The estimator freezes three scenarios. The Cost Evaluation Specialist rejects output-token input, checks ordered output and retry profiles, confirms primary and checker steps, and independently recomputes the ledger without calling the estimator formula. Eligibility filters. Audit checks versions and invariants. Governance blocks a failed evaluation through GOV-009. The human owns the decision.</a:t>
+              <a:t>The implemented prototype is one governed Decision Orchestrator with deterministic specialist stages. It is agentic because it observes structured context, selects a path, produces a frozen action artifact, checks that artifact, and hands an accountable decision to a person. It is not several autonomous LLM agents. Intake confirms facts and formats. Estimation freezes the distribution. The Cost Evaluation Specialist independently recomputes the ledger without calling the estimator formula. Eligibility, audit, and governance cannot mutate or waive prior evidence. No model token is spent to run this path.</a:t>
             </a:r>
           </a:p>
           <a:p xmlns:a="http://schemas.openxmlformats.org/drawingml/2006/main">
@@ -1004,7 +1004,7 @@
           <a:lstStyle xmlns:a="http://schemas.openxmlformats.org/drawingml/2006/main"/>
           <a:p xmlns:a="http://schemas.openxmlformats.org/drawingml/2006/main">
             <a:r>
-              <a:t>Fifteen automated checks pass. They include COST-001 through COST-006, model-owned output profiles, retry and checker inclusion, deliberate ledger corruption, governance failure propagation, deterministic output, fail-closed safety cases, stable ranking, and rendered-page smoke. Zero generative calls can change the decision path. The boundary is explicit: current behavior profiles are planning heuristics, so GOV-015 warns until repeated live evaluation measures them.</a:t>
+              <a:t>Eighteen automated checks pass. They cover COST-001 through COST-006, model-owned output profiles, retry and checker inclusion, deliberate ledger corruption, governance failure propagation, multi-format requirements, unknown-step workflow recommendations, Luna/Terra/Sol tier changes, deterministic output, fail-closed safety, stable ranking, and rendered-page smoke. Build and lint pass. Zero generative calls can change the decision path. This proves the decision contract—not measured model quality or first-time-user comprehension.</a:t>
             </a:r>
           </a:p>
           <a:p xmlns:a="http://schemas.openxmlformats.org/drawingml/2006/main">
@@ -1019,7 +1019,7 @@
           </a:p>
           <a:p xmlns:a="http://schemas.openxmlformats.org/drawingml/2006/main">
             <a:r>
-              <a:t>- AI Build Crew automated test suite, decision engine v1.3.0</a:t>
+              <a:t>- AI Build Crew automated test suite, decision engine v1.4.0</a:t>
             </a:r>
           </a:p>
           <a:p xmlns:a="http://schemas.openxmlformats.org/drawingml/2006/main">
@@ -1099,7 +1099,7 @@
           <a:lstStyle xmlns:a="http://schemas.openxmlformats.org/drawingml/2006/main"/>
           <a:p xmlns:a="http://schemas.openxmlformats.org/drawingml/2006/main">
             <a:r>
-              <a:t>The next release first deploys this corrected cost contract and reruns the first-time-user test. Then repeated synthetic workloads measure task-by-model completed-task success, p10, p50, and p90 output, retry rate, checker rate, latency, and actual charged cost. Only evidence meeting the sample and confidence threshold replaces a heuristic profile. Shared provider evaluation and actual-charge reconciliation follow. The final model decision stays human-owned.</a:t>
+              <a:t>Making the next claim real requires a controlled evidence pipeline. First rerun moderated first-user tests on the corrected flow. Freeze synthetic workloads and task-success rubrics by job family. Add protected OpenAI, Gemini, and Anthropic adapters with per-run budget and concurrency caps. Run at least thirty repeats per task-model cell and capture completed-task success, p10, p50, and p90 output, retries, checker calls, latency, provider usage, and actual charge. Use blinded scoring plus a human calibration sample. Promote a heuristic profile only when the minimum sample, confidence interval, evaluator agreement, price freshness, and governance gates pass. Preserve the old profile and evidence version. Final model decisions remain human-owned.</a:t>
             </a:r>
           </a:p>
           <a:p xmlns:a="http://schemas.openxmlformats.org/drawingml/2006/main">
@@ -1192,7 +1192,7 @@
   </p:cSld>
   <p:clrMap bg1="lt1" tx1="dk1" bg2="lt2" tx2="dk2" accent1="accent1" accent2="accent2" accent3="accent3" accent4="accent4" accent5="accent5" accent6="accent6" hlink="hlink" folHlink="folHlink"/>
   <p:sldLayoutIdLst>
-    <p:sldLayoutId xmlns:r="http://schemas.openxmlformats.org/officeDocument/2006/relationships" id="2147483649" r:id="R2e1c2807af164f45"/>
+    <p:sldLayoutId xmlns:r="http://schemas.openxmlformats.org/officeDocument/2006/relationships" id="2147483649" r:id="R332737bda610476a"/>
   </p:sldLayoutIdLst>
   <p:txStyles>
     <p:titleStyle>
@@ -1757,13 +1757,13 @@
               <c:formatCode>0.00</c:formatCode>
               <c:ptCount val="3"/>
               <c:pt idx="0">
-                <c:v>2.322</c:v>
+                <c:v>3.714</c:v>
               </c:pt>
               <c:pt idx="1">
-                <c:v>4.0848</c:v>
+                <c:v>6.7206</c:v>
               </c:pt>
               <c:pt idx="2">
-                <c:v>8.55675</c:v>
+                <c:v>14.35725</c:v>
               </c:pt>
             </c:numLit>
           </c:val>
@@ -1885,7 +1885,7 @@
           <p:nvPr/>
         </p:nvPicPr>
         <p:blipFill>
-          <a:blip xmlns:r="http://schemas.openxmlformats.org/officeDocument/2006/relationships" xmlns:a="http://schemas.openxmlformats.org/drawingml/2006/main" r:embed="R6d3692eb03e04fa6"/>
+          <a:blip xmlns:r="http://schemas.openxmlformats.org/officeDocument/2006/relationships" xmlns:a="http://schemas.openxmlformats.org/drawingml/2006/main" r:embed="Re83c4070864d4792"/>
           <a:srcRect xmlns:a="http://schemas.openxmlformats.org/drawingml/2006/main" l="0" t="27" r="0" b="27"/>
           <a:stretch xmlns:a="http://schemas.openxmlformats.org/drawingml/2006/main">
             <a:fillRect l="0" t="0" r="0" b="0"/>
@@ -3132,7 +3132,7 @@
                   <a:srgbClr val="152015"/>
                 </a:solidFill>
               </a:rPr>
-              <a:t>THE FIRST USER</a:t>
+              <a:t>PERSONA + JOB TO BE DONE</a:t>
             </a:r>
           </a:p>
         </p:txBody>
@@ -3214,7 +3214,7 @@
                   <a:srgbClr val="152015"/>
                 </a:solidFill>
               </a:rPr>
-              <a:t>A builder wants a cost</a:t>
+              <a:t>A product builder owns the</a:t>
             </a:r>
           </a:p>
           <a:p xmlns:a="http://schemas.openxmlformats.org/drawingml/2006/main">
@@ -3232,7 +3232,7 @@
                   <a:srgbClr val="152015"/>
                 </a:solidFill>
               </a:rPr>
-              <a:t>before committing the build.</a:t>
+              <a:t>go / no-go decision.</a:t>
             </a:r>
           </a:p>
         </p:txBody>
@@ -3283,7 +3283,7 @@
                   <a:srgbClr val="687068"/>
                 </a:solidFill>
               </a:rPr>
-              <a:t>They should not need to know a model name, token count, context window, cache policy, or agent architecture to begin.</a:t>
+              <a:t>They know the product problem—but may have no AI architect or FinOps partner. They should not need a model name, token count, or workflow design to begin.</a:t>
             </a:r>
           </a:p>
         </p:txBody>
@@ -3418,7 +3418,9 @@
                   <a:srgbClr val="FFFFFF"/>
                 </a:solidFill>
               </a:rPr>
-              <a:t>“Help me forecast what this idea could cost, where the estimate is uncertain, and what I give up by choosing differently.”</a:t>
+              <a:t>“WHEN the build choice is unclear,
+HELP ME confirm model + cost,
+SO I CAN commit—or stop.”</a:t>
             </a:r>
           </a:p>
         </p:txBody>
@@ -3500,7 +3502,7 @@
                   <a:srgbClr val="C8D1C8"/>
                 </a:solidFill>
               </a:rPr>
-              <a:t>Outcome: a decision a product team can explain, reproduce, and revisit.</a:t>
+              <a:t>Outcome: a reproducible build decision—not a pricing-table guess.</a:t>
             </a:r>
           </a:p>
         </p:txBody>
@@ -4273,7 +4275,7 @@
                   <a:srgbClr val="FFFFFF"/>
                 </a:solidFill>
               </a:rPr>
-              <a:t>Choose a job, consequence of error, data type, and planning stage.</a:t>
+              <a:t>Choose job, risk, data, every required format, and a stage. Unknown steps get a visible recommendation.</a:t>
             </a:r>
           </a:p>
         </p:txBody>
@@ -4494,7 +4496,7 @@
                   <a:srgbClr val="152015"/>
                 </a:solidFill>
               </a:rPr>
-              <a:t>Review every Known, Assumed, and Unknown field before calculation.</a:t>
+              <a:t>Confirm suggested steps and assumptions. An optional ceiling filters; it never invents the cost.</a:t>
             </a:r>
           </a:p>
         </p:txBody>
@@ -4929,7 +4931,7 @@
                   <a:srgbClr val="687068"/>
                 </a:solidFill>
               </a:rPr>
-              <a:t>Product-analysis profile · 1,000 tasks/day · 2,400 tokens in · detailed result · 1 primary + 1 checker</a:t>
+              <a:t>Product-analysis profile · 1,000 tasks/day · 2,400 tokens in · detailed result · recommended 2 primary + 1 checker</a:t>
             </a:r>
           </a:p>
         </p:txBody>
@@ -4946,7 +4948,7 @@
         </p:xfrm>
         <a:graphic xmlns:a="http://schemas.openxmlformats.org/drawingml/2006/main">
           <a:graphicData uri="http://schemas.openxmlformats.org/drawingml/2006/chart">
-            <c:chart xmlns:r="http://schemas.openxmlformats.org/officeDocument/2006/relationships" xmlns:c="http://schemas.openxmlformats.org/drawingml/2006/chart" r:id="R82eeede9b1134522"/>
+            <c:chart xmlns:r="http://schemas.openxmlformats.org/officeDocument/2006/relationships" xmlns:c="http://schemas.openxmlformats.org/drawingml/2006/chart" r:id="Rad4ac44828e04006"/>
           </a:graphicData>
         </a:graphic>
       </p:graphicFrame>
@@ -5131,7 +5133,7 @@
                   <a:srgbClr val="8F7BFF"/>
                 </a:solidFill>
               </a:rPr>
-              <a:t>$0.0408 / task</a:t>
+              <a:t>$0.0672 / task</a:t>
             </a:r>
           </a:p>
         </p:txBody>
@@ -5200,7 +5202,7 @@
                   <a:srgbClr val="C8D1C8"/>
                 </a:solidFill>
               </a:rPr>
-              <a:t>+$0.0677 / task</a:t>
+              <a:t>+$0.1141 / task</a:t>
             </a:r>
           </a:p>
         </p:txBody>
@@ -5484,7 +5486,7 @@
                   <a:srgbClr val="FFFFFF"/>
                 </a:solidFill>
               </a:rPr>
-              <a:t>HARD COST EVALUATION</a:t>
+              <a:t>AGENTIC WORKFLOW · HONEST BOUNDARY</a:t>
             </a:r>
           </a:p>
         </p:txBody>
@@ -5566,7 +5568,7 @@
                   <a:srgbClr val="FFFFFF"/>
                 </a:solidFill>
               </a:rPr>
-              <a:t>A failed cost check</a:t>
+              <a:t>One Decision Orchestrator.</a:t>
             </a:r>
           </a:p>
           <a:p xmlns:a="http://schemas.openxmlformats.org/drawingml/2006/main">
@@ -5584,7 +5586,7 @@
                   <a:srgbClr val="FFFFFF"/>
                 </a:solidFill>
               </a:rPr>
-              <a:t>blocks the decision.</a:t>
+              <a:t>Hard-bordered specialist stages.</a:t>
             </a:r>
           </a:p>
         </p:txBody>
@@ -5772,7 +5774,7 @@
                   <a:srgbClr val="C8D1C8"/>
                 </a:solidFill>
               </a:rPr>
-              <a:t>Freezes three scenarios</a:t>
+              <a:t>Confirms facts + formats</a:t>
             </a:r>
           </a:p>
         </p:txBody>
@@ -6761,7 +6763,7 @@
                   <a:srgbClr val="D8FF55"/>
                 </a:solidFill>
               </a:rPr>
-              <a:t>COST-001 rejects output-token input. A ledger mismatch fails evaluation and GOV-009 blocks governance.</a:t>
+              <a:t>Deterministic specialists—not autonomous LLM agents. COST-001 rejects output-token input; a ledger mismatch fails evaluation; GOV-009 blocks.</a:t>
             </a:r>
           </a:p>
         </p:txBody>
@@ -7145,7 +7147,7 @@
                   <a:srgbClr val="8F7BFF"/>
                 </a:solidFill>
               </a:rPr>
-              <a:t>15</a:t>
+              <a:t>18</a:t>
             </a:r>
           </a:p>
         </p:txBody>
@@ -7247,7 +7249,7 @@
                   <a:srgbClr val="687068"/>
                 </a:solidFill>
               </a:rPr>
-              <a:t>Cost contract, corruption, governance, safety, and render</a:t>
+              <a:t>Cost contract, multi-format, workflow advice, model switching, governance, safety, and render</a:t>
             </a:r>
           </a:p>
         </p:txBody>
@@ -7926,7 +7928,7 @@
           <p:nvPr/>
         </p:nvPicPr>
         <p:blipFill>
-          <a:blip xmlns:r="http://schemas.openxmlformats.org/officeDocument/2006/relationships" xmlns:a="http://schemas.openxmlformats.org/drawingml/2006/main" r:embed="R4efa55a1d9b343c9"/>
+          <a:blip xmlns:r="http://schemas.openxmlformats.org/officeDocument/2006/relationships" xmlns:a="http://schemas.openxmlformats.org/drawingml/2006/main" r:embed="R88a9ffeee49c4f9d"/>
           <a:srcRect xmlns:a="http://schemas.openxmlformats.org/drawingml/2006/main" l="0" t="27" r="0" b="27"/>
           <a:stretch xmlns:a="http://schemas.openxmlformats.org/drawingml/2006/main">
             <a:fillRect l="0" t="0" r="0" b="0"/>
@@ -8192,7 +8194,7 @@
                   <a:srgbClr val="FFFFFF"/>
                 </a:solidFill>
               </a:rPr>
-              <a:t>Corrected cost contract + independent ledger</a:t>
+              <a:t>Corrected contract + multi-format + workflow guidance</a:t>
             </a:r>
           </a:p>
         </p:txBody>
@@ -8325,7 +8327,7 @@
                   <a:srgbClr val="FFFFFF"/>
                 </a:solidFill>
               </a:rPr>
-              <a:t>Deploy corrected workbench + rerun user test</a:t>
+              <a:t>Rerun first-user test; freeze synthetic task suite</a:t>
             </a:r>
           </a:p>
         </p:txBody>
@@ -8458,7 +8460,7 @@
                   <a:srgbClr val="FFFFFF"/>
                 </a:solidFill>
               </a:rPr>
-              <a:t>Measure task × model output and retry distributions</a:t>
+              <a:t>Run ≥30 repeats/model: success, p10/p50/p90, retries, checker, latency</a:t>
             </a:r>
           </a:p>
         </p:txBody>
@@ -8591,7 +8593,7 @@
                   <a:srgbClr val="FFFFFF"/>
                 </a:solidFill>
               </a:rPr>
-              <a:t>Actual charges + shared provider evaluation</a:t>
+              <a:t>Promote only evidence over threshold; reconcile actual charges</a:t>
             </a:r>
           </a:p>
         </p:txBody>

</xml_diff>

<commit_message>
Add Phase 2 provider platform strategy to deck
</commit_message>
<xml_diff>
--- a/artifacts/AI_BUILD_CREW_COST_CONTRACT_VIDEO_REVIEW.pptx
+++ b/artifacts/AI_BUILD_CREW_COST_CONTRACT_VIDEO_REVIEW.pptx
@@ -2,20 +2,23 @@
 <file path=ppt/presentation.xml><?xml version="1.0" encoding="utf-8"?>
 <p:presentation xmlns:p="http://schemas.openxmlformats.org/presentationml/2006/main">
   <p:sldMasterIdLst>
-    <p:sldMasterId xmlns:r="http://schemas.openxmlformats.org/officeDocument/2006/relationships" id="2147483648" r:id="R0dbf89d702e84697"/>
+    <p:sldMasterId xmlns:r="http://schemas.openxmlformats.org/officeDocument/2006/relationships" id="2147483648" r:id="Rda68c6c13e124e89"/>
   </p:sldMasterIdLst>
   <p:notesMasterIdLst>
-    <p:notesMasterId xmlns:r="http://schemas.openxmlformats.org/officeDocument/2006/relationships" r:id="R0ccfb24263334d26"/>
+    <p:notesMasterId xmlns:r="http://schemas.openxmlformats.org/officeDocument/2006/relationships" r:id="R31ca0785941a497e"/>
   </p:notesMasterIdLst>
   <p:sldIdLst>
-    <p:sldId xmlns:r="http://schemas.openxmlformats.org/officeDocument/2006/relationships" id="256" r:id="R5d8d3ec7a986444a"/>
-    <p:sldId xmlns:r="http://schemas.openxmlformats.org/officeDocument/2006/relationships" id="257" r:id="R6adb5c2113854b0b"/>
-    <p:sldId xmlns:r="http://schemas.openxmlformats.org/officeDocument/2006/relationships" id="258" r:id="R4781dc3035e14b8d"/>
-    <p:sldId xmlns:r="http://schemas.openxmlformats.org/officeDocument/2006/relationships" id="259" r:id="Rd7a34f714822490d"/>
-    <p:sldId xmlns:r="http://schemas.openxmlformats.org/officeDocument/2006/relationships" id="260" r:id="Rb5027c57c1a04217"/>
-    <p:sldId xmlns:r="http://schemas.openxmlformats.org/officeDocument/2006/relationships" id="261" r:id="Rb458509aa2d94d34"/>
-    <p:sldId xmlns:r="http://schemas.openxmlformats.org/officeDocument/2006/relationships" id="262" r:id="Rb789cfdf956847e6"/>
-    <p:sldId xmlns:r="http://schemas.openxmlformats.org/officeDocument/2006/relationships" id="263" r:id="Rb326b6b2d1c543ad"/>
+    <p:sldId xmlns:r="http://schemas.openxmlformats.org/officeDocument/2006/relationships" id="256" r:id="R98b373e1cfab4d58"/>
+    <p:sldId xmlns:r="http://schemas.openxmlformats.org/officeDocument/2006/relationships" id="257" r:id="R764d1e5b88594da0"/>
+    <p:sldId xmlns:r="http://schemas.openxmlformats.org/officeDocument/2006/relationships" id="258" r:id="R474d42d2be4245db"/>
+    <p:sldId xmlns:r="http://schemas.openxmlformats.org/officeDocument/2006/relationships" id="259" r:id="R4020a1a900b84cd5"/>
+    <p:sldId xmlns:r="http://schemas.openxmlformats.org/officeDocument/2006/relationships" id="260" r:id="Rf5bb74ee6080499a"/>
+    <p:sldId xmlns:r="http://schemas.openxmlformats.org/officeDocument/2006/relationships" id="261" r:id="Rc7eee5b5d4314140"/>
+    <p:sldId xmlns:r="http://schemas.openxmlformats.org/officeDocument/2006/relationships" id="262" r:id="R87bffd3a20024a28"/>
+    <p:sldId xmlns:r="http://schemas.openxmlformats.org/officeDocument/2006/relationships" id="263" r:id="R6ee581eff5df4f67"/>
+    <p:sldId xmlns:r="http://schemas.openxmlformats.org/officeDocument/2006/relationships" id="264" r:id="R2f065474507d488b"/>
+    <p:sldId xmlns:r="http://schemas.openxmlformats.org/officeDocument/2006/relationships" id="265" r:id="R540eb597b6034f20"/>
+    <p:sldId xmlns:r="http://schemas.openxmlformats.org/officeDocument/2006/relationships" id="266" r:id="R33fe81211eec4dff"/>
   </p:sldIdLst>
   <p:sldSz cx="12192000" cy="6858000"/>
   <p:notesSz cx="6858000" cy="9144000"/>
@@ -504,6 +507,211 @@
 </p:notes>
 </file>
 
+<file path=ppt/notesSlides/notesSlide10.xml><?xml version="1.0" encoding="utf-8"?>
+<p:notes xmlns:p="http://schemas.openxmlformats.org/presentationml/2006/main">
+  <p:cSld>
+    <p:spTree>
+      <p:nvGrpSpPr>
+        <p:cNvPr id="1" name=""/>
+        <p:cNvGrpSpPr/>
+        <p:nvPr/>
+      </p:nvGrpSpPr>
+      <p:grpSpPr>
+        <a:xfrm xmlns:a="http://schemas.openxmlformats.org/drawingml/2006/main"/>
+      </p:grpSpPr>
+      <p:sp>
+        <p:nvSpPr>
+          <p:cNvPr id="2" name="Slide Image Placeholder 1"/>
+          <p:cNvSpPr>
+            <a:spLocks xmlns:a="http://schemas.openxmlformats.org/drawingml/2006/main" noGrp="1"/>
+          </p:cNvSpPr>
+          <p:nvPr>
+            <p:ph type="sldImg" idx="0"/>
+          </p:nvPr>
+        </p:nvSpPr>
+        <p:spPr/>
+      </p:sp>
+      <p:sp>
+        <p:nvSpPr>
+          <p:cNvPr id="3" name="Notes Placeholder 2"/>
+          <p:cNvSpPr>
+            <a:spLocks xmlns:a="http://schemas.openxmlformats.org/drawingml/2006/main" noGrp="1"/>
+          </p:cNvSpPr>
+          <p:nvPr>
+            <p:ph type="body" idx="1"/>
+          </p:nvPr>
+        </p:nvSpPr>
+        <p:spPr/>
+        <p:txBody>
+          <a:bodyPr xmlns:a="http://schemas.openxmlformats.org/drawingml/2006/main"/>
+          <a:lstStyle xmlns:a="http://schemas.openxmlformats.org/drawingml/2006/main"/>
+          <a:p xmlns:a="http://schemas.openxmlformats.org/drawingml/2006/main">
+            <a:r>
+              <a:t>The six handoffs are intentionally hard-bordered: brief, freeze, provider run, blinded scoring, governance, and report. Catalog-only comparison makes no provider calls and has zero model-token cost. Live comparison begins only after the user sees a maximum spend and explicitly approves it. Every provider receives the same frozen case; runners cannot choose models, raise budgets, score themselves, or change policy.</a:t>
+            </a:r>
+          </a:p>
+          <a:p xmlns:a="http://schemas.openxmlformats.org/drawingml/2006/main">
+            <a:r>
+              <a:t/>
+            </a:r>
+          </a:p>
+          <a:p xmlns:a="http://schemas.openxmlformats.org/drawingml/2006/main">
+            <a:r>
+              <a:t>[Sources]</a:t>
+            </a:r>
+          </a:p>
+          <a:p xmlns:a="http://schemas.openxmlformats.org/drawingml/2006/main">
+            <a:r>
+              <a:t>- AI Build Crew Multi-Agent Provider Platform Plan, August 9, 2026</a:t>
+            </a:r>
+          </a:p>
+          <a:p xmlns:a="http://schemas.openxmlformats.org/drawingml/2006/main">
+            <a:r>
+              <a:t>- https://ai.google.dev/gemini-api/docs/pricing</a:t>
+            </a:r>
+          </a:p>
+          <a:p xmlns:a="http://schemas.openxmlformats.org/drawingml/2006/main">
+            <a:r>
+              <a:t>- https://ai.google.dev/api/models</a:t>
+            </a:r>
+          </a:p>
+          <a:p xmlns:a="http://schemas.openxmlformats.org/drawingml/2006/main">
+            <a:r>
+              <a:t>- https://platform.claude.com/docs/en/api/beta/models/list</a:t>
+            </a:r>
+          </a:p>
+          <a:p xmlns:a="http://schemas.openxmlformats.org/drawingml/2006/main">
+            <a:r>
+              <a:t>- https://developers.openai.com/api/reference/resources/evals</a:t>
+            </a:r>
+          </a:p>
+        </p:txBody>
+      </p:sp>
+      <p:sp>
+        <p:nvSpPr>
+          <p:cNvPr id="4" name="Slide Number Placeholder 3"/>
+          <p:cNvSpPr>
+            <a:spLocks xmlns:a="http://schemas.openxmlformats.org/drawingml/2006/main" noGrp="1"/>
+          </p:cNvSpPr>
+          <p:nvPr>
+            <p:ph type="sldNum" idx="5"/>
+          </p:nvPr>
+        </p:nvSpPr>
+        <p:spPr/>
+        <p:txBody>
+          <a:bodyPr xmlns:a="http://schemas.openxmlformats.org/drawingml/2006/main"/>
+          <a:lstStyle xmlns:a="http://schemas.openxmlformats.org/drawingml/2006/main"/>
+          <a:p xmlns:a="http://schemas.openxmlformats.org/drawingml/2006/main"/>
+        </p:txBody>
+      </p:sp>
+    </p:spTree>
+  </p:cSld>
+  <p:clrMapOvr>
+    <a:masterClrMapping xmlns:a="http://schemas.openxmlformats.org/drawingml/2006/main"/>
+  </p:clrMapOvr>
+</p:notes>
+</file>
+
+<file path=ppt/notesSlides/notesSlide11.xml><?xml version="1.0" encoding="utf-8"?>
+<p:notes xmlns:p="http://schemas.openxmlformats.org/presentationml/2006/main">
+  <p:cSld>
+    <p:spTree>
+      <p:nvGrpSpPr>
+        <p:cNvPr id="1" name=""/>
+        <p:cNvGrpSpPr/>
+        <p:nvPr/>
+      </p:nvGrpSpPr>
+      <p:grpSpPr>
+        <a:xfrm xmlns:a="http://schemas.openxmlformats.org/drawingml/2006/main"/>
+      </p:grpSpPr>
+      <p:sp>
+        <p:nvSpPr>
+          <p:cNvPr id="2" name="Slide Image Placeholder 1"/>
+          <p:cNvSpPr>
+            <a:spLocks xmlns:a="http://schemas.openxmlformats.org/drawingml/2006/main" noGrp="1"/>
+          </p:cNvSpPr>
+          <p:nvPr>
+            <p:ph type="sldImg" idx="0"/>
+          </p:nvPr>
+        </p:nvSpPr>
+        <p:spPr/>
+      </p:sp>
+      <p:sp>
+        <p:nvSpPr>
+          <p:cNvPr id="3" name="Notes Placeholder 2"/>
+          <p:cNvSpPr>
+            <a:spLocks xmlns:a="http://schemas.openxmlformats.org/drawingml/2006/main" noGrp="1"/>
+          </p:cNvSpPr>
+          <p:nvPr>
+            <p:ph type="body" idx="1"/>
+          </p:nvPr>
+        </p:nvSpPr>
+        <p:spPr/>
+        <p:txBody>
+          <a:bodyPr xmlns:a="http://schemas.openxmlformats.org/drawingml/2006/main"/>
+          <a:lstStyle xmlns:a="http://schemas.openxmlformats.org/drawingml/2006/main"/>
+          <a:p xmlns:a="http://schemas.openxmlformats.org/drawingml/2006/main">
+            <a:r>
+              <a:t>AWS is the Phase 2 evidence foundation, not a requirement for the current estimator. S3 holds versioned source snapshots and run artifacts; DynamoDB holds project metadata, budgets, and report history; Secrets Manager protects provider credentials used by server-side runners. Retrieval-augmented generation can ground source summaries, model evidence, and report explanations. It cannot calculate cost, alter eligibility, rewrite policy, or approve a decision. Privacy defaults remain no raw prompt retention, synthetic cases first, and user-controlled export or deletion.</a:t>
+            </a:r>
+          </a:p>
+          <a:p xmlns:a="http://schemas.openxmlformats.org/drawingml/2006/main">
+            <a:r>
+              <a:t/>
+            </a:r>
+          </a:p>
+          <a:p xmlns:a="http://schemas.openxmlformats.org/drawingml/2006/main">
+            <a:r>
+              <a:t>[Sources]</a:t>
+            </a:r>
+          </a:p>
+          <a:p xmlns:a="http://schemas.openxmlformats.org/drawingml/2006/main">
+            <a:r>
+              <a:t>- AI Build Crew Multi-Agent Provider Platform Plan, August 9, 2026</a:t>
+            </a:r>
+          </a:p>
+          <a:p xmlns:a="http://schemas.openxmlformats.org/drawingml/2006/main">
+            <a:r>
+              <a:t>- https://docs.aws.amazon.com/bedrock/latest/userguide/evaluation.html</a:t>
+            </a:r>
+          </a:p>
+          <a:p xmlns:a="http://schemas.openxmlformats.org/drawingml/2006/main">
+            <a:r>
+              <a:t>- https://docs.aws.amazon.com/bedrock/latest/userguide/model-evaluation-report-s3.html</a:t>
+            </a:r>
+          </a:p>
+          <a:p xmlns:a="http://schemas.openxmlformats.org/drawingml/2006/main">
+            <a:r>
+              <a:t>- https://docs.aws.amazon.com/lambda/latest/dg/with-secrets-manager.html</a:t>
+            </a:r>
+          </a:p>
+        </p:txBody>
+      </p:sp>
+      <p:sp>
+        <p:nvSpPr>
+          <p:cNvPr id="4" name="Slide Number Placeholder 3"/>
+          <p:cNvSpPr>
+            <a:spLocks xmlns:a="http://schemas.openxmlformats.org/drawingml/2006/main" noGrp="1"/>
+          </p:cNvSpPr>
+          <p:nvPr>
+            <p:ph type="sldNum" idx="5"/>
+          </p:nvPr>
+        </p:nvSpPr>
+        <p:spPr/>
+        <p:txBody>
+          <a:bodyPr xmlns:a="http://schemas.openxmlformats.org/drawingml/2006/main"/>
+          <a:lstStyle xmlns:a="http://schemas.openxmlformats.org/drawingml/2006/main"/>
+          <a:p xmlns:a="http://schemas.openxmlformats.org/drawingml/2006/main"/>
+        </p:txBody>
+      </p:sp>
+    </p:spTree>
+  </p:cSld>
+  <p:clrMapOvr>
+    <a:masterClrMapping xmlns:a="http://schemas.openxmlformats.org/drawingml/2006/main"/>
+  </p:clrMapOvr>
+</p:notes>
+</file>
+
 <file path=ppt/notesSlides/notesSlide2.xml><?xml version="1.0" encoding="utf-8"?>
 <p:notes xmlns:p="http://schemas.openxmlformats.org/presentationml/2006/main">
   <p:cSld>
@@ -1125,6 +1333,106 @@
           <a:p xmlns:a="http://schemas.openxmlformats.org/drawingml/2006/main">
             <a:r>
               <a:t>- Generated AI Build Crew brand master, OpenAI ImageGen, August 8, 2026</a:t>
+            </a:r>
+          </a:p>
+        </p:txBody>
+      </p:sp>
+      <p:sp>
+        <p:nvSpPr>
+          <p:cNvPr id="4" name="Slide Number Placeholder 3"/>
+          <p:cNvSpPr>
+            <a:spLocks xmlns:a="http://schemas.openxmlformats.org/drawingml/2006/main" noGrp="1"/>
+          </p:cNvSpPr>
+          <p:nvPr>
+            <p:ph type="sldNum" idx="5"/>
+          </p:nvPr>
+        </p:nvSpPr>
+        <p:spPr/>
+        <p:txBody>
+          <a:bodyPr xmlns:a="http://schemas.openxmlformats.org/drawingml/2006/main"/>
+          <a:lstStyle xmlns:a="http://schemas.openxmlformats.org/drawingml/2006/main"/>
+          <a:p xmlns:a="http://schemas.openxmlformats.org/drawingml/2006/main"/>
+        </p:txBody>
+      </p:sp>
+    </p:spTree>
+  </p:cSld>
+  <p:clrMapOvr>
+    <a:masterClrMapping xmlns:a="http://schemas.openxmlformats.org/drawingml/2006/main"/>
+  </p:clrMapOvr>
+</p:notes>
+</file>
+
+<file path=ppt/notesSlides/notesSlide9.xml><?xml version="1.0" encoding="utf-8"?>
+<p:notes xmlns:p="http://schemas.openxmlformats.org/presentationml/2006/main">
+  <p:cSld>
+    <p:spTree>
+      <p:nvGrpSpPr>
+        <p:cNvPr id="1" name=""/>
+        <p:cNvGrpSpPr/>
+        <p:nvPr/>
+      </p:nvGrpSpPr>
+      <p:grpSpPr>
+        <a:xfrm xmlns:a="http://schemas.openxmlformats.org/drawingml/2006/main"/>
+      </p:grpSpPr>
+      <p:sp>
+        <p:nvSpPr>
+          <p:cNvPr id="2" name="Slide Image Placeholder 1"/>
+          <p:cNvSpPr>
+            <a:spLocks xmlns:a="http://schemas.openxmlformats.org/drawingml/2006/main" noGrp="1"/>
+          </p:cNvSpPr>
+          <p:nvPr>
+            <p:ph type="sldImg" idx="0"/>
+          </p:nvPr>
+        </p:nvSpPr>
+        <p:spPr/>
+      </p:sp>
+      <p:sp>
+        <p:nvSpPr>
+          <p:cNvPr id="3" name="Notes Placeholder 2"/>
+          <p:cNvSpPr>
+            <a:spLocks xmlns:a="http://schemas.openxmlformats.org/drawingml/2006/main" noGrp="1"/>
+          </p:cNvSpPr>
+          <p:nvPr>
+            <p:ph type="body" idx="1"/>
+          </p:nvPr>
+        </p:nvSpPr>
+        <p:spPr/>
+        <p:txBody>
+          <a:bodyPr xmlns:a="http://schemas.openxmlformats.org/drawingml/2006/main"/>
+          <a:lstStyle xmlns:a="http://schemas.openxmlformats.org/drawingml/2006/main"/>
+          <a:p xmlns:a="http://schemas.openxmlformats.org/drawingml/2006/main">
+            <a:r>
+              <a:t>Phase 2 makes the current estimator the control plane for provider-neutral comparison. A locked Workload Architect freezes the user-confirmed brief. Deterministic orchestration then dispatches the same sealed evaluation case to provider-specific runners. A blinded evaluator, cost specialist, auditor, and governance gate produce one comparable point-in-time report. The report can be exported; raw ideas do not need to be retained. The full operating contract is published in the Multi-Agent Provider Platform Plan.</a:t>
+            </a:r>
+          </a:p>
+          <a:p xmlns:a="http://schemas.openxmlformats.org/drawingml/2006/main">
+            <a:r>
+              <a:t/>
+            </a:r>
+          </a:p>
+          <a:p xmlns:a="http://schemas.openxmlformats.org/drawingml/2006/main">
+            <a:r>
+              <a:t>[Sources]</a:t>
+            </a:r>
+          </a:p>
+          <a:p xmlns:a="http://schemas.openxmlformats.org/drawingml/2006/main">
+            <a:r>
+              <a:t>- AI Build Crew Multi-Agent Provider Platform Plan, August 9, 2026</a:t>
+            </a:r>
+          </a:p>
+          <a:p xmlns:a="http://schemas.openxmlformats.org/drawingml/2006/main">
+            <a:r>
+              <a:t>- https://ai.google.dev/api/models</a:t>
+            </a:r>
+          </a:p>
+          <a:p xmlns:a="http://schemas.openxmlformats.org/drawingml/2006/main">
+            <a:r>
+              <a:t>- https://platform.claude.com/docs/en/api/beta/models/list</a:t>
+            </a:r>
+          </a:p>
+          <a:p xmlns:a="http://schemas.openxmlformats.org/drawingml/2006/main">
+            <a:r>
+              <a:t>- https://developers.openai.com/api/reference/resources/evals</a:t>
             </a:r>
           </a:p>
         </p:txBody>
@@ -1192,7 +1500,7 @@
   </p:cSld>
   <p:clrMap bg1="lt1" tx1="dk1" bg2="lt2" tx2="dk2" accent1="accent1" accent2="accent2" accent3="accent3" accent4="accent4" accent5="accent5" accent6="accent6" hlink="hlink" folHlink="folHlink"/>
   <p:sldLayoutIdLst>
-    <p:sldLayoutId xmlns:r="http://schemas.openxmlformats.org/officeDocument/2006/relationships" id="2147483649" r:id="R332737bda610476a"/>
+    <p:sldLayoutId xmlns:r="http://schemas.openxmlformats.org/officeDocument/2006/relationships" id="2147483649" r:id="R06a3eae344364870"/>
   </p:sldLayoutIdLst>
   <p:txStyles>
     <p:titleStyle>
@@ -1885,7 +2193,7 @@
           <p:nvPr/>
         </p:nvPicPr>
         <p:blipFill>
-          <a:blip xmlns:r="http://schemas.openxmlformats.org/officeDocument/2006/relationships" xmlns:a="http://schemas.openxmlformats.org/drawingml/2006/main" r:embed="Re83c4070864d4792"/>
+          <a:blip xmlns:r="http://schemas.openxmlformats.org/officeDocument/2006/relationships" xmlns:a="http://schemas.openxmlformats.org/drawingml/2006/main" r:embed="R27cbb2583a0a490e"/>
           <a:srcRect xmlns:a="http://schemas.openxmlformats.org/drawingml/2006/main" l="0" t="27" r="0" b="27"/>
           <a:stretch xmlns:a="http://schemas.openxmlformats.org/drawingml/2006/main">
             <a:fillRect l="0" t="0" r="0" b="0"/>
@@ -2227,6 +2535,2350 @@
     <p:extLst>
       <p:ext uri="{BB962C8B-B14F-4D97-AF65-F5344CB8AC3E}">
         <p14:creationId xmlns:p14="http://schemas.microsoft.com/office/powerpoint/2010/main" val="826955634"/>
+      </p:ext>
+    </p:extLst>
+  </p:cSld>
+</p:sld>
+</file>
+
+<file path=ppt/slides/slide10.xml><?xml version="1.0" encoding="utf-8"?>
+<p:sld xmlns:p="http://schemas.openxmlformats.org/presentationml/2006/main">
+  <p:cSld>
+    <p:bg>
+      <p:bgPr>
+        <a:solidFill xmlns:a="http://schemas.openxmlformats.org/drawingml/2006/main">
+          <a:srgbClr val="152015"/>
+        </a:solidFill>
+      </p:bgPr>
+    </p:bg>
+    <p:spTree>
+      <p:nvGrpSpPr>
+        <p:cNvPr id="1" name=""/>
+        <p:cNvGrpSpPr/>
+        <p:nvPr/>
+      </p:nvGrpSpPr>
+      <p:grpSpPr>
+        <a:xfrm xmlns:a="http://schemas.openxmlformats.org/drawingml/2006/main"/>
+      </p:grpSpPr>
+      <p:sp>
+        <p:nvSpPr>
+          <p:cNvPr id="32" name="">
+            <a:extLst xmlns:a="http://schemas.openxmlformats.org/drawingml/2006/main">
+              <a:ext uri="{FF2B5EF4-FFF2-40B4-BE49-F238E27FC236}">
+                <a16:creationId xmlns:a16="http://schemas.microsoft.com/office/drawing/2014/main" id="{8C553D6B-F6E1-4C23-94F8-0C2E979C37E8}"/>
+              </a:ext>
+            </a:extLst>
+          </p:cNvPr>
+          <p:cNvSpPr>
+            <a:spLocks xmlns:a="http://schemas.openxmlformats.org/drawingml/2006/main" noGrp="1"/>
+          </p:cNvSpPr>
+          <p:nvPr/>
+        </p:nvSpPr>
+        <p:spPr>
+          <a:xfrm xmlns:a="http://schemas.openxmlformats.org/drawingml/2006/main">
+            <a:off x="685800" y="457200"/>
+            <a:ext cx="514350" cy="266700"/>
+          </a:xfrm>
+          <a:prstGeom xmlns:a="http://schemas.openxmlformats.org/drawingml/2006/main" prst="rect">
+            <a:avLst/>
+          </a:prstGeom>
+          <a:noFill xmlns:a="http://schemas.openxmlformats.org/drawingml/2006/main"/>
+          <a:ln xmlns:a="http://schemas.openxmlformats.org/drawingml/2006/main" w="0">
+            <a:noFill/>
+            <a:prstDash val="solid"/>
+          </a:ln>
+        </p:spPr>
+        <p:txBody>
+          <a:bodyPr xmlns:a="http://schemas.openxmlformats.org/drawingml/2006/main"/>
+          <a:lstStyle xmlns:a="http://schemas.openxmlformats.org/drawingml/2006/main"/>
+          <a:p xmlns:a="http://schemas.openxmlformats.org/drawingml/2006/main">
+            <a:pPr algn="l">
+              <a:buNone/>
+              <a:defRPr sz="975" b="1">
+                <a:solidFill>
+                  <a:srgbClr val="D8FF55"/>
+                </a:solidFill>
+              </a:defRPr>
+            </a:pPr>
+            <a:r>
+              <a:rPr sz="975" b="1">
+                <a:solidFill>
+                  <a:srgbClr val="D8FF55"/>
+                </a:solidFill>
+              </a:rPr>
+              <a:t>08</a:t>
+            </a:r>
+          </a:p>
+        </p:txBody>
+      </p:sp>
+      <p:sp>
+        <p:nvSpPr>
+          <p:cNvPr id="2" name="">
+            <a:extLst xmlns:a="http://schemas.openxmlformats.org/drawingml/2006/main">
+              <a:ext uri="{FF2B5EF4-FFF2-40B4-BE49-F238E27FC236}">
+                <a16:creationId xmlns:a16="http://schemas.microsoft.com/office/drawing/2014/main" id="{8A548264-5D78-4063-AE84-D74A11F20831}"/>
+              </a:ext>
+            </a:extLst>
+          </p:cNvPr>
+          <p:cNvSpPr>
+            <a:spLocks xmlns:a="http://schemas.openxmlformats.org/drawingml/2006/main" noGrp="1"/>
+          </p:cNvSpPr>
+          <p:nvPr/>
+        </p:nvSpPr>
+        <p:spPr>
+          <a:xfrm xmlns:a="http://schemas.openxmlformats.org/drawingml/2006/main">
+            <a:off x="1219200" y="457200"/>
+            <a:ext cx="4762500" cy="266700"/>
+          </a:xfrm>
+          <a:prstGeom xmlns:a="http://schemas.openxmlformats.org/drawingml/2006/main" prst="rect">
+            <a:avLst/>
+          </a:prstGeom>
+          <a:noFill xmlns:a="http://schemas.openxmlformats.org/drawingml/2006/main"/>
+          <a:ln xmlns:a="http://schemas.openxmlformats.org/drawingml/2006/main" w="0">
+            <a:noFill/>
+            <a:prstDash val="solid"/>
+          </a:ln>
+        </p:spPr>
+        <p:txBody>
+          <a:bodyPr xmlns:a="http://schemas.openxmlformats.org/drawingml/2006/main"/>
+          <a:lstStyle xmlns:a="http://schemas.openxmlformats.org/drawingml/2006/main"/>
+          <a:p xmlns:a="http://schemas.openxmlformats.org/drawingml/2006/main">
+            <a:pPr algn="l">
+              <a:buNone/>
+              <a:defRPr sz="975" b="1">
+                <a:solidFill>
+                  <a:srgbClr val="FFFFFF"/>
+                </a:solidFill>
+              </a:defRPr>
+            </a:pPr>
+            <a:r>
+              <a:rPr sz="975" b="1">
+                <a:solidFill>
+                  <a:srgbClr val="FFFFFF"/>
+                </a:solidFill>
+              </a:rPr>
+              <a:t>PHASE 2 · CONTROLLED PROVIDER EVALUATION</a:t>
+            </a:r>
+          </a:p>
+        </p:txBody>
+      </p:sp>
+      <p:sp>
+        <p:nvSpPr>
+          <p:cNvPr id="3" name="">
+            <a:extLst xmlns:a="http://schemas.openxmlformats.org/drawingml/2006/main">
+              <a:ext uri="{FF2B5EF4-FFF2-40B4-BE49-F238E27FC236}">
+                <a16:creationId xmlns:a16="http://schemas.microsoft.com/office/drawing/2014/main" id="{EA4DD615-451E-4118-B330-1B17291F0392}"/>
+              </a:ext>
+            </a:extLst>
+          </p:cNvPr>
+          <p:cNvSpPr>
+            <a:spLocks xmlns:a="http://schemas.openxmlformats.org/drawingml/2006/main" noGrp="1"/>
+          </p:cNvSpPr>
+          <p:nvPr/>
+        </p:nvSpPr>
+        <p:spPr>
+          <a:xfrm xmlns:a="http://schemas.openxmlformats.org/drawingml/2006/main">
+            <a:off x="685800" y="781050"/>
+            <a:ext cx="10820400" cy="19050"/>
+          </a:xfrm>
+          <a:prstGeom xmlns:a="http://schemas.openxmlformats.org/drawingml/2006/main" prst="rect">
+            <a:avLst/>
+          </a:prstGeom>
+          <a:solidFill xmlns:a="http://schemas.openxmlformats.org/drawingml/2006/main">
+            <a:srgbClr val="405040"/>
+          </a:solidFill>
+          <a:ln xmlns:a="http://schemas.openxmlformats.org/drawingml/2006/main" w="0">
+            <a:noFill/>
+            <a:prstDash val="solid"/>
+          </a:ln>
+        </p:spPr>
+      </p:sp>
+      <p:sp>
+        <p:nvSpPr>
+          <p:cNvPr id="4" name="">
+            <a:extLst xmlns:a="http://schemas.openxmlformats.org/drawingml/2006/main">
+              <a:ext uri="{FF2B5EF4-FFF2-40B4-BE49-F238E27FC236}">
+                <a16:creationId xmlns:a16="http://schemas.microsoft.com/office/drawing/2014/main" id="{79CBBBB8-4104-412D-B784-5FC1F100316D}"/>
+              </a:ext>
+            </a:extLst>
+          </p:cNvPr>
+          <p:cNvSpPr>
+            <a:spLocks xmlns:a="http://schemas.openxmlformats.org/drawingml/2006/main" noGrp="1"/>
+          </p:cNvSpPr>
+          <p:nvPr/>
+        </p:nvSpPr>
+        <p:spPr>
+          <a:xfrm xmlns:a="http://schemas.openxmlformats.org/drawingml/2006/main">
+            <a:off x="685800" y="1095375"/>
+            <a:ext cx="6191250" cy="990600"/>
+          </a:xfrm>
+          <a:prstGeom xmlns:a="http://schemas.openxmlformats.org/drawingml/2006/main" prst="rect">
+            <a:avLst/>
+          </a:prstGeom>
+          <a:noFill xmlns:a="http://schemas.openxmlformats.org/drawingml/2006/main"/>
+          <a:ln xmlns:a="http://schemas.openxmlformats.org/drawingml/2006/main" w="0">
+            <a:noFill/>
+            <a:prstDash val="solid"/>
+          </a:ln>
+        </p:spPr>
+        <p:txBody>
+          <a:bodyPr xmlns:a="http://schemas.openxmlformats.org/drawingml/2006/main"/>
+          <a:lstStyle xmlns:a="http://schemas.openxmlformats.org/drawingml/2006/main"/>
+          <a:p xmlns:a="http://schemas.openxmlformats.org/drawingml/2006/main">
+            <a:pPr algn="l">
+              <a:buNone/>
+              <a:defRPr sz="3450" b="1">
+                <a:solidFill>
+                  <a:srgbClr val="FFFFFF"/>
+                </a:solidFill>
+              </a:defRPr>
+            </a:pPr>
+            <a:r>
+              <a:rPr sz="3450" b="1">
+                <a:solidFill>
+                  <a:srgbClr val="FFFFFF"/>
+                </a:solidFill>
+              </a:rPr>
+              <a:t>One orchestrator.</a:t>
+            </a:r>
+          </a:p>
+          <a:p xmlns:a="http://schemas.openxmlformats.org/drawingml/2006/main">
+            <a:pPr algn="l">
+              <a:buNone/>
+              <a:defRPr sz="3450" b="1">
+                <a:solidFill>
+                  <a:srgbClr val="FFFFFF"/>
+                </a:solidFill>
+              </a:defRPr>
+            </a:pPr>
+            <a:r>
+              <a:rPr sz="3450" b="1">
+                <a:solidFill>
+                  <a:srgbClr val="FFFFFF"/>
+                </a:solidFill>
+              </a:rPr>
+              <a:t>Six locked handoffs.</a:t>
+            </a:r>
+          </a:p>
+        </p:txBody>
+      </p:sp>
+      <p:sp>
+        <p:nvSpPr>
+          <p:cNvPr id="5" name="">
+            <a:extLst xmlns:a="http://schemas.openxmlformats.org/drawingml/2006/main">
+              <a:ext uri="{FF2B5EF4-FFF2-40B4-BE49-F238E27FC236}">
+                <a16:creationId xmlns:a16="http://schemas.microsoft.com/office/drawing/2014/main" id="{96F1FD02-CAA2-4996-94C1-9C8C87D775C4}"/>
+              </a:ext>
+            </a:extLst>
+          </p:cNvPr>
+          <p:cNvSpPr>
+            <a:spLocks xmlns:a="http://schemas.openxmlformats.org/drawingml/2006/main" noGrp="1"/>
+          </p:cNvSpPr>
+          <p:nvPr/>
+        </p:nvSpPr>
+        <p:spPr>
+          <a:xfrm xmlns:a="http://schemas.openxmlformats.org/drawingml/2006/main">
+            <a:off x="685800" y="3048000"/>
+            <a:ext cx="1524000" cy="1666875"/>
+          </a:xfrm>
+          <a:prstGeom xmlns:a="http://schemas.openxmlformats.org/drawingml/2006/main" prst="roundRect">
+            <a:avLst>
+              <a:gd name="adj" fmla="val 11250"/>
+            </a:avLst>
+          </a:prstGeom>
+          <a:solidFill xmlns:a="http://schemas.openxmlformats.org/drawingml/2006/main">
+            <a:srgbClr val="223022"/>
+          </a:solidFill>
+          <a:ln xmlns:a="http://schemas.openxmlformats.org/drawingml/2006/main" w="9525">
+            <a:solidFill>
+              <a:srgbClr val="455345"/>
+            </a:solidFill>
+            <a:prstDash val="solid"/>
+          </a:ln>
+        </p:spPr>
+      </p:sp>
+      <p:sp>
+        <p:nvSpPr>
+          <p:cNvPr id="6" name="">
+            <a:extLst xmlns:a="http://schemas.openxmlformats.org/drawingml/2006/main">
+              <a:ext uri="{FF2B5EF4-FFF2-40B4-BE49-F238E27FC236}">
+                <a16:creationId xmlns:a16="http://schemas.microsoft.com/office/drawing/2014/main" id="{137F0DB5-FA6F-46E7-A72D-A461AD5B31A5}"/>
+              </a:ext>
+            </a:extLst>
+          </p:cNvPr>
+          <p:cNvSpPr>
+            <a:spLocks xmlns:a="http://schemas.openxmlformats.org/drawingml/2006/main" noGrp="1"/>
+          </p:cNvSpPr>
+          <p:nvPr/>
+        </p:nvSpPr>
+        <p:spPr>
+          <a:xfrm xmlns:a="http://schemas.openxmlformats.org/drawingml/2006/main">
+            <a:off x="857250" y="3238500"/>
+            <a:ext cx="476250" cy="209550"/>
+          </a:xfrm>
+          <a:prstGeom xmlns:a="http://schemas.openxmlformats.org/drawingml/2006/main" prst="rect">
+            <a:avLst/>
+          </a:prstGeom>
+          <a:noFill xmlns:a="http://schemas.openxmlformats.org/drawingml/2006/main"/>
+          <a:ln xmlns:a="http://schemas.openxmlformats.org/drawingml/2006/main" w="0">
+            <a:noFill/>
+            <a:prstDash val="solid"/>
+          </a:ln>
+        </p:spPr>
+        <p:txBody>
+          <a:bodyPr xmlns:a="http://schemas.openxmlformats.org/drawingml/2006/main"/>
+          <a:lstStyle xmlns:a="http://schemas.openxmlformats.org/drawingml/2006/main"/>
+          <a:p xmlns:a="http://schemas.openxmlformats.org/drawingml/2006/main">
+            <a:pPr algn="l">
+              <a:buNone/>
+              <a:defRPr sz="900" b="1">
+                <a:solidFill>
+                  <a:srgbClr val="D8FF55"/>
+                </a:solidFill>
+              </a:defRPr>
+            </a:pPr>
+            <a:r>
+              <a:rPr sz="900" b="1">
+                <a:solidFill>
+                  <a:srgbClr val="D8FF55"/>
+                </a:solidFill>
+              </a:rPr>
+              <a:t>01</a:t>
+            </a:r>
+          </a:p>
+        </p:txBody>
+      </p:sp>
+      <p:sp>
+        <p:nvSpPr>
+          <p:cNvPr id="7" name="">
+            <a:extLst xmlns:a="http://schemas.openxmlformats.org/drawingml/2006/main">
+              <a:ext uri="{FF2B5EF4-FFF2-40B4-BE49-F238E27FC236}">
+                <a16:creationId xmlns:a16="http://schemas.microsoft.com/office/drawing/2014/main" id="{4B6A99AC-429C-4A8A-B1BC-7551C22CDDE3}"/>
+              </a:ext>
+            </a:extLst>
+          </p:cNvPr>
+          <p:cNvSpPr>
+            <a:spLocks xmlns:a="http://schemas.openxmlformats.org/drawingml/2006/main" noGrp="1"/>
+          </p:cNvSpPr>
+          <p:nvPr/>
+        </p:nvSpPr>
+        <p:spPr>
+          <a:xfrm xmlns:a="http://schemas.openxmlformats.org/drawingml/2006/main">
+            <a:off x="857250" y="3657600"/>
+            <a:ext cx="1219200" cy="257175"/>
+          </a:xfrm>
+          <a:prstGeom xmlns:a="http://schemas.openxmlformats.org/drawingml/2006/main" prst="rect">
+            <a:avLst/>
+          </a:prstGeom>
+          <a:noFill xmlns:a="http://schemas.openxmlformats.org/drawingml/2006/main"/>
+          <a:ln xmlns:a="http://schemas.openxmlformats.org/drawingml/2006/main" w="0">
+            <a:noFill/>
+            <a:prstDash val="solid"/>
+          </a:ln>
+        </p:spPr>
+        <p:txBody>
+          <a:bodyPr xmlns:a="http://schemas.openxmlformats.org/drawingml/2006/main"/>
+          <a:lstStyle xmlns:a="http://schemas.openxmlformats.org/drawingml/2006/main"/>
+          <a:p xmlns:a="http://schemas.openxmlformats.org/drawingml/2006/main">
+            <a:pPr algn="l">
+              <a:buNone/>
+              <a:defRPr sz="1050" b="1">
+                <a:solidFill>
+                  <a:srgbClr val="FFFFFF"/>
+                </a:solidFill>
+              </a:defRPr>
+            </a:pPr>
+            <a:r>
+              <a:rPr sz="1050" b="1">
+                <a:solidFill>
+                  <a:srgbClr val="FFFFFF"/>
+                </a:solidFill>
+              </a:rPr>
+              <a:t>BRIEF</a:t>
+            </a:r>
+          </a:p>
+        </p:txBody>
+      </p:sp>
+      <p:sp>
+        <p:nvSpPr>
+          <p:cNvPr id="8" name="">
+            <a:extLst xmlns:a="http://schemas.openxmlformats.org/drawingml/2006/main">
+              <a:ext uri="{FF2B5EF4-FFF2-40B4-BE49-F238E27FC236}">
+                <a16:creationId xmlns:a16="http://schemas.microsoft.com/office/drawing/2014/main" id="{58948618-01E0-4D47-A98E-9E2C88B3AD91}"/>
+              </a:ext>
+            </a:extLst>
+          </p:cNvPr>
+          <p:cNvSpPr>
+            <a:spLocks xmlns:a="http://schemas.openxmlformats.org/drawingml/2006/main" noGrp="1"/>
+          </p:cNvSpPr>
+          <p:nvPr/>
+        </p:nvSpPr>
+        <p:spPr>
+          <a:xfrm xmlns:a="http://schemas.openxmlformats.org/drawingml/2006/main">
+            <a:off x="857250" y="4095750"/>
+            <a:ext cx="1190625" cy="495300"/>
+          </a:xfrm>
+          <a:prstGeom xmlns:a="http://schemas.openxmlformats.org/drawingml/2006/main" prst="rect">
+            <a:avLst/>
+          </a:prstGeom>
+          <a:noFill xmlns:a="http://schemas.openxmlformats.org/drawingml/2006/main"/>
+          <a:ln xmlns:a="http://schemas.openxmlformats.org/drawingml/2006/main" w="0">
+            <a:noFill/>
+            <a:prstDash val="solid"/>
+          </a:ln>
+        </p:spPr>
+        <p:txBody>
+          <a:bodyPr xmlns:a="http://schemas.openxmlformats.org/drawingml/2006/main"/>
+          <a:lstStyle xmlns:a="http://schemas.openxmlformats.org/drawingml/2006/main"/>
+          <a:p xmlns:a="http://schemas.openxmlformats.org/drawingml/2006/main">
+            <a:pPr algn="l">
+              <a:buNone/>
+              <a:defRPr sz="1050" b="0">
+                <a:solidFill>
+                  <a:srgbClr val="C8D1C8"/>
+                </a:solidFill>
+              </a:defRPr>
+            </a:pPr>
+            <a:r>
+              <a:rPr sz="1050" b="0">
+                <a:solidFill>
+                  <a:srgbClr val="C8D1C8"/>
+                </a:solidFill>
+              </a:rPr>
+              <a:t>User-owned idea</a:t>
+            </a:r>
+          </a:p>
+        </p:txBody>
+      </p:sp>
+      <p:sp>
+        <p:nvSpPr>
+          <p:cNvPr id="9" name="">
+            <a:extLst xmlns:a="http://schemas.openxmlformats.org/drawingml/2006/main">
+              <a:ext uri="{FF2B5EF4-FFF2-40B4-BE49-F238E27FC236}">
+                <a16:creationId xmlns:a16="http://schemas.microsoft.com/office/drawing/2014/main" id="{40BCF2A3-B492-40B8-B3D0-8B92943D7EAE}"/>
+              </a:ext>
+            </a:extLst>
+          </p:cNvPr>
+          <p:cNvSpPr>
+            <a:spLocks xmlns:a="http://schemas.openxmlformats.org/drawingml/2006/main" noGrp="1"/>
+          </p:cNvSpPr>
+          <p:nvPr/>
+        </p:nvSpPr>
+        <p:spPr>
+          <a:xfrm xmlns:a="http://schemas.openxmlformats.org/drawingml/2006/main">
+            <a:off x="2466975" y="3048000"/>
+            <a:ext cx="1524000" cy="1666875"/>
+          </a:xfrm>
+          <a:prstGeom xmlns:a="http://schemas.openxmlformats.org/drawingml/2006/main" prst="roundRect">
+            <a:avLst>
+              <a:gd name="adj" fmla="val 11250"/>
+            </a:avLst>
+          </a:prstGeom>
+          <a:solidFill xmlns:a="http://schemas.openxmlformats.org/drawingml/2006/main">
+            <a:srgbClr val="223022"/>
+          </a:solidFill>
+          <a:ln xmlns:a="http://schemas.openxmlformats.org/drawingml/2006/main" w="9525">
+            <a:solidFill>
+              <a:srgbClr val="455345"/>
+            </a:solidFill>
+            <a:prstDash val="solid"/>
+          </a:ln>
+        </p:spPr>
+      </p:sp>
+      <p:sp>
+        <p:nvSpPr>
+          <p:cNvPr id="10" name="">
+            <a:extLst xmlns:a="http://schemas.openxmlformats.org/drawingml/2006/main">
+              <a:ext uri="{FF2B5EF4-FFF2-40B4-BE49-F238E27FC236}">
+                <a16:creationId xmlns:a16="http://schemas.microsoft.com/office/drawing/2014/main" id="{1A16C494-524D-41A3-B6CE-CFF67AFA3618}"/>
+              </a:ext>
+            </a:extLst>
+          </p:cNvPr>
+          <p:cNvSpPr>
+            <a:spLocks xmlns:a="http://schemas.openxmlformats.org/drawingml/2006/main" noGrp="1"/>
+          </p:cNvSpPr>
+          <p:nvPr/>
+        </p:nvSpPr>
+        <p:spPr>
+          <a:xfrm xmlns:a="http://schemas.openxmlformats.org/drawingml/2006/main">
+            <a:off x="2638425" y="3238500"/>
+            <a:ext cx="476250" cy="209550"/>
+          </a:xfrm>
+          <a:prstGeom xmlns:a="http://schemas.openxmlformats.org/drawingml/2006/main" prst="rect">
+            <a:avLst/>
+          </a:prstGeom>
+          <a:noFill xmlns:a="http://schemas.openxmlformats.org/drawingml/2006/main"/>
+          <a:ln xmlns:a="http://schemas.openxmlformats.org/drawingml/2006/main" w="0">
+            <a:noFill/>
+            <a:prstDash val="solid"/>
+          </a:ln>
+        </p:spPr>
+        <p:txBody>
+          <a:bodyPr xmlns:a="http://schemas.openxmlformats.org/drawingml/2006/main"/>
+          <a:lstStyle xmlns:a="http://schemas.openxmlformats.org/drawingml/2006/main"/>
+          <a:p xmlns:a="http://schemas.openxmlformats.org/drawingml/2006/main">
+            <a:pPr algn="l">
+              <a:buNone/>
+              <a:defRPr sz="900" b="1">
+                <a:solidFill>
+                  <a:srgbClr val="8F7BFF"/>
+                </a:solidFill>
+              </a:defRPr>
+            </a:pPr>
+            <a:r>
+              <a:rPr sz="900" b="1">
+                <a:solidFill>
+                  <a:srgbClr val="8F7BFF"/>
+                </a:solidFill>
+              </a:rPr>
+              <a:t>02</a:t>
+            </a:r>
+          </a:p>
+        </p:txBody>
+      </p:sp>
+      <p:sp>
+        <p:nvSpPr>
+          <p:cNvPr id="11" name="">
+            <a:extLst xmlns:a="http://schemas.openxmlformats.org/drawingml/2006/main">
+              <a:ext uri="{FF2B5EF4-FFF2-40B4-BE49-F238E27FC236}">
+                <a16:creationId xmlns:a16="http://schemas.microsoft.com/office/drawing/2014/main" id="{F029AA08-A6B3-4526-8D3A-7A6977D08A67}"/>
+              </a:ext>
+            </a:extLst>
+          </p:cNvPr>
+          <p:cNvSpPr>
+            <a:spLocks xmlns:a="http://schemas.openxmlformats.org/drawingml/2006/main" noGrp="1"/>
+          </p:cNvSpPr>
+          <p:nvPr/>
+        </p:nvSpPr>
+        <p:spPr>
+          <a:xfrm xmlns:a="http://schemas.openxmlformats.org/drawingml/2006/main">
+            <a:off x="2638425" y="3657600"/>
+            <a:ext cx="1219200" cy="257175"/>
+          </a:xfrm>
+          <a:prstGeom xmlns:a="http://schemas.openxmlformats.org/drawingml/2006/main" prst="rect">
+            <a:avLst/>
+          </a:prstGeom>
+          <a:noFill xmlns:a="http://schemas.openxmlformats.org/drawingml/2006/main"/>
+          <a:ln xmlns:a="http://schemas.openxmlformats.org/drawingml/2006/main" w="0">
+            <a:noFill/>
+            <a:prstDash val="solid"/>
+          </a:ln>
+        </p:spPr>
+        <p:txBody>
+          <a:bodyPr xmlns:a="http://schemas.openxmlformats.org/drawingml/2006/main"/>
+          <a:lstStyle xmlns:a="http://schemas.openxmlformats.org/drawingml/2006/main"/>
+          <a:p xmlns:a="http://schemas.openxmlformats.org/drawingml/2006/main">
+            <a:pPr algn="l">
+              <a:buNone/>
+              <a:defRPr sz="1050" b="1">
+                <a:solidFill>
+                  <a:srgbClr val="FFFFFF"/>
+                </a:solidFill>
+              </a:defRPr>
+            </a:pPr>
+            <a:r>
+              <a:rPr sz="1050" b="1">
+                <a:solidFill>
+                  <a:srgbClr val="FFFFFF"/>
+                </a:solidFill>
+              </a:rPr>
+              <a:t>FREEZE</a:t>
+            </a:r>
+          </a:p>
+        </p:txBody>
+      </p:sp>
+      <p:sp>
+        <p:nvSpPr>
+          <p:cNvPr id="12" name="">
+            <a:extLst xmlns:a="http://schemas.openxmlformats.org/drawingml/2006/main">
+              <a:ext uri="{FF2B5EF4-FFF2-40B4-BE49-F238E27FC236}">
+                <a16:creationId xmlns:a16="http://schemas.microsoft.com/office/drawing/2014/main" id="{D88E9A1E-8003-49F4-9871-B13628242017}"/>
+              </a:ext>
+            </a:extLst>
+          </p:cNvPr>
+          <p:cNvSpPr>
+            <a:spLocks xmlns:a="http://schemas.openxmlformats.org/drawingml/2006/main" noGrp="1"/>
+          </p:cNvSpPr>
+          <p:nvPr/>
+        </p:nvSpPr>
+        <p:spPr>
+          <a:xfrm xmlns:a="http://schemas.openxmlformats.org/drawingml/2006/main">
+            <a:off x="2638425" y="4095750"/>
+            <a:ext cx="1190625" cy="495300"/>
+          </a:xfrm>
+          <a:prstGeom xmlns:a="http://schemas.openxmlformats.org/drawingml/2006/main" prst="rect">
+            <a:avLst/>
+          </a:prstGeom>
+          <a:noFill xmlns:a="http://schemas.openxmlformats.org/drawingml/2006/main"/>
+          <a:ln xmlns:a="http://schemas.openxmlformats.org/drawingml/2006/main" w="0">
+            <a:noFill/>
+            <a:prstDash val="solid"/>
+          </a:ln>
+        </p:spPr>
+        <p:txBody>
+          <a:bodyPr xmlns:a="http://schemas.openxmlformats.org/drawingml/2006/main"/>
+          <a:lstStyle xmlns:a="http://schemas.openxmlformats.org/drawingml/2006/main"/>
+          <a:p xmlns:a="http://schemas.openxmlformats.org/drawingml/2006/main">
+            <a:pPr algn="l">
+              <a:buNone/>
+              <a:defRPr sz="1050" b="0">
+                <a:solidFill>
+                  <a:srgbClr val="C8D1C8"/>
+                </a:solidFill>
+              </a:defRPr>
+            </a:pPr>
+            <a:r>
+              <a:rPr sz="1050" b="0">
+                <a:solidFill>
+                  <a:srgbClr val="C8D1C8"/>
+                </a:solidFill>
+              </a:rPr>
+              <a:t>Scope + spend cap</a:t>
+            </a:r>
+          </a:p>
+        </p:txBody>
+      </p:sp>
+      <p:sp>
+        <p:nvSpPr>
+          <p:cNvPr id="13" name="">
+            <a:extLst xmlns:a="http://schemas.openxmlformats.org/drawingml/2006/main">
+              <a:ext uri="{FF2B5EF4-FFF2-40B4-BE49-F238E27FC236}">
+                <a16:creationId xmlns:a16="http://schemas.microsoft.com/office/drawing/2014/main" id="{20798DAA-E978-4E3E-98F0-7842B1B1CE65}"/>
+              </a:ext>
+            </a:extLst>
+          </p:cNvPr>
+          <p:cNvSpPr>
+            <a:spLocks xmlns:a="http://schemas.openxmlformats.org/drawingml/2006/main" noGrp="1"/>
+          </p:cNvSpPr>
+          <p:nvPr/>
+        </p:nvSpPr>
+        <p:spPr>
+          <a:xfrm xmlns:a="http://schemas.openxmlformats.org/drawingml/2006/main">
+            <a:off x="4248150" y="3048000"/>
+            <a:ext cx="1524000" cy="1666875"/>
+          </a:xfrm>
+          <a:prstGeom xmlns:a="http://schemas.openxmlformats.org/drawingml/2006/main" prst="roundRect">
+            <a:avLst>
+              <a:gd name="adj" fmla="val 11250"/>
+            </a:avLst>
+          </a:prstGeom>
+          <a:solidFill xmlns:a="http://schemas.openxmlformats.org/drawingml/2006/main">
+            <a:srgbClr val="223022"/>
+          </a:solidFill>
+          <a:ln xmlns:a="http://schemas.openxmlformats.org/drawingml/2006/main" w="9525">
+            <a:solidFill>
+              <a:srgbClr val="455345"/>
+            </a:solidFill>
+            <a:prstDash val="solid"/>
+          </a:ln>
+        </p:spPr>
+      </p:sp>
+      <p:sp>
+        <p:nvSpPr>
+          <p:cNvPr id="14" name="">
+            <a:extLst xmlns:a="http://schemas.openxmlformats.org/drawingml/2006/main">
+              <a:ext uri="{FF2B5EF4-FFF2-40B4-BE49-F238E27FC236}">
+                <a16:creationId xmlns:a16="http://schemas.microsoft.com/office/drawing/2014/main" id="{1F47C2F3-A785-41FA-9584-6CBB9E20BC02}"/>
+              </a:ext>
+            </a:extLst>
+          </p:cNvPr>
+          <p:cNvSpPr>
+            <a:spLocks xmlns:a="http://schemas.openxmlformats.org/drawingml/2006/main" noGrp="1"/>
+          </p:cNvSpPr>
+          <p:nvPr/>
+        </p:nvSpPr>
+        <p:spPr>
+          <a:xfrm xmlns:a="http://schemas.openxmlformats.org/drawingml/2006/main">
+            <a:off x="4419600" y="3238500"/>
+            <a:ext cx="476250" cy="209550"/>
+          </a:xfrm>
+          <a:prstGeom xmlns:a="http://schemas.openxmlformats.org/drawingml/2006/main" prst="rect">
+            <a:avLst/>
+          </a:prstGeom>
+          <a:noFill xmlns:a="http://schemas.openxmlformats.org/drawingml/2006/main"/>
+          <a:ln xmlns:a="http://schemas.openxmlformats.org/drawingml/2006/main" w="0">
+            <a:noFill/>
+            <a:prstDash val="solid"/>
+          </a:ln>
+        </p:spPr>
+        <p:txBody>
+          <a:bodyPr xmlns:a="http://schemas.openxmlformats.org/drawingml/2006/main"/>
+          <a:lstStyle xmlns:a="http://schemas.openxmlformats.org/drawingml/2006/main"/>
+          <a:p xmlns:a="http://schemas.openxmlformats.org/drawingml/2006/main">
+            <a:pPr algn="l">
+              <a:buNone/>
+              <a:defRPr sz="900" b="1">
+                <a:solidFill>
+                  <a:srgbClr val="FF8159"/>
+                </a:solidFill>
+              </a:defRPr>
+            </a:pPr>
+            <a:r>
+              <a:rPr sz="900" b="1">
+                <a:solidFill>
+                  <a:srgbClr val="FF8159"/>
+                </a:solidFill>
+              </a:rPr>
+              <a:t>03</a:t>
+            </a:r>
+          </a:p>
+        </p:txBody>
+      </p:sp>
+      <p:sp>
+        <p:nvSpPr>
+          <p:cNvPr id="15" name="">
+            <a:extLst xmlns:a="http://schemas.openxmlformats.org/drawingml/2006/main">
+              <a:ext uri="{FF2B5EF4-FFF2-40B4-BE49-F238E27FC236}">
+                <a16:creationId xmlns:a16="http://schemas.microsoft.com/office/drawing/2014/main" id="{06553089-7474-4DD8-A366-961A1948DED8}"/>
+              </a:ext>
+            </a:extLst>
+          </p:cNvPr>
+          <p:cNvSpPr>
+            <a:spLocks xmlns:a="http://schemas.openxmlformats.org/drawingml/2006/main" noGrp="1"/>
+          </p:cNvSpPr>
+          <p:nvPr/>
+        </p:nvSpPr>
+        <p:spPr>
+          <a:xfrm xmlns:a="http://schemas.openxmlformats.org/drawingml/2006/main">
+            <a:off x="4419600" y="3657600"/>
+            <a:ext cx="1219200" cy="257175"/>
+          </a:xfrm>
+          <a:prstGeom xmlns:a="http://schemas.openxmlformats.org/drawingml/2006/main" prst="rect">
+            <a:avLst/>
+          </a:prstGeom>
+          <a:noFill xmlns:a="http://schemas.openxmlformats.org/drawingml/2006/main"/>
+          <a:ln xmlns:a="http://schemas.openxmlformats.org/drawingml/2006/main" w="0">
+            <a:noFill/>
+            <a:prstDash val="solid"/>
+          </a:ln>
+        </p:spPr>
+        <p:txBody>
+          <a:bodyPr xmlns:a="http://schemas.openxmlformats.org/drawingml/2006/main"/>
+          <a:lstStyle xmlns:a="http://schemas.openxmlformats.org/drawingml/2006/main"/>
+          <a:p xmlns:a="http://schemas.openxmlformats.org/drawingml/2006/main">
+            <a:pPr algn="l">
+              <a:buNone/>
+              <a:defRPr sz="1050" b="1">
+                <a:solidFill>
+                  <a:srgbClr val="FFFFFF"/>
+                </a:solidFill>
+              </a:defRPr>
+            </a:pPr>
+            <a:r>
+              <a:rPr sz="1050" b="1">
+                <a:solidFill>
+                  <a:srgbClr val="FFFFFF"/>
+                </a:solidFill>
+              </a:rPr>
+              <a:t>FARM</a:t>
+            </a:r>
+          </a:p>
+        </p:txBody>
+      </p:sp>
+      <p:sp>
+        <p:nvSpPr>
+          <p:cNvPr id="16" name="">
+            <a:extLst xmlns:a="http://schemas.openxmlformats.org/drawingml/2006/main">
+              <a:ext uri="{FF2B5EF4-FFF2-40B4-BE49-F238E27FC236}">
+                <a16:creationId xmlns:a16="http://schemas.microsoft.com/office/drawing/2014/main" id="{4BD3E9F9-86A8-49B2-AEC7-A525F4A59C42}"/>
+              </a:ext>
+            </a:extLst>
+          </p:cNvPr>
+          <p:cNvSpPr>
+            <a:spLocks xmlns:a="http://schemas.openxmlformats.org/drawingml/2006/main" noGrp="1"/>
+          </p:cNvSpPr>
+          <p:nvPr/>
+        </p:nvSpPr>
+        <p:spPr>
+          <a:xfrm xmlns:a="http://schemas.openxmlformats.org/drawingml/2006/main">
+            <a:off x="4419600" y="4095750"/>
+            <a:ext cx="1190625" cy="495300"/>
+          </a:xfrm>
+          <a:prstGeom xmlns:a="http://schemas.openxmlformats.org/drawingml/2006/main" prst="rect">
+            <a:avLst/>
+          </a:prstGeom>
+          <a:noFill xmlns:a="http://schemas.openxmlformats.org/drawingml/2006/main"/>
+          <a:ln xmlns:a="http://schemas.openxmlformats.org/drawingml/2006/main" w="0">
+            <a:noFill/>
+            <a:prstDash val="solid"/>
+          </a:ln>
+        </p:spPr>
+        <p:txBody>
+          <a:bodyPr xmlns:a="http://schemas.openxmlformats.org/drawingml/2006/main"/>
+          <a:lstStyle xmlns:a="http://schemas.openxmlformats.org/drawingml/2006/main"/>
+          <a:p xmlns:a="http://schemas.openxmlformats.org/drawingml/2006/main">
+            <a:pPr algn="l">
+              <a:buNone/>
+              <a:defRPr sz="1050" b="0">
+                <a:solidFill>
+                  <a:srgbClr val="C8D1C8"/>
+                </a:solidFill>
+              </a:defRPr>
+            </a:pPr>
+            <a:r>
+              <a:rPr sz="1050" b="0">
+                <a:solidFill>
+                  <a:srgbClr val="C8D1C8"/>
+                </a:solidFill>
+              </a:rPr>
+              <a:t>Three provider runners</a:t>
+            </a:r>
+          </a:p>
+        </p:txBody>
+      </p:sp>
+      <p:sp>
+        <p:nvSpPr>
+          <p:cNvPr id="17" name="">
+            <a:extLst xmlns:a="http://schemas.openxmlformats.org/drawingml/2006/main">
+              <a:ext uri="{FF2B5EF4-FFF2-40B4-BE49-F238E27FC236}">
+                <a16:creationId xmlns:a16="http://schemas.microsoft.com/office/drawing/2014/main" id="{FA044EE6-A973-464A-8DE6-0F5C47476EBA}"/>
+              </a:ext>
+            </a:extLst>
+          </p:cNvPr>
+          <p:cNvSpPr>
+            <a:spLocks xmlns:a="http://schemas.openxmlformats.org/drawingml/2006/main" noGrp="1"/>
+          </p:cNvSpPr>
+          <p:nvPr/>
+        </p:nvSpPr>
+        <p:spPr>
+          <a:xfrm xmlns:a="http://schemas.openxmlformats.org/drawingml/2006/main">
+            <a:off x="6029325" y="3048000"/>
+            <a:ext cx="1524000" cy="1666875"/>
+          </a:xfrm>
+          <a:prstGeom xmlns:a="http://schemas.openxmlformats.org/drawingml/2006/main" prst="roundRect">
+            <a:avLst>
+              <a:gd name="adj" fmla="val 11250"/>
+            </a:avLst>
+          </a:prstGeom>
+          <a:solidFill xmlns:a="http://schemas.openxmlformats.org/drawingml/2006/main">
+            <a:srgbClr val="223022"/>
+          </a:solidFill>
+          <a:ln xmlns:a="http://schemas.openxmlformats.org/drawingml/2006/main" w="9525">
+            <a:solidFill>
+              <a:srgbClr val="455345"/>
+            </a:solidFill>
+            <a:prstDash val="solid"/>
+          </a:ln>
+        </p:spPr>
+      </p:sp>
+      <p:sp>
+        <p:nvSpPr>
+          <p:cNvPr id="18" name="">
+            <a:extLst xmlns:a="http://schemas.openxmlformats.org/drawingml/2006/main">
+              <a:ext uri="{FF2B5EF4-FFF2-40B4-BE49-F238E27FC236}">
+                <a16:creationId xmlns:a16="http://schemas.microsoft.com/office/drawing/2014/main" id="{C0AF604B-FAE1-46F5-89CD-AF9CA900342E}"/>
+              </a:ext>
+            </a:extLst>
+          </p:cNvPr>
+          <p:cNvSpPr>
+            <a:spLocks xmlns:a="http://schemas.openxmlformats.org/drawingml/2006/main" noGrp="1"/>
+          </p:cNvSpPr>
+          <p:nvPr/>
+        </p:nvSpPr>
+        <p:spPr>
+          <a:xfrm xmlns:a="http://schemas.openxmlformats.org/drawingml/2006/main">
+            <a:off x="6200775" y="3238500"/>
+            <a:ext cx="476250" cy="209550"/>
+          </a:xfrm>
+          <a:prstGeom xmlns:a="http://schemas.openxmlformats.org/drawingml/2006/main" prst="rect">
+            <a:avLst/>
+          </a:prstGeom>
+          <a:noFill xmlns:a="http://schemas.openxmlformats.org/drawingml/2006/main"/>
+          <a:ln xmlns:a="http://schemas.openxmlformats.org/drawingml/2006/main" w="0">
+            <a:noFill/>
+            <a:prstDash val="solid"/>
+          </a:ln>
+        </p:spPr>
+        <p:txBody>
+          <a:bodyPr xmlns:a="http://schemas.openxmlformats.org/drawingml/2006/main"/>
+          <a:lstStyle xmlns:a="http://schemas.openxmlformats.org/drawingml/2006/main"/>
+          <a:p xmlns:a="http://schemas.openxmlformats.org/drawingml/2006/main">
+            <a:pPr algn="l">
+              <a:buNone/>
+              <a:defRPr sz="900" b="1">
+                <a:solidFill>
+                  <a:srgbClr val="D8FF55"/>
+                </a:solidFill>
+              </a:defRPr>
+            </a:pPr>
+            <a:r>
+              <a:rPr sz="900" b="1">
+                <a:solidFill>
+                  <a:srgbClr val="D8FF55"/>
+                </a:solidFill>
+              </a:rPr>
+              <a:t>04</a:t>
+            </a:r>
+          </a:p>
+        </p:txBody>
+      </p:sp>
+      <p:sp>
+        <p:nvSpPr>
+          <p:cNvPr id="19" name="">
+            <a:extLst xmlns:a="http://schemas.openxmlformats.org/drawingml/2006/main">
+              <a:ext uri="{FF2B5EF4-FFF2-40B4-BE49-F238E27FC236}">
+                <a16:creationId xmlns:a16="http://schemas.microsoft.com/office/drawing/2014/main" id="{84D17153-0F79-465B-8E65-0F2A102F6A03}"/>
+              </a:ext>
+            </a:extLst>
+          </p:cNvPr>
+          <p:cNvSpPr>
+            <a:spLocks xmlns:a="http://schemas.openxmlformats.org/drawingml/2006/main" noGrp="1"/>
+          </p:cNvSpPr>
+          <p:nvPr/>
+        </p:nvSpPr>
+        <p:spPr>
+          <a:xfrm xmlns:a="http://schemas.openxmlformats.org/drawingml/2006/main">
+            <a:off x="6200775" y="3657600"/>
+            <a:ext cx="1219200" cy="257175"/>
+          </a:xfrm>
+          <a:prstGeom xmlns:a="http://schemas.openxmlformats.org/drawingml/2006/main" prst="rect">
+            <a:avLst/>
+          </a:prstGeom>
+          <a:noFill xmlns:a="http://schemas.openxmlformats.org/drawingml/2006/main"/>
+          <a:ln xmlns:a="http://schemas.openxmlformats.org/drawingml/2006/main" w="0">
+            <a:noFill/>
+            <a:prstDash val="solid"/>
+          </a:ln>
+        </p:spPr>
+        <p:txBody>
+          <a:bodyPr xmlns:a="http://schemas.openxmlformats.org/drawingml/2006/main"/>
+          <a:lstStyle xmlns:a="http://schemas.openxmlformats.org/drawingml/2006/main"/>
+          <a:p xmlns:a="http://schemas.openxmlformats.org/drawingml/2006/main">
+            <a:pPr algn="l">
+              <a:buNone/>
+              <a:defRPr sz="1050" b="1">
+                <a:solidFill>
+                  <a:srgbClr val="FFFFFF"/>
+                </a:solidFill>
+              </a:defRPr>
+            </a:pPr>
+            <a:r>
+              <a:rPr sz="1050" b="1">
+                <a:solidFill>
+                  <a:srgbClr val="FFFFFF"/>
+                </a:solidFill>
+              </a:rPr>
+              <a:t>SCORE</a:t>
+            </a:r>
+          </a:p>
+        </p:txBody>
+      </p:sp>
+      <p:sp>
+        <p:nvSpPr>
+          <p:cNvPr id="20" name="">
+            <a:extLst xmlns:a="http://schemas.openxmlformats.org/drawingml/2006/main">
+              <a:ext uri="{FF2B5EF4-FFF2-40B4-BE49-F238E27FC236}">
+                <a16:creationId xmlns:a16="http://schemas.microsoft.com/office/drawing/2014/main" id="{156A8EC0-5428-4CE4-86DB-4547A061B82D}"/>
+              </a:ext>
+            </a:extLst>
+          </p:cNvPr>
+          <p:cNvSpPr>
+            <a:spLocks xmlns:a="http://schemas.openxmlformats.org/drawingml/2006/main" noGrp="1"/>
+          </p:cNvSpPr>
+          <p:nvPr/>
+        </p:nvSpPr>
+        <p:spPr>
+          <a:xfrm xmlns:a="http://schemas.openxmlformats.org/drawingml/2006/main">
+            <a:off x="6200775" y="4095750"/>
+            <a:ext cx="1190625" cy="495300"/>
+          </a:xfrm>
+          <a:prstGeom xmlns:a="http://schemas.openxmlformats.org/drawingml/2006/main" prst="rect">
+            <a:avLst/>
+          </a:prstGeom>
+          <a:noFill xmlns:a="http://schemas.openxmlformats.org/drawingml/2006/main"/>
+          <a:ln xmlns:a="http://schemas.openxmlformats.org/drawingml/2006/main" w="0">
+            <a:noFill/>
+            <a:prstDash val="solid"/>
+          </a:ln>
+        </p:spPr>
+        <p:txBody>
+          <a:bodyPr xmlns:a="http://schemas.openxmlformats.org/drawingml/2006/main"/>
+          <a:lstStyle xmlns:a="http://schemas.openxmlformats.org/drawingml/2006/main"/>
+          <a:p xmlns:a="http://schemas.openxmlformats.org/drawingml/2006/main">
+            <a:pPr algn="l">
+              <a:buNone/>
+              <a:defRPr sz="1050" b="0">
+                <a:solidFill>
+                  <a:srgbClr val="C8D1C8"/>
+                </a:solidFill>
+              </a:defRPr>
+            </a:pPr>
+            <a:r>
+              <a:rPr sz="1050" b="0">
+                <a:solidFill>
+                  <a:srgbClr val="C8D1C8"/>
+                </a:solidFill>
+              </a:rPr>
+              <a:t>Success · latency · cost</a:t>
+            </a:r>
+          </a:p>
+        </p:txBody>
+      </p:sp>
+      <p:sp>
+        <p:nvSpPr>
+          <p:cNvPr id="21" name="">
+            <a:extLst xmlns:a="http://schemas.openxmlformats.org/drawingml/2006/main">
+              <a:ext uri="{FF2B5EF4-FFF2-40B4-BE49-F238E27FC236}">
+                <a16:creationId xmlns:a16="http://schemas.microsoft.com/office/drawing/2014/main" id="{E6848313-6EC6-4AB0-BCB7-DD2F6DACB709}"/>
+              </a:ext>
+            </a:extLst>
+          </p:cNvPr>
+          <p:cNvSpPr>
+            <a:spLocks xmlns:a="http://schemas.openxmlformats.org/drawingml/2006/main" noGrp="1"/>
+          </p:cNvSpPr>
+          <p:nvPr/>
+        </p:nvSpPr>
+        <p:spPr>
+          <a:xfrm xmlns:a="http://schemas.openxmlformats.org/drawingml/2006/main">
+            <a:off x="7810500" y="3048000"/>
+            <a:ext cx="1524000" cy="1666875"/>
+          </a:xfrm>
+          <a:prstGeom xmlns:a="http://schemas.openxmlformats.org/drawingml/2006/main" prst="roundRect">
+            <a:avLst>
+              <a:gd name="adj" fmla="val 11250"/>
+            </a:avLst>
+          </a:prstGeom>
+          <a:solidFill xmlns:a="http://schemas.openxmlformats.org/drawingml/2006/main">
+            <a:srgbClr val="223022"/>
+          </a:solidFill>
+          <a:ln xmlns:a="http://schemas.openxmlformats.org/drawingml/2006/main" w="9525">
+            <a:solidFill>
+              <a:srgbClr val="455345"/>
+            </a:solidFill>
+            <a:prstDash val="solid"/>
+          </a:ln>
+        </p:spPr>
+      </p:sp>
+      <p:sp>
+        <p:nvSpPr>
+          <p:cNvPr id="22" name="">
+            <a:extLst xmlns:a="http://schemas.openxmlformats.org/drawingml/2006/main">
+              <a:ext uri="{FF2B5EF4-FFF2-40B4-BE49-F238E27FC236}">
+                <a16:creationId xmlns:a16="http://schemas.microsoft.com/office/drawing/2014/main" id="{6A50CBF7-37EE-47F1-8E2C-D928AAA3C6EA}"/>
+              </a:ext>
+            </a:extLst>
+          </p:cNvPr>
+          <p:cNvSpPr>
+            <a:spLocks xmlns:a="http://schemas.openxmlformats.org/drawingml/2006/main" noGrp="1"/>
+          </p:cNvSpPr>
+          <p:nvPr/>
+        </p:nvSpPr>
+        <p:spPr>
+          <a:xfrm xmlns:a="http://schemas.openxmlformats.org/drawingml/2006/main">
+            <a:off x="7981950" y="3238500"/>
+            <a:ext cx="476250" cy="209550"/>
+          </a:xfrm>
+          <a:prstGeom xmlns:a="http://schemas.openxmlformats.org/drawingml/2006/main" prst="rect">
+            <a:avLst/>
+          </a:prstGeom>
+          <a:noFill xmlns:a="http://schemas.openxmlformats.org/drawingml/2006/main"/>
+          <a:ln xmlns:a="http://schemas.openxmlformats.org/drawingml/2006/main" w="0">
+            <a:noFill/>
+            <a:prstDash val="solid"/>
+          </a:ln>
+        </p:spPr>
+        <p:txBody>
+          <a:bodyPr xmlns:a="http://schemas.openxmlformats.org/drawingml/2006/main"/>
+          <a:lstStyle xmlns:a="http://schemas.openxmlformats.org/drawingml/2006/main"/>
+          <a:p xmlns:a="http://schemas.openxmlformats.org/drawingml/2006/main">
+            <a:pPr algn="l">
+              <a:buNone/>
+              <a:defRPr sz="900" b="1">
+                <a:solidFill>
+                  <a:srgbClr val="8F7BFF"/>
+                </a:solidFill>
+              </a:defRPr>
+            </a:pPr>
+            <a:r>
+              <a:rPr sz="900" b="1">
+                <a:solidFill>
+                  <a:srgbClr val="8F7BFF"/>
+                </a:solidFill>
+              </a:rPr>
+              <a:t>05</a:t>
+            </a:r>
+          </a:p>
+        </p:txBody>
+      </p:sp>
+      <p:sp>
+        <p:nvSpPr>
+          <p:cNvPr id="23" name="">
+            <a:extLst xmlns:a="http://schemas.openxmlformats.org/drawingml/2006/main">
+              <a:ext uri="{FF2B5EF4-FFF2-40B4-BE49-F238E27FC236}">
+                <a16:creationId xmlns:a16="http://schemas.microsoft.com/office/drawing/2014/main" id="{C7A4F8B1-E43D-450F-9D7F-8B07D1A320A6}"/>
+              </a:ext>
+            </a:extLst>
+          </p:cNvPr>
+          <p:cNvSpPr>
+            <a:spLocks xmlns:a="http://schemas.openxmlformats.org/drawingml/2006/main" noGrp="1"/>
+          </p:cNvSpPr>
+          <p:nvPr/>
+        </p:nvSpPr>
+        <p:spPr>
+          <a:xfrm xmlns:a="http://schemas.openxmlformats.org/drawingml/2006/main">
+            <a:off x="7981950" y="3657600"/>
+            <a:ext cx="1219200" cy="257175"/>
+          </a:xfrm>
+          <a:prstGeom xmlns:a="http://schemas.openxmlformats.org/drawingml/2006/main" prst="rect">
+            <a:avLst/>
+          </a:prstGeom>
+          <a:noFill xmlns:a="http://schemas.openxmlformats.org/drawingml/2006/main"/>
+          <a:ln xmlns:a="http://schemas.openxmlformats.org/drawingml/2006/main" w="0">
+            <a:noFill/>
+            <a:prstDash val="solid"/>
+          </a:ln>
+        </p:spPr>
+        <p:txBody>
+          <a:bodyPr xmlns:a="http://schemas.openxmlformats.org/drawingml/2006/main"/>
+          <a:lstStyle xmlns:a="http://schemas.openxmlformats.org/drawingml/2006/main"/>
+          <a:p xmlns:a="http://schemas.openxmlformats.org/drawingml/2006/main">
+            <a:pPr algn="l">
+              <a:buNone/>
+              <a:defRPr sz="1050" b="1">
+                <a:solidFill>
+                  <a:srgbClr val="FFFFFF"/>
+                </a:solidFill>
+              </a:defRPr>
+            </a:pPr>
+            <a:r>
+              <a:rPr sz="1050" b="1">
+                <a:solidFill>
+                  <a:srgbClr val="FFFFFF"/>
+                </a:solidFill>
+              </a:rPr>
+              <a:t>GOVERN</a:t>
+            </a:r>
+          </a:p>
+        </p:txBody>
+      </p:sp>
+      <p:sp>
+        <p:nvSpPr>
+          <p:cNvPr id="24" name="">
+            <a:extLst xmlns:a="http://schemas.openxmlformats.org/drawingml/2006/main">
+              <a:ext uri="{FF2B5EF4-FFF2-40B4-BE49-F238E27FC236}">
+                <a16:creationId xmlns:a16="http://schemas.microsoft.com/office/drawing/2014/main" id="{B4A9F002-87D8-4422-A02A-85E4D660A6C5}"/>
+              </a:ext>
+            </a:extLst>
+          </p:cNvPr>
+          <p:cNvSpPr>
+            <a:spLocks xmlns:a="http://schemas.openxmlformats.org/drawingml/2006/main" noGrp="1"/>
+          </p:cNvSpPr>
+          <p:nvPr/>
+        </p:nvSpPr>
+        <p:spPr>
+          <a:xfrm xmlns:a="http://schemas.openxmlformats.org/drawingml/2006/main">
+            <a:off x="7981950" y="4095750"/>
+            <a:ext cx="1190625" cy="495300"/>
+          </a:xfrm>
+          <a:prstGeom xmlns:a="http://schemas.openxmlformats.org/drawingml/2006/main" prst="rect">
+            <a:avLst/>
+          </a:prstGeom>
+          <a:noFill xmlns:a="http://schemas.openxmlformats.org/drawingml/2006/main"/>
+          <a:ln xmlns:a="http://schemas.openxmlformats.org/drawingml/2006/main" w="0">
+            <a:noFill/>
+            <a:prstDash val="solid"/>
+          </a:ln>
+        </p:spPr>
+        <p:txBody>
+          <a:bodyPr xmlns:a="http://schemas.openxmlformats.org/drawingml/2006/main"/>
+          <a:lstStyle xmlns:a="http://schemas.openxmlformats.org/drawingml/2006/main"/>
+          <a:p xmlns:a="http://schemas.openxmlformats.org/drawingml/2006/main">
+            <a:pPr algn="l">
+              <a:buNone/>
+              <a:defRPr sz="1050" b="0">
+                <a:solidFill>
+                  <a:srgbClr val="C8D1C8"/>
+                </a:solidFill>
+              </a:defRPr>
+            </a:pPr>
+            <a:r>
+              <a:rPr sz="1050" b="0">
+                <a:solidFill>
+                  <a:srgbClr val="C8D1C8"/>
+                </a:solidFill>
+              </a:rPr>
+              <a:t>Rules + evidence gates</a:t>
+            </a:r>
+          </a:p>
+        </p:txBody>
+      </p:sp>
+      <p:sp>
+        <p:nvSpPr>
+          <p:cNvPr id="25" name="">
+            <a:extLst xmlns:a="http://schemas.openxmlformats.org/drawingml/2006/main">
+              <a:ext uri="{FF2B5EF4-FFF2-40B4-BE49-F238E27FC236}">
+                <a16:creationId xmlns:a16="http://schemas.microsoft.com/office/drawing/2014/main" id="{61489C50-EF27-423D-8579-42767AF40DB6}"/>
+              </a:ext>
+            </a:extLst>
+          </p:cNvPr>
+          <p:cNvSpPr>
+            <a:spLocks xmlns:a="http://schemas.openxmlformats.org/drawingml/2006/main" noGrp="1"/>
+          </p:cNvSpPr>
+          <p:nvPr/>
+        </p:nvSpPr>
+        <p:spPr>
+          <a:xfrm xmlns:a="http://schemas.openxmlformats.org/drawingml/2006/main">
+            <a:off x="9591675" y="3048000"/>
+            <a:ext cx="1524000" cy="1666875"/>
+          </a:xfrm>
+          <a:prstGeom xmlns:a="http://schemas.openxmlformats.org/drawingml/2006/main" prst="roundRect">
+            <a:avLst>
+              <a:gd name="adj" fmla="val 11250"/>
+            </a:avLst>
+          </a:prstGeom>
+          <a:solidFill xmlns:a="http://schemas.openxmlformats.org/drawingml/2006/main">
+            <a:srgbClr val="D8FF55"/>
+          </a:solidFill>
+          <a:ln xmlns:a="http://schemas.openxmlformats.org/drawingml/2006/main" w="0">
+            <a:noFill/>
+            <a:prstDash val="solid"/>
+          </a:ln>
+        </p:spPr>
+      </p:sp>
+      <p:sp>
+        <p:nvSpPr>
+          <p:cNvPr id="26" name="">
+            <a:extLst xmlns:a="http://schemas.openxmlformats.org/drawingml/2006/main">
+              <a:ext uri="{FF2B5EF4-FFF2-40B4-BE49-F238E27FC236}">
+                <a16:creationId xmlns:a16="http://schemas.microsoft.com/office/drawing/2014/main" id="{6607E68B-F340-41D8-9512-BAB065A482E6}"/>
+              </a:ext>
+            </a:extLst>
+          </p:cNvPr>
+          <p:cNvSpPr>
+            <a:spLocks xmlns:a="http://schemas.openxmlformats.org/drawingml/2006/main" noGrp="1"/>
+          </p:cNvSpPr>
+          <p:nvPr/>
+        </p:nvSpPr>
+        <p:spPr>
+          <a:xfrm xmlns:a="http://schemas.openxmlformats.org/drawingml/2006/main">
+            <a:off x="9763125" y="3238500"/>
+            <a:ext cx="476250" cy="209550"/>
+          </a:xfrm>
+          <a:prstGeom xmlns:a="http://schemas.openxmlformats.org/drawingml/2006/main" prst="rect">
+            <a:avLst/>
+          </a:prstGeom>
+          <a:noFill xmlns:a="http://schemas.openxmlformats.org/drawingml/2006/main"/>
+          <a:ln xmlns:a="http://schemas.openxmlformats.org/drawingml/2006/main" w="0">
+            <a:noFill/>
+            <a:prstDash val="solid"/>
+          </a:ln>
+        </p:spPr>
+        <p:txBody>
+          <a:bodyPr xmlns:a="http://schemas.openxmlformats.org/drawingml/2006/main"/>
+          <a:lstStyle xmlns:a="http://schemas.openxmlformats.org/drawingml/2006/main"/>
+          <a:p xmlns:a="http://schemas.openxmlformats.org/drawingml/2006/main">
+            <a:pPr algn="l">
+              <a:buNone/>
+              <a:defRPr sz="900" b="1">
+                <a:solidFill>
+                  <a:srgbClr val="152015"/>
+                </a:solidFill>
+              </a:defRPr>
+            </a:pPr>
+            <a:r>
+              <a:rPr sz="900" b="1">
+                <a:solidFill>
+                  <a:srgbClr val="152015"/>
+                </a:solidFill>
+              </a:rPr>
+              <a:t>06</a:t>
+            </a:r>
+          </a:p>
+        </p:txBody>
+      </p:sp>
+      <p:sp>
+        <p:nvSpPr>
+          <p:cNvPr id="27" name="">
+            <a:extLst xmlns:a="http://schemas.openxmlformats.org/drawingml/2006/main">
+              <a:ext uri="{FF2B5EF4-FFF2-40B4-BE49-F238E27FC236}">
+                <a16:creationId xmlns:a16="http://schemas.microsoft.com/office/drawing/2014/main" id="{12FA8381-87C9-4C8C-B66F-83068E3100DE}"/>
+              </a:ext>
+            </a:extLst>
+          </p:cNvPr>
+          <p:cNvSpPr>
+            <a:spLocks xmlns:a="http://schemas.openxmlformats.org/drawingml/2006/main" noGrp="1"/>
+          </p:cNvSpPr>
+          <p:nvPr/>
+        </p:nvSpPr>
+        <p:spPr>
+          <a:xfrm xmlns:a="http://schemas.openxmlformats.org/drawingml/2006/main">
+            <a:off x="9763125" y="3657600"/>
+            <a:ext cx="1219200" cy="257175"/>
+          </a:xfrm>
+          <a:prstGeom xmlns:a="http://schemas.openxmlformats.org/drawingml/2006/main" prst="rect">
+            <a:avLst/>
+          </a:prstGeom>
+          <a:noFill xmlns:a="http://schemas.openxmlformats.org/drawingml/2006/main"/>
+          <a:ln xmlns:a="http://schemas.openxmlformats.org/drawingml/2006/main" w="0">
+            <a:noFill/>
+            <a:prstDash val="solid"/>
+          </a:ln>
+        </p:spPr>
+        <p:txBody>
+          <a:bodyPr xmlns:a="http://schemas.openxmlformats.org/drawingml/2006/main"/>
+          <a:lstStyle xmlns:a="http://schemas.openxmlformats.org/drawingml/2006/main"/>
+          <a:p xmlns:a="http://schemas.openxmlformats.org/drawingml/2006/main">
+            <a:pPr algn="l">
+              <a:buNone/>
+              <a:defRPr sz="1050" b="1">
+                <a:solidFill>
+                  <a:srgbClr val="152015"/>
+                </a:solidFill>
+              </a:defRPr>
+            </a:pPr>
+            <a:r>
+              <a:rPr sz="1050" b="1">
+                <a:solidFill>
+                  <a:srgbClr val="152015"/>
+                </a:solidFill>
+              </a:rPr>
+              <a:t>REPORT</a:t>
+            </a:r>
+          </a:p>
+        </p:txBody>
+      </p:sp>
+      <p:sp>
+        <p:nvSpPr>
+          <p:cNvPr id="28" name="">
+            <a:extLst xmlns:a="http://schemas.openxmlformats.org/drawingml/2006/main">
+              <a:ext uri="{FF2B5EF4-FFF2-40B4-BE49-F238E27FC236}">
+                <a16:creationId xmlns:a16="http://schemas.microsoft.com/office/drawing/2014/main" id="{B98F5683-0D97-4094-A83B-0A0EC6739306}"/>
+              </a:ext>
+            </a:extLst>
+          </p:cNvPr>
+          <p:cNvSpPr>
+            <a:spLocks xmlns:a="http://schemas.openxmlformats.org/drawingml/2006/main" noGrp="1"/>
+          </p:cNvSpPr>
+          <p:nvPr/>
+        </p:nvSpPr>
+        <p:spPr>
+          <a:xfrm xmlns:a="http://schemas.openxmlformats.org/drawingml/2006/main">
+            <a:off x="9763125" y="4095750"/>
+            <a:ext cx="1190625" cy="495300"/>
+          </a:xfrm>
+          <a:prstGeom xmlns:a="http://schemas.openxmlformats.org/drawingml/2006/main" prst="rect">
+            <a:avLst/>
+          </a:prstGeom>
+          <a:noFill xmlns:a="http://schemas.openxmlformats.org/drawingml/2006/main"/>
+          <a:ln xmlns:a="http://schemas.openxmlformats.org/drawingml/2006/main" w="0">
+            <a:noFill/>
+            <a:prstDash val="solid"/>
+          </a:ln>
+        </p:spPr>
+        <p:txBody>
+          <a:bodyPr xmlns:a="http://schemas.openxmlformats.org/drawingml/2006/main"/>
+          <a:lstStyle xmlns:a="http://schemas.openxmlformats.org/drawingml/2006/main"/>
+          <a:p xmlns:a="http://schemas.openxmlformats.org/drawingml/2006/main">
+            <a:pPr algn="l">
+              <a:buNone/>
+              <a:defRPr sz="1050" b="0">
+                <a:solidFill>
+                  <a:srgbClr val="152015"/>
+                </a:solidFill>
+              </a:defRPr>
+            </a:pPr>
+            <a:r>
+              <a:rPr sz="1050" b="0">
+                <a:solidFill>
+                  <a:srgbClr val="152015"/>
+                </a:solidFill>
+              </a:rPr>
+              <a:t>Export or flush</a:t>
+            </a:r>
+          </a:p>
+        </p:txBody>
+      </p:sp>
+      <p:sp>
+        <p:nvSpPr>
+          <p:cNvPr id="29" name="">
+            <a:extLst xmlns:a="http://schemas.openxmlformats.org/drawingml/2006/main">
+              <a:ext uri="{FF2B5EF4-FFF2-40B4-BE49-F238E27FC236}">
+                <a16:creationId xmlns:a16="http://schemas.microsoft.com/office/drawing/2014/main" id="{255768F6-867A-426D-8DC3-D5C1E189EFF5}"/>
+              </a:ext>
+            </a:extLst>
+          </p:cNvPr>
+          <p:cNvSpPr>
+            <a:spLocks xmlns:a="http://schemas.openxmlformats.org/drawingml/2006/main" noGrp="1"/>
+          </p:cNvSpPr>
+          <p:nvPr/>
+        </p:nvSpPr>
+        <p:spPr>
+          <a:xfrm xmlns:a="http://schemas.openxmlformats.org/drawingml/2006/main">
+            <a:off x="685800" y="5286375"/>
+            <a:ext cx="10001250" cy="457200"/>
+          </a:xfrm>
+          <a:prstGeom xmlns:a="http://schemas.openxmlformats.org/drawingml/2006/main" prst="rect">
+            <a:avLst/>
+          </a:prstGeom>
+          <a:noFill xmlns:a="http://schemas.openxmlformats.org/drawingml/2006/main"/>
+          <a:ln xmlns:a="http://schemas.openxmlformats.org/drawingml/2006/main" w="0">
+            <a:noFill/>
+            <a:prstDash val="solid"/>
+          </a:ln>
+        </p:spPr>
+        <p:txBody>
+          <a:bodyPr xmlns:a="http://schemas.openxmlformats.org/drawingml/2006/main"/>
+          <a:lstStyle xmlns:a="http://schemas.openxmlformats.org/drawingml/2006/main"/>
+          <a:p xmlns:a="http://schemas.openxmlformats.org/drawingml/2006/main">
+            <a:pPr algn="l">
+              <a:buNone/>
+              <a:defRPr sz="1725" b="1">
+                <a:solidFill>
+                  <a:srgbClr val="D8FF55"/>
+                </a:solidFill>
+              </a:defRPr>
+            </a:pPr>
+            <a:r>
+              <a:rPr sz="1725" b="1">
+                <a:solidFill>
+                  <a:srgbClr val="D8FF55"/>
+                </a:solidFill>
+              </a:rPr>
+              <a:t>Catalog comparison stays $0. Live runs start only after a disclosed ceiling and explicit approval.</a:t>
+            </a:r>
+          </a:p>
+        </p:txBody>
+      </p:sp>
+      <p:sp>
+        <p:nvSpPr>
+          <p:cNvPr id="30" name="">
+            <a:extLst xmlns:a="http://schemas.openxmlformats.org/drawingml/2006/main">
+              <a:ext uri="{FF2B5EF4-FFF2-40B4-BE49-F238E27FC236}">
+                <a16:creationId xmlns:a16="http://schemas.microsoft.com/office/drawing/2014/main" id="{C7B803FE-BC72-488F-B900-B932946E02B7}"/>
+              </a:ext>
+            </a:extLst>
+          </p:cNvPr>
+          <p:cNvSpPr>
+            <a:spLocks xmlns:a="http://schemas.openxmlformats.org/drawingml/2006/main" noGrp="1"/>
+          </p:cNvSpPr>
+          <p:nvPr/>
+        </p:nvSpPr>
+        <p:spPr>
+          <a:xfrm xmlns:a="http://schemas.openxmlformats.org/drawingml/2006/main">
+            <a:off x="685800" y="6496050"/>
+            <a:ext cx="4000500" cy="171450"/>
+          </a:xfrm>
+          <a:prstGeom xmlns:a="http://schemas.openxmlformats.org/drawingml/2006/main" prst="rect">
+            <a:avLst/>
+          </a:prstGeom>
+          <a:noFill xmlns:a="http://schemas.openxmlformats.org/drawingml/2006/main"/>
+          <a:ln xmlns:a="http://schemas.openxmlformats.org/drawingml/2006/main" w="0">
+            <a:noFill/>
+            <a:prstDash val="solid"/>
+          </a:ln>
+        </p:spPr>
+        <p:txBody>
+          <a:bodyPr xmlns:a="http://schemas.openxmlformats.org/drawingml/2006/main"/>
+          <a:lstStyle xmlns:a="http://schemas.openxmlformats.org/drawingml/2006/main"/>
+          <a:p xmlns:a="http://schemas.openxmlformats.org/drawingml/2006/main">
+            <a:pPr algn="l">
+              <a:buNone/>
+              <a:defRPr sz="825" b="1">
+                <a:solidFill>
+                  <a:srgbClr val="B7C0B7"/>
+                </a:solidFill>
+              </a:defRPr>
+            </a:pPr>
+            <a:r>
+              <a:rPr sz="825" b="1">
+                <a:solidFill>
+                  <a:srgbClr val="B7C0B7"/>
+                </a:solidFill>
+              </a:rPr>
+              <a:t>AI BUILD CREW · BADLABZ.COM</a:t>
+            </a:r>
+          </a:p>
+        </p:txBody>
+      </p:sp>
+      <p:sp>
+        <p:nvSpPr>
+          <p:cNvPr id="31" name="">
+            <a:extLst xmlns:a="http://schemas.openxmlformats.org/drawingml/2006/main">
+              <a:ext uri="{FF2B5EF4-FFF2-40B4-BE49-F238E27FC236}">
+                <a16:creationId xmlns:a16="http://schemas.microsoft.com/office/drawing/2014/main" id="{CA373767-CC7C-4CDC-AADE-0F0B9DA627CD}"/>
+              </a:ext>
+            </a:extLst>
+          </p:cNvPr>
+          <p:cNvSpPr>
+            <a:spLocks xmlns:a="http://schemas.openxmlformats.org/drawingml/2006/main" noGrp="1"/>
+          </p:cNvSpPr>
+          <p:nvPr/>
+        </p:nvSpPr>
+        <p:spPr>
+          <a:xfrm xmlns:a="http://schemas.openxmlformats.org/drawingml/2006/main">
+            <a:off x="10858500" y="6496050"/>
+            <a:ext cx="647700" cy="171450"/>
+          </a:xfrm>
+          <a:prstGeom xmlns:a="http://schemas.openxmlformats.org/drawingml/2006/main" prst="rect">
+            <a:avLst/>
+          </a:prstGeom>
+          <a:noFill xmlns:a="http://schemas.openxmlformats.org/drawingml/2006/main"/>
+          <a:ln xmlns:a="http://schemas.openxmlformats.org/drawingml/2006/main" w="0">
+            <a:noFill/>
+            <a:prstDash val="solid"/>
+          </a:ln>
+        </p:spPr>
+        <p:txBody>
+          <a:bodyPr xmlns:a="http://schemas.openxmlformats.org/drawingml/2006/main"/>
+          <a:lstStyle xmlns:a="http://schemas.openxmlformats.org/drawingml/2006/main"/>
+          <a:p xmlns:a="http://schemas.openxmlformats.org/drawingml/2006/main">
+            <a:pPr algn="r">
+              <a:buNone/>
+              <a:defRPr sz="825" b="1">
+                <a:solidFill>
+                  <a:srgbClr val="D8FF55"/>
+                </a:solidFill>
+              </a:defRPr>
+            </a:pPr>
+            <a:r>
+              <a:rPr sz="825" b="1">
+                <a:solidFill>
+                  <a:srgbClr val="D8FF55"/>
+                </a:solidFill>
+              </a:rPr>
+              <a:t>10</a:t>
+            </a:r>
+          </a:p>
+        </p:txBody>
+      </p:sp>
+    </p:spTree>
+    <p:extLst>
+      <p:ext uri="{BB962C8B-B14F-4D97-AF65-F5344CB8AC3E}">
+        <p14:creationId xmlns:p14="http://schemas.microsoft.com/office/powerpoint/2010/main" val="707526045"/>
+      </p:ext>
+    </p:extLst>
+  </p:cSld>
+</p:sld>
+</file>
+
+<file path=ppt/slides/slide11.xml><?xml version="1.0" encoding="utf-8"?>
+<p:sld xmlns:p="http://schemas.openxmlformats.org/presentationml/2006/main">
+  <p:cSld>
+    <p:spTree>
+      <p:nvGrpSpPr>
+        <p:cNvPr id="1" name=""/>
+        <p:cNvGrpSpPr/>
+        <p:nvPr/>
+      </p:nvGrpSpPr>
+      <p:grpSpPr>
+        <a:xfrm xmlns:a="http://schemas.openxmlformats.org/drawingml/2006/main"/>
+      </p:grpSpPr>
+      <p:pic>
+        <p:nvPicPr>
+          <p:cNvPr id="20" name=""/>
+          <p:cNvPicPr>
+            <a:picLocks xmlns:a="http://schemas.openxmlformats.org/drawingml/2006/main" noChangeAspect="1"/>
+          </p:cNvPicPr>
+          <p:nvPr/>
+        </p:nvPicPr>
+        <p:blipFill>
+          <a:blip xmlns:r="http://schemas.openxmlformats.org/officeDocument/2006/relationships" xmlns:a="http://schemas.openxmlformats.org/drawingml/2006/main" r:embed="R97fdd1ca7be34a35"/>
+          <a:srcRect xmlns:a="http://schemas.openxmlformats.org/drawingml/2006/main" l="0" t="27" r="0" b="27"/>
+          <a:stretch xmlns:a="http://schemas.openxmlformats.org/drawingml/2006/main">
+            <a:fillRect l="0" t="0" r="0" b="0"/>
+          </a:stretch>
+        </p:blipFill>
+        <p:spPr>
+          <a:xfrm xmlns:a="http://schemas.openxmlformats.org/drawingml/2006/main">
+            <a:off x="0" y="0"/>
+            <a:ext cx="12192000" cy="6858000"/>
+          </a:xfrm>
+          <a:prstGeom xmlns:a="http://schemas.openxmlformats.org/drawingml/2006/main" prst="rect">
+            <a:avLst/>
+          </a:prstGeom>
+        </p:spPr>
+      </p:pic>
+      <p:sp>
+        <p:nvSpPr>
+          <p:cNvPr id="2" name="">
+            <a:extLst xmlns:a="http://schemas.openxmlformats.org/drawingml/2006/main">
+              <a:ext uri="{FF2B5EF4-FFF2-40B4-BE49-F238E27FC236}">
+                <a16:creationId xmlns:a16="http://schemas.microsoft.com/office/drawing/2014/main" id="{26505945-590A-4C2D-98F2-EED54361D376}"/>
+              </a:ext>
+            </a:extLst>
+          </p:cNvPr>
+          <p:cNvSpPr>
+            <a:spLocks xmlns:a="http://schemas.openxmlformats.org/drawingml/2006/main" noGrp="1"/>
+          </p:cNvSpPr>
+          <p:nvPr/>
+        </p:nvSpPr>
+        <p:spPr>
+          <a:xfrm xmlns:a="http://schemas.openxmlformats.org/drawingml/2006/main">
+            <a:off x="0" y="0"/>
+            <a:ext cx="7334250" cy="6858000"/>
+          </a:xfrm>
+          <a:prstGeom xmlns:a="http://schemas.openxmlformats.org/drawingml/2006/main" prst="rect">
+            <a:avLst/>
+          </a:prstGeom>
+          <a:solidFill xmlns:a="http://schemas.openxmlformats.org/drawingml/2006/main">
+            <a:srgbClr val="152015">
+              <a:alpha val="94902"/>
+            </a:srgbClr>
+          </a:solidFill>
+          <a:ln xmlns:a="http://schemas.openxmlformats.org/drawingml/2006/main" w="0">
+            <a:noFill/>
+            <a:prstDash val="solid"/>
+          </a:ln>
+        </p:spPr>
+      </p:sp>
+      <p:sp>
+        <p:nvSpPr>
+          <p:cNvPr id="3" name="">
+            <a:extLst xmlns:a="http://schemas.openxmlformats.org/drawingml/2006/main">
+              <a:ext uri="{FF2B5EF4-FFF2-40B4-BE49-F238E27FC236}">
+                <a16:creationId xmlns:a16="http://schemas.microsoft.com/office/drawing/2014/main" id="{ED9484EF-407F-4944-8879-B3FDBB7FFA64}"/>
+              </a:ext>
+            </a:extLst>
+          </p:cNvPr>
+          <p:cNvSpPr>
+            <a:spLocks xmlns:a="http://schemas.openxmlformats.org/drawingml/2006/main" noGrp="1"/>
+          </p:cNvSpPr>
+          <p:nvPr/>
+        </p:nvSpPr>
+        <p:spPr>
+          <a:xfrm xmlns:a="http://schemas.openxmlformats.org/drawingml/2006/main">
+            <a:off x="685800" y="552450"/>
+            <a:ext cx="3429000" cy="266700"/>
+          </a:xfrm>
+          <a:prstGeom xmlns:a="http://schemas.openxmlformats.org/drawingml/2006/main" prst="rect">
+            <a:avLst/>
+          </a:prstGeom>
+          <a:noFill xmlns:a="http://schemas.openxmlformats.org/drawingml/2006/main"/>
+          <a:ln xmlns:a="http://schemas.openxmlformats.org/drawingml/2006/main" w="0">
+            <a:noFill/>
+            <a:prstDash val="solid"/>
+          </a:ln>
+        </p:spPr>
+        <p:txBody>
+          <a:bodyPr xmlns:a="http://schemas.openxmlformats.org/drawingml/2006/main"/>
+          <a:lstStyle xmlns:a="http://schemas.openxmlformats.org/drawingml/2006/main"/>
+          <a:p xmlns:a="http://schemas.openxmlformats.org/drawingml/2006/main">
+            <a:pPr algn="l">
+              <a:buNone/>
+              <a:defRPr sz="975" b="1">
+                <a:solidFill>
+                  <a:srgbClr val="D8FF55"/>
+                </a:solidFill>
+              </a:defRPr>
+            </a:pPr>
+            <a:r>
+              <a:rPr sz="975" b="1">
+                <a:solidFill>
+                  <a:srgbClr val="D8FF55"/>
+                </a:solidFill>
+              </a:rPr>
+              <a:t>PHASE 2 · EVIDENCE FOUNDATION</a:t>
+            </a:r>
+          </a:p>
+        </p:txBody>
+      </p:sp>
+      <p:sp>
+        <p:nvSpPr>
+          <p:cNvPr id="4" name="">
+            <a:extLst xmlns:a="http://schemas.openxmlformats.org/drawingml/2006/main">
+              <a:ext uri="{FF2B5EF4-FFF2-40B4-BE49-F238E27FC236}">
+                <a16:creationId xmlns:a16="http://schemas.microsoft.com/office/drawing/2014/main" id="{71C7F68A-8294-4D64-AD07-7B2B4F0C7FAF}"/>
+              </a:ext>
+            </a:extLst>
+          </p:cNvPr>
+          <p:cNvSpPr>
+            <a:spLocks xmlns:a="http://schemas.openxmlformats.org/drawingml/2006/main" noGrp="1"/>
+          </p:cNvSpPr>
+          <p:nvPr/>
+        </p:nvSpPr>
+        <p:spPr>
+          <a:xfrm xmlns:a="http://schemas.openxmlformats.org/drawingml/2006/main">
+            <a:off x="685800" y="1219200"/>
+            <a:ext cx="5905500" cy="1066800"/>
+          </a:xfrm>
+          <a:prstGeom xmlns:a="http://schemas.openxmlformats.org/drawingml/2006/main" prst="rect">
+            <a:avLst/>
+          </a:prstGeom>
+          <a:noFill xmlns:a="http://schemas.openxmlformats.org/drawingml/2006/main"/>
+          <a:ln xmlns:a="http://schemas.openxmlformats.org/drawingml/2006/main" w="0">
+            <a:noFill/>
+            <a:prstDash val="solid"/>
+          </a:ln>
+        </p:spPr>
+        <p:txBody>
+          <a:bodyPr xmlns:a="http://schemas.openxmlformats.org/drawingml/2006/main"/>
+          <a:lstStyle xmlns:a="http://schemas.openxmlformats.org/drawingml/2006/main"/>
+          <a:p xmlns:a="http://schemas.openxmlformats.org/drawingml/2006/main">
+            <a:pPr algn="l">
+              <a:buNone/>
+              <a:defRPr sz="3600" b="1">
+                <a:solidFill>
+                  <a:srgbClr val="FFFFFF"/>
+                </a:solidFill>
+              </a:defRPr>
+            </a:pPr>
+            <a:r>
+              <a:rPr sz="3600" b="1">
+                <a:solidFill>
+                  <a:srgbClr val="FFFFFF"/>
+                </a:solidFill>
+              </a:rPr>
+              <a:t>Store evidence,</a:t>
+            </a:r>
+          </a:p>
+          <a:p xmlns:a="http://schemas.openxmlformats.org/drawingml/2006/main">
+            <a:pPr algn="l">
+              <a:buNone/>
+              <a:defRPr sz="3600" b="1">
+                <a:solidFill>
+                  <a:srgbClr val="FFFFFF"/>
+                </a:solidFill>
+              </a:defRPr>
+            </a:pPr>
+            <a:r>
+              <a:rPr sz="3600" b="1">
+                <a:solidFill>
+                  <a:srgbClr val="FFFFFF"/>
+                </a:solidFill>
+              </a:rPr>
+              <a:t>not ideas.</a:t>
+            </a:r>
+          </a:p>
+        </p:txBody>
+      </p:sp>
+      <p:sp>
+        <p:nvSpPr>
+          <p:cNvPr id="5" name="">
+            <a:extLst xmlns:a="http://schemas.openxmlformats.org/drawingml/2006/main">
+              <a:ext uri="{FF2B5EF4-FFF2-40B4-BE49-F238E27FC236}">
+                <a16:creationId xmlns:a16="http://schemas.microsoft.com/office/drawing/2014/main" id="{6D1389EE-CE1F-4BD0-B381-9B1964471F2C}"/>
+              </a:ext>
+            </a:extLst>
+          </p:cNvPr>
+          <p:cNvSpPr>
+            <a:spLocks xmlns:a="http://schemas.openxmlformats.org/drawingml/2006/main" noGrp="1"/>
+          </p:cNvSpPr>
+          <p:nvPr/>
+        </p:nvSpPr>
+        <p:spPr>
+          <a:xfrm xmlns:a="http://schemas.openxmlformats.org/drawingml/2006/main">
+            <a:off x="685800" y="2857500"/>
+            <a:ext cx="838200" cy="228600"/>
+          </a:xfrm>
+          <a:prstGeom xmlns:a="http://schemas.openxmlformats.org/drawingml/2006/main" prst="rect">
+            <a:avLst/>
+          </a:prstGeom>
+          <a:noFill xmlns:a="http://schemas.openxmlformats.org/drawingml/2006/main"/>
+          <a:ln xmlns:a="http://schemas.openxmlformats.org/drawingml/2006/main" w="0">
+            <a:noFill/>
+            <a:prstDash val="solid"/>
+          </a:ln>
+        </p:spPr>
+        <p:txBody>
+          <a:bodyPr xmlns:a="http://schemas.openxmlformats.org/drawingml/2006/main"/>
+          <a:lstStyle xmlns:a="http://schemas.openxmlformats.org/drawingml/2006/main"/>
+          <a:p xmlns:a="http://schemas.openxmlformats.org/drawingml/2006/main">
+            <a:pPr algn="l">
+              <a:buNone/>
+              <a:defRPr sz="975" b="1">
+                <a:solidFill>
+                  <a:srgbClr val="D8FF55"/>
+                </a:solidFill>
+              </a:defRPr>
+            </a:pPr>
+            <a:r>
+              <a:rPr sz="975" b="1">
+                <a:solidFill>
+                  <a:srgbClr val="D8FF55"/>
+                </a:solidFill>
+              </a:rPr>
+              <a:t>S3</a:t>
+            </a:r>
+          </a:p>
+        </p:txBody>
+      </p:sp>
+      <p:sp>
+        <p:nvSpPr>
+          <p:cNvPr id="6" name="">
+            <a:extLst xmlns:a="http://schemas.openxmlformats.org/drawingml/2006/main">
+              <a:ext uri="{FF2B5EF4-FFF2-40B4-BE49-F238E27FC236}">
+                <a16:creationId xmlns:a16="http://schemas.microsoft.com/office/drawing/2014/main" id="{E2C85436-B20D-499F-BA93-76A745913F6B}"/>
+              </a:ext>
+            </a:extLst>
+          </p:cNvPr>
+          <p:cNvSpPr>
+            <a:spLocks xmlns:a="http://schemas.openxmlformats.org/drawingml/2006/main" noGrp="1"/>
+          </p:cNvSpPr>
+          <p:nvPr/>
+        </p:nvSpPr>
+        <p:spPr>
+          <a:xfrm xmlns:a="http://schemas.openxmlformats.org/drawingml/2006/main">
+            <a:off x="1666875" y="2838450"/>
+            <a:ext cx="4762500" cy="514350"/>
+          </a:xfrm>
+          <a:prstGeom xmlns:a="http://schemas.openxmlformats.org/drawingml/2006/main" prst="rect">
+            <a:avLst/>
+          </a:prstGeom>
+          <a:noFill xmlns:a="http://schemas.openxmlformats.org/drawingml/2006/main"/>
+          <a:ln xmlns:a="http://schemas.openxmlformats.org/drawingml/2006/main" w="0">
+            <a:noFill/>
+            <a:prstDash val="solid"/>
+          </a:ln>
+        </p:spPr>
+        <p:txBody>
+          <a:bodyPr xmlns:a="http://schemas.openxmlformats.org/drawingml/2006/main"/>
+          <a:lstStyle xmlns:a="http://schemas.openxmlformats.org/drawingml/2006/main"/>
+          <a:p xmlns:a="http://schemas.openxmlformats.org/drawingml/2006/main">
+            <a:pPr algn="l">
+              <a:buNone/>
+              <a:defRPr sz="1425" b="0">
+                <a:solidFill>
+                  <a:srgbClr val="FFFFFF"/>
+                </a:solidFill>
+              </a:defRPr>
+            </a:pPr>
+            <a:r>
+              <a:rPr sz="1425" b="0">
+                <a:solidFill>
+                  <a:srgbClr val="FFFFFF"/>
+                </a:solidFill>
+              </a:rPr>
+              <a:t>Immutable catalog snapshots, run inputs, outputs, and reports</a:t>
+            </a:r>
+          </a:p>
+        </p:txBody>
+      </p:sp>
+      <p:sp>
+        <p:nvSpPr>
+          <p:cNvPr id="7" name="">
+            <a:extLst xmlns:a="http://schemas.openxmlformats.org/drawingml/2006/main">
+              <a:ext uri="{FF2B5EF4-FFF2-40B4-BE49-F238E27FC236}">
+                <a16:creationId xmlns:a16="http://schemas.microsoft.com/office/drawing/2014/main" id="{7AE00594-A482-4BB2-873D-969FFE861134}"/>
+              </a:ext>
+            </a:extLst>
+          </p:cNvPr>
+          <p:cNvSpPr>
+            <a:spLocks xmlns:a="http://schemas.openxmlformats.org/drawingml/2006/main" noGrp="1"/>
+          </p:cNvSpPr>
+          <p:nvPr/>
+        </p:nvSpPr>
+        <p:spPr>
+          <a:xfrm xmlns:a="http://schemas.openxmlformats.org/drawingml/2006/main">
+            <a:off x="685800" y="3400425"/>
+            <a:ext cx="5715000" cy="9525"/>
+          </a:xfrm>
+          <a:prstGeom xmlns:a="http://schemas.openxmlformats.org/drawingml/2006/main" prst="rect">
+            <a:avLst/>
+          </a:prstGeom>
+          <a:solidFill xmlns:a="http://schemas.openxmlformats.org/drawingml/2006/main">
+            <a:srgbClr val="4A5A4A"/>
+          </a:solidFill>
+          <a:ln xmlns:a="http://schemas.openxmlformats.org/drawingml/2006/main" w="0">
+            <a:noFill/>
+            <a:prstDash val="solid"/>
+          </a:ln>
+        </p:spPr>
+      </p:sp>
+      <p:sp>
+        <p:nvSpPr>
+          <p:cNvPr id="8" name="">
+            <a:extLst xmlns:a="http://schemas.openxmlformats.org/drawingml/2006/main">
+              <a:ext uri="{FF2B5EF4-FFF2-40B4-BE49-F238E27FC236}">
+                <a16:creationId xmlns:a16="http://schemas.microsoft.com/office/drawing/2014/main" id="{D18F43BC-3A50-451E-9EE6-AA670936DAE4}"/>
+              </a:ext>
+            </a:extLst>
+          </p:cNvPr>
+          <p:cNvSpPr>
+            <a:spLocks xmlns:a="http://schemas.openxmlformats.org/drawingml/2006/main" noGrp="1"/>
+          </p:cNvSpPr>
+          <p:nvPr/>
+        </p:nvSpPr>
+        <p:spPr>
+          <a:xfrm xmlns:a="http://schemas.openxmlformats.org/drawingml/2006/main">
+            <a:off x="685800" y="3543300"/>
+            <a:ext cx="838200" cy="228600"/>
+          </a:xfrm>
+          <a:prstGeom xmlns:a="http://schemas.openxmlformats.org/drawingml/2006/main" prst="rect">
+            <a:avLst/>
+          </a:prstGeom>
+          <a:noFill xmlns:a="http://schemas.openxmlformats.org/drawingml/2006/main"/>
+          <a:ln xmlns:a="http://schemas.openxmlformats.org/drawingml/2006/main" w="0">
+            <a:noFill/>
+            <a:prstDash val="solid"/>
+          </a:ln>
+        </p:spPr>
+        <p:txBody>
+          <a:bodyPr xmlns:a="http://schemas.openxmlformats.org/drawingml/2006/main"/>
+          <a:lstStyle xmlns:a="http://schemas.openxmlformats.org/drawingml/2006/main"/>
+          <a:p xmlns:a="http://schemas.openxmlformats.org/drawingml/2006/main">
+            <a:pPr algn="l">
+              <a:buNone/>
+              <a:defRPr sz="975" b="1">
+                <a:solidFill>
+                  <a:srgbClr val="8F7BFF"/>
+                </a:solidFill>
+              </a:defRPr>
+            </a:pPr>
+            <a:r>
+              <a:rPr sz="975" b="1">
+                <a:solidFill>
+                  <a:srgbClr val="8F7BFF"/>
+                </a:solidFill>
+              </a:rPr>
+              <a:t>DYNAMO</a:t>
+            </a:r>
+          </a:p>
+        </p:txBody>
+      </p:sp>
+      <p:sp>
+        <p:nvSpPr>
+          <p:cNvPr id="9" name="">
+            <a:extLst xmlns:a="http://schemas.openxmlformats.org/drawingml/2006/main">
+              <a:ext uri="{FF2B5EF4-FFF2-40B4-BE49-F238E27FC236}">
+                <a16:creationId xmlns:a16="http://schemas.microsoft.com/office/drawing/2014/main" id="{2F690732-B07D-4033-A156-9ACCAB3AD1FC}"/>
+              </a:ext>
+            </a:extLst>
+          </p:cNvPr>
+          <p:cNvSpPr>
+            <a:spLocks xmlns:a="http://schemas.openxmlformats.org/drawingml/2006/main" noGrp="1"/>
+          </p:cNvSpPr>
+          <p:nvPr/>
+        </p:nvSpPr>
+        <p:spPr>
+          <a:xfrm xmlns:a="http://schemas.openxmlformats.org/drawingml/2006/main">
+            <a:off x="1666875" y="3524250"/>
+            <a:ext cx="4762500" cy="514350"/>
+          </a:xfrm>
+          <a:prstGeom xmlns:a="http://schemas.openxmlformats.org/drawingml/2006/main" prst="rect">
+            <a:avLst/>
+          </a:prstGeom>
+          <a:noFill xmlns:a="http://schemas.openxmlformats.org/drawingml/2006/main"/>
+          <a:ln xmlns:a="http://schemas.openxmlformats.org/drawingml/2006/main" w="0">
+            <a:noFill/>
+            <a:prstDash val="solid"/>
+          </a:ln>
+        </p:spPr>
+        <p:txBody>
+          <a:bodyPr xmlns:a="http://schemas.openxmlformats.org/drawingml/2006/main"/>
+          <a:lstStyle xmlns:a="http://schemas.openxmlformats.org/drawingml/2006/main"/>
+          <a:p xmlns:a="http://schemas.openxmlformats.org/drawingml/2006/main">
+            <a:pPr algn="l">
+              <a:buNone/>
+              <a:defRPr sz="1425" b="0">
+                <a:solidFill>
+                  <a:srgbClr val="FFFFFF"/>
+                </a:solidFill>
+              </a:defRPr>
+            </a:pPr>
+            <a:r>
+              <a:rPr sz="1425" b="0">
+                <a:solidFill>
+                  <a:srgbClr val="FFFFFF"/>
+                </a:solidFill>
+              </a:rPr>
+              <a:t>Projects, budgets, metadata, and point-in-time history</a:t>
+            </a:r>
+          </a:p>
+        </p:txBody>
+      </p:sp>
+      <p:sp>
+        <p:nvSpPr>
+          <p:cNvPr id="10" name="">
+            <a:extLst xmlns:a="http://schemas.openxmlformats.org/drawingml/2006/main">
+              <a:ext uri="{FF2B5EF4-FFF2-40B4-BE49-F238E27FC236}">
+                <a16:creationId xmlns:a16="http://schemas.microsoft.com/office/drawing/2014/main" id="{A0D4318D-1F35-4D88-8253-6E0B591843E1}"/>
+              </a:ext>
+            </a:extLst>
+          </p:cNvPr>
+          <p:cNvSpPr>
+            <a:spLocks xmlns:a="http://schemas.openxmlformats.org/drawingml/2006/main" noGrp="1"/>
+          </p:cNvSpPr>
+          <p:nvPr/>
+        </p:nvSpPr>
+        <p:spPr>
+          <a:xfrm xmlns:a="http://schemas.openxmlformats.org/drawingml/2006/main">
+            <a:off x="685800" y="4086225"/>
+            <a:ext cx="5715000" cy="9525"/>
+          </a:xfrm>
+          <a:prstGeom xmlns:a="http://schemas.openxmlformats.org/drawingml/2006/main" prst="rect">
+            <a:avLst/>
+          </a:prstGeom>
+          <a:solidFill xmlns:a="http://schemas.openxmlformats.org/drawingml/2006/main">
+            <a:srgbClr val="4A5A4A"/>
+          </a:solidFill>
+          <a:ln xmlns:a="http://schemas.openxmlformats.org/drawingml/2006/main" w="0">
+            <a:noFill/>
+            <a:prstDash val="solid"/>
+          </a:ln>
+        </p:spPr>
+      </p:sp>
+      <p:sp>
+        <p:nvSpPr>
+          <p:cNvPr id="11" name="">
+            <a:extLst xmlns:a="http://schemas.openxmlformats.org/drawingml/2006/main">
+              <a:ext uri="{FF2B5EF4-FFF2-40B4-BE49-F238E27FC236}">
+                <a16:creationId xmlns:a16="http://schemas.microsoft.com/office/drawing/2014/main" id="{1DCE0B84-783F-4F4D-991F-A34A23F70025}"/>
+              </a:ext>
+            </a:extLst>
+          </p:cNvPr>
+          <p:cNvSpPr>
+            <a:spLocks xmlns:a="http://schemas.openxmlformats.org/drawingml/2006/main" noGrp="1"/>
+          </p:cNvSpPr>
+          <p:nvPr/>
+        </p:nvSpPr>
+        <p:spPr>
+          <a:xfrm xmlns:a="http://schemas.openxmlformats.org/drawingml/2006/main">
+            <a:off x="685800" y="4229100"/>
+            <a:ext cx="838200" cy="228600"/>
+          </a:xfrm>
+          <a:prstGeom xmlns:a="http://schemas.openxmlformats.org/drawingml/2006/main" prst="rect">
+            <a:avLst/>
+          </a:prstGeom>
+          <a:noFill xmlns:a="http://schemas.openxmlformats.org/drawingml/2006/main"/>
+          <a:ln xmlns:a="http://schemas.openxmlformats.org/drawingml/2006/main" w="0">
+            <a:noFill/>
+            <a:prstDash val="solid"/>
+          </a:ln>
+        </p:spPr>
+        <p:txBody>
+          <a:bodyPr xmlns:a="http://schemas.openxmlformats.org/drawingml/2006/main"/>
+          <a:lstStyle xmlns:a="http://schemas.openxmlformats.org/drawingml/2006/main"/>
+          <a:p xmlns:a="http://schemas.openxmlformats.org/drawingml/2006/main">
+            <a:pPr algn="l">
+              <a:buNone/>
+              <a:defRPr sz="975" b="1">
+                <a:solidFill>
+                  <a:srgbClr val="FF8159"/>
+                </a:solidFill>
+              </a:defRPr>
+            </a:pPr>
+            <a:r>
+              <a:rPr sz="975" b="1">
+                <a:solidFill>
+                  <a:srgbClr val="FF8159"/>
+                </a:solidFill>
+              </a:rPr>
+              <a:t>SECRETS</a:t>
+            </a:r>
+          </a:p>
+        </p:txBody>
+      </p:sp>
+      <p:sp>
+        <p:nvSpPr>
+          <p:cNvPr id="12" name="">
+            <a:extLst xmlns:a="http://schemas.openxmlformats.org/drawingml/2006/main">
+              <a:ext uri="{FF2B5EF4-FFF2-40B4-BE49-F238E27FC236}">
+                <a16:creationId xmlns:a16="http://schemas.microsoft.com/office/drawing/2014/main" id="{6C5B3A81-64FC-4228-BF01-81EF7F2934CC}"/>
+              </a:ext>
+            </a:extLst>
+          </p:cNvPr>
+          <p:cNvSpPr>
+            <a:spLocks xmlns:a="http://schemas.openxmlformats.org/drawingml/2006/main" noGrp="1"/>
+          </p:cNvSpPr>
+          <p:nvPr/>
+        </p:nvSpPr>
+        <p:spPr>
+          <a:xfrm xmlns:a="http://schemas.openxmlformats.org/drawingml/2006/main">
+            <a:off x="1666875" y="4210050"/>
+            <a:ext cx="4762500" cy="514350"/>
+          </a:xfrm>
+          <a:prstGeom xmlns:a="http://schemas.openxmlformats.org/drawingml/2006/main" prst="rect">
+            <a:avLst/>
+          </a:prstGeom>
+          <a:noFill xmlns:a="http://schemas.openxmlformats.org/drawingml/2006/main"/>
+          <a:ln xmlns:a="http://schemas.openxmlformats.org/drawingml/2006/main" w="0">
+            <a:noFill/>
+            <a:prstDash val="solid"/>
+          </a:ln>
+        </p:spPr>
+        <p:txBody>
+          <a:bodyPr xmlns:a="http://schemas.openxmlformats.org/drawingml/2006/main"/>
+          <a:lstStyle xmlns:a="http://schemas.openxmlformats.org/drawingml/2006/main"/>
+          <a:p xmlns:a="http://schemas.openxmlformats.org/drawingml/2006/main">
+            <a:pPr algn="l">
+              <a:buNone/>
+              <a:defRPr sz="1425" b="0">
+                <a:solidFill>
+                  <a:srgbClr val="FFFFFF"/>
+                </a:solidFill>
+              </a:defRPr>
+            </a:pPr>
+            <a:r>
+              <a:rPr sz="1425" b="0">
+                <a:solidFill>
+                  <a:srgbClr val="FFFFFF"/>
+                </a:solidFill>
+              </a:rPr>
+              <a:t>Provider keys remain protected and server-side</a:t>
+            </a:r>
+          </a:p>
+        </p:txBody>
+      </p:sp>
+      <p:sp>
+        <p:nvSpPr>
+          <p:cNvPr id="13" name="">
+            <a:extLst xmlns:a="http://schemas.openxmlformats.org/drawingml/2006/main">
+              <a:ext uri="{FF2B5EF4-FFF2-40B4-BE49-F238E27FC236}">
+                <a16:creationId xmlns:a16="http://schemas.microsoft.com/office/drawing/2014/main" id="{51F9489E-2112-46B6-A8DE-9F34AEBCA139}"/>
+              </a:ext>
+            </a:extLst>
+          </p:cNvPr>
+          <p:cNvSpPr>
+            <a:spLocks xmlns:a="http://schemas.openxmlformats.org/drawingml/2006/main" noGrp="1"/>
+          </p:cNvSpPr>
+          <p:nvPr/>
+        </p:nvSpPr>
+        <p:spPr>
+          <a:xfrm xmlns:a="http://schemas.openxmlformats.org/drawingml/2006/main">
+            <a:off x="685800" y="4772025"/>
+            <a:ext cx="5715000" cy="9525"/>
+          </a:xfrm>
+          <a:prstGeom xmlns:a="http://schemas.openxmlformats.org/drawingml/2006/main" prst="rect">
+            <a:avLst/>
+          </a:prstGeom>
+          <a:solidFill xmlns:a="http://schemas.openxmlformats.org/drawingml/2006/main">
+            <a:srgbClr val="4A5A4A"/>
+          </a:solidFill>
+          <a:ln xmlns:a="http://schemas.openxmlformats.org/drawingml/2006/main" w="0">
+            <a:noFill/>
+            <a:prstDash val="solid"/>
+          </a:ln>
+        </p:spPr>
+      </p:sp>
+      <p:sp>
+        <p:nvSpPr>
+          <p:cNvPr id="14" name="">
+            <a:extLst xmlns:a="http://schemas.openxmlformats.org/drawingml/2006/main">
+              <a:ext uri="{FF2B5EF4-FFF2-40B4-BE49-F238E27FC236}">
+                <a16:creationId xmlns:a16="http://schemas.microsoft.com/office/drawing/2014/main" id="{52FC565A-7F52-47F4-98A2-B3E00095EB8E}"/>
+              </a:ext>
+            </a:extLst>
+          </p:cNvPr>
+          <p:cNvSpPr>
+            <a:spLocks xmlns:a="http://schemas.openxmlformats.org/drawingml/2006/main" noGrp="1"/>
+          </p:cNvSpPr>
+          <p:nvPr/>
+        </p:nvSpPr>
+        <p:spPr>
+          <a:xfrm xmlns:a="http://schemas.openxmlformats.org/drawingml/2006/main">
+            <a:off x="685800" y="4914900"/>
+            <a:ext cx="838200" cy="228600"/>
+          </a:xfrm>
+          <a:prstGeom xmlns:a="http://schemas.openxmlformats.org/drawingml/2006/main" prst="rect">
+            <a:avLst/>
+          </a:prstGeom>
+          <a:noFill xmlns:a="http://schemas.openxmlformats.org/drawingml/2006/main"/>
+          <a:ln xmlns:a="http://schemas.openxmlformats.org/drawingml/2006/main" w="0">
+            <a:noFill/>
+            <a:prstDash val="solid"/>
+          </a:ln>
+        </p:spPr>
+        <p:txBody>
+          <a:bodyPr xmlns:a="http://schemas.openxmlformats.org/drawingml/2006/main"/>
+          <a:lstStyle xmlns:a="http://schemas.openxmlformats.org/drawingml/2006/main"/>
+          <a:p xmlns:a="http://schemas.openxmlformats.org/drawingml/2006/main">
+            <a:pPr algn="l">
+              <a:buNone/>
+              <a:defRPr sz="975" b="1">
+                <a:solidFill>
+                  <a:srgbClr val="D8FF55"/>
+                </a:solidFill>
+              </a:defRPr>
+            </a:pPr>
+            <a:r>
+              <a:rPr sz="975" b="1">
+                <a:solidFill>
+                  <a:srgbClr val="D8FF55"/>
+                </a:solidFill>
+              </a:rPr>
+              <a:t>RAG</a:t>
+            </a:r>
+          </a:p>
+        </p:txBody>
+      </p:sp>
+      <p:sp>
+        <p:nvSpPr>
+          <p:cNvPr id="15" name="">
+            <a:extLst xmlns:a="http://schemas.openxmlformats.org/drawingml/2006/main">
+              <a:ext uri="{FF2B5EF4-FFF2-40B4-BE49-F238E27FC236}">
+                <a16:creationId xmlns:a16="http://schemas.microsoft.com/office/drawing/2014/main" id="{2EE692EA-1197-4BB5-AF5E-FDBB5D7D855E}"/>
+              </a:ext>
+            </a:extLst>
+          </p:cNvPr>
+          <p:cNvSpPr>
+            <a:spLocks xmlns:a="http://schemas.openxmlformats.org/drawingml/2006/main" noGrp="1"/>
+          </p:cNvSpPr>
+          <p:nvPr/>
+        </p:nvSpPr>
+        <p:spPr>
+          <a:xfrm xmlns:a="http://schemas.openxmlformats.org/drawingml/2006/main">
+            <a:off x="1666875" y="4895850"/>
+            <a:ext cx="4762500" cy="514350"/>
+          </a:xfrm>
+          <a:prstGeom xmlns:a="http://schemas.openxmlformats.org/drawingml/2006/main" prst="rect">
+            <a:avLst/>
+          </a:prstGeom>
+          <a:noFill xmlns:a="http://schemas.openxmlformats.org/drawingml/2006/main"/>
+          <a:ln xmlns:a="http://schemas.openxmlformats.org/drawingml/2006/main" w="0">
+            <a:noFill/>
+            <a:prstDash val="solid"/>
+          </a:ln>
+        </p:spPr>
+        <p:txBody>
+          <a:bodyPr xmlns:a="http://schemas.openxmlformats.org/drawingml/2006/main"/>
+          <a:lstStyle xmlns:a="http://schemas.openxmlformats.org/drawingml/2006/main"/>
+          <a:p xmlns:a="http://schemas.openxmlformats.org/drawingml/2006/main">
+            <a:pPr algn="l">
+              <a:buNone/>
+              <a:defRPr sz="1425" b="0">
+                <a:solidFill>
+                  <a:srgbClr val="FFFFFF"/>
+                </a:solidFill>
+              </a:defRPr>
+            </a:pPr>
+            <a:r>
+              <a:rPr sz="1425" b="0">
+                <a:solidFill>
+                  <a:srgbClr val="FFFFFF"/>
+                </a:solidFill>
+              </a:rPr>
+              <a:t>Grounds sources and reports; never changes cost math or policy</a:t>
+            </a:r>
+          </a:p>
+        </p:txBody>
+      </p:sp>
+      <p:sp>
+        <p:nvSpPr>
+          <p:cNvPr id="16" name="">
+            <a:extLst xmlns:a="http://schemas.openxmlformats.org/drawingml/2006/main">
+              <a:ext uri="{FF2B5EF4-FFF2-40B4-BE49-F238E27FC236}">
+                <a16:creationId xmlns:a16="http://schemas.microsoft.com/office/drawing/2014/main" id="{10B5F276-B2B3-4E9E-8405-2E0497288684}"/>
+              </a:ext>
+            </a:extLst>
+          </p:cNvPr>
+          <p:cNvSpPr>
+            <a:spLocks xmlns:a="http://schemas.openxmlformats.org/drawingml/2006/main" noGrp="1"/>
+          </p:cNvSpPr>
+          <p:nvPr/>
+        </p:nvSpPr>
+        <p:spPr>
+          <a:xfrm xmlns:a="http://schemas.openxmlformats.org/drawingml/2006/main">
+            <a:off x="685800" y="5457825"/>
+            <a:ext cx="5715000" cy="9525"/>
+          </a:xfrm>
+          <a:prstGeom xmlns:a="http://schemas.openxmlformats.org/drawingml/2006/main" prst="rect">
+            <a:avLst/>
+          </a:prstGeom>
+          <a:solidFill xmlns:a="http://schemas.openxmlformats.org/drawingml/2006/main">
+            <a:srgbClr val="4A5A4A"/>
+          </a:solidFill>
+          <a:ln xmlns:a="http://schemas.openxmlformats.org/drawingml/2006/main" w="0">
+            <a:noFill/>
+            <a:prstDash val="solid"/>
+          </a:ln>
+        </p:spPr>
+      </p:sp>
+      <p:sp>
+        <p:nvSpPr>
+          <p:cNvPr id="17" name="">
+            <a:extLst xmlns:a="http://schemas.openxmlformats.org/drawingml/2006/main">
+              <a:ext uri="{FF2B5EF4-FFF2-40B4-BE49-F238E27FC236}">
+                <a16:creationId xmlns:a16="http://schemas.microsoft.com/office/drawing/2014/main" id="{C40BB595-FE5F-445E-9766-B4C6E7B74349}"/>
+              </a:ext>
+            </a:extLst>
+          </p:cNvPr>
+          <p:cNvSpPr>
+            <a:spLocks xmlns:a="http://schemas.openxmlformats.org/drawingml/2006/main" noGrp="1"/>
+          </p:cNvSpPr>
+          <p:nvPr/>
+        </p:nvSpPr>
+        <p:spPr>
+          <a:xfrm xmlns:a="http://schemas.openxmlformats.org/drawingml/2006/main">
+            <a:off x="685800" y="6048375"/>
+            <a:ext cx="3810000" cy="266700"/>
+          </a:xfrm>
+          <a:prstGeom xmlns:a="http://schemas.openxmlformats.org/drawingml/2006/main" prst="rect">
+            <a:avLst/>
+          </a:prstGeom>
+          <a:noFill xmlns:a="http://schemas.openxmlformats.org/drawingml/2006/main"/>
+          <a:ln xmlns:a="http://schemas.openxmlformats.org/drawingml/2006/main" w="0">
+            <a:noFill/>
+            <a:prstDash val="solid"/>
+          </a:ln>
+        </p:spPr>
+        <p:txBody>
+          <a:bodyPr xmlns:a="http://schemas.openxmlformats.org/drawingml/2006/main"/>
+          <a:lstStyle xmlns:a="http://schemas.openxmlformats.org/drawingml/2006/main"/>
+          <a:p xmlns:a="http://schemas.openxmlformats.org/drawingml/2006/main">
+            <a:pPr algn="l">
+              <a:buNone/>
+              <a:defRPr sz="1350" b="1">
+                <a:solidFill>
+                  <a:srgbClr val="D8FF55"/>
+                </a:solidFill>
+              </a:defRPr>
+            </a:pPr>
+            <a:r>
+              <a:rPr sz="1350" b="1">
+                <a:solidFill>
+                  <a:srgbClr val="D8FF55"/>
+                </a:solidFill>
+              </a:rPr>
+              <a:t>aibuildcrew.badlabz.com</a:t>
+            </a:r>
+          </a:p>
+        </p:txBody>
+      </p:sp>
+      <p:sp>
+        <p:nvSpPr>
+          <p:cNvPr id="18" name="">
+            <a:extLst xmlns:a="http://schemas.openxmlformats.org/drawingml/2006/main">
+              <a:ext uri="{FF2B5EF4-FFF2-40B4-BE49-F238E27FC236}">
+                <a16:creationId xmlns:a16="http://schemas.microsoft.com/office/drawing/2014/main" id="{5CBB6A72-5DD2-496B-8633-E9890D3CD892}"/>
+              </a:ext>
+            </a:extLst>
+          </p:cNvPr>
+          <p:cNvSpPr>
+            <a:spLocks xmlns:a="http://schemas.openxmlformats.org/drawingml/2006/main" noGrp="1"/>
+          </p:cNvSpPr>
+          <p:nvPr/>
+        </p:nvSpPr>
+        <p:spPr>
+          <a:xfrm xmlns:a="http://schemas.openxmlformats.org/drawingml/2006/main">
+            <a:off x="685800" y="6362700"/>
+            <a:ext cx="4095750" cy="209550"/>
+          </a:xfrm>
+          <a:prstGeom xmlns:a="http://schemas.openxmlformats.org/drawingml/2006/main" prst="rect">
+            <a:avLst/>
+          </a:prstGeom>
+          <a:noFill xmlns:a="http://schemas.openxmlformats.org/drawingml/2006/main"/>
+          <a:ln xmlns:a="http://schemas.openxmlformats.org/drawingml/2006/main" w="0">
+            <a:noFill/>
+            <a:prstDash val="solid"/>
+          </a:ln>
+        </p:spPr>
+        <p:txBody>
+          <a:bodyPr xmlns:a="http://schemas.openxmlformats.org/drawingml/2006/main"/>
+          <a:lstStyle xmlns:a="http://schemas.openxmlformats.org/drawingml/2006/main"/>
+          <a:p xmlns:a="http://schemas.openxmlformats.org/drawingml/2006/main">
+            <a:pPr algn="l">
+              <a:buNone/>
+              <a:defRPr sz="975" b="0">
+                <a:solidFill>
+                  <a:srgbClr val="C8D1C8"/>
+                </a:solidFill>
+              </a:defRPr>
+            </a:pPr>
+            <a:r>
+              <a:rPr sz="975" b="0">
+                <a:solidFill>
+                  <a:srgbClr val="C8D1C8"/>
+                </a:solidFill>
+              </a:rPr>
+              <a:t>github.com/CTATX/ai-build-crew</a:t>
+            </a:r>
+          </a:p>
+        </p:txBody>
+      </p:sp>
+    </p:spTree>
+    <p:extLst>
+      <p:ext uri="{BB962C8B-B14F-4D97-AF65-F5344CB8AC3E}">
+        <p14:creationId xmlns:p14="http://schemas.microsoft.com/office/powerpoint/2010/main" val="2139355806"/>
       </p:ext>
     </p:extLst>
   </p:cSld>
@@ -4948,7 +7600,7 @@
         </p:xfrm>
         <a:graphic xmlns:a="http://schemas.openxmlformats.org/drawingml/2006/main">
           <a:graphicData uri="http://schemas.openxmlformats.org/drawingml/2006/chart">
-            <c:chart xmlns:r="http://schemas.openxmlformats.org/officeDocument/2006/relationships" xmlns:c="http://schemas.openxmlformats.org/drawingml/2006/chart" r:id="Rad4ac44828e04006"/>
+            <c:chart xmlns:r="http://schemas.openxmlformats.org/officeDocument/2006/relationships" xmlns:c="http://schemas.openxmlformats.org/drawingml/2006/chart" r:id="R04c1eac78a3c480b"/>
           </a:graphicData>
         </a:graphic>
       </p:graphicFrame>
@@ -7928,7 +10580,7 @@
           <p:nvPr/>
         </p:nvPicPr>
         <p:blipFill>
-          <a:blip xmlns:r="http://schemas.openxmlformats.org/officeDocument/2006/relationships" xmlns:a="http://schemas.openxmlformats.org/drawingml/2006/main" r:embed="R88a9ffeee49c4f9d"/>
+          <a:blip xmlns:r="http://schemas.openxmlformats.org/officeDocument/2006/relationships" xmlns:a="http://schemas.openxmlformats.org/drawingml/2006/main" r:embed="R1fa3f6720400422f"/>
           <a:srcRect xmlns:a="http://schemas.openxmlformats.org/drawingml/2006/main" l="0" t="27" r="0" b="27"/>
           <a:stretch xmlns:a="http://schemas.openxmlformats.org/drawingml/2006/main">
             <a:fillRect l="0" t="0" r="0" b="0"/>
@@ -8735,6 +11387,1051 @@
     <p:extLst>
       <p:ext uri="{BB962C8B-B14F-4D97-AF65-F5344CB8AC3E}">
         <p14:creationId xmlns:p14="http://schemas.microsoft.com/office/powerpoint/2010/main" val="2139355806"/>
+      </p:ext>
+    </p:extLst>
+  </p:cSld>
+</p:sld>
+</file>
+
+<file path=ppt/slides/slide9.xml><?xml version="1.0" encoding="utf-8"?>
+<p:sld xmlns:p="http://schemas.openxmlformats.org/presentationml/2006/main">
+  <p:cSld>
+    <p:bg>
+      <p:bgPr>
+        <a:solidFill xmlns:a="http://schemas.openxmlformats.org/drawingml/2006/main">
+          <a:srgbClr val="F3EFE5"/>
+        </a:solidFill>
+      </p:bgPr>
+    </p:bg>
+    <p:spTree>
+      <p:nvGrpSpPr>
+        <p:cNvPr id="1" name=""/>
+        <p:cNvGrpSpPr/>
+        <p:nvPr/>
+      </p:nvGrpSpPr>
+      <p:grpSpPr>
+        <a:xfrm xmlns:a="http://schemas.openxmlformats.org/drawingml/2006/main"/>
+      </p:grpSpPr>
+      <p:sp>
+        <p:nvSpPr>
+          <p:cNvPr id="23" name="">
+            <a:extLst xmlns:a="http://schemas.openxmlformats.org/drawingml/2006/main">
+              <a:ext uri="{FF2B5EF4-FFF2-40B4-BE49-F238E27FC236}">
+                <a16:creationId xmlns:a16="http://schemas.microsoft.com/office/drawing/2014/main" id="{F595416C-835D-435F-BC12-610E6A00EEB6}"/>
+              </a:ext>
+            </a:extLst>
+          </p:cNvPr>
+          <p:cNvSpPr>
+            <a:spLocks xmlns:a="http://schemas.openxmlformats.org/drawingml/2006/main" noGrp="1"/>
+          </p:cNvSpPr>
+          <p:nvPr/>
+        </p:nvSpPr>
+        <p:spPr>
+          <a:xfrm xmlns:a="http://schemas.openxmlformats.org/drawingml/2006/main">
+            <a:off x="685800" y="457200"/>
+            <a:ext cx="514350" cy="266700"/>
+          </a:xfrm>
+          <a:prstGeom xmlns:a="http://schemas.openxmlformats.org/drawingml/2006/main" prst="rect">
+            <a:avLst/>
+          </a:prstGeom>
+          <a:noFill xmlns:a="http://schemas.openxmlformats.org/drawingml/2006/main"/>
+          <a:ln xmlns:a="http://schemas.openxmlformats.org/drawingml/2006/main" w="0">
+            <a:noFill/>
+            <a:prstDash val="solid"/>
+          </a:ln>
+        </p:spPr>
+        <p:txBody>
+          <a:bodyPr xmlns:a="http://schemas.openxmlformats.org/drawingml/2006/main"/>
+          <a:lstStyle xmlns:a="http://schemas.openxmlformats.org/drawingml/2006/main"/>
+          <a:p xmlns:a="http://schemas.openxmlformats.org/drawingml/2006/main">
+            <a:pPr algn="l">
+              <a:buNone/>
+              <a:defRPr sz="975" b="1">
+                <a:solidFill>
+                  <a:srgbClr val="8F7BFF"/>
+                </a:solidFill>
+              </a:defRPr>
+            </a:pPr>
+            <a:r>
+              <a:rPr sz="975" b="1">
+                <a:solidFill>
+                  <a:srgbClr val="8F7BFF"/>
+                </a:solidFill>
+              </a:rPr>
+              <a:t>07</a:t>
+            </a:r>
+          </a:p>
+        </p:txBody>
+      </p:sp>
+      <p:sp>
+        <p:nvSpPr>
+          <p:cNvPr id="2" name="">
+            <a:extLst xmlns:a="http://schemas.openxmlformats.org/drawingml/2006/main">
+              <a:ext uri="{FF2B5EF4-FFF2-40B4-BE49-F238E27FC236}">
+                <a16:creationId xmlns:a16="http://schemas.microsoft.com/office/drawing/2014/main" id="{D1C0A470-81CC-4128-A843-C3A698DE5035}"/>
+              </a:ext>
+            </a:extLst>
+          </p:cNvPr>
+          <p:cNvSpPr>
+            <a:spLocks xmlns:a="http://schemas.openxmlformats.org/drawingml/2006/main" noGrp="1"/>
+          </p:cNvSpPr>
+          <p:nvPr/>
+        </p:nvSpPr>
+        <p:spPr>
+          <a:xfrm xmlns:a="http://schemas.openxmlformats.org/drawingml/2006/main">
+            <a:off x="1219200" y="457200"/>
+            <a:ext cx="4762500" cy="266700"/>
+          </a:xfrm>
+          <a:prstGeom xmlns:a="http://schemas.openxmlformats.org/drawingml/2006/main" prst="rect">
+            <a:avLst/>
+          </a:prstGeom>
+          <a:noFill xmlns:a="http://schemas.openxmlformats.org/drawingml/2006/main"/>
+          <a:ln xmlns:a="http://schemas.openxmlformats.org/drawingml/2006/main" w="0">
+            <a:noFill/>
+            <a:prstDash val="solid"/>
+          </a:ln>
+        </p:spPr>
+        <p:txBody>
+          <a:bodyPr xmlns:a="http://schemas.openxmlformats.org/drawingml/2006/main"/>
+          <a:lstStyle xmlns:a="http://schemas.openxmlformats.org/drawingml/2006/main"/>
+          <a:p xmlns:a="http://schemas.openxmlformats.org/drawingml/2006/main">
+            <a:pPr algn="l">
+              <a:buNone/>
+              <a:defRPr sz="975" b="1">
+                <a:solidFill>
+                  <a:srgbClr val="152015"/>
+                </a:solidFill>
+              </a:defRPr>
+            </a:pPr>
+            <a:r>
+              <a:rPr sz="975" b="1">
+                <a:solidFill>
+                  <a:srgbClr val="152015"/>
+                </a:solidFill>
+              </a:rPr>
+              <a:t>PHASE 2 · OPERATING MODEL</a:t>
+            </a:r>
+          </a:p>
+        </p:txBody>
+      </p:sp>
+      <p:sp>
+        <p:nvSpPr>
+          <p:cNvPr id="3" name="">
+            <a:extLst xmlns:a="http://schemas.openxmlformats.org/drawingml/2006/main">
+              <a:ext uri="{FF2B5EF4-FFF2-40B4-BE49-F238E27FC236}">
+                <a16:creationId xmlns:a16="http://schemas.microsoft.com/office/drawing/2014/main" id="{55822932-EF21-468D-8B02-B71F4C482449}"/>
+              </a:ext>
+            </a:extLst>
+          </p:cNvPr>
+          <p:cNvSpPr>
+            <a:spLocks xmlns:a="http://schemas.openxmlformats.org/drawingml/2006/main" noGrp="1"/>
+          </p:cNvSpPr>
+          <p:nvPr/>
+        </p:nvSpPr>
+        <p:spPr>
+          <a:xfrm xmlns:a="http://schemas.openxmlformats.org/drawingml/2006/main">
+            <a:off x="685800" y="781050"/>
+            <a:ext cx="10820400" cy="19050"/>
+          </a:xfrm>
+          <a:prstGeom xmlns:a="http://schemas.openxmlformats.org/drawingml/2006/main" prst="rect">
+            <a:avLst/>
+          </a:prstGeom>
+          <a:solidFill xmlns:a="http://schemas.openxmlformats.org/drawingml/2006/main">
+            <a:srgbClr val="CDD0C8"/>
+          </a:solidFill>
+          <a:ln xmlns:a="http://schemas.openxmlformats.org/drawingml/2006/main" w="0">
+            <a:noFill/>
+            <a:prstDash val="solid"/>
+          </a:ln>
+        </p:spPr>
+      </p:sp>
+      <p:sp>
+        <p:nvSpPr>
+          <p:cNvPr id="4" name="">
+            <a:extLst xmlns:a="http://schemas.openxmlformats.org/drawingml/2006/main">
+              <a:ext uri="{FF2B5EF4-FFF2-40B4-BE49-F238E27FC236}">
+                <a16:creationId xmlns:a16="http://schemas.microsoft.com/office/drawing/2014/main" id="{0A5A30F2-A980-4F8E-901F-F23233E02BEF}"/>
+              </a:ext>
+            </a:extLst>
+          </p:cNvPr>
+          <p:cNvSpPr>
+            <a:spLocks xmlns:a="http://schemas.openxmlformats.org/drawingml/2006/main" noGrp="1"/>
+          </p:cNvSpPr>
+          <p:nvPr/>
+        </p:nvSpPr>
+        <p:spPr>
+          <a:xfrm xmlns:a="http://schemas.openxmlformats.org/drawingml/2006/main">
+            <a:off x="685800" y="1123950"/>
+            <a:ext cx="7429500" cy="1028700"/>
+          </a:xfrm>
+          <a:prstGeom xmlns:a="http://schemas.openxmlformats.org/drawingml/2006/main" prst="rect">
+            <a:avLst/>
+          </a:prstGeom>
+          <a:noFill xmlns:a="http://schemas.openxmlformats.org/drawingml/2006/main"/>
+          <a:ln xmlns:a="http://schemas.openxmlformats.org/drawingml/2006/main" w="0">
+            <a:noFill/>
+            <a:prstDash val="solid"/>
+          </a:ln>
+        </p:spPr>
+        <p:txBody>
+          <a:bodyPr xmlns:a="http://schemas.openxmlformats.org/drawingml/2006/main"/>
+          <a:lstStyle xmlns:a="http://schemas.openxmlformats.org/drawingml/2006/main"/>
+          <a:p xmlns:a="http://schemas.openxmlformats.org/drawingml/2006/main">
+            <a:pPr algn="l">
+              <a:buNone/>
+              <a:defRPr sz="3300" b="1">
+                <a:solidFill>
+                  <a:srgbClr val="152015"/>
+                </a:solidFill>
+              </a:defRPr>
+            </a:pPr>
+            <a:r>
+              <a:rPr sz="3300" b="1">
+                <a:solidFill>
+                  <a:srgbClr val="152015"/>
+                </a:solidFill>
+              </a:rPr>
+              <a:t>One brief becomes a controlled</a:t>
+            </a:r>
+          </a:p>
+          <a:p xmlns:a="http://schemas.openxmlformats.org/drawingml/2006/main">
+            <a:pPr algn="l">
+              <a:buNone/>
+              <a:defRPr sz="3300" b="1">
+                <a:solidFill>
+                  <a:srgbClr val="152015"/>
+                </a:solidFill>
+              </a:defRPr>
+            </a:pPr>
+            <a:r>
+              <a:rPr sz="3300" b="1">
+                <a:solidFill>
+                  <a:srgbClr val="152015"/>
+                </a:solidFill>
+              </a:rPr>
+              <a:t>provider comparison.</a:t>
+            </a:r>
+          </a:p>
+        </p:txBody>
+      </p:sp>
+      <p:sp>
+        <p:nvSpPr>
+          <p:cNvPr id="5" name="">
+            <a:extLst xmlns:a="http://schemas.openxmlformats.org/drawingml/2006/main">
+              <a:ext uri="{FF2B5EF4-FFF2-40B4-BE49-F238E27FC236}">
+                <a16:creationId xmlns:a16="http://schemas.microsoft.com/office/drawing/2014/main" id="{C76F5C34-5E74-4C1C-8437-2F1389791FA5}"/>
+              </a:ext>
+            </a:extLst>
+          </p:cNvPr>
+          <p:cNvSpPr>
+            <a:spLocks xmlns:a="http://schemas.openxmlformats.org/drawingml/2006/main" noGrp="1"/>
+          </p:cNvSpPr>
+          <p:nvPr/>
+        </p:nvSpPr>
+        <p:spPr>
+          <a:xfrm xmlns:a="http://schemas.openxmlformats.org/drawingml/2006/main">
+            <a:off x="685800" y="2857500"/>
+            <a:ext cx="3048000" cy="2266950"/>
+          </a:xfrm>
+          <a:prstGeom xmlns:a="http://schemas.openxmlformats.org/drawingml/2006/main" prst="roundRect">
+            <a:avLst>
+              <a:gd name="adj" fmla="val 8403"/>
+            </a:avLst>
+          </a:prstGeom>
+          <a:solidFill xmlns:a="http://schemas.openxmlformats.org/drawingml/2006/main">
+            <a:srgbClr val="FFFFFF"/>
+          </a:solidFill>
+          <a:ln xmlns:a="http://schemas.openxmlformats.org/drawingml/2006/main" w="9525">
+            <a:solidFill>
+              <a:srgbClr val="CDD0C8"/>
+            </a:solidFill>
+            <a:prstDash val="solid"/>
+          </a:ln>
+        </p:spPr>
+      </p:sp>
+      <p:sp>
+        <p:nvSpPr>
+          <p:cNvPr id="6" name="">
+            <a:extLst xmlns:a="http://schemas.openxmlformats.org/drawingml/2006/main">
+              <a:ext uri="{FF2B5EF4-FFF2-40B4-BE49-F238E27FC236}">
+                <a16:creationId xmlns:a16="http://schemas.microsoft.com/office/drawing/2014/main" id="{FA4374CB-4474-4B5A-AC33-B973B5BD8692}"/>
+              </a:ext>
+            </a:extLst>
+          </p:cNvPr>
+          <p:cNvSpPr>
+            <a:spLocks xmlns:a="http://schemas.openxmlformats.org/drawingml/2006/main" noGrp="1"/>
+          </p:cNvSpPr>
+          <p:nvPr/>
+        </p:nvSpPr>
+        <p:spPr>
+          <a:xfrm xmlns:a="http://schemas.openxmlformats.org/drawingml/2006/main">
+            <a:off x="914400" y="3095625"/>
+            <a:ext cx="438150" cy="438150"/>
+          </a:xfrm>
+          <a:prstGeom xmlns:a="http://schemas.openxmlformats.org/drawingml/2006/main" prst="roundRect">
+            <a:avLst>
+              <a:gd name="adj" fmla="val 50000"/>
+            </a:avLst>
+          </a:prstGeom>
+          <a:solidFill xmlns:a="http://schemas.openxmlformats.org/drawingml/2006/main">
+            <a:srgbClr val="D8FF55"/>
+          </a:solidFill>
+          <a:ln xmlns:a="http://schemas.openxmlformats.org/drawingml/2006/main" w="0">
+            <a:noFill/>
+            <a:prstDash val="solid"/>
+          </a:ln>
+        </p:spPr>
+      </p:sp>
+      <p:sp>
+        <p:nvSpPr>
+          <p:cNvPr id="7" name="">
+            <a:extLst xmlns:a="http://schemas.openxmlformats.org/drawingml/2006/main">
+              <a:ext uri="{FF2B5EF4-FFF2-40B4-BE49-F238E27FC236}">
+                <a16:creationId xmlns:a16="http://schemas.microsoft.com/office/drawing/2014/main" id="{46ECE422-DC44-47CC-8F1A-D4DA4C4D48A0}"/>
+              </a:ext>
+            </a:extLst>
+          </p:cNvPr>
+          <p:cNvSpPr>
+            <a:spLocks xmlns:a="http://schemas.openxmlformats.org/drawingml/2006/main" noGrp="1"/>
+          </p:cNvSpPr>
+          <p:nvPr/>
+        </p:nvSpPr>
+        <p:spPr>
+          <a:xfrm xmlns:a="http://schemas.openxmlformats.org/drawingml/2006/main">
+            <a:off x="914400" y="3171825"/>
+            <a:ext cx="438150" cy="228600"/>
+          </a:xfrm>
+          <a:prstGeom xmlns:a="http://schemas.openxmlformats.org/drawingml/2006/main" prst="rect">
+            <a:avLst/>
+          </a:prstGeom>
+          <a:noFill xmlns:a="http://schemas.openxmlformats.org/drawingml/2006/main"/>
+          <a:ln xmlns:a="http://schemas.openxmlformats.org/drawingml/2006/main" w="0">
+            <a:noFill/>
+            <a:prstDash val="solid"/>
+          </a:ln>
+        </p:spPr>
+        <p:txBody>
+          <a:bodyPr xmlns:a="http://schemas.openxmlformats.org/drawingml/2006/main"/>
+          <a:lstStyle xmlns:a="http://schemas.openxmlformats.org/drawingml/2006/main"/>
+          <a:p xmlns:a="http://schemas.openxmlformats.org/drawingml/2006/main">
+            <a:pPr algn="ctr">
+              <a:buNone/>
+              <a:defRPr sz="1200" b="1">
+                <a:solidFill>
+                  <a:srgbClr val="152015"/>
+                </a:solidFill>
+              </a:defRPr>
+            </a:pPr>
+            <a:r>
+              <a:rPr sz="1200" b="1">
+                <a:solidFill>
+                  <a:srgbClr val="152015"/>
+                </a:solidFill>
+              </a:rPr>
+              <a:t>1</a:t>
+            </a:r>
+          </a:p>
+        </p:txBody>
+      </p:sp>
+      <p:sp>
+        <p:nvSpPr>
+          <p:cNvPr id="8" name="">
+            <a:extLst xmlns:a="http://schemas.openxmlformats.org/drawingml/2006/main">
+              <a:ext uri="{FF2B5EF4-FFF2-40B4-BE49-F238E27FC236}">
+                <a16:creationId xmlns:a16="http://schemas.microsoft.com/office/drawing/2014/main" id="{3167DCDE-8D59-4BEB-B3AB-6992467AFC2A}"/>
+              </a:ext>
+            </a:extLst>
+          </p:cNvPr>
+          <p:cNvSpPr>
+            <a:spLocks xmlns:a="http://schemas.openxmlformats.org/drawingml/2006/main" noGrp="1"/>
+          </p:cNvSpPr>
+          <p:nvPr/>
+        </p:nvSpPr>
+        <p:spPr>
+          <a:xfrm xmlns:a="http://schemas.openxmlformats.org/drawingml/2006/main">
+            <a:off x="914400" y="3781425"/>
+            <a:ext cx="2286000" cy="266700"/>
+          </a:xfrm>
+          <a:prstGeom xmlns:a="http://schemas.openxmlformats.org/drawingml/2006/main" prst="rect">
+            <a:avLst/>
+          </a:prstGeom>
+          <a:noFill xmlns:a="http://schemas.openxmlformats.org/drawingml/2006/main"/>
+          <a:ln xmlns:a="http://schemas.openxmlformats.org/drawingml/2006/main" w="0">
+            <a:noFill/>
+            <a:prstDash val="solid"/>
+          </a:ln>
+        </p:spPr>
+        <p:txBody>
+          <a:bodyPr xmlns:a="http://schemas.openxmlformats.org/drawingml/2006/main"/>
+          <a:lstStyle xmlns:a="http://schemas.openxmlformats.org/drawingml/2006/main"/>
+          <a:p xmlns:a="http://schemas.openxmlformats.org/drawingml/2006/main">
+            <a:pPr algn="l">
+              <a:buNone/>
+              <a:defRPr sz="1125" b="1">
+                <a:solidFill>
+                  <a:srgbClr val="8F7BFF"/>
+                </a:solidFill>
+              </a:defRPr>
+            </a:pPr>
+            <a:r>
+              <a:rPr sz="1125" b="1">
+                <a:solidFill>
+                  <a:srgbClr val="8F7BFF"/>
+                </a:solidFill>
+              </a:rPr>
+              <a:t>CONTROL</a:t>
+            </a:r>
+          </a:p>
+        </p:txBody>
+      </p:sp>
+      <p:sp>
+        <p:nvSpPr>
+          <p:cNvPr id="9" name="">
+            <a:extLst xmlns:a="http://schemas.openxmlformats.org/drawingml/2006/main">
+              <a:ext uri="{FF2B5EF4-FFF2-40B4-BE49-F238E27FC236}">
+                <a16:creationId xmlns:a16="http://schemas.microsoft.com/office/drawing/2014/main" id="{81CF3EF3-74C5-4C07-A253-896873C4989E}"/>
+              </a:ext>
+            </a:extLst>
+          </p:cNvPr>
+          <p:cNvSpPr>
+            <a:spLocks xmlns:a="http://schemas.openxmlformats.org/drawingml/2006/main" noGrp="1"/>
+          </p:cNvSpPr>
+          <p:nvPr/>
+        </p:nvSpPr>
+        <p:spPr>
+          <a:xfrm xmlns:a="http://schemas.openxmlformats.org/drawingml/2006/main">
+            <a:off x="914400" y="4238625"/>
+            <a:ext cx="2571750" cy="800100"/>
+          </a:xfrm>
+          <a:prstGeom xmlns:a="http://schemas.openxmlformats.org/drawingml/2006/main" prst="rect">
+            <a:avLst/>
+          </a:prstGeom>
+          <a:noFill xmlns:a="http://schemas.openxmlformats.org/drawingml/2006/main"/>
+          <a:ln xmlns:a="http://schemas.openxmlformats.org/drawingml/2006/main" w="0">
+            <a:noFill/>
+            <a:prstDash val="solid"/>
+          </a:ln>
+        </p:spPr>
+        <p:txBody>
+          <a:bodyPr xmlns:a="http://schemas.openxmlformats.org/drawingml/2006/main"/>
+          <a:lstStyle xmlns:a="http://schemas.openxmlformats.org/drawingml/2006/main"/>
+          <a:p xmlns:a="http://schemas.openxmlformats.org/drawingml/2006/main">
+            <a:pPr algn="l">
+              <a:buNone/>
+              <a:defRPr sz="1425" b="0">
+                <a:solidFill>
+                  <a:srgbClr val="152015"/>
+                </a:solidFill>
+              </a:defRPr>
+            </a:pPr>
+            <a:r>
+              <a:rPr sz="1425" b="0">
+                <a:solidFill>
+                  <a:srgbClr val="152015"/>
+                </a:solidFill>
+              </a:rPr>
+              <a:t>Freeze the confirmed workload, formats, risk, and spend limit.</a:t>
+            </a:r>
+          </a:p>
+        </p:txBody>
+      </p:sp>
+      <p:sp>
+        <p:nvSpPr>
+          <p:cNvPr id="10" name="">
+            <a:extLst xmlns:a="http://schemas.openxmlformats.org/drawingml/2006/main">
+              <a:ext uri="{FF2B5EF4-FFF2-40B4-BE49-F238E27FC236}">
+                <a16:creationId xmlns:a16="http://schemas.microsoft.com/office/drawing/2014/main" id="{9675C56A-026E-439E-93C7-3AC237103AAA}"/>
+              </a:ext>
+            </a:extLst>
+          </p:cNvPr>
+          <p:cNvSpPr>
+            <a:spLocks xmlns:a="http://schemas.openxmlformats.org/drawingml/2006/main" noGrp="1"/>
+          </p:cNvSpPr>
+          <p:nvPr/>
+        </p:nvSpPr>
+        <p:spPr>
+          <a:xfrm xmlns:a="http://schemas.openxmlformats.org/drawingml/2006/main">
+            <a:off x="4276725" y="2857500"/>
+            <a:ext cx="3048000" cy="2266950"/>
+          </a:xfrm>
+          <a:prstGeom xmlns:a="http://schemas.openxmlformats.org/drawingml/2006/main" prst="roundRect">
+            <a:avLst>
+              <a:gd name="adj" fmla="val 8403"/>
+            </a:avLst>
+          </a:prstGeom>
+          <a:solidFill xmlns:a="http://schemas.openxmlformats.org/drawingml/2006/main">
+            <a:srgbClr val="152015"/>
+          </a:solidFill>
+          <a:ln xmlns:a="http://schemas.openxmlformats.org/drawingml/2006/main" w="0">
+            <a:noFill/>
+            <a:prstDash val="solid"/>
+          </a:ln>
+        </p:spPr>
+      </p:sp>
+      <p:sp>
+        <p:nvSpPr>
+          <p:cNvPr id="11" name="">
+            <a:extLst xmlns:a="http://schemas.openxmlformats.org/drawingml/2006/main">
+              <a:ext uri="{FF2B5EF4-FFF2-40B4-BE49-F238E27FC236}">
+                <a16:creationId xmlns:a16="http://schemas.microsoft.com/office/drawing/2014/main" id="{B1E67260-98F0-4F3C-80A5-3D31811DDCFD}"/>
+              </a:ext>
+            </a:extLst>
+          </p:cNvPr>
+          <p:cNvSpPr>
+            <a:spLocks xmlns:a="http://schemas.openxmlformats.org/drawingml/2006/main" noGrp="1"/>
+          </p:cNvSpPr>
+          <p:nvPr/>
+        </p:nvSpPr>
+        <p:spPr>
+          <a:xfrm xmlns:a="http://schemas.openxmlformats.org/drawingml/2006/main">
+            <a:off x="4505325" y="3095625"/>
+            <a:ext cx="438150" cy="438150"/>
+          </a:xfrm>
+          <a:prstGeom xmlns:a="http://schemas.openxmlformats.org/drawingml/2006/main" prst="roundRect">
+            <a:avLst>
+              <a:gd name="adj" fmla="val 50000"/>
+            </a:avLst>
+          </a:prstGeom>
+          <a:solidFill xmlns:a="http://schemas.openxmlformats.org/drawingml/2006/main">
+            <a:srgbClr val="8F7BFF"/>
+          </a:solidFill>
+          <a:ln xmlns:a="http://schemas.openxmlformats.org/drawingml/2006/main" w="0">
+            <a:noFill/>
+            <a:prstDash val="solid"/>
+          </a:ln>
+        </p:spPr>
+      </p:sp>
+      <p:sp>
+        <p:nvSpPr>
+          <p:cNvPr id="12" name="">
+            <a:extLst xmlns:a="http://schemas.openxmlformats.org/drawingml/2006/main">
+              <a:ext uri="{FF2B5EF4-FFF2-40B4-BE49-F238E27FC236}">
+                <a16:creationId xmlns:a16="http://schemas.microsoft.com/office/drawing/2014/main" id="{166A3942-AAD4-48E2-9026-A29FC8EF509D}"/>
+              </a:ext>
+            </a:extLst>
+          </p:cNvPr>
+          <p:cNvSpPr>
+            <a:spLocks xmlns:a="http://schemas.openxmlformats.org/drawingml/2006/main" noGrp="1"/>
+          </p:cNvSpPr>
+          <p:nvPr/>
+        </p:nvSpPr>
+        <p:spPr>
+          <a:xfrm xmlns:a="http://schemas.openxmlformats.org/drawingml/2006/main">
+            <a:off x="4505325" y="3171825"/>
+            <a:ext cx="438150" cy="228600"/>
+          </a:xfrm>
+          <a:prstGeom xmlns:a="http://schemas.openxmlformats.org/drawingml/2006/main" prst="rect">
+            <a:avLst/>
+          </a:prstGeom>
+          <a:noFill xmlns:a="http://schemas.openxmlformats.org/drawingml/2006/main"/>
+          <a:ln xmlns:a="http://schemas.openxmlformats.org/drawingml/2006/main" w="0">
+            <a:noFill/>
+            <a:prstDash val="solid"/>
+          </a:ln>
+        </p:spPr>
+        <p:txBody>
+          <a:bodyPr xmlns:a="http://schemas.openxmlformats.org/drawingml/2006/main"/>
+          <a:lstStyle xmlns:a="http://schemas.openxmlformats.org/drawingml/2006/main"/>
+          <a:p xmlns:a="http://schemas.openxmlformats.org/drawingml/2006/main">
+            <a:pPr algn="ctr">
+              <a:buNone/>
+              <a:defRPr sz="1200" b="1">
+                <a:solidFill>
+                  <a:srgbClr val="152015"/>
+                </a:solidFill>
+              </a:defRPr>
+            </a:pPr>
+            <a:r>
+              <a:rPr sz="1200" b="1">
+                <a:solidFill>
+                  <a:srgbClr val="152015"/>
+                </a:solidFill>
+              </a:rPr>
+              <a:t>2</a:t>
+            </a:r>
+          </a:p>
+        </p:txBody>
+      </p:sp>
+      <p:sp>
+        <p:nvSpPr>
+          <p:cNvPr id="13" name="">
+            <a:extLst xmlns:a="http://schemas.openxmlformats.org/drawingml/2006/main">
+              <a:ext uri="{FF2B5EF4-FFF2-40B4-BE49-F238E27FC236}">
+                <a16:creationId xmlns:a16="http://schemas.microsoft.com/office/drawing/2014/main" id="{D6C8AC39-F317-42D8-A4D9-4108B789B5B7}"/>
+              </a:ext>
+            </a:extLst>
+          </p:cNvPr>
+          <p:cNvSpPr>
+            <a:spLocks xmlns:a="http://schemas.openxmlformats.org/drawingml/2006/main" noGrp="1"/>
+          </p:cNvSpPr>
+          <p:nvPr/>
+        </p:nvSpPr>
+        <p:spPr>
+          <a:xfrm xmlns:a="http://schemas.openxmlformats.org/drawingml/2006/main">
+            <a:off x="4505325" y="3781425"/>
+            <a:ext cx="2286000" cy="266700"/>
+          </a:xfrm>
+          <a:prstGeom xmlns:a="http://schemas.openxmlformats.org/drawingml/2006/main" prst="rect">
+            <a:avLst/>
+          </a:prstGeom>
+          <a:noFill xmlns:a="http://schemas.openxmlformats.org/drawingml/2006/main"/>
+          <a:ln xmlns:a="http://schemas.openxmlformats.org/drawingml/2006/main" w="0">
+            <a:noFill/>
+            <a:prstDash val="solid"/>
+          </a:ln>
+        </p:spPr>
+        <p:txBody>
+          <a:bodyPr xmlns:a="http://schemas.openxmlformats.org/drawingml/2006/main"/>
+          <a:lstStyle xmlns:a="http://schemas.openxmlformats.org/drawingml/2006/main"/>
+          <a:p xmlns:a="http://schemas.openxmlformats.org/drawingml/2006/main">
+            <a:pPr algn="l">
+              <a:buNone/>
+              <a:defRPr sz="1125" b="1">
+                <a:solidFill>
+                  <a:srgbClr val="D8FF55"/>
+                </a:solidFill>
+              </a:defRPr>
+            </a:pPr>
+            <a:r>
+              <a:rPr sz="1125" b="1">
+                <a:solidFill>
+                  <a:srgbClr val="D8FF55"/>
+                </a:solidFill>
+              </a:rPr>
+              <a:t>RUN</a:t>
+            </a:r>
+          </a:p>
+        </p:txBody>
+      </p:sp>
+      <p:sp>
+        <p:nvSpPr>
+          <p:cNvPr id="14" name="">
+            <a:extLst xmlns:a="http://schemas.openxmlformats.org/drawingml/2006/main">
+              <a:ext uri="{FF2B5EF4-FFF2-40B4-BE49-F238E27FC236}">
+                <a16:creationId xmlns:a16="http://schemas.microsoft.com/office/drawing/2014/main" id="{65D36F35-26C8-447A-B870-E786D4BC8409}"/>
+              </a:ext>
+            </a:extLst>
+          </p:cNvPr>
+          <p:cNvSpPr>
+            <a:spLocks xmlns:a="http://schemas.openxmlformats.org/drawingml/2006/main" noGrp="1"/>
+          </p:cNvSpPr>
+          <p:nvPr/>
+        </p:nvSpPr>
+        <p:spPr>
+          <a:xfrm xmlns:a="http://schemas.openxmlformats.org/drawingml/2006/main">
+            <a:off x="4505325" y="4238625"/>
+            <a:ext cx="2571750" cy="800100"/>
+          </a:xfrm>
+          <a:prstGeom xmlns:a="http://schemas.openxmlformats.org/drawingml/2006/main" prst="rect">
+            <a:avLst/>
+          </a:prstGeom>
+          <a:noFill xmlns:a="http://schemas.openxmlformats.org/drawingml/2006/main"/>
+          <a:ln xmlns:a="http://schemas.openxmlformats.org/drawingml/2006/main" w="0">
+            <a:noFill/>
+            <a:prstDash val="solid"/>
+          </a:ln>
+        </p:spPr>
+        <p:txBody>
+          <a:bodyPr xmlns:a="http://schemas.openxmlformats.org/drawingml/2006/main"/>
+          <a:lstStyle xmlns:a="http://schemas.openxmlformats.org/drawingml/2006/main"/>
+          <a:p xmlns:a="http://schemas.openxmlformats.org/drawingml/2006/main">
+            <a:pPr algn="l">
+              <a:buNone/>
+              <a:defRPr sz="1425" b="0">
+                <a:solidFill>
+                  <a:srgbClr val="FFFFFF"/>
+                </a:solidFill>
+              </a:defRPr>
+            </a:pPr>
+            <a:r>
+              <a:rPr sz="1425" b="0">
+                <a:solidFill>
+                  <a:srgbClr val="FFFFFF"/>
+                </a:solidFill>
+              </a:rPr>
+              <a:t>Provider runners use the same sealed case—only after approval.</a:t>
+            </a:r>
+          </a:p>
+        </p:txBody>
+      </p:sp>
+      <p:sp>
+        <p:nvSpPr>
+          <p:cNvPr id="15" name="">
+            <a:extLst xmlns:a="http://schemas.openxmlformats.org/drawingml/2006/main">
+              <a:ext uri="{FF2B5EF4-FFF2-40B4-BE49-F238E27FC236}">
+                <a16:creationId xmlns:a16="http://schemas.microsoft.com/office/drawing/2014/main" id="{D99E029B-5297-4AE3-82DA-6975A2A91EB1}"/>
+              </a:ext>
+            </a:extLst>
+          </p:cNvPr>
+          <p:cNvSpPr>
+            <a:spLocks xmlns:a="http://schemas.openxmlformats.org/drawingml/2006/main" noGrp="1"/>
+          </p:cNvSpPr>
+          <p:nvPr/>
+        </p:nvSpPr>
+        <p:spPr>
+          <a:xfrm xmlns:a="http://schemas.openxmlformats.org/drawingml/2006/main">
+            <a:off x="7867650" y="2857500"/>
+            <a:ext cx="3048000" cy="2266950"/>
+          </a:xfrm>
+          <a:prstGeom xmlns:a="http://schemas.openxmlformats.org/drawingml/2006/main" prst="roundRect">
+            <a:avLst>
+              <a:gd name="adj" fmla="val 8403"/>
+            </a:avLst>
+          </a:prstGeom>
+          <a:solidFill xmlns:a="http://schemas.openxmlformats.org/drawingml/2006/main">
+            <a:srgbClr val="FFFFFF"/>
+          </a:solidFill>
+          <a:ln xmlns:a="http://schemas.openxmlformats.org/drawingml/2006/main" w="9525">
+            <a:solidFill>
+              <a:srgbClr val="CDD0C8"/>
+            </a:solidFill>
+            <a:prstDash val="solid"/>
+          </a:ln>
+        </p:spPr>
+      </p:sp>
+      <p:sp>
+        <p:nvSpPr>
+          <p:cNvPr id="16" name="">
+            <a:extLst xmlns:a="http://schemas.openxmlformats.org/drawingml/2006/main">
+              <a:ext uri="{FF2B5EF4-FFF2-40B4-BE49-F238E27FC236}">
+                <a16:creationId xmlns:a16="http://schemas.microsoft.com/office/drawing/2014/main" id="{8C241CF8-2770-4B71-9566-A38260E96F28}"/>
+              </a:ext>
+            </a:extLst>
+          </p:cNvPr>
+          <p:cNvSpPr>
+            <a:spLocks xmlns:a="http://schemas.openxmlformats.org/drawingml/2006/main" noGrp="1"/>
+          </p:cNvSpPr>
+          <p:nvPr/>
+        </p:nvSpPr>
+        <p:spPr>
+          <a:xfrm xmlns:a="http://schemas.openxmlformats.org/drawingml/2006/main">
+            <a:off x="8096250" y="3095625"/>
+            <a:ext cx="438150" cy="438150"/>
+          </a:xfrm>
+          <a:prstGeom xmlns:a="http://schemas.openxmlformats.org/drawingml/2006/main" prst="roundRect">
+            <a:avLst>
+              <a:gd name="adj" fmla="val 50000"/>
+            </a:avLst>
+          </a:prstGeom>
+          <a:solidFill xmlns:a="http://schemas.openxmlformats.org/drawingml/2006/main">
+            <a:srgbClr val="FF8159"/>
+          </a:solidFill>
+          <a:ln xmlns:a="http://schemas.openxmlformats.org/drawingml/2006/main" w="0">
+            <a:noFill/>
+            <a:prstDash val="solid"/>
+          </a:ln>
+        </p:spPr>
+      </p:sp>
+      <p:sp>
+        <p:nvSpPr>
+          <p:cNvPr id="17" name="">
+            <a:extLst xmlns:a="http://schemas.openxmlformats.org/drawingml/2006/main">
+              <a:ext uri="{FF2B5EF4-FFF2-40B4-BE49-F238E27FC236}">
+                <a16:creationId xmlns:a16="http://schemas.microsoft.com/office/drawing/2014/main" id="{4FAB3E40-36FD-4532-A9F4-A2ACBDB3D262}"/>
+              </a:ext>
+            </a:extLst>
+          </p:cNvPr>
+          <p:cNvSpPr>
+            <a:spLocks xmlns:a="http://schemas.openxmlformats.org/drawingml/2006/main" noGrp="1"/>
+          </p:cNvSpPr>
+          <p:nvPr/>
+        </p:nvSpPr>
+        <p:spPr>
+          <a:xfrm xmlns:a="http://schemas.openxmlformats.org/drawingml/2006/main">
+            <a:off x="8096250" y="3171825"/>
+            <a:ext cx="438150" cy="228600"/>
+          </a:xfrm>
+          <a:prstGeom xmlns:a="http://schemas.openxmlformats.org/drawingml/2006/main" prst="rect">
+            <a:avLst/>
+          </a:prstGeom>
+          <a:noFill xmlns:a="http://schemas.openxmlformats.org/drawingml/2006/main"/>
+          <a:ln xmlns:a="http://schemas.openxmlformats.org/drawingml/2006/main" w="0">
+            <a:noFill/>
+            <a:prstDash val="solid"/>
+          </a:ln>
+        </p:spPr>
+        <p:txBody>
+          <a:bodyPr xmlns:a="http://schemas.openxmlformats.org/drawingml/2006/main"/>
+          <a:lstStyle xmlns:a="http://schemas.openxmlformats.org/drawingml/2006/main"/>
+          <a:p xmlns:a="http://schemas.openxmlformats.org/drawingml/2006/main">
+            <a:pPr algn="ctr">
+              <a:buNone/>
+              <a:defRPr sz="1200" b="1">
+                <a:solidFill>
+                  <a:srgbClr val="152015"/>
+                </a:solidFill>
+              </a:defRPr>
+            </a:pPr>
+            <a:r>
+              <a:rPr sz="1200" b="1">
+                <a:solidFill>
+                  <a:srgbClr val="152015"/>
+                </a:solidFill>
+              </a:rPr>
+              <a:t>3</a:t>
+            </a:r>
+          </a:p>
+        </p:txBody>
+      </p:sp>
+      <p:sp>
+        <p:nvSpPr>
+          <p:cNvPr id="18" name="">
+            <a:extLst xmlns:a="http://schemas.openxmlformats.org/drawingml/2006/main">
+              <a:ext uri="{FF2B5EF4-FFF2-40B4-BE49-F238E27FC236}">
+                <a16:creationId xmlns:a16="http://schemas.microsoft.com/office/drawing/2014/main" id="{0A220EAC-9F7A-42E1-B85A-70646B175116}"/>
+              </a:ext>
+            </a:extLst>
+          </p:cNvPr>
+          <p:cNvSpPr>
+            <a:spLocks xmlns:a="http://schemas.openxmlformats.org/drawingml/2006/main" noGrp="1"/>
+          </p:cNvSpPr>
+          <p:nvPr/>
+        </p:nvSpPr>
+        <p:spPr>
+          <a:xfrm xmlns:a="http://schemas.openxmlformats.org/drawingml/2006/main">
+            <a:off x="8096250" y="3781425"/>
+            <a:ext cx="2286000" cy="266700"/>
+          </a:xfrm>
+          <a:prstGeom xmlns:a="http://schemas.openxmlformats.org/drawingml/2006/main" prst="rect">
+            <a:avLst/>
+          </a:prstGeom>
+          <a:noFill xmlns:a="http://schemas.openxmlformats.org/drawingml/2006/main"/>
+          <a:ln xmlns:a="http://schemas.openxmlformats.org/drawingml/2006/main" w="0">
+            <a:noFill/>
+            <a:prstDash val="solid"/>
+          </a:ln>
+        </p:spPr>
+        <p:txBody>
+          <a:bodyPr xmlns:a="http://schemas.openxmlformats.org/drawingml/2006/main"/>
+          <a:lstStyle xmlns:a="http://schemas.openxmlformats.org/drawingml/2006/main"/>
+          <a:p xmlns:a="http://schemas.openxmlformats.org/drawingml/2006/main">
+            <a:pPr algn="l">
+              <a:buNone/>
+              <a:defRPr sz="1125" b="1">
+                <a:solidFill>
+                  <a:srgbClr val="8F7BFF"/>
+                </a:solidFill>
+              </a:defRPr>
+            </a:pPr>
+            <a:r>
+              <a:rPr sz="1125" b="1">
+                <a:solidFill>
+                  <a:srgbClr val="8F7BFF"/>
+                </a:solidFill>
+              </a:rPr>
+              <a:t>PROVE</a:t>
+            </a:r>
+          </a:p>
+        </p:txBody>
+      </p:sp>
+      <p:sp>
+        <p:nvSpPr>
+          <p:cNvPr id="19" name="">
+            <a:extLst xmlns:a="http://schemas.openxmlformats.org/drawingml/2006/main">
+              <a:ext uri="{FF2B5EF4-FFF2-40B4-BE49-F238E27FC236}">
+                <a16:creationId xmlns:a16="http://schemas.microsoft.com/office/drawing/2014/main" id="{1EAE9D48-9B74-4383-9D45-B7361AF48861}"/>
+              </a:ext>
+            </a:extLst>
+          </p:cNvPr>
+          <p:cNvSpPr>
+            <a:spLocks xmlns:a="http://schemas.openxmlformats.org/drawingml/2006/main" noGrp="1"/>
+          </p:cNvSpPr>
+          <p:nvPr/>
+        </p:nvSpPr>
+        <p:spPr>
+          <a:xfrm xmlns:a="http://schemas.openxmlformats.org/drawingml/2006/main">
+            <a:off x="8096250" y="4238625"/>
+            <a:ext cx="2571750" cy="800100"/>
+          </a:xfrm>
+          <a:prstGeom xmlns:a="http://schemas.openxmlformats.org/drawingml/2006/main" prst="rect">
+            <a:avLst/>
+          </a:prstGeom>
+          <a:noFill xmlns:a="http://schemas.openxmlformats.org/drawingml/2006/main"/>
+          <a:ln xmlns:a="http://schemas.openxmlformats.org/drawingml/2006/main" w="0">
+            <a:noFill/>
+            <a:prstDash val="solid"/>
+          </a:ln>
+        </p:spPr>
+        <p:txBody>
+          <a:bodyPr xmlns:a="http://schemas.openxmlformats.org/drawingml/2006/main"/>
+          <a:lstStyle xmlns:a="http://schemas.openxmlformats.org/drawingml/2006/main"/>
+          <a:p xmlns:a="http://schemas.openxmlformats.org/drawingml/2006/main">
+            <a:pPr algn="l">
+              <a:buNone/>
+              <a:defRPr sz="1425" b="0">
+                <a:solidFill>
+                  <a:srgbClr val="152015"/>
+                </a:solidFill>
+              </a:defRPr>
+            </a:pPr>
+            <a:r>
+              <a:rPr sz="1425" b="0">
+                <a:solidFill>
+                  <a:srgbClr val="152015"/>
+                </a:solidFill>
+              </a:rPr>
+              <a:t>Blind scoring, governance, and a point-in-time report make differences visible.</a:t>
+            </a:r>
+          </a:p>
+        </p:txBody>
+      </p:sp>
+      <p:sp>
+        <p:nvSpPr>
+          <p:cNvPr id="20" name="">
+            <a:extLst xmlns:a="http://schemas.openxmlformats.org/drawingml/2006/main">
+              <a:ext uri="{FF2B5EF4-FFF2-40B4-BE49-F238E27FC236}">
+                <a16:creationId xmlns:a16="http://schemas.microsoft.com/office/drawing/2014/main" id="{5027562A-2C6A-4CB9-9D99-BE48BB8FDDBC}"/>
+              </a:ext>
+            </a:extLst>
+          </p:cNvPr>
+          <p:cNvSpPr>
+            <a:spLocks xmlns:a="http://schemas.openxmlformats.org/drawingml/2006/main" noGrp="1"/>
+          </p:cNvSpPr>
+          <p:nvPr/>
+        </p:nvSpPr>
+        <p:spPr>
+          <a:xfrm xmlns:a="http://schemas.openxmlformats.org/drawingml/2006/main">
+            <a:off x="685800" y="5581650"/>
+            <a:ext cx="8953500" cy="323850"/>
+          </a:xfrm>
+          <a:prstGeom xmlns:a="http://schemas.openxmlformats.org/drawingml/2006/main" prst="rect">
+            <a:avLst/>
+          </a:prstGeom>
+          <a:noFill xmlns:a="http://schemas.openxmlformats.org/drawingml/2006/main"/>
+          <a:ln xmlns:a="http://schemas.openxmlformats.org/drawingml/2006/main" w="0">
+            <a:noFill/>
+            <a:prstDash val="solid"/>
+          </a:ln>
+        </p:spPr>
+        <p:txBody>
+          <a:bodyPr xmlns:a="http://schemas.openxmlformats.org/drawingml/2006/main"/>
+          <a:lstStyle xmlns:a="http://schemas.openxmlformats.org/drawingml/2006/main"/>
+          <a:p xmlns:a="http://schemas.openxmlformats.org/drawingml/2006/main">
+            <a:pPr algn="l">
+              <a:buNone/>
+              <a:defRPr sz="1800" b="1">
+                <a:solidFill>
+                  <a:srgbClr val="8F7BFF"/>
+                </a:solidFill>
+              </a:defRPr>
+            </a:pPr>
+            <a:r>
+              <a:rPr sz="1800" b="1">
+                <a:solidFill>
+                  <a:srgbClr val="8F7BFF"/>
+                </a:solidFill>
+              </a:rPr>
+              <a:t>One workload. Multiple controlled runs. One report to export—or delete.</a:t>
+            </a:r>
+          </a:p>
+        </p:txBody>
+      </p:sp>
+      <p:sp>
+        <p:nvSpPr>
+          <p:cNvPr id="21" name="">
+            <a:extLst xmlns:a="http://schemas.openxmlformats.org/drawingml/2006/main">
+              <a:ext uri="{FF2B5EF4-FFF2-40B4-BE49-F238E27FC236}">
+                <a16:creationId xmlns:a16="http://schemas.microsoft.com/office/drawing/2014/main" id="{1EFBFCAD-AC5E-4D43-8F56-8311CE364574}"/>
+              </a:ext>
+            </a:extLst>
+          </p:cNvPr>
+          <p:cNvSpPr>
+            <a:spLocks xmlns:a="http://schemas.openxmlformats.org/drawingml/2006/main" noGrp="1"/>
+          </p:cNvSpPr>
+          <p:nvPr/>
+        </p:nvSpPr>
+        <p:spPr>
+          <a:xfrm xmlns:a="http://schemas.openxmlformats.org/drawingml/2006/main">
+            <a:off x="685800" y="6496050"/>
+            <a:ext cx="4000500" cy="171450"/>
+          </a:xfrm>
+          <a:prstGeom xmlns:a="http://schemas.openxmlformats.org/drawingml/2006/main" prst="rect">
+            <a:avLst/>
+          </a:prstGeom>
+          <a:noFill xmlns:a="http://schemas.openxmlformats.org/drawingml/2006/main"/>
+          <a:ln xmlns:a="http://schemas.openxmlformats.org/drawingml/2006/main" w="0">
+            <a:noFill/>
+            <a:prstDash val="solid"/>
+          </a:ln>
+        </p:spPr>
+        <p:txBody>
+          <a:bodyPr xmlns:a="http://schemas.openxmlformats.org/drawingml/2006/main"/>
+          <a:lstStyle xmlns:a="http://schemas.openxmlformats.org/drawingml/2006/main"/>
+          <a:p xmlns:a="http://schemas.openxmlformats.org/drawingml/2006/main">
+            <a:pPr algn="l">
+              <a:buNone/>
+              <a:defRPr sz="825" b="1">
+                <a:solidFill>
+                  <a:srgbClr val="687068"/>
+                </a:solidFill>
+              </a:defRPr>
+            </a:pPr>
+            <a:r>
+              <a:rPr sz="825" b="1">
+                <a:solidFill>
+                  <a:srgbClr val="687068"/>
+                </a:solidFill>
+              </a:rPr>
+              <a:t>AI BUILD CREW · BADLABZ.COM</a:t>
+            </a:r>
+          </a:p>
+        </p:txBody>
+      </p:sp>
+      <p:sp>
+        <p:nvSpPr>
+          <p:cNvPr id="22" name="">
+            <a:extLst xmlns:a="http://schemas.openxmlformats.org/drawingml/2006/main">
+              <a:ext uri="{FF2B5EF4-FFF2-40B4-BE49-F238E27FC236}">
+                <a16:creationId xmlns:a16="http://schemas.microsoft.com/office/drawing/2014/main" id="{0E78C71B-E1E9-4CCE-AD87-856072D44A76}"/>
+              </a:ext>
+            </a:extLst>
+          </p:cNvPr>
+          <p:cNvSpPr>
+            <a:spLocks xmlns:a="http://schemas.openxmlformats.org/drawingml/2006/main" noGrp="1"/>
+          </p:cNvSpPr>
+          <p:nvPr/>
+        </p:nvSpPr>
+        <p:spPr>
+          <a:xfrm xmlns:a="http://schemas.openxmlformats.org/drawingml/2006/main">
+            <a:off x="10858500" y="6496050"/>
+            <a:ext cx="647700" cy="171450"/>
+          </a:xfrm>
+          <a:prstGeom xmlns:a="http://schemas.openxmlformats.org/drawingml/2006/main" prst="rect">
+            <a:avLst/>
+          </a:prstGeom>
+          <a:noFill xmlns:a="http://schemas.openxmlformats.org/drawingml/2006/main"/>
+          <a:ln xmlns:a="http://schemas.openxmlformats.org/drawingml/2006/main" w="0">
+            <a:noFill/>
+            <a:prstDash val="solid"/>
+          </a:ln>
+        </p:spPr>
+        <p:txBody>
+          <a:bodyPr xmlns:a="http://schemas.openxmlformats.org/drawingml/2006/main"/>
+          <a:lstStyle xmlns:a="http://schemas.openxmlformats.org/drawingml/2006/main"/>
+          <a:p xmlns:a="http://schemas.openxmlformats.org/drawingml/2006/main">
+            <a:pPr algn="r">
+              <a:buNone/>
+              <a:defRPr sz="825" b="1">
+                <a:solidFill>
+                  <a:srgbClr val="8F7BFF"/>
+                </a:solidFill>
+              </a:defRPr>
+            </a:pPr>
+            <a:r>
+              <a:rPr sz="825" b="1">
+                <a:solidFill>
+                  <a:srgbClr val="8F7BFF"/>
+                </a:solidFill>
+              </a:rPr>
+              <a:t>09</a:t>
+            </a:r>
+          </a:p>
+        </p:txBody>
+      </p:sp>
+    </p:spTree>
+    <p:extLst>
+      <p:ext uri="{BB962C8B-B14F-4D97-AF65-F5344CB8AC3E}">
+        <p14:creationId xmlns:p14="http://schemas.microsoft.com/office/powerpoint/2010/main" val="1488857310"/>
       </p:ext>
     </p:extLst>
   </p:cSld>

</xml_diff>

<commit_message>
Publish Phase 2 multi-agent provider platform plan (#1)
* Publish multi-agent provider platform plan

* Add Phase 2 provider platform strategy to deck

* Align artifact hub with Phase 2 deck

---------

Co-authored-by: Christopher Ansted <ctansted@Christophers-MacBook-Pro.local>
</commit_message>
<xml_diff>
--- a/artifacts/AI_BUILD_CREW_COST_CONTRACT_VIDEO_REVIEW.pptx
+++ b/artifacts/AI_BUILD_CREW_COST_CONTRACT_VIDEO_REVIEW.pptx
@@ -2,20 +2,23 @@
 <file path=ppt/presentation.xml><?xml version="1.0" encoding="utf-8"?>
 <p:presentation xmlns:p="http://schemas.openxmlformats.org/presentationml/2006/main">
   <p:sldMasterIdLst>
-    <p:sldMasterId xmlns:r="http://schemas.openxmlformats.org/officeDocument/2006/relationships" id="2147483648" r:id="R0dbf89d702e84697"/>
+    <p:sldMasterId xmlns:r="http://schemas.openxmlformats.org/officeDocument/2006/relationships" id="2147483648" r:id="Rda68c6c13e124e89"/>
   </p:sldMasterIdLst>
   <p:notesMasterIdLst>
-    <p:notesMasterId xmlns:r="http://schemas.openxmlformats.org/officeDocument/2006/relationships" r:id="R0ccfb24263334d26"/>
+    <p:notesMasterId xmlns:r="http://schemas.openxmlformats.org/officeDocument/2006/relationships" r:id="R31ca0785941a497e"/>
   </p:notesMasterIdLst>
   <p:sldIdLst>
-    <p:sldId xmlns:r="http://schemas.openxmlformats.org/officeDocument/2006/relationships" id="256" r:id="R5d8d3ec7a986444a"/>
-    <p:sldId xmlns:r="http://schemas.openxmlformats.org/officeDocument/2006/relationships" id="257" r:id="R6adb5c2113854b0b"/>
-    <p:sldId xmlns:r="http://schemas.openxmlformats.org/officeDocument/2006/relationships" id="258" r:id="R4781dc3035e14b8d"/>
-    <p:sldId xmlns:r="http://schemas.openxmlformats.org/officeDocument/2006/relationships" id="259" r:id="Rd7a34f714822490d"/>
-    <p:sldId xmlns:r="http://schemas.openxmlformats.org/officeDocument/2006/relationships" id="260" r:id="Rb5027c57c1a04217"/>
-    <p:sldId xmlns:r="http://schemas.openxmlformats.org/officeDocument/2006/relationships" id="261" r:id="Rb458509aa2d94d34"/>
-    <p:sldId xmlns:r="http://schemas.openxmlformats.org/officeDocument/2006/relationships" id="262" r:id="Rb789cfdf956847e6"/>
-    <p:sldId xmlns:r="http://schemas.openxmlformats.org/officeDocument/2006/relationships" id="263" r:id="Rb326b6b2d1c543ad"/>
+    <p:sldId xmlns:r="http://schemas.openxmlformats.org/officeDocument/2006/relationships" id="256" r:id="R98b373e1cfab4d58"/>
+    <p:sldId xmlns:r="http://schemas.openxmlformats.org/officeDocument/2006/relationships" id="257" r:id="R764d1e5b88594da0"/>
+    <p:sldId xmlns:r="http://schemas.openxmlformats.org/officeDocument/2006/relationships" id="258" r:id="R474d42d2be4245db"/>
+    <p:sldId xmlns:r="http://schemas.openxmlformats.org/officeDocument/2006/relationships" id="259" r:id="R4020a1a900b84cd5"/>
+    <p:sldId xmlns:r="http://schemas.openxmlformats.org/officeDocument/2006/relationships" id="260" r:id="Rf5bb74ee6080499a"/>
+    <p:sldId xmlns:r="http://schemas.openxmlformats.org/officeDocument/2006/relationships" id="261" r:id="Rc7eee5b5d4314140"/>
+    <p:sldId xmlns:r="http://schemas.openxmlformats.org/officeDocument/2006/relationships" id="262" r:id="R87bffd3a20024a28"/>
+    <p:sldId xmlns:r="http://schemas.openxmlformats.org/officeDocument/2006/relationships" id="263" r:id="R6ee581eff5df4f67"/>
+    <p:sldId xmlns:r="http://schemas.openxmlformats.org/officeDocument/2006/relationships" id="264" r:id="R2f065474507d488b"/>
+    <p:sldId xmlns:r="http://schemas.openxmlformats.org/officeDocument/2006/relationships" id="265" r:id="R540eb597b6034f20"/>
+    <p:sldId xmlns:r="http://schemas.openxmlformats.org/officeDocument/2006/relationships" id="266" r:id="R33fe81211eec4dff"/>
   </p:sldIdLst>
   <p:sldSz cx="12192000" cy="6858000"/>
   <p:notesSz cx="6858000" cy="9144000"/>
@@ -504,6 +507,211 @@
 </p:notes>
 </file>
 
+<file path=ppt/notesSlides/notesSlide10.xml><?xml version="1.0" encoding="utf-8"?>
+<p:notes xmlns:p="http://schemas.openxmlformats.org/presentationml/2006/main">
+  <p:cSld>
+    <p:spTree>
+      <p:nvGrpSpPr>
+        <p:cNvPr id="1" name=""/>
+        <p:cNvGrpSpPr/>
+        <p:nvPr/>
+      </p:nvGrpSpPr>
+      <p:grpSpPr>
+        <a:xfrm xmlns:a="http://schemas.openxmlformats.org/drawingml/2006/main"/>
+      </p:grpSpPr>
+      <p:sp>
+        <p:nvSpPr>
+          <p:cNvPr id="2" name="Slide Image Placeholder 1"/>
+          <p:cNvSpPr>
+            <a:spLocks xmlns:a="http://schemas.openxmlformats.org/drawingml/2006/main" noGrp="1"/>
+          </p:cNvSpPr>
+          <p:nvPr>
+            <p:ph type="sldImg" idx="0"/>
+          </p:nvPr>
+        </p:nvSpPr>
+        <p:spPr/>
+      </p:sp>
+      <p:sp>
+        <p:nvSpPr>
+          <p:cNvPr id="3" name="Notes Placeholder 2"/>
+          <p:cNvSpPr>
+            <a:spLocks xmlns:a="http://schemas.openxmlformats.org/drawingml/2006/main" noGrp="1"/>
+          </p:cNvSpPr>
+          <p:nvPr>
+            <p:ph type="body" idx="1"/>
+          </p:nvPr>
+        </p:nvSpPr>
+        <p:spPr/>
+        <p:txBody>
+          <a:bodyPr xmlns:a="http://schemas.openxmlformats.org/drawingml/2006/main"/>
+          <a:lstStyle xmlns:a="http://schemas.openxmlformats.org/drawingml/2006/main"/>
+          <a:p xmlns:a="http://schemas.openxmlformats.org/drawingml/2006/main">
+            <a:r>
+              <a:t>The six handoffs are intentionally hard-bordered: brief, freeze, provider run, blinded scoring, governance, and report. Catalog-only comparison makes no provider calls and has zero model-token cost. Live comparison begins only after the user sees a maximum spend and explicitly approves it. Every provider receives the same frozen case; runners cannot choose models, raise budgets, score themselves, or change policy.</a:t>
+            </a:r>
+          </a:p>
+          <a:p xmlns:a="http://schemas.openxmlformats.org/drawingml/2006/main">
+            <a:r>
+              <a:t/>
+            </a:r>
+          </a:p>
+          <a:p xmlns:a="http://schemas.openxmlformats.org/drawingml/2006/main">
+            <a:r>
+              <a:t>[Sources]</a:t>
+            </a:r>
+          </a:p>
+          <a:p xmlns:a="http://schemas.openxmlformats.org/drawingml/2006/main">
+            <a:r>
+              <a:t>- AI Build Crew Multi-Agent Provider Platform Plan, August 9, 2026</a:t>
+            </a:r>
+          </a:p>
+          <a:p xmlns:a="http://schemas.openxmlformats.org/drawingml/2006/main">
+            <a:r>
+              <a:t>- https://ai.google.dev/gemini-api/docs/pricing</a:t>
+            </a:r>
+          </a:p>
+          <a:p xmlns:a="http://schemas.openxmlformats.org/drawingml/2006/main">
+            <a:r>
+              <a:t>- https://ai.google.dev/api/models</a:t>
+            </a:r>
+          </a:p>
+          <a:p xmlns:a="http://schemas.openxmlformats.org/drawingml/2006/main">
+            <a:r>
+              <a:t>- https://platform.claude.com/docs/en/api/beta/models/list</a:t>
+            </a:r>
+          </a:p>
+          <a:p xmlns:a="http://schemas.openxmlformats.org/drawingml/2006/main">
+            <a:r>
+              <a:t>- https://developers.openai.com/api/reference/resources/evals</a:t>
+            </a:r>
+          </a:p>
+        </p:txBody>
+      </p:sp>
+      <p:sp>
+        <p:nvSpPr>
+          <p:cNvPr id="4" name="Slide Number Placeholder 3"/>
+          <p:cNvSpPr>
+            <a:spLocks xmlns:a="http://schemas.openxmlformats.org/drawingml/2006/main" noGrp="1"/>
+          </p:cNvSpPr>
+          <p:nvPr>
+            <p:ph type="sldNum" idx="5"/>
+          </p:nvPr>
+        </p:nvSpPr>
+        <p:spPr/>
+        <p:txBody>
+          <a:bodyPr xmlns:a="http://schemas.openxmlformats.org/drawingml/2006/main"/>
+          <a:lstStyle xmlns:a="http://schemas.openxmlformats.org/drawingml/2006/main"/>
+          <a:p xmlns:a="http://schemas.openxmlformats.org/drawingml/2006/main"/>
+        </p:txBody>
+      </p:sp>
+    </p:spTree>
+  </p:cSld>
+  <p:clrMapOvr>
+    <a:masterClrMapping xmlns:a="http://schemas.openxmlformats.org/drawingml/2006/main"/>
+  </p:clrMapOvr>
+</p:notes>
+</file>
+
+<file path=ppt/notesSlides/notesSlide11.xml><?xml version="1.0" encoding="utf-8"?>
+<p:notes xmlns:p="http://schemas.openxmlformats.org/presentationml/2006/main">
+  <p:cSld>
+    <p:spTree>
+      <p:nvGrpSpPr>
+        <p:cNvPr id="1" name=""/>
+        <p:cNvGrpSpPr/>
+        <p:nvPr/>
+      </p:nvGrpSpPr>
+      <p:grpSpPr>
+        <a:xfrm xmlns:a="http://schemas.openxmlformats.org/drawingml/2006/main"/>
+      </p:grpSpPr>
+      <p:sp>
+        <p:nvSpPr>
+          <p:cNvPr id="2" name="Slide Image Placeholder 1"/>
+          <p:cNvSpPr>
+            <a:spLocks xmlns:a="http://schemas.openxmlformats.org/drawingml/2006/main" noGrp="1"/>
+          </p:cNvSpPr>
+          <p:nvPr>
+            <p:ph type="sldImg" idx="0"/>
+          </p:nvPr>
+        </p:nvSpPr>
+        <p:spPr/>
+      </p:sp>
+      <p:sp>
+        <p:nvSpPr>
+          <p:cNvPr id="3" name="Notes Placeholder 2"/>
+          <p:cNvSpPr>
+            <a:spLocks xmlns:a="http://schemas.openxmlformats.org/drawingml/2006/main" noGrp="1"/>
+          </p:cNvSpPr>
+          <p:nvPr>
+            <p:ph type="body" idx="1"/>
+          </p:nvPr>
+        </p:nvSpPr>
+        <p:spPr/>
+        <p:txBody>
+          <a:bodyPr xmlns:a="http://schemas.openxmlformats.org/drawingml/2006/main"/>
+          <a:lstStyle xmlns:a="http://schemas.openxmlformats.org/drawingml/2006/main"/>
+          <a:p xmlns:a="http://schemas.openxmlformats.org/drawingml/2006/main">
+            <a:r>
+              <a:t>AWS is the Phase 2 evidence foundation, not a requirement for the current estimator. S3 holds versioned source snapshots and run artifacts; DynamoDB holds project metadata, budgets, and report history; Secrets Manager protects provider credentials used by server-side runners. Retrieval-augmented generation can ground source summaries, model evidence, and report explanations. It cannot calculate cost, alter eligibility, rewrite policy, or approve a decision. Privacy defaults remain no raw prompt retention, synthetic cases first, and user-controlled export or deletion.</a:t>
+            </a:r>
+          </a:p>
+          <a:p xmlns:a="http://schemas.openxmlformats.org/drawingml/2006/main">
+            <a:r>
+              <a:t/>
+            </a:r>
+          </a:p>
+          <a:p xmlns:a="http://schemas.openxmlformats.org/drawingml/2006/main">
+            <a:r>
+              <a:t>[Sources]</a:t>
+            </a:r>
+          </a:p>
+          <a:p xmlns:a="http://schemas.openxmlformats.org/drawingml/2006/main">
+            <a:r>
+              <a:t>- AI Build Crew Multi-Agent Provider Platform Plan, August 9, 2026</a:t>
+            </a:r>
+          </a:p>
+          <a:p xmlns:a="http://schemas.openxmlformats.org/drawingml/2006/main">
+            <a:r>
+              <a:t>- https://docs.aws.amazon.com/bedrock/latest/userguide/evaluation.html</a:t>
+            </a:r>
+          </a:p>
+          <a:p xmlns:a="http://schemas.openxmlformats.org/drawingml/2006/main">
+            <a:r>
+              <a:t>- https://docs.aws.amazon.com/bedrock/latest/userguide/model-evaluation-report-s3.html</a:t>
+            </a:r>
+          </a:p>
+          <a:p xmlns:a="http://schemas.openxmlformats.org/drawingml/2006/main">
+            <a:r>
+              <a:t>- https://docs.aws.amazon.com/lambda/latest/dg/with-secrets-manager.html</a:t>
+            </a:r>
+          </a:p>
+        </p:txBody>
+      </p:sp>
+      <p:sp>
+        <p:nvSpPr>
+          <p:cNvPr id="4" name="Slide Number Placeholder 3"/>
+          <p:cNvSpPr>
+            <a:spLocks xmlns:a="http://schemas.openxmlformats.org/drawingml/2006/main" noGrp="1"/>
+          </p:cNvSpPr>
+          <p:nvPr>
+            <p:ph type="sldNum" idx="5"/>
+          </p:nvPr>
+        </p:nvSpPr>
+        <p:spPr/>
+        <p:txBody>
+          <a:bodyPr xmlns:a="http://schemas.openxmlformats.org/drawingml/2006/main"/>
+          <a:lstStyle xmlns:a="http://schemas.openxmlformats.org/drawingml/2006/main"/>
+          <a:p xmlns:a="http://schemas.openxmlformats.org/drawingml/2006/main"/>
+        </p:txBody>
+      </p:sp>
+    </p:spTree>
+  </p:cSld>
+  <p:clrMapOvr>
+    <a:masterClrMapping xmlns:a="http://schemas.openxmlformats.org/drawingml/2006/main"/>
+  </p:clrMapOvr>
+</p:notes>
+</file>
+
 <file path=ppt/notesSlides/notesSlide2.xml><?xml version="1.0" encoding="utf-8"?>
 <p:notes xmlns:p="http://schemas.openxmlformats.org/presentationml/2006/main">
   <p:cSld>
@@ -1125,6 +1333,106 @@
           <a:p xmlns:a="http://schemas.openxmlformats.org/drawingml/2006/main">
             <a:r>
               <a:t>- Generated AI Build Crew brand master, OpenAI ImageGen, August 8, 2026</a:t>
+            </a:r>
+          </a:p>
+        </p:txBody>
+      </p:sp>
+      <p:sp>
+        <p:nvSpPr>
+          <p:cNvPr id="4" name="Slide Number Placeholder 3"/>
+          <p:cNvSpPr>
+            <a:spLocks xmlns:a="http://schemas.openxmlformats.org/drawingml/2006/main" noGrp="1"/>
+          </p:cNvSpPr>
+          <p:nvPr>
+            <p:ph type="sldNum" idx="5"/>
+          </p:nvPr>
+        </p:nvSpPr>
+        <p:spPr/>
+        <p:txBody>
+          <a:bodyPr xmlns:a="http://schemas.openxmlformats.org/drawingml/2006/main"/>
+          <a:lstStyle xmlns:a="http://schemas.openxmlformats.org/drawingml/2006/main"/>
+          <a:p xmlns:a="http://schemas.openxmlformats.org/drawingml/2006/main"/>
+        </p:txBody>
+      </p:sp>
+    </p:spTree>
+  </p:cSld>
+  <p:clrMapOvr>
+    <a:masterClrMapping xmlns:a="http://schemas.openxmlformats.org/drawingml/2006/main"/>
+  </p:clrMapOvr>
+</p:notes>
+</file>
+
+<file path=ppt/notesSlides/notesSlide9.xml><?xml version="1.0" encoding="utf-8"?>
+<p:notes xmlns:p="http://schemas.openxmlformats.org/presentationml/2006/main">
+  <p:cSld>
+    <p:spTree>
+      <p:nvGrpSpPr>
+        <p:cNvPr id="1" name=""/>
+        <p:cNvGrpSpPr/>
+        <p:nvPr/>
+      </p:nvGrpSpPr>
+      <p:grpSpPr>
+        <a:xfrm xmlns:a="http://schemas.openxmlformats.org/drawingml/2006/main"/>
+      </p:grpSpPr>
+      <p:sp>
+        <p:nvSpPr>
+          <p:cNvPr id="2" name="Slide Image Placeholder 1"/>
+          <p:cNvSpPr>
+            <a:spLocks xmlns:a="http://schemas.openxmlformats.org/drawingml/2006/main" noGrp="1"/>
+          </p:cNvSpPr>
+          <p:nvPr>
+            <p:ph type="sldImg" idx="0"/>
+          </p:nvPr>
+        </p:nvSpPr>
+        <p:spPr/>
+      </p:sp>
+      <p:sp>
+        <p:nvSpPr>
+          <p:cNvPr id="3" name="Notes Placeholder 2"/>
+          <p:cNvSpPr>
+            <a:spLocks xmlns:a="http://schemas.openxmlformats.org/drawingml/2006/main" noGrp="1"/>
+          </p:cNvSpPr>
+          <p:nvPr>
+            <p:ph type="body" idx="1"/>
+          </p:nvPr>
+        </p:nvSpPr>
+        <p:spPr/>
+        <p:txBody>
+          <a:bodyPr xmlns:a="http://schemas.openxmlformats.org/drawingml/2006/main"/>
+          <a:lstStyle xmlns:a="http://schemas.openxmlformats.org/drawingml/2006/main"/>
+          <a:p xmlns:a="http://schemas.openxmlformats.org/drawingml/2006/main">
+            <a:r>
+              <a:t>Phase 2 makes the current estimator the control plane for provider-neutral comparison. A locked Workload Architect freezes the user-confirmed brief. Deterministic orchestration then dispatches the same sealed evaluation case to provider-specific runners. A blinded evaluator, cost specialist, auditor, and governance gate produce one comparable point-in-time report. The report can be exported; raw ideas do not need to be retained. The full operating contract is published in the Multi-Agent Provider Platform Plan.</a:t>
+            </a:r>
+          </a:p>
+          <a:p xmlns:a="http://schemas.openxmlformats.org/drawingml/2006/main">
+            <a:r>
+              <a:t/>
+            </a:r>
+          </a:p>
+          <a:p xmlns:a="http://schemas.openxmlformats.org/drawingml/2006/main">
+            <a:r>
+              <a:t>[Sources]</a:t>
+            </a:r>
+          </a:p>
+          <a:p xmlns:a="http://schemas.openxmlformats.org/drawingml/2006/main">
+            <a:r>
+              <a:t>- AI Build Crew Multi-Agent Provider Platform Plan, August 9, 2026</a:t>
+            </a:r>
+          </a:p>
+          <a:p xmlns:a="http://schemas.openxmlformats.org/drawingml/2006/main">
+            <a:r>
+              <a:t>- https://ai.google.dev/api/models</a:t>
+            </a:r>
+          </a:p>
+          <a:p xmlns:a="http://schemas.openxmlformats.org/drawingml/2006/main">
+            <a:r>
+              <a:t>- https://platform.claude.com/docs/en/api/beta/models/list</a:t>
+            </a:r>
+          </a:p>
+          <a:p xmlns:a="http://schemas.openxmlformats.org/drawingml/2006/main">
+            <a:r>
+              <a:t>- https://developers.openai.com/api/reference/resources/evals</a:t>
             </a:r>
           </a:p>
         </p:txBody>
@@ -1192,7 +1500,7 @@
   </p:cSld>
   <p:clrMap bg1="lt1" tx1="dk1" bg2="lt2" tx2="dk2" accent1="accent1" accent2="accent2" accent3="accent3" accent4="accent4" accent5="accent5" accent6="accent6" hlink="hlink" folHlink="folHlink"/>
   <p:sldLayoutIdLst>
-    <p:sldLayoutId xmlns:r="http://schemas.openxmlformats.org/officeDocument/2006/relationships" id="2147483649" r:id="R332737bda610476a"/>
+    <p:sldLayoutId xmlns:r="http://schemas.openxmlformats.org/officeDocument/2006/relationships" id="2147483649" r:id="R06a3eae344364870"/>
   </p:sldLayoutIdLst>
   <p:txStyles>
     <p:titleStyle>
@@ -1885,7 +2193,7 @@
           <p:nvPr/>
         </p:nvPicPr>
         <p:blipFill>
-          <a:blip xmlns:r="http://schemas.openxmlformats.org/officeDocument/2006/relationships" xmlns:a="http://schemas.openxmlformats.org/drawingml/2006/main" r:embed="Re83c4070864d4792"/>
+          <a:blip xmlns:r="http://schemas.openxmlformats.org/officeDocument/2006/relationships" xmlns:a="http://schemas.openxmlformats.org/drawingml/2006/main" r:embed="R27cbb2583a0a490e"/>
           <a:srcRect xmlns:a="http://schemas.openxmlformats.org/drawingml/2006/main" l="0" t="27" r="0" b="27"/>
           <a:stretch xmlns:a="http://schemas.openxmlformats.org/drawingml/2006/main">
             <a:fillRect l="0" t="0" r="0" b="0"/>
@@ -2227,6 +2535,2350 @@
     <p:extLst>
       <p:ext uri="{BB962C8B-B14F-4D97-AF65-F5344CB8AC3E}">
         <p14:creationId xmlns:p14="http://schemas.microsoft.com/office/powerpoint/2010/main" val="826955634"/>
+      </p:ext>
+    </p:extLst>
+  </p:cSld>
+</p:sld>
+</file>
+
+<file path=ppt/slides/slide10.xml><?xml version="1.0" encoding="utf-8"?>
+<p:sld xmlns:p="http://schemas.openxmlformats.org/presentationml/2006/main">
+  <p:cSld>
+    <p:bg>
+      <p:bgPr>
+        <a:solidFill xmlns:a="http://schemas.openxmlformats.org/drawingml/2006/main">
+          <a:srgbClr val="152015"/>
+        </a:solidFill>
+      </p:bgPr>
+    </p:bg>
+    <p:spTree>
+      <p:nvGrpSpPr>
+        <p:cNvPr id="1" name=""/>
+        <p:cNvGrpSpPr/>
+        <p:nvPr/>
+      </p:nvGrpSpPr>
+      <p:grpSpPr>
+        <a:xfrm xmlns:a="http://schemas.openxmlformats.org/drawingml/2006/main"/>
+      </p:grpSpPr>
+      <p:sp>
+        <p:nvSpPr>
+          <p:cNvPr id="32" name="">
+            <a:extLst xmlns:a="http://schemas.openxmlformats.org/drawingml/2006/main">
+              <a:ext uri="{FF2B5EF4-FFF2-40B4-BE49-F238E27FC236}">
+                <a16:creationId xmlns:a16="http://schemas.microsoft.com/office/drawing/2014/main" id="{8C553D6B-F6E1-4C23-94F8-0C2E979C37E8}"/>
+              </a:ext>
+            </a:extLst>
+          </p:cNvPr>
+          <p:cNvSpPr>
+            <a:spLocks xmlns:a="http://schemas.openxmlformats.org/drawingml/2006/main" noGrp="1"/>
+          </p:cNvSpPr>
+          <p:nvPr/>
+        </p:nvSpPr>
+        <p:spPr>
+          <a:xfrm xmlns:a="http://schemas.openxmlformats.org/drawingml/2006/main">
+            <a:off x="685800" y="457200"/>
+            <a:ext cx="514350" cy="266700"/>
+          </a:xfrm>
+          <a:prstGeom xmlns:a="http://schemas.openxmlformats.org/drawingml/2006/main" prst="rect">
+            <a:avLst/>
+          </a:prstGeom>
+          <a:noFill xmlns:a="http://schemas.openxmlformats.org/drawingml/2006/main"/>
+          <a:ln xmlns:a="http://schemas.openxmlformats.org/drawingml/2006/main" w="0">
+            <a:noFill/>
+            <a:prstDash val="solid"/>
+          </a:ln>
+        </p:spPr>
+        <p:txBody>
+          <a:bodyPr xmlns:a="http://schemas.openxmlformats.org/drawingml/2006/main"/>
+          <a:lstStyle xmlns:a="http://schemas.openxmlformats.org/drawingml/2006/main"/>
+          <a:p xmlns:a="http://schemas.openxmlformats.org/drawingml/2006/main">
+            <a:pPr algn="l">
+              <a:buNone/>
+              <a:defRPr sz="975" b="1">
+                <a:solidFill>
+                  <a:srgbClr val="D8FF55"/>
+                </a:solidFill>
+              </a:defRPr>
+            </a:pPr>
+            <a:r>
+              <a:rPr sz="975" b="1">
+                <a:solidFill>
+                  <a:srgbClr val="D8FF55"/>
+                </a:solidFill>
+              </a:rPr>
+              <a:t>08</a:t>
+            </a:r>
+          </a:p>
+        </p:txBody>
+      </p:sp>
+      <p:sp>
+        <p:nvSpPr>
+          <p:cNvPr id="2" name="">
+            <a:extLst xmlns:a="http://schemas.openxmlformats.org/drawingml/2006/main">
+              <a:ext uri="{FF2B5EF4-FFF2-40B4-BE49-F238E27FC236}">
+                <a16:creationId xmlns:a16="http://schemas.microsoft.com/office/drawing/2014/main" id="{8A548264-5D78-4063-AE84-D74A11F20831}"/>
+              </a:ext>
+            </a:extLst>
+          </p:cNvPr>
+          <p:cNvSpPr>
+            <a:spLocks xmlns:a="http://schemas.openxmlformats.org/drawingml/2006/main" noGrp="1"/>
+          </p:cNvSpPr>
+          <p:nvPr/>
+        </p:nvSpPr>
+        <p:spPr>
+          <a:xfrm xmlns:a="http://schemas.openxmlformats.org/drawingml/2006/main">
+            <a:off x="1219200" y="457200"/>
+            <a:ext cx="4762500" cy="266700"/>
+          </a:xfrm>
+          <a:prstGeom xmlns:a="http://schemas.openxmlformats.org/drawingml/2006/main" prst="rect">
+            <a:avLst/>
+          </a:prstGeom>
+          <a:noFill xmlns:a="http://schemas.openxmlformats.org/drawingml/2006/main"/>
+          <a:ln xmlns:a="http://schemas.openxmlformats.org/drawingml/2006/main" w="0">
+            <a:noFill/>
+            <a:prstDash val="solid"/>
+          </a:ln>
+        </p:spPr>
+        <p:txBody>
+          <a:bodyPr xmlns:a="http://schemas.openxmlformats.org/drawingml/2006/main"/>
+          <a:lstStyle xmlns:a="http://schemas.openxmlformats.org/drawingml/2006/main"/>
+          <a:p xmlns:a="http://schemas.openxmlformats.org/drawingml/2006/main">
+            <a:pPr algn="l">
+              <a:buNone/>
+              <a:defRPr sz="975" b="1">
+                <a:solidFill>
+                  <a:srgbClr val="FFFFFF"/>
+                </a:solidFill>
+              </a:defRPr>
+            </a:pPr>
+            <a:r>
+              <a:rPr sz="975" b="1">
+                <a:solidFill>
+                  <a:srgbClr val="FFFFFF"/>
+                </a:solidFill>
+              </a:rPr>
+              <a:t>PHASE 2 · CONTROLLED PROVIDER EVALUATION</a:t>
+            </a:r>
+          </a:p>
+        </p:txBody>
+      </p:sp>
+      <p:sp>
+        <p:nvSpPr>
+          <p:cNvPr id="3" name="">
+            <a:extLst xmlns:a="http://schemas.openxmlformats.org/drawingml/2006/main">
+              <a:ext uri="{FF2B5EF4-FFF2-40B4-BE49-F238E27FC236}">
+                <a16:creationId xmlns:a16="http://schemas.microsoft.com/office/drawing/2014/main" id="{EA4DD615-451E-4118-B330-1B17291F0392}"/>
+              </a:ext>
+            </a:extLst>
+          </p:cNvPr>
+          <p:cNvSpPr>
+            <a:spLocks xmlns:a="http://schemas.openxmlformats.org/drawingml/2006/main" noGrp="1"/>
+          </p:cNvSpPr>
+          <p:nvPr/>
+        </p:nvSpPr>
+        <p:spPr>
+          <a:xfrm xmlns:a="http://schemas.openxmlformats.org/drawingml/2006/main">
+            <a:off x="685800" y="781050"/>
+            <a:ext cx="10820400" cy="19050"/>
+          </a:xfrm>
+          <a:prstGeom xmlns:a="http://schemas.openxmlformats.org/drawingml/2006/main" prst="rect">
+            <a:avLst/>
+          </a:prstGeom>
+          <a:solidFill xmlns:a="http://schemas.openxmlformats.org/drawingml/2006/main">
+            <a:srgbClr val="405040"/>
+          </a:solidFill>
+          <a:ln xmlns:a="http://schemas.openxmlformats.org/drawingml/2006/main" w="0">
+            <a:noFill/>
+            <a:prstDash val="solid"/>
+          </a:ln>
+        </p:spPr>
+      </p:sp>
+      <p:sp>
+        <p:nvSpPr>
+          <p:cNvPr id="4" name="">
+            <a:extLst xmlns:a="http://schemas.openxmlformats.org/drawingml/2006/main">
+              <a:ext uri="{FF2B5EF4-FFF2-40B4-BE49-F238E27FC236}">
+                <a16:creationId xmlns:a16="http://schemas.microsoft.com/office/drawing/2014/main" id="{79CBBBB8-4104-412D-B784-5FC1F100316D}"/>
+              </a:ext>
+            </a:extLst>
+          </p:cNvPr>
+          <p:cNvSpPr>
+            <a:spLocks xmlns:a="http://schemas.openxmlformats.org/drawingml/2006/main" noGrp="1"/>
+          </p:cNvSpPr>
+          <p:nvPr/>
+        </p:nvSpPr>
+        <p:spPr>
+          <a:xfrm xmlns:a="http://schemas.openxmlformats.org/drawingml/2006/main">
+            <a:off x="685800" y="1095375"/>
+            <a:ext cx="6191250" cy="990600"/>
+          </a:xfrm>
+          <a:prstGeom xmlns:a="http://schemas.openxmlformats.org/drawingml/2006/main" prst="rect">
+            <a:avLst/>
+          </a:prstGeom>
+          <a:noFill xmlns:a="http://schemas.openxmlformats.org/drawingml/2006/main"/>
+          <a:ln xmlns:a="http://schemas.openxmlformats.org/drawingml/2006/main" w="0">
+            <a:noFill/>
+            <a:prstDash val="solid"/>
+          </a:ln>
+        </p:spPr>
+        <p:txBody>
+          <a:bodyPr xmlns:a="http://schemas.openxmlformats.org/drawingml/2006/main"/>
+          <a:lstStyle xmlns:a="http://schemas.openxmlformats.org/drawingml/2006/main"/>
+          <a:p xmlns:a="http://schemas.openxmlformats.org/drawingml/2006/main">
+            <a:pPr algn="l">
+              <a:buNone/>
+              <a:defRPr sz="3450" b="1">
+                <a:solidFill>
+                  <a:srgbClr val="FFFFFF"/>
+                </a:solidFill>
+              </a:defRPr>
+            </a:pPr>
+            <a:r>
+              <a:rPr sz="3450" b="1">
+                <a:solidFill>
+                  <a:srgbClr val="FFFFFF"/>
+                </a:solidFill>
+              </a:rPr>
+              <a:t>One orchestrator.</a:t>
+            </a:r>
+          </a:p>
+          <a:p xmlns:a="http://schemas.openxmlformats.org/drawingml/2006/main">
+            <a:pPr algn="l">
+              <a:buNone/>
+              <a:defRPr sz="3450" b="1">
+                <a:solidFill>
+                  <a:srgbClr val="FFFFFF"/>
+                </a:solidFill>
+              </a:defRPr>
+            </a:pPr>
+            <a:r>
+              <a:rPr sz="3450" b="1">
+                <a:solidFill>
+                  <a:srgbClr val="FFFFFF"/>
+                </a:solidFill>
+              </a:rPr>
+              <a:t>Six locked handoffs.</a:t>
+            </a:r>
+          </a:p>
+        </p:txBody>
+      </p:sp>
+      <p:sp>
+        <p:nvSpPr>
+          <p:cNvPr id="5" name="">
+            <a:extLst xmlns:a="http://schemas.openxmlformats.org/drawingml/2006/main">
+              <a:ext uri="{FF2B5EF4-FFF2-40B4-BE49-F238E27FC236}">
+                <a16:creationId xmlns:a16="http://schemas.microsoft.com/office/drawing/2014/main" id="{96F1FD02-CAA2-4996-94C1-9C8C87D775C4}"/>
+              </a:ext>
+            </a:extLst>
+          </p:cNvPr>
+          <p:cNvSpPr>
+            <a:spLocks xmlns:a="http://schemas.openxmlformats.org/drawingml/2006/main" noGrp="1"/>
+          </p:cNvSpPr>
+          <p:nvPr/>
+        </p:nvSpPr>
+        <p:spPr>
+          <a:xfrm xmlns:a="http://schemas.openxmlformats.org/drawingml/2006/main">
+            <a:off x="685800" y="3048000"/>
+            <a:ext cx="1524000" cy="1666875"/>
+          </a:xfrm>
+          <a:prstGeom xmlns:a="http://schemas.openxmlformats.org/drawingml/2006/main" prst="roundRect">
+            <a:avLst>
+              <a:gd name="adj" fmla="val 11250"/>
+            </a:avLst>
+          </a:prstGeom>
+          <a:solidFill xmlns:a="http://schemas.openxmlformats.org/drawingml/2006/main">
+            <a:srgbClr val="223022"/>
+          </a:solidFill>
+          <a:ln xmlns:a="http://schemas.openxmlformats.org/drawingml/2006/main" w="9525">
+            <a:solidFill>
+              <a:srgbClr val="455345"/>
+            </a:solidFill>
+            <a:prstDash val="solid"/>
+          </a:ln>
+        </p:spPr>
+      </p:sp>
+      <p:sp>
+        <p:nvSpPr>
+          <p:cNvPr id="6" name="">
+            <a:extLst xmlns:a="http://schemas.openxmlformats.org/drawingml/2006/main">
+              <a:ext uri="{FF2B5EF4-FFF2-40B4-BE49-F238E27FC236}">
+                <a16:creationId xmlns:a16="http://schemas.microsoft.com/office/drawing/2014/main" id="{137F0DB5-FA6F-46E7-A72D-A461AD5B31A5}"/>
+              </a:ext>
+            </a:extLst>
+          </p:cNvPr>
+          <p:cNvSpPr>
+            <a:spLocks xmlns:a="http://schemas.openxmlformats.org/drawingml/2006/main" noGrp="1"/>
+          </p:cNvSpPr>
+          <p:nvPr/>
+        </p:nvSpPr>
+        <p:spPr>
+          <a:xfrm xmlns:a="http://schemas.openxmlformats.org/drawingml/2006/main">
+            <a:off x="857250" y="3238500"/>
+            <a:ext cx="476250" cy="209550"/>
+          </a:xfrm>
+          <a:prstGeom xmlns:a="http://schemas.openxmlformats.org/drawingml/2006/main" prst="rect">
+            <a:avLst/>
+          </a:prstGeom>
+          <a:noFill xmlns:a="http://schemas.openxmlformats.org/drawingml/2006/main"/>
+          <a:ln xmlns:a="http://schemas.openxmlformats.org/drawingml/2006/main" w="0">
+            <a:noFill/>
+            <a:prstDash val="solid"/>
+          </a:ln>
+        </p:spPr>
+        <p:txBody>
+          <a:bodyPr xmlns:a="http://schemas.openxmlformats.org/drawingml/2006/main"/>
+          <a:lstStyle xmlns:a="http://schemas.openxmlformats.org/drawingml/2006/main"/>
+          <a:p xmlns:a="http://schemas.openxmlformats.org/drawingml/2006/main">
+            <a:pPr algn="l">
+              <a:buNone/>
+              <a:defRPr sz="900" b="1">
+                <a:solidFill>
+                  <a:srgbClr val="D8FF55"/>
+                </a:solidFill>
+              </a:defRPr>
+            </a:pPr>
+            <a:r>
+              <a:rPr sz="900" b="1">
+                <a:solidFill>
+                  <a:srgbClr val="D8FF55"/>
+                </a:solidFill>
+              </a:rPr>
+              <a:t>01</a:t>
+            </a:r>
+          </a:p>
+        </p:txBody>
+      </p:sp>
+      <p:sp>
+        <p:nvSpPr>
+          <p:cNvPr id="7" name="">
+            <a:extLst xmlns:a="http://schemas.openxmlformats.org/drawingml/2006/main">
+              <a:ext uri="{FF2B5EF4-FFF2-40B4-BE49-F238E27FC236}">
+                <a16:creationId xmlns:a16="http://schemas.microsoft.com/office/drawing/2014/main" id="{4B6A99AC-429C-4A8A-B1BC-7551C22CDDE3}"/>
+              </a:ext>
+            </a:extLst>
+          </p:cNvPr>
+          <p:cNvSpPr>
+            <a:spLocks xmlns:a="http://schemas.openxmlformats.org/drawingml/2006/main" noGrp="1"/>
+          </p:cNvSpPr>
+          <p:nvPr/>
+        </p:nvSpPr>
+        <p:spPr>
+          <a:xfrm xmlns:a="http://schemas.openxmlformats.org/drawingml/2006/main">
+            <a:off x="857250" y="3657600"/>
+            <a:ext cx="1219200" cy="257175"/>
+          </a:xfrm>
+          <a:prstGeom xmlns:a="http://schemas.openxmlformats.org/drawingml/2006/main" prst="rect">
+            <a:avLst/>
+          </a:prstGeom>
+          <a:noFill xmlns:a="http://schemas.openxmlformats.org/drawingml/2006/main"/>
+          <a:ln xmlns:a="http://schemas.openxmlformats.org/drawingml/2006/main" w="0">
+            <a:noFill/>
+            <a:prstDash val="solid"/>
+          </a:ln>
+        </p:spPr>
+        <p:txBody>
+          <a:bodyPr xmlns:a="http://schemas.openxmlformats.org/drawingml/2006/main"/>
+          <a:lstStyle xmlns:a="http://schemas.openxmlformats.org/drawingml/2006/main"/>
+          <a:p xmlns:a="http://schemas.openxmlformats.org/drawingml/2006/main">
+            <a:pPr algn="l">
+              <a:buNone/>
+              <a:defRPr sz="1050" b="1">
+                <a:solidFill>
+                  <a:srgbClr val="FFFFFF"/>
+                </a:solidFill>
+              </a:defRPr>
+            </a:pPr>
+            <a:r>
+              <a:rPr sz="1050" b="1">
+                <a:solidFill>
+                  <a:srgbClr val="FFFFFF"/>
+                </a:solidFill>
+              </a:rPr>
+              <a:t>BRIEF</a:t>
+            </a:r>
+          </a:p>
+        </p:txBody>
+      </p:sp>
+      <p:sp>
+        <p:nvSpPr>
+          <p:cNvPr id="8" name="">
+            <a:extLst xmlns:a="http://schemas.openxmlformats.org/drawingml/2006/main">
+              <a:ext uri="{FF2B5EF4-FFF2-40B4-BE49-F238E27FC236}">
+                <a16:creationId xmlns:a16="http://schemas.microsoft.com/office/drawing/2014/main" id="{58948618-01E0-4D47-A98E-9E2C88B3AD91}"/>
+              </a:ext>
+            </a:extLst>
+          </p:cNvPr>
+          <p:cNvSpPr>
+            <a:spLocks xmlns:a="http://schemas.openxmlformats.org/drawingml/2006/main" noGrp="1"/>
+          </p:cNvSpPr>
+          <p:nvPr/>
+        </p:nvSpPr>
+        <p:spPr>
+          <a:xfrm xmlns:a="http://schemas.openxmlformats.org/drawingml/2006/main">
+            <a:off x="857250" y="4095750"/>
+            <a:ext cx="1190625" cy="495300"/>
+          </a:xfrm>
+          <a:prstGeom xmlns:a="http://schemas.openxmlformats.org/drawingml/2006/main" prst="rect">
+            <a:avLst/>
+          </a:prstGeom>
+          <a:noFill xmlns:a="http://schemas.openxmlformats.org/drawingml/2006/main"/>
+          <a:ln xmlns:a="http://schemas.openxmlformats.org/drawingml/2006/main" w="0">
+            <a:noFill/>
+            <a:prstDash val="solid"/>
+          </a:ln>
+        </p:spPr>
+        <p:txBody>
+          <a:bodyPr xmlns:a="http://schemas.openxmlformats.org/drawingml/2006/main"/>
+          <a:lstStyle xmlns:a="http://schemas.openxmlformats.org/drawingml/2006/main"/>
+          <a:p xmlns:a="http://schemas.openxmlformats.org/drawingml/2006/main">
+            <a:pPr algn="l">
+              <a:buNone/>
+              <a:defRPr sz="1050" b="0">
+                <a:solidFill>
+                  <a:srgbClr val="C8D1C8"/>
+                </a:solidFill>
+              </a:defRPr>
+            </a:pPr>
+            <a:r>
+              <a:rPr sz="1050" b="0">
+                <a:solidFill>
+                  <a:srgbClr val="C8D1C8"/>
+                </a:solidFill>
+              </a:rPr>
+              <a:t>User-owned idea</a:t>
+            </a:r>
+          </a:p>
+        </p:txBody>
+      </p:sp>
+      <p:sp>
+        <p:nvSpPr>
+          <p:cNvPr id="9" name="">
+            <a:extLst xmlns:a="http://schemas.openxmlformats.org/drawingml/2006/main">
+              <a:ext uri="{FF2B5EF4-FFF2-40B4-BE49-F238E27FC236}">
+                <a16:creationId xmlns:a16="http://schemas.microsoft.com/office/drawing/2014/main" id="{40BCF2A3-B492-40B8-B3D0-8B92943D7EAE}"/>
+              </a:ext>
+            </a:extLst>
+          </p:cNvPr>
+          <p:cNvSpPr>
+            <a:spLocks xmlns:a="http://schemas.openxmlformats.org/drawingml/2006/main" noGrp="1"/>
+          </p:cNvSpPr>
+          <p:nvPr/>
+        </p:nvSpPr>
+        <p:spPr>
+          <a:xfrm xmlns:a="http://schemas.openxmlformats.org/drawingml/2006/main">
+            <a:off x="2466975" y="3048000"/>
+            <a:ext cx="1524000" cy="1666875"/>
+          </a:xfrm>
+          <a:prstGeom xmlns:a="http://schemas.openxmlformats.org/drawingml/2006/main" prst="roundRect">
+            <a:avLst>
+              <a:gd name="adj" fmla="val 11250"/>
+            </a:avLst>
+          </a:prstGeom>
+          <a:solidFill xmlns:a="http://schemas.openxmlformats.org/drawingml/2006/main">
+            <a:srgbClr val="223022"/>
+          </a:solidFill>
+          <a:ln xmlns:a="http://schemas.openxmlformats.org/drawingml/2006/main" w="9525">
+            <a:solidFill>
+              <a:srgbClr val="455345"/>
+            </a:solidFill>
+            <a:prstDash val="solid"/>
+          </a:ln>
+        </p:spPr>
+      </p:sp>
+      <p:sp>
+        <p:nvSpPr>
+          <p:cNvPr id="10" name="">
+            <a:extLst xmlns:a="http://schemas.openxmlformats.org/drawingml/2006/main">
+              <a:ext uri="{FF2B5EF4-FFF2-40B4-BE49-F238E27FC236}">
+                <a16:creationId xmlns:a16="http://schemas.microsoft.com/office/drawing/2014/main" id="{1A16C494-524D-41A3-B6CE-CFF67AFA3618}"/>
+              </a:ext>
+            </a:extLst>
+          </p:cNvPr>
+          <p:cNvSpPr>
+            <a:spLocks xmlns:a="http://schemas.openxmlformats.org/drawingml/2006/main" noGrp="1"/>
+          </p:cNvSpPr>
+          <p:nvPr/>
+        </p:nvSpPr>
+        <p:spPr>
+          <a:xfrm xmlns:a="http://schemas.openxmlformats.org/drawingml/2006/main">
+            <a:off x="2638425" y="3238500"/>
+            <a:ext cx="476250" cy="209550"/>
+          </a:xfrm>
+          <a:prstGeom xmlns:a="http://schemas.openxmlformats.org/drawingml/2006/main" prst="rect">
+            <a:avLst/>
+          </a:prstGeom>
+          <a:noFill xmlns:a="http://schemas.openxmlformats.org/drawingml/2006/main"/>
+          <a:ln xmlns:a="http://schemas.openxmlformats.org/drawingml/2006/main" w="0">
+            <a:noFill/>
+            <a:prstDash val="solid"/>
+          </a:ln>
+        </p:spPr>
+        <p:txBody>
+          <a:bodyPr xmlns:a="http://schemas.openxmlformats.org/drawingml/2006/main"/>
+          <a:lstStyle xmlns:a="http://schemas.openxmlformats.org/drawingml/2006/main"/>
+          <a:p xmlns:a="http://schemas.openxmlformats.org/drawingml/2006/main">
+            <a:pPr algn="l">
+              <a:buNone/>
+              <a:defRPr sz="900" b="1">
+                <a:solidFill>
+                  <a:srgbClr val="8F7BFF"/>
+                </a:solidFill>
+              </a:defRPr>
+            </a:pPr>
+            <a:r>
+              <a:rPr sz="900" b="1">
+                <a:solidFill>
+                  <a:srgbClr val="8F7BFF"/>
+                </a:solidFill>
+              </a:rPr>
+              <a:t>02</a:t>
+            </a:r>
+          </a:p>
+        </p:txBody>
+      </p:sp>
+      <p:sp>
+        <p:nvSpPr>
+          <p:cNvPr id="11" name="">
+            <a:extLst xmlns:a="http://schemas.openxmlformats.org/drawingml/2006/main">
+              <a:ext uri="{FF2B5EF4-FFF2-40B4-BE49-F238E27FC236}">
+                <a16:creationId xmlns:a16="http://schemas.microsoft.com/office/drawing/2014/main" id="{F029AA08-A6B3-4526-8D3A-7A6977D08A67}"/>
+              </a:ext>
+            </a:extLst>
+          </p:cNvPr>
+          <p:cNvSpPr>
+            <a:spLocks xmlns:a="http://schemas.openxmlformats.org/drawingml/2006/main" noGrp="1"/>
+          </p:cNvSpPr>
+          <p:nvPr/>
+        </p:nvSpPr>
+        <p:spPr>
+          <a:xfrm xmlns:a="http://schemas.openxmlformats.org/drawingml/2006/main">
+            <a:off x="2638425" y="3657600"/>
+            <a:ext cx="1219200" cy="257175"/>
+          </a:xfrm>
+          <a:prstGeom xmlns:a="http://schemas.openxmlformats.org/drawingml/2006/main" prst="rect">
+            <a:avLst/>
+          </a:prstGeom>
+          <a:noFill xmlns:a="http://schemas.openxmlformats.org/drawingml/2006/main"/>
+          <a:ln xmlns:a="http://schemas.openxmlformats.org/drawingml/2006/main" w="0">
+            <a:noFill/>
+            <a:prstDash val="solid"/>
+          </a:ln>
+        </p:spPr>
+        <p:txBody>
+          <a:bodyPr xmlns:a="http://schemas.openxmlformats.org/drawingml/2006/main"/>
+          <a:lstStyle xmlns:a="http://schemas.openxmlformats.org/drawingml/2006/main"/>
+          <a:p xmlns:a="http://schemas.openxmlformats.org/drawingml/2006/main">
+            <a:pPr algn="l">
+              <a:buNone/>
+              <a:defRPr sz="1050" b="1">
+                <a:solidFill>
+                  <a:srgbClr val="FFFFFF"/>
+                </a:solidFill>
+              </a:defRPr>
+            </a:pPr>
+            <a:r>
+              <a:rPr sz="1050" b="1">
+                <a:solidFill>
+                  <a:srgbClr val="FFFFFF"/>
+                </a:solidFill>
+              </a:rPr>
+              <a:t>FREEZE</a:t>
+            </a:r>
+          </a:p>
+        </p:txBody>
+      </p:sp>
+      <p:sp>
+        <p:nvSpPr>
+          <p:cNvPr id="12" name="">
+            <a:extLst xmlns:a="http://schemas.openxmlformats.org/drawingml/2006/main">
+              <a:ext uri="{FF2B5EF4-FFF2-40B4-BE49-F238E27FC236}">
+                <a16:creationId xmlns:a16="http://schemas.microsoft.com/office/drawing/2014/main" id="{D88E9A1E-8003-49F4-9871-B13628242017}"/>
+              </a:ext>
+            </a:extLst>
+          </p:cNvPr>
+          <p:cNvSpPr>
+            <a:spLocks xmlns:a="http://schemas.openxmlformats.org/drawingml/2006/main" noGrp="1"/>
+          </p:cNvSpPr>
+          <p:nvPr/>
+        </p:nvSpPr>
+        <p:spPr>
+          <a:xfrm xmlns:a="http://schemas.openxmlformats.org/drawingml/2006/main">
+            <a:off x="2638425" y="4095750"/>
+            <a:ext cx="1190625" cy="495300"/>
+          </a:xfrm>
+          <a:prstGeom xmlns:a="http://schemas.openxmlformats.org/drawingml/2006/main" prst="rect">
+            <a:avLst/>
+          </a:prstGeom>
+          <a:noFill xmlns:a="http://schemas.openxmlformats.org/drawingml/2006/main"/>
+          <a:ln xmlns:a="http://schemas.openxmlformats.org/drawingml/2006/main" w="0">
+            <a:noFill/>
+            <a:prstDash val="solid"/>
+          </a:ln>
+        </p:spPr>
+        <p:txBody>
+          <a:bodyPr xmlns:a="http://schemas.openxmlformats.org/drawingml/2006/main"/>
+          <a:lstStyle xmlns:a="http://schemas.openxmlformats.org/drawingml/2006/main"/>
+          <a:p xmlns:a="http://schemas.openxmlformats.org/drawingml/2006/main">
+            <a:pPr algn="l">
+              <a:buNone/>
+              <a:defRPr sz="1050" b="0">
+                <a:solidFill>
+                  <a:srgbClr val="C8D1C8"/>
+                </a:solidFill>
+              </a:defRPr>
+            </a:pPr>
+            <a:r>
+              <a:rPr sz="1050" b="0">
+                <a:solidFill>
+                  <a:srgbClr val="C8D1C8"/>
+                </a:solidFill>
+              </a:rPr>
+              <a:t>Scope + spend cap</a:t>
+            </a:r>
+          </a:p>
+        </p:txBody>
+      </p:sp>
+      <p:sp>
+        <p:nvSpPr>
+          <p:cNvPr id="13" name="">
+            <a:extLst xmlns:a="http://schemas.openxmlformats.org/drawingml/2006/main">
+              <a:ext uri="{FF2B5EF4-FFF2-40B4-BE49-F238E27FC236}">
+                <a16:creationId xmlns:a16="http://schemas.microsoft.com/office/drawing/2014/main" id="{20798DAA-E978-4E3E-98F0-7842B1B1CE65}"/>
+              </a:ext>
+            </a:extLst>
+          </p:cNvPr>
+          <p:cNvSpPr>
+            <a:spLocks xmlns:a="http://schemas.openxmlformats.org/drawingml/2006/main" noGrp="1"/>
+          </p:cNvSpPr>
+          <p:nvPr/>
+        </p:nvSpPr>
+        <p:spPr>
+          <a:xfrm xmlns:a="http://schemas.openxmlformats.org/drawingml/2006/main">
+            <a:off x="4248150" y="3048000"/>
+            <a:ext cx="1524000" cy="1666875"/>
+          </a:xfrm>
+          <a:prstGeom xmlns:a="http://schemas.openxmlformats.org/drawingml/2006/main" prst="roundRect">
+            <a:avLst>
+              <a:gd name="adj" fmla="val 11250"/>
+            </a:avLst>
+          </a:prstGeom>
+          <a:solidFill xmlns:a="http://schemas.openxmlformats.org/drawingml/2006/main">
+            <a:srgbClr val="223022"/>
+          </a:solidFill>
+          <a:ln xmlns:a="http://schemas.openxmlformats.org/drawingml/2006/main" w="9525">
+            <a:solidFill>
+              <a:srgbClr val="455345"/>
+            </a:solidFill>
+            <a:prstDash val="solid"/>
+          </a:ln>
+        </p:spPr>
+      </p:sp>
+      <p:sp>
+        <p:nvSpPr>
+          <p:cNvPr id="14" name="">
+            <a:extLst xmlns:a="http://schemas.openxmlformats.org/drawingml/2006/main">
+              <a:ext uri="{FF2B5EF4-FFF2-40B4-BE49-F238E27FC236}">
+                <a16:creationId xmlns:a16="http://schemas.microsoft.com/office/drawing/2014/main" id="{1F47C2F3-A785-41FA-9584-6CBB9E20BC02}"/>
+              </a:ext>
+            </a:extLst>
+          </p:cNvPr>
+          <p:cNvSpPr>
+            <a:spLocks xmlns:a="http://schemas.openxmlformats.org/drawingml/2006/main" noGrp="1"/>
+          </p:cNvSpPr>
+          <p:nvPr/>
+        </p:nvSpPr>
+        <p:spPr>
+          <a:xfrm xmlns:a="http://schemas.openxmlformats.org/drawingml/2006/main">
+            <a:off x="4419600" y="3238500"/>
+            <a:ext cx="476250" cy="209550"/>
+          </a:xfrm>
+          <a:prstGeom xmlns:a="http://schemas.openxmlformats.org/drawingml/2006/main" prst="rect">
+            <a:avLst/>
+          </a:prstGeom>
+          <a:noFill xmlns:a="http://schemas.openxmlformats.org/drawingml/2006/main"/>
+          <a:ln xmlns:a="http://schemas.openxmlformats.org/drawingml/2006/main" w="0">
+            <a:noFill/>
+            <a:prstDash val="solid"/>
+          </a:ln>
+        </p:spPr>
+        <p:txBody>
+          <a:bodyPr xmlns:a="http://schemas.openxmlformats.org/drawingml/2006/main"/>
+          <a:lstStyle xmlns:a="http://schemas.openxmlformats.org/drawingml/2006/main"/>
+          <a:p xmlns:a="http://schemas.openxmlformats.org/drawingml/2006/main">
+            <a:pPr algn="l">
+              <a:buNone/>
+              <a:defRPr sz="900" b="1">
+                <a:solidFill>
+                  <a:srgbClr val="FF8159"/>
+                </a:solidFill>
+              </a:defRPr>
+            </a:pPr>
+            <a:r>
+              <a:rPr sz="900" b="1">
+                <a:solidFill>
+                  <a:srgbClr val="FF8159"/>
+                </a:solidFill>
+              </a:rPr>
+              <a:t>03</a:t>
+            </a:r>
+          </a:p>
+        </p:txBody>
+      </p:sp>
+      <p:sp>
+        <p:nvSpPr>
+          <p:cNvPr id="15" name="">
+            <a:extLst xmlns:a="http://schemas.openxmlformats.org/drawingml/2006/main">
+              <a:ext uri="{FF2B5EF4-FFF2-40B4-BE49-F238E27FC236}">
+                <a16:creationId xmlns:a16="http://schemas.microsoft.com/office/drawing/2014/main" id="{06553089-7474-4DD8-A366-961A1948DED8}"/>
+              </a:ext>
+            </a:extLst>
+          </p:cNvPr>
+          <p:cNvSpPr>
+            <a:spLocks xmlns:a="http://schemas.openxmlformats.org/drawingml/2006/main" noGrp="1"/>
+          </p:cNvSpPr>
+          <p:nvPr/>
+        </p:nvSpPr>
+        <p:spPr>
+          <a:xfrm xmlns:a="http://schemas.openxmlformats.org/drawingml/2006/main">
+            <a:off x="4419600" y="3657600"/>
+            <a:ext cx="1219200" cy="257175"/>
+          </a:xfrm>
+          <a:prstGeom xmlns:a="http://schemas.openxmlformats.org/drawingml/2006/main" prst="rect">
+            <a:avLst/>
+          </a:prstGeom>
+          <a:noFill xmlns:a="http://schemas.openxmlformats.org/drawingml/2006/main"/>
+          <a:ln xmlns:a="http://schemas.openxmlformats.org/drawingml/2006/main" w="0">
+            <a:noFill/>
+            <a:prstDash val="solid"/>
+          </a:ln>
+        </p:spPr>
+        <p:txBody>
+          <a:bodyPr xmlns:a="http://schemas.openxmlformats.org/drawingml/2006/main"/>
+          <a:lstStyle xmlns:a="http://schemas.openxmlformats.org/drawingml/2006/main"/>
+          <a:p xmlns:a="http://schemas.openxmlformats.org/drawingml/2006/main">
+            <a:pPr algn="l">
+              <a:buNone/>
+              <a:defRPr sz="1050" b="1">
+                <a:solidFill>
+                  <a:srgbClr val="FFFFFF"/>
+                </a:solidFill>
+              </a:defRPr>
+            </a:pPr>
+            <a:r>
+              <a:rPr sz="1050" b="1">
+                <a:solidFill>
+                  <a:srgbClr val="FFFFFF"/>
+                </a:solidFill>
+              </a:rPr>
+              <a:t>FARM</a:t>
+            </a:r>
+          </a:p>
+        </p:txBody>
+      </p:sp>
+      <p:sp>
+        <p:nvSpPr>
+          <p:cNvPr id="16" name="">
+            <a:extLst xmlns:a="http://schemas.openxmlformats.org/drawingml/2006/main">
+              <a:ext uri="{FF2B5EF4-FFF2-40B4-BE49-F238E27FC236}">
+                <a16:creationId xmlns:a16="http://schemas.microsoft.com/office/drawing/2014/main" id="{4BD3E9F9-86A8-49B2-AEC7-A525F4A59C42}"/>
+              </a:ext>
+            </a:extLst>
+          </p:cNvPr>
+          <p:cNvSpPr>
+            <a:spLocks xmlns:a="http://schemas.openxmlformats.org/drawingml/2006/main" noGrp="1"/>
+          </p:cNvSpPr>
+          <p:nvPr/>
+        </p:nvSpPr>
+        <p:spPr>
+          <a:xfrm xmlns:a="http://schemas.openxmlformats.org/drawingml/2006/main">
+            <a:off x="4419600" y="4095750"/>
+            <a:ext cx="1190625" cy="495300"/>
+          </a:xfrm>
+          <a:prstGeom xmlns:a="http://schemas.openxmlformats.org/drawingml/2006/main" prst="rect">
+            <a:avLst/>
+          </a:prstGeom>
+          <a:noFill xmlns:a="http://schemas.openxmlformats.org/drawingml/2006/main"/>
+          <a:ln xmlns:a="http://schemas.openxmlformats.org/drawingml/2006/main" w="0">
+            <a:noFill/>
+            <a:prstDash val="solid"/>
+          </a:ln>
+        </p:spPr>
+        <p:txBody>
+          <a:bodyPr xmlns:a="http://schemas.openxmlformats.org/drawingml/2006/main"/>
+          <a:lstStyle xmlns:a="http://schemas.openxmlformats.org/drawingml/2006/main"/>
+          <a:p xmlns:a="http://schemas.openxmlformats.org/drawingml/2006/main">
+            <a:pPr algn="l">
+              <a:buNone/>
+              <a:defRPr sz="1050" b="0">
+                <a:solidFill>
+                  <a:srgbClr val="C8D1C8"/>
+                </a:solidFill>
+              </a:defRPr>
+            </a:pPr>
+            <a:r>
+              <a:rPr sz="1050" b="0">
+                <a:solidFill>
+                  <a:srgbClr val="C8D1C8"/>
+                </a:solidFill>
+              </a:rPr>
+              <a:t>Three provider runners</a:t>
+            </a:r>
+          </a:p>
+        </p:txBody>
+      </p:sp>
+      <p:sp>
+        <p:nvSpPr>
+          <p:cNvPr id="17" name="">
+            <a:extLst xmlns:a="http://schemas.openxmlformats.org/drawingml/2006/main">
+              <a:ext uri="{FF2B5EF4-FFF2-40B4-BE49-F238E27FC236}">
+                <a16:creationId xmlns:a16="http://schemas.microsoft.com/office/drawing/2014/main" id="{FA044EE6-A973-464A-8DE6-0F5C47476EBA}"/>
+              </a:ext>
+            </a:extLst>
+          </p:cNvPr>
+          <p:cNvSpPr>
+            <a:spLocks xmlns:a="http://schemas.openxmlformats.org/drawingml/2006/main" noGrp="1"/>
+          </p:cNvSpPr>
+          <p:nvPr/>
+        </p:nvSpPr>
+        <p:spPr>
+          <a:xfrm xmlns:a="http://schemas.openxmlformats.org/drawingml/2006/main">
+            <a:off x="6029325" y="3048000"/>
+            <a:ext cx="1524000" cy="1666875"/>
+          </a:xfrm>
+          <a:prstGeom xmlns:a="http://schemas.openxmlformats.org/drawingml/2006/main" prst="roundRect">
+            <a:avLst>
+              <a:gd name="adj" fmla="val 11250"/>
+            </a:avLst>
+          </a:prstGeom>
+          <a:solidFill xmlns:a="http://schemas.openxmlformats.org/drawingml/2006/main">
+            <a:srgbClr val="223022"/>
+          </a:solidFill>
+          <a:ln xmlns:a="http://schemas.openxmlformats.org/drawingml/2006/main" w="9525">
+            <a:solidFill>
+              <a:srgbClr val="455345"/>
+            </a:solidFill>
+            <a:prstDash val="solid"/>
+          </a:ln>
+        </p:spPr>
+      </p:sp>
+      <p:sp>
+        <p:nvSpPr>
+          <p:cNvPr id="18" name="">
+            <a:extLst xmlns:a="http://schemas.openxmlformats.org/drawingml/2006/main">
+              <a:ext uri="{FF2B5EF4-FFF2-40B4-BE49-F238E27FC236}">
+                <a16:creationId xmlns:a16="http://schemas.microsoft.com/office/drawing/2014/main" id="{C0AF604B-FAE1-46F5-89CD-AF9CA900342E}"/>
+              </a:ext>
+            </a:extLst>
+          </p:cNvPr>
+          <p:cNvSpPr>
+            <a:spLocks xmlns:a="http://schemas.openxmlformats.org/drawingml/2006/main" noGrp="1"/>
+          </p:cNvSpPr>
+          <p:nvPr/>
+        </p:nvSpPr>
+        <p:spPr>
+          <a:xfrm xmlns:a="http://schemas.openxmlformats.org/drawingml/2006/main">
+            <a:off x="6200775" y="3238500"/>
+            <a:ext cx="476250" cy="209550"/>
+          </a:xfrm>
+          <a:prstGeom xmlns:a="http://schemas.openxmlformats.org/drawingml/2006/main" prst="rect">
+            <a:avLst/>
+          </a:prstGeom>
+          <a:noFill xmlns:a="http://schemas.openxmlformats.org/drawingml/2006/main"/>
+          <a:ln xmlns:a="http://schemas.openxmlformats.org/drawingml/2006/main" w="0">
+            <a:noFill/>
+            <a:prstDash val="solid"/>
+          </a:ln>
+        </p:spPr>
+        <p:txBody>
+          <a:bodyPr xmlns:a="http://schemas.openxmlformats.org/drawingml/2006/main"/>
+          <a:lstStyle xmlns:a="http://schemas.openxmlformats.org/drawingml/2006/main"/>
+          <a:p xmlns:a="http://schemas.openxmlformats.org/drawingml/2006/main">
+            <a:pPr algn="l">
+              <a:buNone/>
+              <a:defRPr sz="900" b="1">
+                <a:solidFill>
+                  <a:srgbClr val="D8FF55"/>
+                </a:solidFill>
+              </a:defRPr>
+            </a:pPr>
+            <a:r>
+              <a:rPr sz="900" b="1">
+                <a:solidFill>
+                  <a:srgbClr val="D8FF55"/>
+                </a:solidFill>
+              </a:rPr>
+              <a:t>04</a:t>
+            </a:r>
+          </a:p>
+        </p:txBody>
+      </p:sp>
+      <p:sp>
+        <p:nvSpPr>
+          <p:cNvPr id="19" name="">
+            <a:extLst xmlns:a="http://schemas.openxmlformats.org/drawingml/2006/main">
+              <a:ext uri="{FF2B5EF4-FFF2-40B4-BE49-F238E27FC236}">
+                <a16:creationId xmlns:a16="http://schemas.microsoft.com/office/drawing/2014/main" id="{84D17153-0F79-465B-8E65-0F2A102F6A03}"/>
+              </a:ext>
+            </a:extLst>
+          </p:cNvPr>
+          <p:cNvSpPr>
+            <a:spLocks xmlns:a="http://schemas.openxmlformats.org/drawingml/2006/main" noGrp="1"/>
+          </p:cNvSpPr>
+          <p:nvPr/>
+        </p:nvSpPr>
+        <p:spPr>
+          <a:xfrm xmlns:a="http://schemas.openxmlformats.org/drawingml/2006/main">
+            <a:off x="6200775" y="3657600"/>
+            <a:ext cx="1219200" cy="257175"/>
+          </a:xfrm>
+          <a:prstGeom xmlns:a="http://schemas.openxmlformats.org/drawingml/2006/main" prst="rect">
+            <a:avLst/>
+          </a:prstGeom>
+          <a:noFill xmlns:a="http://schemas.openxmlformats.org/drawingml/2006/main"/>
+          <a:ln xmlns:a="http://schemas.openxmlformats.org/drawingml/2006/main" w="0">
+            <a:noFill/>
+            <a:prstDash val="solid"/>
+          </a:ln>
+        </p:spPr>
+        <p:txBody>
+          <a:bodyPr xmlns:a="http://schemas.openxmlformats.org/drawingml/2006/main"/>
+          <a:lstStyle xmlns:a="http://schemas.openxmlformats.org/drawingml/2006/main"/>
+          <a:p xmlns:a="http://schemas.openxmlformats.org/drawingml/2006/main">
+            <a:pPr algn="l">
+              <a:buNone/>
+              <a:defRPr sz="1050" b="1">
+                <a:solidFill>
+                  <a:srgbClr val="FFFFFF"/>
+                </a:solidFill>
+              </a:defRPr>
+            </a:pPr>
+            <a:r>
+              <a:rPr sz="1050" b="1">
+                <a:solidFill>
+                  <a:srgbClr val="FFFFFF"/>
+                </a:solidFill>
+              </a:rPr>
+              <a:t>SCORE</a:t>
+            </a:r>
+          </a:p>
+        </p:txBody>
+      </p:sp>
+      <p:sp>
+        <p:nvSpPr>
+          <p:cNvPr id="20" name="">
+            <a:extLst xmlns:a="http://schemas.openxmlformats.org/drawingml/2006/main">
+              <a:ext uri="{FF2B5EF4-FFF2-40B4-BE49-F238E27FC236}">
+                <a16:creationId xmlns:a16="http://schemas.microsoft.com/office/drawing/2014/main" id="{156A8EC0-5428-4CE4-86DB-4547A061B82D}"/>
+              </a:ext>
+            </a:extLst>
+          </p:cNvPr>
+          <p:cNvSpPr>
+            <a:spLocks xmlns:a="http://schemas.openxmlformats.org/drawingml/2006/main" noGrp="1"/>
+          </p:cNvSpPr>
+          <p:nvPr/>
+        </p:nvSpPr>
+        <p:spPr>
+          <a:xfrm xmlns:a="http://schemas.openxmlformats.org/drawingml/2006/main">
+            <a:off x="6200775" y="4095750"/>
+            <a:ext cx="1190625" cy="495300"/>
+          </a:xfrm>
+          <a:prstGeom xmlns:a="http://schemas.openxmlformats.org/drawingml/2006/main" prst="rect">
+            <a:avLst/>
+          </a:prstGeom>
+          <a:noFill xmlns:a="http://schemas.openxmlformats.org/drawingml/2006/main"/>
+          <a:ln xmlns:a="http://schemas.openxmlformats.org/drawingml/2006/main" w="0">
+            <a:noFill/>
+            <a:prstDash val="solid"/>
+          </a:ln>
+        </p:spPr>
+        <p:txBody>
+          <a:bodyPr xmlns:a="http://schemas.openxmlformats.org/drawingml/2006/main"/>
+          <a:lstStyle xmlns:a="http://schemas.openxmlformats.org/drawingml/2006/main"/>
+          <a:p xmlns:a="http://schemas.openxmlformats.org/drawingml/2006/main">
+            <a:pPr algn="l">
+              <a:buNone/>
+              <a:defRPr sz="1050" b="0">
+                <a:solidFill>
+                  <a:srgbClr val="C8D1C8"/>
+                </a:solidFill>
+              </a:defRPr>
+            </a:pPr>
+            <a:r>
+              <a:rPr sz="1050" b="0">
+                <a:solidFill>
+                  <a:srgbClr val="C8D1C8"/>
+                </a:solidFill>
+              </a:rPr>
+              <a:t>Success · latency · cost</a:t>
+            </a:r>
+          </a:p>
+        </p:txBody>
+      </p:sp>
+      <p:sp>
+        <p:nvSpPr>
+          <p:cNvPr id="21" name="">
+            <a:extLst xmlns:a="http://schemas.openxmlformats.org/drawingml/2006/main">
+              <a:ext uri="{FF2B5EF4-FFF2-40B4-BE49-F238E27FC236}">
+                <a16:creationId xmlns:a16="http://schemas.microsoft.com/office/drawing/2014/main" id="{E6848313-6EC6-4AB0-BCB7-DD2F6DACB709}"/>
+              </a:ext>
+            </a:extLst>
+          </p:cNvPr>
+          <p:cNvSpPr>
+            <a:spLocks xmlns:a="http://schemas.openxmlformats.org/drawingml/2006/main" noGrp="1"/>
+          </p:cNvSpPr>
+          <p:nvPr/>
+        </p:nvSpPr>
+        <p:spPr>
+          <a:xfrm xmlns:a="http://schemas.openxmlformats.org/drawingml/2006/main">
+            <a:off x="7810500" y="3048000"/>
+            <a:ext cx="1524000" cy="1666875"/>
+          </a:xfrm>
+          <a:prstGeom xmlns:a="http://schemas.openxmlformats.org/drawingml/2006/main" prst="roundRect">
+            <a:avLst>
+              <a:gd name="adj" fmla="val 11250"/>
+            </a:avLst>
+          </a:prstGeom>
+          <a:solidFill xmlns:a="http://schemas.openxmlformats.org/drawingml/2006/main">
+            <a:srgbClr val="223022"/>
+          </a:solidFill>
+          <a:ln xmlns:a="http://schemas.openxmlformats.org/drawingml/2006/main" w="9525">
+            <a:solidFill>
+              <a:srgbClr val="455345"/>
+            </a:solidFill>
+            <a:prstDash val="solid"/>
+          </a:ln>
+        </p:spPr>
+      </p:sp>
+      <p:sp>
+        <p:nvSpPr>
+          <p:cNvPr id="22" name="">
+            <a:extLst xmlns:a="http://schemas.openxmlformats.org/drawingml/2006/main">
+              <a:ext uri="{FF2B5EF4-FFF2-40B4-BE49-F238E27FC236}">
+                <a16:creationId xmlns:a16="http://schemas.microsoft.com/office/drawing/2014/main" id="{6A50CBF7-37EE-47F1-8E2C-D928AAA3C6EA}"/>
+              </a:ext>
+            </a:extLst>
+          </p:cNvPr>
+          <p:cNvSpPr>
+            <a:spLocks xmlns:a="http://schemas.openxmlformats.org/drawingml/2006/main" noGrp="1"/>
+          </p:cNvSpPr>
+          <p:nvPr/>
+        </p:nvSpPr>
+        <p:spPr>
+          <a:xfrm xmlns:a="http://schemas.openxmlformats.org/drawingml/2006/main">
+            <a:off x="7981950" y="3238500"/>
+            <a:ext cx="476250" cy="209550"/>
+          </a:xfrm>
+          <a:prstGeom xmlns:a="http://schemas.openxmlformats.org/drawingml/2006/main" prst="rect">
+            <a:avLst/>
+          </a:prstGeom>
+          <a:noFill xmlns:a="http://schemas.openxmlformats.org/drawingml/2006/main"/>
+          <a:ln xmlns:a="http://schemas.openxmlformats.org/drawingml/2006/main" w="0">
+            <a:noFill/>
+            <a:prstDash val="solid"/>
+          </a:ln>
+        </p:spPr>
+        <p:txBody>
+          <a:bodyPr xmlns:a="http://schemas.openxmlformats.org/drawingml/2006/main"/>
+          <a:lstStyle xmlns:a="http://schemas.openxmlformats.org/drawingml/2006/main"/>
+          <a:p xmlns:a="http://schemas.openxmlformats.org/drawingml/2006/main">
+            <a:pPr algn="l">
+              <a:buNone/>
+              <a:defRPr sz="900" b="1">
+                <a:solidFill>
+                  <a:srgbClr val="8F7BFF"/>
+                </a:solidFill>
+              </a:defRPr>
+            </a:pPr>
+            <a:r>
+              <a:rPr sz="900" b="1">
+                <a:solidFill>
+                  <a:srgbClr val="8F7BFF"/>
+                </a:solidFill>
+              </a:rPr>
+              <a:t>05</a:t>
+            </a:r>
+          </a:p>
+        </p:txBody>
+      </p:sp>
+      <p:sp>
+        <p:nvSpPr>
+          <p:cNvPr id="23" name="">
+            <a:extLst xmlns:a="http://schemas.openxmlformats.org/drawingml/2006/main">
+              <a:ext uri="{FF2B5EF4-FFF2-40B4-BE49-F238E27FC236}">
+                <a16:creationId xmlns:a16="http://schemas.microsoft.com/office/drawing/2014/main" id="{C7A4F8B1-E43D-450F-9D7F-8B07D1A320A6}"/>
+              </a:ext>
+            </a:extLst>
+          </p:cNvPr>
+          <p:cNvSpPr>
+            <a:spLocks xmlns:a="http://schemas.openxmlformats.org/drawingml/2006/main" noGrp="1"/>
+          </p:cNvSpPr>
+          <p:nvPr/>
+        </p:nvSpPr>
+        <p:spPr>
+          <a:xfrm xmlns:a="http://schemas.openxmlformats.org/drawingml/2006/main">
+            <a:off x="7981950" y="3657600"/>
+            <a:ext cx="1219200" cy="257175"/>
+          </a:xfrm>
+          <a:prstGeom xmlns:a="http://schemas.openxmlformats.org/drawingml/2006/main" prst="rect">
+            <a:avLst/>
+          </a:prstGeom>
+          <a:noFill xmlns:a="http://schemas.openxmlformats.org/drawingml/2006/main"/>
+          <a:ln xmlns:a="http://schemas.openxmlformats.org/drawingml/2006/main" w="0">
+            <a:noFill/>
+            <a:prstDash val="solid"/>
+          </a:ln>
+        </p:spPr>
+        <p:txBody>
+          <a:bodyPr xmlns:a="http://schemas.openxmlformats.org/drawingml/2006/main"/>
+          <a:lstStyle xmlns:a="http://schemas.openxmlformats.org/drawingml/2006/main"/>
+          <a:p xmlns:a="http://schemas.openxmlformats.org/drawingml/2006/main">
+            <a:pPr algn="l">
+              <a:buNone/>
+              <a:defRPr sz="1050" b="1">
+                <a:solidFill>
+                  <a:srgbClr val="FFFFFF"/>
+                </a:solidFill>
+              </a:defRPr>
+            </a:pPr>
+            <a:r>
+              <a:rPr sz="1050" b="1">
+                <a:solidFill>
+                  <a:srgbClr val="FFFFFF"/>
+                </a:solidFill>
+              </a:rPr>
+              <a:t>GOVERN</a:t>
+            </a:r>
+          </a:p>
+        </p:txBody>
+      </p:sp>
+      <p:sp>
+        <p:nvSpPr>
+          <p:cNvPr id="24" name="">
+            <a:extLst xmlns:a="http://schemas.openxmlformats.org/drawingml/2006/main">
+              <a:ext uri="{FF2B5EF4-FFF2-40B4-BE49-F238E27FC236}">
+                <a16:creationId xmlns:a16="http://schemas.microsoft.com/office/drawing/2014/main" id="{B4A9F002-87D8-4422-A02A-85E4D660A6C5}"/>
+              </a:ext>
+            </a:extLst>
+          </p:cNvPr>
+          <p:cNvSpPr>
+            <a:spLocks xmlns:a="http://schemas.openxmlformats.org/drawingml/2006/main" noGrp="1"/>
+          </p:cNvSpPr>
+          <p:nvPr/>
+        </p:nvSpPr>
+        <p:spPr>
+          <a:xfrm xmlns:a="http://schemas.openxmlformats.org/drawingml/2006/main">
+            <a:off x="7981950" y="4095750"/>
+            <a:ext cx="1190625" cy="495300"/>
+          </a:xfrm>
+          <a:prstGeom xmlns:a="http://schemas.openxmlformats.org/drawingml/2006/main" prst="rect">
+            <a:avLst/>
+          </a:prstGeom>
+          <a:noFill xmlns:a="http://schemas.openxmlformats.org/drawingml/2006/main"/>
+          <a:ln xmlns:a="http://schemas.openxmlformats.org/drawingml/2006/main" w="0">
+            <a:noFill/>
+            <a:prstDash val="solid"/>
+          </a:ln>
+        </p:spPr>
+        <p:txBody>
+          <a:bodyPr xmlns:a="http://schemas.openxmlformats.org/drawingml/2006/main"/>
+          <a:lstStyle xmlns:a="http://schemas.openxmlformats.org/drawingml/2006/main"/>
+          <a:p xmlns:a="http://schemas.openxmlformats.org/drawingml/2006/main">
+            <a:pPr algn="l">
+              <a:buNone/>
+              <a:defRPr sz="1050" b="0">
+                <a:solidFill>
+                  <a:srgbClr val="C8D1C8"/>
+                </a:solidFill>
+              </a:defRPr>
+            </a:pPr>
+            <a:r>
+              <a:rPr sz="1050" b="0">
+                <a:solidFill>
+                  <a:srgbClr val="C8D1C8"/>
+                </a:solidFill>
+              </a:rPr>
+              <a:t>Rules + evidence gates</a:t>
+            </a:r>
+          </a:p>
+        </p:txBody>
+      </p:sp>
+      <p:sp>
+        <p:nvSpPr>
+          <p:cNvPr id="25" name="">
+            <a:extLst xmlns:a="http://schemas.openxmlformats.org/drawingml/2006/main">
+              <a:ext uri="{FF2B5EF4-FFF2-40B4-BE49-F238E27FC236}">
+                <a16:creationId xmlns:a16="http://schemas.microsoft.com/office/drawing/2014/main" id="{61489C50-EF27-423D-8579-42767AF40DB6}"/>
+              </a:ext>
+            </a:extLst>
+          </p:cNvPr>
+          <p:cNvSpPr>
+            <a:spLocks xmlns:a="http://schemas.openxmlformats.org/drawingml/2006/main" noGrp="1"/>
+          </p:cNvSpPr>
+          <p:nvPr/>
+        </p:nvSpPr>
+        <p:spPr>
+          <a:xfrm xmlns:a="http://schemas.openxmlformats.org/drawingml/2006/main">
+            <a:off x="9591675" y="3048000"/>
+            <a:ext cx="1524000" cy="1666875"/>
+          </a:xfrm>
+          <a:prstGeom xmlns:a="http://schemas.openxmlformats.org/drawingml/2006/main" prst="roundRect">
+            <a:avLst>
+              <a:gd name="adj" fmla="val 11250"/>
+            </a:avLst>
+          </a:prstGeom>
+          <a:solidFill xmlns:a="http://schemas.openxmlformats.org/drawingml/2006/main">
+            <a:srgbClr val="D8FF55"/>
+          </a:solidFill>
+          <a:ln xmlns:a="http://schemas.openxmlformats.org/drawingml/2006/main" w="0">
+            <a:noFill/>
+            <a:prstDash val="solid"/>
+          </a:ln>
+        </p:spPr>
+      </p:sp>
+      <p:sp>
+        <p:nvSpPr>
+          <p:cNvPr id="26" name="">
+            <a:extLst xmlns:a="http://schemas.openxmlformats.org/drawingml/2006/main">
+              <a:ext uri="{FF2B5EF4-FFF2-40B4-BE49-F238E27FC236}">
+                <a16:creationId xmlns:a16="http://schemas.microsoft.com/office/drawing/2014/main" id="{6607E68B-F340-41D8-9512-BAB065A482E6}"/>
+              </a:ext>
+            </a:extLst>
+          </p:cNvPr>
+          <p:cNvSpPr>
+            <a:spLocks xmlns:a="http://schemas.openxmlformats.org/drawingml/2006/main" noGrp="1"/>
+          </p:cNvSpPr>
+          <p:nvPr/>
+        </p:nvSpPr>
+        <p:spPr>
+          <a:xfrm xmlns:a="http://schemas.openxmlformats.org/drawingml/2006/main">
+            <a:off x="9763125" y="3238500"/>
+            <a:ext cx="476250" cy="209550"/>
+          </a:xfrm>
+          <a:prstGeom xmlns:a="http://schemas.openxmlformats.org/drawingml/2006/main" prst="rect">
+            <a:avLst/>
+          </a:prstGeom>
+          <a:noFill xmlns:a="http://schemas.openxmlformats.org/drawingml/2006/main"/>
+          <a:ln xmlns:a="http://schemas.openxmlformats.org/drawingml/2006/main" w="0">
+            <a:noFill/>
+            <a:prstDash val="solid"/>
+          </a:ln>
+        </p:spPr>
+        <p:txBody>
+          <a:bodyPr xmlns:a="http://schemas.openxmlformats.org/drawingml/2006/main"/>
+          <a:lstStyle xmlns:a="http://schemas.openxmlformats.org/drawingml/2006/main"/>
+          <a:p xmlns:a="http://schemas.openxmlformats.org/drawingml/2006/main">
+            <a:pPr algn="l">
+              <a:buNone/>
+              <a:defRPr sz="900" b="1">
+                <a:solidFill>
+                  <a:srgbClr val="152015"/>
+                </a:solidFill>
+              </a:defRPr>
+            </a:pPr>
+            <a:r>
+              <a:rPr sz="900" b="1">
+                <a:solidFill>
+                  <a:srgbClr val="152015"/>
+                </a:solidFill>
+              </a:rPr>
+              <a:t>06</a:t>
+            </a:r>
+          </a:p>
+        </p:txBody>
+      </p:sp>
+      <p:sp>
+        <p:nvSpPr>
+          <p:cNvPr id="27" name="">
+            <a:extLst xmlns:a="http://schemas.openxmlformats.org/drawingml/2006/main">
+              <a:ext uri="{FF2B5EF4-FFF2-40B4-BE49-F238E27FC236}">
+                <a16:creationId xmlns:a16="http://schemas.microsoft.com/office/drawing/2014/main" id="{12FA8381-87C9-4C8C-B66F-83068E3100DE}"/>
+              </a:ext>
+            </a:extLst>
+          </p:cNvPr>
+          <p:cNvSpPr>
+            <a:spLocks xmlns:a="http://schemas.openxmlformats.org/drawingml/2006/main" noGrp="1"/>
+          </p:cNvSpPr>
+          <p:nvPr/>
+        </p:nvSpPr>
+        <p:spPr>
+          <a:xfrm xmlns:a="http://schemas.openxmlformats.org/drawingml/2006/main">
+            <a:off x="9763125" y="3657600"/>
+            <a:ext cx="1219200" cy="257175"/>
+          </a:xfrm>
+          <a:prstGeom xmlns:a="http://schemas.openxmlformats.org/drawingml/2006/main" prst="rect">
+            <a:avLst/>
+          </a:prstGeom>
+          <a:noFill xmlns:a="http://schemas.openxmlformats.org/drawingml/2006/main"/>
+          <a:ln xmlns:a="http://schemas.openxmlformats.org/drawingml/2006/main" w="0">
+            <a:noFill/>
+            <a:prstDash val="solid"/>
+          </a:ln>
+        </p:spPr>
+        <p:txBody>
+          <a:bodyPr xmlns:a="http://schemas.openxmlformats.org/drawingml/2006/main"/>
+          <a:lstStyle xmlns:a="http://schemas.openxmlformats.org/drawingml/2006/main"/>
+          <a:p xmlns:a="http://schemas.openxmlformats.org/drawingml/2006/main">
+            <a:pPr algn="l">
+              <a:buNone/>
+              <a:defRPr sz="1050" b="1">
+                <a:solidFill>
+                  <a:srgbClr val="152015"/>
+                </a:solidFill>
+              </a:defRPr>
+            </a:pPr>
+            <a:r>
+              <a:rPr sz="1050" b="1">
+                <a:solidFill>
+                  <a:srgbClr val="152015"/>
+                </a:solidFill>
+              </a:rPr>
+              <a:t>REPORT</a:t>
+            </a:r>
+          </a:p>
+        </p:txBody>
+      </p:sp>
+      <p:sp>
+        <p:nvSpPr>
+          <p:cNvPr id="28" name="">
+            <a:extLst xmlns:a="http://schemas.openxmlformats.org/drawingml/2006/main">
+              <a:ext uri="{FF2B5EF4-FFF2-40B4-BE49-F238E27FC236}">
+                <a16:creationId xmlns:a16="http://schemas.microsoft.com/office/drawing/2014/main" id="{B98F5683-0D97-4094-A83B-0A0EC6739306}"/>
+              </a:ext>
+            </a:extLst>
+          </p:cNvPr>
+          <p:cNvSpPr>
+            <a:spLocks xmlns:a="http://schemas.openxmlformats.org/drawingml/2006/main" noGrp="1"/>
+          </p:cNvSpPr>
+          <p:nvPr/>
+        </p:nvSpPr>
+        <p:spPr>
+          <a:xfrm xmlns:a="http://schemas.openxmlformats.org/drawingml/2006/main">
+            <a:off x="9763125" y="4095750"/>
+            <a:ext cx="1190625" cy="495300"/>
+          </a:xfrm>
+          <a:prstGeom xmlns:a="http://schemas.openxmlformats.org/drawingml/2006/main" prst="rect">
+            <a:avLst/>
+          </a:prstGeom>
+          <a:noFill xmlns:a="http://schemas.openxmlformats.org/drawingml/2006/main"/>
+          <a:ln xmlns:a="http://schemas.openxmlformats.org/drawingml/2006/main" w="0">
+            <a:noFill/>
+            <a:prstDash val="solid"/>
+          </a:ln>
+        </p:spPr>
+        <p:txBody>
+          <a:bodyPr xmlns:a="http://schemas.openxmlformats.org/drawingml/2006/main"/>
+          <a:lstStyle xmlns:a="http://schemas.openxmlformats.org/drawingml/2006/main"/>
+          <a:p xmlns:a="http://schemas.openxmlformats.org/drawingml/2006/main">
+            <a:pPr algn="l">
+              <a:buNone/>
+              <a:defRPr sz="1050" b="0">
+                <a:solidFill>
+                  <a:srgbClr val="152015"/>
+                </a:solidFill>
+              </a:defRPr>
+            </a:pPr>
+            <a:r>
+              <a:rPr sz="1050" b="0">
+                <a:solidFill>
+                  <a:srgbClr val="152015"/>
+                </a:solidFill>
+              </a:rPr>
+              <a:t>Export or flush</a:t>
+            </a:r>
+          </a:p>
+        </p:txBody>
+      </p:sp>
+      <p:sp>
+        <p:nvSpPr>
+          <p:cNvPr id="29" name="">
+            <a:extLst xmlns:a="http://schemas.openxmlformats.org/drawingml/2006/main">
+              <a:ext uri="{FF2B5EF4-FFF2-40B4-BE49-F238E27FC236}">
+                <a16:creationId xmlns:a16="http://schemas.microsoft.com/office/drawing/2014/main" id="{255768F6-867A-426D-8DC3-D5C1E189EFF5}"/>
+              </a:ext>
+            </a:extLst>
+          </p:cNvPr>
+          <p:cNvSpPr>
+            <a:spLocks xmlns:a="http://schemas.openxmlformats.org/drawingml/2006/main" noGrp="1"/>
+          </p:cNvSpPr>
+          <p:nvPr/>
+        </p:nvSpPr>
+        <p:spPr>
+          <a:xfrm xmlns:a="http://schemas.openxmlformats.org/drawingml/2006/main">
+            <a:off x="685800" y="5286375"/>
+            <a:ext cx="10001250" cy="457200"/>
+          </a:xfrm>
+          <a:prstGeom xmlns:a="http://schemas.openxmlformats.org/drawingml/2006/main" prst="rect">
+            <a:avLst/>
+          </a:prstGeom>
+          <a:noFill xmlns:a="http://schemas.openxmlformats.org/drawingml/2006/main"/>
+          <a:ln xmlns:a="http://schemas.openxmlformats.org/drawingml/2006/main" w="0">
+            <a:noFill/>
+            <a:prstDash val="solid"/>
+          </a:ln>
+        </p:spPr>
+        <p:txBody>
+          <a:bodyPr xmlns:a="http://schemas.openxmlformats.org/drawingml/2006/main"/>
+          <a:lstStyle xmlns:a="http://schemas.openxmlformats.org/drawingml/2006/main"/>
+          <a:p xmlns:a="http://schemas.openxmlformats.org/drawingml/2006/main">
+            <a:pPr algn="l">
+              <a:buNone/>
+              <a:defRPr sz="1725" b="1">
+                <a:solidFill>
+                  <a:srgbClr val="D8FF55"/>
+                </a:solidFill>
+              </a:defRPr>
+            </a:pPr>
+            <a:r>
+              <a:rPr sz="1725" b="1">
+                <a:solidFill>
+                  <a:srgbClr val="D8FF55"/>
+                </a:solidFill>
+              </a:rPr>
+              <a:t>Catalog comparison stays $0. Live runs start only after a disclosed ceiling and explicit approval.</a:t>
+            </a:r>
+          </a:p>
+        </p:txBody>
+      </p:sp>
+      <p:sp>
+        <p:nvSpPr>
+          <p:cNvPr id="30" name="">
+            <a:extLst xmlns:a="http://schemas.openxmlformats.org/drawingml/2006/main">
+              <a:ext uri="{FF2B5EF4-FFF2-40B4-BE49-F238E27FC236}">
+                <a16:creationId xmlns:a16="http://schemas.microsoft.com/office/drawing/2014/main" id="{C7B803FE-BC72-488F-B900-B932946E02B7}"/>
+              </a:ext>
+            </a:extLst>
+          </p:cNvPr>
+          <p:cNvSpPr>
+            <a:spLocks xmlns:a="http://schemas.openxmlformats.org/drawingml/2006/main" noGrp="1"/>
+          </p:cNvSpPr>
+          <p:nvPr/>
+        </p:nvSpPr>
+        <p:spPr>
+          <a:xfrm xmlns:a="http://schemas.openxmlformats.org/drawingml/2006/main">
+            <a:off x="685800" y="6496050"/>
+            <a:ext cx="4000500" cy="171450"/>
+          </a:xfrm>
+          <a:prstGeom xmlns:a="http://schemas.openxmlformats.org/drawingml/2006/main" prst="rect">
+            <a:avLst/>
+          </a:prstGeom>
+          <a:noFill xmlns:a="http://schemas.openxmlformats.org/drawingml/2006/main"/>
+          <a:ln xmlns:a="http://schemas.openxmlformats.org/drawingml/2006/main" w="0">
+            <a:noFill/>
+            <a:prstDash val="solid"/>
+          </a:ln>
+        </p:spPr>
+        <p:txBody>
+          <a:bodyPr xmlns:a="http://schemas.openxmlformats.org/drawingml/2006/main"/>
+          <a:lstStyle xmlns:a="http://schemas.openxmlformats.org/drawingml/2006/main"/>
+          <a:p xmlns:a="http://schemas.openxmlformats.org/drawingml/2006/main">
+            <a:pPr algn="l">
+              <a:buNone/>
+              <a:defRPr sz="825" b="1">
+                <a:solidFill>
+                  <a:srgbClr val="B7C0B7"/>
+                </a:solidFill>
+              </a:defRPr>
+            </a:pPr>
+            <a:r>
+              <a:rPr sz="825" b="1">
+                <a:solidFill>
+                  <a:srgbClr val="B7C0B7"/>
+                </a:solidFill>
+              </a:rPr>
+              <a:t>AI BUILD CREW · BADLABZ.COM</a:t>
+            </a:r>
+          </a:p>
+        </p:txBody>
+      </p:sp>
+      <p:sp>
+        <p:nvSpPr>
+          <p:cNvPr id="31" name="">
+            <a:extLst xmlns:a="http://schemas.openxmlformats.org/drawingml/2006/main">
+              <a:ext uri="{FF2B5EF4-FFF2-40B4-BE49-F238E27FC236}">
+                <a16:creationId xmlns:a16="http://schemas.microsoft.com/office/drawing/2014/main" id="{CA373767-CC7C-4CDC-AADE-0F0B9DA627CD}"/>
+              </a:ext>
+            </a:extLst>
+          </p:cNvPr>
+          <p:cNvSpPr>
+            <a:spLocks xmlns:a="http://schemas.openxmlformats.org/drawingml/2006/main" noGrp="1"/>
+          </p:cNvSpPr>
+          <p:nvPr/>
+        </p:nvSpPr>
+        <p:spPr>
+          <a:xfrm xmlns:a="http://schemas.openxmlformats.org/drawingml/2006/main">
+            <a:off x="10858500" y="6496050"/>
+            <a:ext cx="647700" cy="171450"/>
+          </a:xfrm>
+          <a:prstGeom xmlns:a="http://schemas.openxmlformats.org/drawingml/2006/main" prst="rect">
+            <a:avLst/>
+          </a:prstGeom>
+          <a:noFill xmlns:a="http://schemas.openxmlformats.org/drawingml/2006/main"/>
+          <a:ln xmlns:a="http://schemas.openxmlformats.org/drawingml/2006/main" w="0">
+            <a:noFill/>
+            <a:prstDash val="solid"/>
+          </a:ln>
+        </p:spPr>
+        <p:txBody>
+          <a:bodyPr xmlns:a="http://schemas.openxmlformats.org/drawingml/2006/main"/>
+          <a:lstStyle xmlns:a="http://schemas.openxmlformats.org/drawingml/2006/main"/>
+          <a:p xmlns:a="http://schemas.openxmlformats.org/drawingml/2006/main">
+            <a:pPr algn="r">
+              <a:buNone/>
+              <a:defRPr sz="825" b="1">
+                <a:solidFill>
+                  <a:srgbClr val="D8FF55"/>
+                </a:solidFill>
+              </a:defRPr>
+            </a:pPr>
+            <a:r>
+              <a:rPr sz="825" b="1">
+                <a:solidFill>
+                  <a:srgbClr val="D8FF55"/>
+                </a:solidFill>
+              </a:rPr>
+              <a:t>10</a:t>
+            </a:r>
+          </a:p>
+        </p:txBody>
+      </p:sp>
+    </p:spTree>
+    <p:extLst>
+      <p:ext uri="{BB962C8B-B14F-4D97-AF65-F5344CB8AC3E}">
+        <p14:creationId xmlns:p14="http://schemas.microsoft.com/office/powerpoint/2010/main" val="707526045"/>
+      </p:ext>
+    </p:extLst>
+  </p:cSld>
+</p:sld>
+</file>
+
+<file path=ppt/slides/slide11.xml><?xml version="1.0" encoding="utf-8"?>
+<p:sld xmlns:p="http://schemas.openxmlformats.org/presentationml/2006/main">
+  <p:cSld>
+    <p:spTree>
+      <p:nvGrpSpPr>
+        <p:cNvPr id="1" name=""/>
+        <p:cNvGrpSpPr/>
+        <p:nvPr/>
+      </p:nvGrpSpPr>
+      <p:grpSpPr>
+        <a:xfrm xmlns:a="http://schemas.openxmlformats.org/drawingml/2006/main"/>
+      </p:grpSpPr>
+      <p:pic>
+        <p:nvPicPr>
+          <p:cNvPr id="20" name=""/>
+          <p:cNvPicPr>
+            <a:picLocks xmlns:a="http://schemas.openxmlformats.org/drawingml/2006/main" noChangeAspect="1"/>
+          </p:cNvPicPr>
+          <p:nvPr/>
+        </p:nvPicPr>
+        <p:blipFill>
+          <a:blip xmlns:r="http://schemas.openxmlformats.org/officeDocument/2006/relationships" xmlns:a="http://schemas.openxmlformats.org/drawingml/2006/main" r:embed="R97fdd1ca7be34a35"/>
+          <a:srcRect xmlns:a="http://schemas.openxmlformats.org/drawingml/2006/main" l="0" t="27" r="0" b="27"/>
+          <a:stretch xmlns:a="http://schemas.openxmlformats.org/drawingml/2006/main">
+            <a:fillRect l="0" t="0" r="0" b="0"/>
+          </a:stretch>
+        </p:blipFill>
+        <p:spPr>
+          <a:xfrm xmlns:a="http://schemas.openxmlformats.org/drawingml/2006/main">
+            <a:off x="0" y="0"/>
+            <a:ext cx="12192000" cy="6858000"/>
+          </a:xfrm>
+          <a:prstGeom xmlns:a="http://schemas.openxmlformats.org/drawingml/2006/main" prst="rect">
+            <a:avLst/>
+          </a:prstGeom>
+        </p:spPr>
+      </p:pic>
+      <p:sp>
+        <p:nvSpPr>
+          <p:cNvPr id="2" name="">
+            <a:extLst xmlns:a="http://schemas.openxmlformats.org/drawingml/2006/main">
+              <a:ext uri="{FF2B5EF4-FFF2-40B4-BE49-F238E27FC236}">
+                <a16:creationId xmlns:a16="http://schemas.microsoft.com/office/drawing/2014/main" id="{26505945-590A-4C2D-98F2-EED54361D376}"/>
+              </a:ext>
+            </a:extLst>
+          </p:cNvPr>
+          <p:cNvSpPr>
+            <a:spLocks xmlns:a="http://schemas.openxmlformats.org/drawingml/2006/main" noGrp="1"/>
+          </p:cNvSpPr>
+          <p:nvPr/>
+        </p:nvSpPr>
+        <p:spPr>
+          <a:xfrm xmlns:a="http://schemas.openxmlformats.org/drawingml/2006/main">
+            <a:off x="0" y="0"/>
+            <a:ext cx="7334250" cy="6858000"/>
+          </a:xfrm>
+          <a:prstGeom xmlns:a="http://schemas.openxmlformats.org/drawingml/2006/main" prst="rect">
+            <a:avLst/>
+          </a:prstGeom>
+          <a:solidFill xmlns:a="http://schemas.openxmlformats.org/drawingml/2006/main">
+            <a:srgbClr val="152015">
+              <a:alpha val="94902"/>
+            </a:srgbClr>
+          </a:solidFill>
+          <a:ln xmlns:a="http://schemas.openxmlformats.org/drawingml/2006/main" w="0">
+            <a:noFill/>
+            <a:prstDash val="solid"/>
+          </a:ln>
+        </p:spPr>
+      </p:sp>
+      <p:sp>
+        <p:nvSpPr>
+          <p:cNvPr id="3" name="">
+            <a:extLst xmlns:a="http://schemas.openxmlformats.org/drawingml/2006/main">
+              <a:ext uri="{FF2B5EF4-FFF2-40B4-BE49-F238E27FC236}">
+                <a16:creationId xmlns:a16="http://schemas.microsoft.com/office/drawing/2014/main" id="{ED9484EF-407F-4944-8879-B3FDBB7FFA64}"/>
+              </a:ext>
+            </a:extLst>
+          </p:cNvPr>
+          <p:cNvSpPr>
+            <a:spLocks xmlns:a="http://schemas.openxmlformats.org/drawingml/2006/main" noGrp="1"/>
+          </p:cNvSpPr>
+          <p:nvPr/>
+        </p:nvSpPr>
+        <p:spPr>
+          <a:xfrm xmlns:a="http://schemas.openxmlformats.org/drawingml/2006/main">
+            <a:off x="685800" y="552450"/>
+            <a:ext cx="3429000" cy="266700"/>
+          </a:xfrm>
+          <a:prstGeom xmlns:a="http://schemas.openxmlformats.org/drawingml/2006/main" prst="rect">
+            <a:avLst/>
+          </a:prstGeom>
+          <a:noFill xmlns:a="http://schemas.openxmlformats.org/drawingml/2006/main"/>
+          <a:ln xmlns:a="http://schemas.openxmlformats.org/drawingml/2006/main" w="0">
+            <a:noFill/>
+            <a:prstDash val="solid"/>
+          </a:ln>
+        </p:spPr>
+        <p:txBody>
+          <a:bodyPr xmlns:a="http://schemas.openxmlformats.org/drawingml/2006/main"/>
+          <a:lstStyle xmlns:a="http://schemas.openxmlformats.org/drawingml/2006/main"/>
+          <a:p xmlns:a="http://schemas.openxmlformats.org/drawingml/2006/main">
+            <a:pPr algn="l">
+              <a:buNone/>
+              <a:defRPr sz="975" b="1">
+                <a:solidFill>
+                  <a:srgbClr val="D8FF55"/>
+                </a:solidFill>
+              </a:defRPr>
+            </a:pPr>
+            <a:r>
+              <a:rPr sz="975" b="1">
+                <a:solidFill>
+                  <a:srgbClr val="D8FF55"/>
+                </a:solidFill>
+              </a:rPr>
+              <a:t>PHASE 2 · EVIDENCE FOUNDATION</a:t>
+            </a:r>
+          </a:p>
+        </p:txBody>
+      </p:sp>
+      <p:sp>
+        <p:nvSpPr>
+          <p:cNvPr id="4" name="">
+            <a:extLst xmlns:a="http://schemas.openxmlformats.org/drawingml/2006/main">
+              <a:ext uri="{FF2B5EF4-FFF2-40B4-BE49-F238E27FC236}">
+                <a16:creationId xmlns:a16="http://schemas.microsoft.com/office/drawing/2014/main" id="{71C7F68A-8294-4D64-AD07-7B2B4F0C7FAF}"/>
+              </a:ext>
+            </a:extLst>
+          </p:cNvPr>
+          <p:cNvSpPr>
+            <a:spLocks xmlns:a="http://schemas.openxmlformats.org/drawingml/2006/main" noGrp="1"/>
+          </p:cNvSpPr>
+          <p:nvPr/>
+        </p:nvSpPr>
+        <p:spPr>
+          <a:xfrm xmlns:a="http://schemas.openxmlformats.org/drawingml/2006/main">
+            <a:off x="685800" y="1219200"/>
+            <a:ext cx="5905500" cy="1066800"/>
+          </a:xfrm>
+          <a:prstGeom xmlns:a="http://schemas.openxmlformats.org/drawingml/2006/main" prst="rect">
+            <a:avLst/>
+          </a:prstGeom>
+          <a:noFill xmlns:a="http://schemas.openxmlformats.org/drawingml/2006/main"/>
+          <a:ln xmlns:a="http://schemas.openxmlformats.org/drawingml/2006/main" w="0">
+            <a:noFill/>
+            <a:prstDash val="solid"/>
+          </a:ln>
+        </p:spPr>
+        <p:txBody>
+          <a:bodyPr xmlns:a="http://schemas.openxmlformats.org/drawingml/2006/main"/>
+          <a:lstStyle xmlns:a="http://schemas.openxmlformats.org/drawingml/2006/main"/>
+          <a:p xmlns:a="http://schemas.openxmlformats.org/drawingml/2006/main">
+            <a:pPr algn="l">
+              <a:buNone/>
+              <a:defRPr sz="3600" b="1">
+                <a:solidFill>
+                  <a:srgbClr val="FFFFFF"/>
+                </a:solidFill>
+              </a:defRPr>
+            </a:pPr>
+            <a:r>
+              <a:rPr sz="3600" b="1">
+                <a:solidFill>
+                  <a:srgbClr val="FFFFFF"/>
+                </a:solidFill>
+              </a:rPr>
+              <a:t>Store evidence,</a:t>
+            </a:r>
+          </a:p>
+          <a:p xmlns:a="http://schemas.openxmlformats.org/drawingml/2006/main">
+            <a:pPr algn="l">
+              <a:buNone/>
+              <a:defRPr sz="3600" b="1">
+                <a:solidFill>
+                  <a:srgbClr val="FFFFFF"/>
+                </a:solidFill>
+              </a:defRPr>
+            </a:pPr>
+            <a:r>
+              <a:rPr sz="3600" b="1">
+                <a:solidFill>
+                  <a:srgbClr val="FFFFFF"/>
+                </a:solidFill>
+              </a:rPr>
+              <a:t>not ideas.</a:t>
+            </a:r>
+          </a:p>
+        </p:txBody>
+      </p:sp>
+      <p:sp>
+        <p:nvSpPr>
+          <p:cNvPr id="5" name="">
+            <a:extLst xmlns:a="http://schemas.openxmlformats.org/drawingml/2006/main">
+              <a:ext uri="{FF2B5EF4-FFF2-40B4-BE49-F238E27FC236}">
+                <a16:creationId xmlns:a16="http://schemas.microsoft.com/office/drawing/2014/main" id="{6D1389EE-CE1F-4BD0-B381-9B1964471F2C}"/>
+              </a:ext>
+            </a:extLst>
+          </p:cNvPr>
+          <p:cNvSpPr>
+            <a:spLocks xmlns:a="http://schemas.openxmlformats.org/drawingml/2006/main" noGrp="1"/>
+          </p:cNvSpPr>
+          <p:nvPr/>
+        </p:nvSpPr>
+        <p:spPr>
+          <a:xfrm xmlns:a="http://schemas.openxmlformats.org/drawingml/2006/main">
+            <a:off x="685800" y="2857500"/>
+            <a:ext cx="838200" cy="228600"/>
+          </a:xfrm>
+          <a:prstGeom xmlns:a="http://schemas.openxmlformats.org/drawingml/2006/main" prst="rect">
+            <a:avLst/>
+          </a:prstGeom>
+          <a:noFill xmlns:a="http://schemas.openxmlformats.org/drawingml/2006/main"/>
+          <a:ln xmlns:a="http://schemas.openxmlformats.org/drawingml/2006/main" w="0">
+            <a:noFill/>
+            <a:prstDash val="solid"/>
+          </a:ln>
+        </p:spPr>
+        <p:txBody>
+          <a:bodyPr xmlns:a="http://schemas.openxmlformats.org/drawingml/2006/main"/>
+          <a:lstStyle xmlns:a="http://schemas.openxmlformats.org/drawingml/2006/main"/>
+          <a:p xmlns:a="http://schemas.openxmlformats.org/drawingml/2006/main">
+            <a:pPr algn="l">
+              <a:buNone/>
+              <a:defRPr sz="975" b="1">
+                <a:solidFill>
+                  <a:srgbClr val="D8FF55"/>
+                </a:solidFill>
+              </a:defRPr>
+            </a:pPr>
+            <a:r>
+              <a:rPr sz="975" b="1">
+                <a:solidFill>
+                  <a:srgbClr val="D8FF55"/>
+                </a:solidFill>
+              </a:rPr>
+              <a:t>S3</a:t>
+            </a:r>
+          </a:p>
+        </p:txBody>
+      </p:sp>
+      <p:sp>
+        <p:nvSpPr>
+          <p:cNvPr id="6" name="">
+            <a:extLst xmlns:a="http://schemas.openxmlformats.org/drawingml/2006/main">
+              <a:ext uri="{FF2B5EF4-FFF2-40B4-BE49-F238E27FC236}">
+                <a16:creationId xmlns:a16="http://schemas.microsoft.com/office/drawing/2014/main" id="{E2C85436-B20D-499F-BA93-76A745913F6B}"/>
+              </a:ext>
+            </a:extLst>
+          </p:cNvPr>
+          <p:cNvSpPr>
+            <a:spLocks xmlns:a="http://schemas.openxmlformats.org/drawingml/2006/main" noGrp="1"/>
+          </p:cNvSpPr>
+          <p:nvPr/>
+        </p:nvSpPr>
+        <p:spPr>
+          <a:xfrm xmlns:a="http://schemas.openxmlformats.org/drawingml/2006/main">
+            <a:off x="1666875" y="2838450"/>
+            <a:ext cx="4762500" cy="514350"/>
+          </a:xfrm>
+          <a:prstGeom xmlns:a="http://schemas.openxmlformats.org/drawingml/2006/main" prst="rect">
+            <a:avLst/>
+          </a:prstGeom>
+          <a:noFill xmlns:a="http://schemas.openxmlformats.org/drawingml/2006/main"/>
+          <a:ln xmlns:a="http://schemas.openxmlformats.org/drawingml/2006/main" w="0">
+            <a:noFill/>
+            <a:prstDash val="solid"/>
+          </a:ln>
+        </p:spPr>
+        <p:txBody>
+          <a:bodyPr xmlns:a="http://schemas.openxmlformats.org/drawingml/2006/main"/>
+          <a:lstStyle xmlns:a="http://schemas.openxmlformats.org/drawingml/2006/main"/>
+          <a:p xmlns:a="http://schemas.openxmlformats.org/drawingml/2006/main">
+            <a:pPr algn="l">
+              <a:buNone/>
+              <a:defRPr sz="1425" b="0">
+                <a:solidFill>
+                  <a:srgbClr val="FFFFFF"/>
+                </a:solidFill>
+              </a:defRPr>
+            </a:pPr>
+            <a:r>
+              <a:rPr sz="1425" b="0">
+                <a:solidFill>
+                  <a:srgbClr val="FFFFFF"/>
+                </a:solidFill>
+              </a:rPr>
+              <a:t>Immutable catalog snapshots, run inputs, outputs, and reports</a:t>
+            </a:r>
+          </a:p>
+        </p:txBody>
+      </p:sp>
+      <p:sp>
+        <p:nvSpPr>
+          <p:cNvPr id="7" name="">
+            <a:extLst xmlns:a="http://schemas.openxmlformats.org/drawingml/2006/main">
+              <a:ext uri="{FF2B5EF4-FFF2-40B4-BE49-F238E27FC236}">
+                <a16:creationId xmlns:a16="http://schemas.microsoft.com/office/drawing/2014/main" id="{7AE00594-A482-4BB2-873D-969FFE861134}"/>
+              </a:ext>
+            </a:extLst>
+          </p:cNvPr>
+          <p:cNvSpPr>
+            <a:spLocks xmlns:a="http://schemas.openxmlformats.org/drawingml/2006/main" noGrp="1"/>
+          </p:cNvSpPr>
+          <p:nvPr/>
+        </p:nvSpPr>
+        <p:spPr>
+          <a:xfrm xmlns:a="http://schemas.openxmlformats.org/drawingml/2006/main">
+            <a:off x="685800" y="3400425"/>
+            <a:ext cx="5715000" cy="9525"/>
+          </a:xfrm>
+          <a:prstGeom xmlns:a="http://schemas.openxmlformats.org/drawingml/2006/main" prst="rect">
+            <a:avLst/>
+          </a:prstGeom>
+          <a:solidFill xmlns:a="http://schemas.openxmlformats.org/drawingml/2006/main">
+            <a:srgbClr val="4A5A4A"/>
+          </a:solidFill>
+          <a:ln xmlns:a="http://schemas.openxmlformats.org/drawingml/2006/main" w="0">
+            <a:noFill/>
+            <a:prstDash val="solid"/>
+          </a:ln>
+        </p:spPr>
+      </p:sp>
+      <p:sp>
+        <p:nvSpPr>
+          <p:cNvPr id="8" name="">
+            <a:extLst xmlns:a="http://schemas.openxmlformats.org/drawingml/2006/main">
+              <a:ext uri="{FF2B5EF4-FFF2-40B4-BE49-F238E27FC236}">
+                <a16:creationId xmlns:a16="http://schemas.microsoft.com/office/drawing/2014/main" id="{D18F43BC-3A50-451E-9EE6-AA670936DAE4}"/>
+              </a:ext>
+            </a:extLst>
+          </p:cNvPr>
+          <p:cNvSpPr>
+            <a:spLocks xmlns:a="http://schemas.openxmlformats.org/drawingml/2006/main" noGrp="1"/>
+          </p:cNvSpPr>
+          <p:nvPr/>
+        </p:nvSpPr>
+        <p:spPr>
+          <a:xfrm xmlns:a="http://schemas.openxmlformats.org/drawingml/2006/main">
+            <a:off x="685800" y="3543300"/>
+            <a:ext cx="838200" cy="228600"/>
+          </a:xfrm>
+          <a:prstGeom xmlns:a="http://schemas.openxmlformats.org/drawingml/2006/main" prst="rect">
+            <a:avLst/>
+          </a:prstGeom>
+          <a:noFill xmlns:a="http://schemas.openxmlformats.org/drawingml/2006/main"/>
+          <a:ln xmlns:a="http://schemas.openxmlformats.org/drawingml/2006/main" w="0">
+            <a:noFill/>
+            <a:prstDash val="solid"/>
+          </a:ln>
+        </p:spPr>
+        <p:txBody>
+          <a:bodyPr xmlns:a="http://schemas.openxmlformats.org/drawingml/2006/main"/>
+          <a:lstStyle xmlns:a="http://schemas.openxmlformats.org/drawingml/2006/main"/>
+          <a:p xmlns:a="http://schemas.openxmlformats.org/drawingml/2006/main">
+            <a:pPr algn="l">
+              <a:buNone/>
+              <a:defRPr sz="975" b="1">
+                <a:solidFill>
+                  <a:srgbClr val="8F7BFF"/>
+                </a:solidFill>
+              </a:defRPr>
+            </a:pPr>
+            <a:r>
+              <a:rPr sz="975" b="1">
+                <a:solidFill>
+                  <a:srgbClr val="8F7BFF"/>
+                </a:solidFill>
+              </a:rPr>
+              <a:t>DYNAMO</a:t>
+            </a:r>
+          </a:p>
+        </p:txBody>
+      </p:sp>
+      <p:sp>
+        <p:nvSpPr>
+          <p:cNvPr id="9" name="">
+            <a:extLst xmlns:a="http://schemas.openxmlformats.org/drawingml/2006/main">
+              <a:ext uri="{FF2B5EF4-FFF2-40B4-BE49-F238E27FC236}">
+                <a16:creationId xmlns:a16="http://schemas.microsoft.com/office/drawing/2014/main" id="{2F690732-B07D-4033-A156-9ACCAB3AD1FC}"/>
+              </a:ext>
+            </a:extLst>
+          </p:cNvPr>
+          <p:cNvSpPr>
+            <a:spLocks xmlns:a="http://schemas.openxmlformats.org/drawingml/2006/main" noGrp="1"/>
+          </p:cNvSpPr>
+          <p:nvPr/>
+        </p:nvSpPr>
+        <p:spPr>
+          <a:xfrm xmlns:a="http://schemas.openxmlformats.org/drawingml/2006/main">
+            <a:off x="1666875" y="3524250"/>
+            <a:ext cx="4762500" cy="514350"/>
+          </a:xfrm>
+          <a:prstGeom xmlns:a="http://schemas.openxmlformats.org/drawingml/2006/main" prst="rect">
+            <a:avLst/>
+          </a:prstGeom>
+          <a:noFill xmlns:a="http://schemas.openxmlformats.org/drawingml/2006/main"/>
+          <a:ln xmlns:a="http://schemas.openxmlformats.org/drawingml/2006/main" w="0">
+            <a:noFill/>
+            <a:prstDash val="solid"/>
+          </a:ln>
+        </p:spPr>
+        <p:txBody>
+          <a:bodyPr xmlns:a="http://schemas.openxmlformats.org/drawingml/2006/main"/>
+          <a:lstStyle xmlns:a="http://schemas.openxmlformats.org/drawingml/2006/main"/>
+          <a:p xmlns:a="http://schemas.openxmlformats.org/drawingml/2006/main">
+            <a:pPr algn="l">
+              <a:buNone/>
+              <a:defRPr sz="1425" b="0">
+                <a:solidFill>
+                  <a:srgbClr val="FFFFFF"/>
+                </a:solidFill>
+              </a:defRPr>
+            </a:pPr>
+            <a:r>
+              <a:rPr sz="1425" b="0">
+                <a:solidFill>
+                  <a:srgbClr val="FFFFFF"/>
+                </a:solidFill>
+              </a:rPr>
+              <a:t>Projects, budgets, metadata, and point-in-time history</a:t>
+            </a:r>
+          </a:p>
+        </p:txBody>
+      </p:sp>
+      <p:sp>
+        <p:nvSpPr>
+          <p:cNvPr id="10" name="">
+            <a:extLst xmlns:a="http://schemas.openxmlformats.org/drawingml/2006/main">
+              <a:ext uri="{FF2B5EF4-FFF2-40B4-BE49-F238E27FC236}">
+                <a16:creationId xmlns:a16="http://schemas.microsoft.com/office/drawing/2014/main" id="{A0D4318D-1F35-4D88-8253-6E0B591843E1}"/>
+              </a:ext>
+            </a:extLst>
+          </p:cNvPr>
+          <p:cNvSpPr>
+            <a:spLocks xmlns:a="http://schemas.openxmlformats.org/drawingml/2006/main" noGrp="1"/>
+          </p:cNvSpPr>
+          <p:nvPr/>
+        </p:nvSpPr>
+        <p:spPr>
+          <a:xfrm xmlns:a="http://schemas.openxmlformats.org/drawingml/2006/main">
+            <a:off x="685800" y="4086225"/>
+            <a:ext cx="5715000" cy="9525"/>
+          </a:xfrm>
+          <a:prstGeom xmlns:a="http://schemas.openxmlformats.org/drawingml/2006/main" prst="rect">
+            <a:avLst/>
+          </a:prstGeom>
+          <a:solidFill xmlns:a="http://schemas.openxmlformats.org/drawingml/2006/main">
+            <a:srgbClr val="4A5A4A"/>
+          </a:solidFill>
+          <a:ln xmlns:a="http://schemas.openxmlformats.org/drawingml/2006/main" w="0">
+            <a:noFill/>
+            <a:prstDash val="solid"/>
+          </a:ln>
+        </p:spPr>
+      </p:sp>
+      <p:sp>
+        <p:nvSpPr>
+          <p:cNvPr id="11" name="">
+            <a:extLst xmlns:a="http://schemas.openxmlformats.org/drawingml/2006/main">
+              <a:ext uri="{FF2B5EF4-FFF2-40B4-BE49-F238E27FC236}">
+                <a16:creationId xmlns:a16="http://schemas.microsoft.com/office/drawing/2014/main" id="{1DCE0B84-783F-4F4D-991F-A34A23F70025}"/>
+              </a:ext>
+            </a:extLst>
+          </p:cNvPr>
+          <p:cNvSpPr>
+            <a:spLocks xmlns:a="http://schemas.openxmlformats.org/drawingml/2006/main" noGrp="1"/>
+          </p:cNvSpPr>
+          <p:nvPr/>
+        </p:nvSpPr>
+        <p:spPr>
+          <a:xfrm xmlns:a="http://schemas.openxmlformats.org/drawingml/2006/main">
+            <a:off x="685800" y="4229100"/>
+            <a:ext cx="838200" cy="228600"/>
+          </a:xfrm>
+          <a:prstGeom xmlns:a="http://schemas.openxmlformats.org/drawingml/2006/main" prst="rect">
+            <a:avLst/>
+          </a:prstGeom>
+          <a:noFill xmlns:a="http://schemas.openxmlformats.org/drawingml/2006/main"/>
+          <a:ln xmlns:a="http://schemas.openxmlformats.org/drawingml/2006/main" w="0">
+            <a:noFill/>
+            <a:prstDash val="solid"/>
+          </a:ln>
+        </p:spPr>
+        <p:txBody>
+          <a:bodyPr xmlns:a="http://schemas.openxmlformats.org/drawingml/2006/main"/>
+          <a:lstStyle xmlns:a="http://schemas.openxmlformats.org/drawingml/2006/main"/>
+          <a:p xmlns:a="http://schemas.openxmlformats.org/drawingml/2006/main">
+            <a:pPr algn="l">
+              <a:buNone/>
+              <a:defRPr sz="975" b="1">
+                <a:solidFill>
+                  <a:srgbClr val="FF8159"/>
+                </a:solidFill>
+              </a:defRPr>
+            </a:pPr>
+            <a:r>
+              <a:rPr sz="975" b="1">
+                <a:solidFill>
+                  <a:srgbClr val="FF8159"/>
+                </a:solidFill>
+              </a:rPr>
+              <a:t>SECRETS</a:t>
+            </a:r>
+          </a:p>
+        </p:txBody>
+      </p:sp>
+      <p:sp>
+        <p:nvSpPr>
+          <p:cNvPr id="12" name="">
+            <a:extLst xmlns:a="http://schemas.openxmlformats.org/drawingml/2006/main">
+              <a:ext uri="{FF2B5EF4-FFF2-40B4-BE49-F238E27FC236}">
+                <a16:creationId xmlns:a16="http://schemas.microsoft.com/office/drawing/2014/main" id="{6C5B3A81-64FC-4228-BF01-81EF7F2934CC}"/>
+              </a:ext>
+            </a:extLst>
+          </p:cNvPr>
+          <p:cNvSpPr>
+            <a:spLocks xmlns:a="http://schemas.openxmlformats.org/drawingml/2006/main" noGrp="1"/>
+          </p:cNvSpPr>
+          <p:nvPr/>
+        </p:nvSpPr>
+        <p:spPr>
+          <a:xfrm xmlns:a="http://schemas.openxmlformats.org/drawingml/2006/main">
+            <a:off x="1666875" y="4210050"/>
+            <a:ext cx="4762500" cy="514350"/>
+          </a:xfrm>
+          <a:prstGeom xmlns:a="http://schemas.openxmlformats.org/drawingml/2006/main" prst="rect">
+            <a:avLst/>
+          </a:prstGeom>
+          <a:noFill xmlns:a="http://schemas.openxmlformats.org/drawingml/2006/main"/>
+          <a:ln xmlns:a="http://schemas.openxmlformats.org/drawingml/2006/main" w="0">
+            <a:noFill/>
+            <a:prstDash val="solid"/>
+          </a:ln>
+        </p:spPr>
+        <p:txBody>
+          <a:bodyPr xmlns:a="http://schemas.openxmlformats.org/drawingml/2006/main"/>
+          <a:lstStyle xmlns:a="http://schemas.openxmlformats.org/drawingml/2006/main"/>
+          <a:p xmlns:a="http://schemas.openxmlformats.org/drawingml/2006/main">
+            <a:pPr algn="l">
+              <a:buNone/>
+              <a:defRPr sz="1425" b="0">
+                <a:solidFill>
+                  <a:srgbClr val="FFFFFF"/>
+                </a:solidFill>
+              </a:defRPr>
+            </a:pPr>
+            <a:r>
+              <a:rPr sz="1425" b="0">
+                <a:solidFill>
+                  <a:srgbClr val="FFFFFF"/>
+                </a:solidFill>
+              </a:rPr>
+              <a:t>Provider keys remain protected and server-side</a:t>
+            </a:r>
+          </a:p>
+        </p:txBody>
+      </p:sp>
+      <p:sp>
+        <p:nvSpPr>
+          <p:cNvPr id="13" name="">
+            <a:extLst xmlns:a="http://schemas.openxmlformats.org/drawingml/2006/main">
+              <a:ext uri="{FF2B5EF4-FFF2-40B4-BE49-F238E27FC236}">
+                <a16:creationId xmlns:a16="http://schemas.microsoft.com/office/drawing/2014/main" id="{51F9489E-2112-46B6-A8DE-9F34AEBCA139}"/>
+              </a:ext>
+            </a:extLst>
+          </p:cNvPr>
+          <p:cNvSpPr>
+            <a:spLocks xmlns:a="http://schemas.openxmlformats.org/drawingml/2006/main" noGrp="1"/>
+          </p:cNvSpPr>
+          <p:nvPr/>
+        </p:nvSpPr>
+        <p:spPr>
+          <a:xfrm xmlns:a="http://schemas.openxmlformats.org/drawingml/2006/main">
+            <a:off x="685800" y="4772025"/>
+            <a:ext cx="5715000" cy="9525"/>
+          </a:xfrm>
+          <a:prstGeom xmlns:a="http://schemas.openxmlformats.org/drawingml/2006/main" prst="rect">
+            <a:avLst/>
+          </a:prstGeom>
+          <a:solidFill xmlns:a="http://schemas.openxmlformats.org/drawingml/2006/main">
+            <a:srgbClr val="4A5A4A"/>
+          </a:solidFill>
+          <a:ln xmlns:a="http://schemas.openxmlformats.org/drawingml/2006/main" w="0">
+            <a:noFill/>
+            <a:prstDash val="solid"/>
+          </a:ln>
+        </p:spPr>
+      </p:sp>
+      <p:sp>
+        <p:nvSpPr>
+          <p:cNvPr id="14" name="">
+            <a:extLst xmlns:a="http://schemas.openxmlformats.org/drawingml/2006/main">
+              <a:ext uri="{FF2B5EF4-FFF2-40B4-BE49-F238E27FC236}">
+                <a16:creationId xmlns:a16="http://schemas.microsoft.com/office/drawing/2014/main" id="{52FC565A-7F52-47F4-98A2-B3E00095EB8E}"/>
+              </a:ext>
+            </a:extLst>
+          </p:cNvPr>
+          <p:cNvSpPr>
+            <a:spLocks xmlns:a="http://schemas.openxmlformats.org/drawingml/2006/main" noGrp="1"/>
+          </p:cNvSpPr>
+          <p:nvPr/>
+        </p:nvSpPr>
+        <p:spPr>
+          <a:xfrm xmlns:a="http://schemas.openxmlformats.org/drawingml/2006/main">
+            <a:off x="685800" y="4914900"/>
+            <a:ext cx="838200" cy="228600"/>
+          </a:xfrm>
+          <a:prstGeom xmlns:a="http://schemas.openxmlformats.org/drawingml/2006/main" prst="rect">
+            <a:avLst/>
+          </a:prstGeom>
+          <a:noFill xmlns:a="http://schemas.openxmlformats.org/drawingml/2006/main"/>
+          <a:ln xmlns:a="http://schemas.openxmlformats.org/drawingml/2006/main" w="0">
+            <a:noFill/>
+            <a:prstDash val="solid"/>
+          </a:ln>
+        </p:spPr>
+        <p:txBody>
+          <a:bodyPr xmlns:a="http://schemas.openxmlformats.org/drawingml/2006/main"/>
+          <a:lstStyle xmlns:a="http://schemas.openxmlformats.org/drawingml/2006/main"/>
+          <a:p xmlns:a="http://schemas.openxmlformats.org/drawingml/2006/main">
+            <a:pPr algn="l">
+              <a:buNone/>
+              <a:defRPr sz="975" b="1">
+                <a:solidFill>
+                  <a:srgbClr val="D8FF55"/>
+                </a:solidFill>
+              </a:defRPr>
+            </a:pPr>
+            <a:r>
+              <a:rPr sz="975" b="1">
+                <a:solidFill>
+                  <a:srgbClr val="D8FF55"/>
+                </a:solidFill>
+              </a:rPr>
+              <a:t>RAG</a:t>
+            </a:r>
+          </a:p>
+        </p:txBody>
+      </p:sp>
+      <p:sp>
+        <p:nvSpPr>
+          <p:cNvPr id="15" name="">
+            <a:extLst xmlns:a="http://schemas.openxmlformats.org/drawingml/2006/main">
+              <a:ext uri="{FF2B5EF4-FFF2-40B4-BE49-F238E27FC236}">
+                <a16:creationId xmlns:a16="http://schemas.microsoft.com/office/drawing/2014/main" id="{2EE692EA-1197-4BB5-AF5E-FDBB5D7D855E}"/>
+              </a:ext>
+            </a:extLst>
+          </p:cNvPr>
+          <p:cNvSpPr>
+            <a:spLocks xmlns:a="http://schemas.openxmlformats.org/drawingml/2006/main" noGrp="1"/>
+          </p:cNvSpPr>
+          <p:nvPr/>
+        </p:nvSpPr>
+        <p:spPr>
+          <a:xfrm xmlns:a="http://schemas.openxmlformats.org/drawingml/2006/main">
+            <a:off x="1666875" y="4895850"/>
+            <a:ext cx="4762500" cy="514350"/>
+          </a:xfrm>
+          <a:prstGeom xmlns:a="http://schemas.openxmlformats.org/drawingml/2006/main" prst="rect">
+            <a:avLst/>
+          </a:prstGeom>
+          <a:noFill xmlns:a="http://schemas.openxmlformats.org/drawingml/2006/main"/>
+          <a:ln xmlns:a="http://schemas.openxmlformats.org/drawingml/2006/main" w="0">
+            <a:noFill/>
+            <a:prstDash val="solid"/>
+          </a:ln>
+        </p:spPr>
+        <p:txBody>
+          <a:bodyPr xmlns:a="http://schemas.openxmlformats.org/drawingml/2006/main"/>
+          <a:lstStyle xmlns:a="http://schemas.openxmlformats.org/drawingml/2006/main"/>
+          <a:p xmlns:a="http://schemas.openxmlformats.org/drawingml/2006/main">
+            <a:pPr algn="l">
+              <a:buNone/>
+              <a:defRPr sz="1425" b="0">
+                <a:solidFill>
+                  <a:srgbClr val="FFFFFF"/>
+                </a:solidFill>
+              </a:defRPr>
+            </a:pPr>
+            <a:r>
+              <a:rPr sz="1425" b="0">
+                <a:solidFill>
+                  <a:srgbClr val="FFFFFF"/>
+                </a:solidFill>
+              </a:rPr>
+              <a:t>Grounds sources and reports; never changes cost math or policy</a:t>
+            </a:r>
+          </a:p>
+        </p:txBody>
+      </p:sp>
+      <p:sp>
+        <p:nvSpPr>
+          <p:cNvPr id="16" name="">
+            <a:extLst xmlns:a="http://schemas.openxmlformats.org/drawingml/2006/main">
+              <a:ext uri="{FF2B5EF4-FFF2-40B4-BE49-F238E27FC236}">
+                <a16:creationId xmlns:a16="http://schemas.microsoft.com/office/drawing/2014/main" id="{10B5F276-B2B3-4E9E-8405-2E0497288684}"/>
+              </a:ext>
+            </a:extLst>
+          </p:cNvPr>
+          <p:cNvSpPr>
+            <a:spLocks xmlns:a="http://schemas.openxmlformats.org/drawingml/2006/main" noGrp="1"/>
+          </p:cNvSpPr>
+          <p:nvPr/>
+        </p:nvSpPr>
+        <p:spPr>
+          <a:xfrm xmlns:a="http://schemas.openxmlformats.org/drawingml/2006/main">
+            <a:off x="685800" y="5457825"/>
+            <a:ext cx="5715000" cy="9525"/>
+          </a:xfrm>
+          <a:prstGeom xmlns:a="http://schemas.openxmlformats.org/drawingml/2006/main" prst="rect">
+            <a:avLst/>
+          </a:prstGeom>
+          <a:solidFill xmlns:a="http://schemas.openxmlformats.org/drawingml/2006/main">
+            <a:srgbClr val="4A5A4A"/>
+          </a:solidFill>
+          <a:ln xmlns:a="http://schemas.openxmlformats.org/drawingml/2006/main" w="0">
+            <a:noFill/>
+            <a:prstDash val="solid"/>
+          </a:ln>
+        </p:spPr>
+      </p:sp>
+      <p:sp>
+        <p:nvSpPr>
+          <p:cNvPr id="17" name="">
+            <a:extLst xmlns:a="http://schemas.openxmlformats.org/drawingml/2006/main">
+              <a:ext uri="{FF2B5EF4-FFF2-40B4-BE49-F238E27FC236}">
+                <a16:creationId xmlns:a16="http://schemas.microsoft.com/office/drawing/2014/main" id="{C40BB595-FE5F-445E-9766-B4C6E7B74349}"/>
+              </a:ext>
+            </a:extLst>
+          </p:cNvPr>
+          <p:cNvSpPr>
+            <a:spLocks xmlns:a="http://schemas.openxmlformats.org/drawingml/2006/main" noGrp="1"/>
+          </p:cNvSpPr>
+          <p:nvPr/>
+        </p:nvSpPr>
+        <p:spPr>
+          <a:xfrm xmlns:a="http://schemas.openxmlformats.org/drawingml/2006/main">
+            <a:off x="685800" y="6048375"/>
+            <a:ext cx="3810000" cy="266700"/>
+          </a:xfrm>
+          <a:prstGeom xmlns:a="http://schemas.openxmlformats.org/drawingml/2006/main" prst="rect">
+            <a:avLst/>
+          </a:prstGeom>
+          <a:noFill xmlns:a="http://schemas.openxmlformats.org/drawingml/2006/main"/>
+          <a:ln xmlns:a="http://schemas.openxmlformats.org/drawingml/2006/main" w="0">
+            <a:noFill/>
+            <a:prstDash val="solid"/>
+          </a:ln>
+        </p:spPr>
+        <p:txBody>
+          <a:bodyPr xmlns:a="http://schemas.openxmlformats.org/drawingml/2006/main"/>
+          <a:lstStyle xmlns:a="http://schemas.openxmlformats.org/drawingml/2006/main"/>
+          <a:p xmlns:a="http://schemas.openxmlformats.org/drawingml/2006/main">
+            <a:pPr algn="l">
+              <a:buNone/>
+              <a:defRPr sz="1350" b="1">
+                <a:solidFill>
+                  <a:srgbClr val="D8FF55"/>
+                </a:solidFill>
+              </a:defRPr>
+            </a:pPr>
+            <a:r>
+              <a:rPr sz="1350" b="1">
+                <a:solidFill>
+                  <a:srgbClr val="D8FF55"/>
+                </a:solidFill>
+              </a:rPr>
+              <a:t>aibuildcrew.badlabz.com</a:t>
+            </a:r>
+          </a:p>
+        </p:txBody>
+      </p:sp>
+      <p:sp>
+        <p:nvSpPr>
+          <p:cNvPr id="18" name="">
+            <a:extLst xmlns:a="http://schemas.openxmlformats.org/drawingml/2006/main">
+              <a:ext uri="{FF2B5EF4-FFF2-40B4-BE49-F238E27FC236}">
+                <a16:creationId xmlns:a16="http://schemas.microsoft.com/office/drawing/2014/main" id="{5CBB6A72-5DD2-496B-8633-E9890D3CD892}"/>
+              </a:ext>
+            </a:extLst>
+          </p:cNvPr>
+          <p:cNvSpPr>
+            <a:spLocks xmlns:a="http://schemas.openxmlformats.org/drawingml/2006/main" noGrp="1"/>
+          </p:cNvSpPr>
+          <p:nvPr/>
+        </p:nvSpPr>
+        <p:spPr>
+          <a:xfrm xmlns:a="http://schemas.openxmlformats.org/drawingml/2006/main">
+            <a:off x="685800" y="6362700"/>
+            <a:ext cx="4095750" cy="209550"/>
+          </a:xfrm>
+          <a:prstGeom xmlns:a="http://schemas.openxmlformats.org/drawingml/2006/main" prst="rect">
+            <a:avLst/>
+          </a:prstGeom>
+          <a:noFill xmlns:a="http://schemas.openxmlformats.org/drawingml/2006/main"/>
+          <a:ln xmlns:a="http://schemas.openxmlformats.org/drawingml/2006/main" w="0">
+            <a:noFill/>
+            <a:prstDash val="solid"/>
+          </a:ln>
+        </p:spPr>
+        <p:txBody>
+          <a:bodyPr xmlns:a="http://schemas.openxmlformats.org/drawingml/2006/main"/>
+          <a:lstStyle xmlns:a="http://schemas.openxmlformats.org/drawingml/2006/main"/>
+          <a:p xmlns:a="http://schemas.openxmlformats.org/drawingml/2006/main">
+            <a:pPr algn="l">
+              <a:buNone/>
+              <a:defRPr sz="975" b="0">
+                <a:solidFill>
+                  <a:srgbClr val="C8D1C8"/>
+                </a:solidFill>
+              </a:defRPr>
+            </a:pPr>
+            <a:r>
+              <a:rPr sz="975" b="0">
+                <a:solidFill>
+                  <a:srgbClr val="C8D1C8"/>
+                </a:solidFill>
+              </a:rPr>
+              <a:t>github.com/CTATX/ai-build-crew</a:t>
+            </a:r>
+          </a:p>
+        </p:txBody>
+      </p:sp>
+    </p:spTree>
+    <p:extLst>
+      <p:ext uri="{BB962C8B-B14F-4D97-AF65-F5344CB8AC3E}">
+        <p14:creationId xmlns:p14="http://schemas.microsoft.com/office/powerpoint/2010/main" val="2139355806"/>
       </p:ext>
     </p:extLst>
   </p:cSld>
@@ -4948,7 +7600,7 @@
         </p:xfrm>
         <a:graphic xmlns:a="http://schemas.openxmlformats.org/drawingml/2006/main">
           <a:graphicData uri="http://schemas.openxmlformats.org/drawingml/2006/chart">
-            <c:chart xmlns:r="http://schemas.openxmlformats.org/officeDocument/2006/relationships" xmlns:c="http://schemas.openxmlformats.org/drawingml/2006/chart" r:id="Rad4ac44828e04006"/>
+            <c:chart xmlns:r="http://schemas.openxmlformats.org/officeDocument/2006/relationships" xmlns:c="http://schemas.openxmlformats.org/drawingml/2006/chart" r:id="R04c1eac78a3c480b"/>
           </a:graphicData>
         </a:graphic>
       </p:graphicFrame>
@@ -7928,7 +10580,7 @@
           <p:nvPr/>
         </p:nvPicPr>
         <p:blipFill>
-          <a:blip xmlns:r="http://schemas.openxmlformats.org/officeDocument/2006/relationships" xmlns:a="http://schemas.openxmlformats.org/drawingml/2006/main" r:embed="R88a9ffeee49c4f9d"/>
+          <a:blip xmlns:r="http://schemas.openxmlformats.org/officeDocument/2006/relationships" xmlns:a="http://schemas.openxmlformats.org/drawingml/2006/main" r:embed="R1fa3f6720400422f"/>
           <a:srcRect xmlns:a="http://schemas.openxmlformats.org/drawingml/2006/main" l="0" t="27" r="0" b="27"/>
           <a:stretch xmlns:a="http://schemas.openxmlformats.org/drawingml/2006/main">
             <a:fillRect l="0" t="0" r="0" b="0"/>
@@ -8735,6 +11387,1051 @@
     <p:extLst>
       <p:ext uri="{BB962C8B-B14F-4D97-AF65-F5344CB8AC3E}">
         <p14:creationId xmlns:p14="http://schemas.microsoft.com/office/powerpoint/2010/main" val="2139355806"/>
+      </p:ext>
+    </p:extLst>
+  </p:cSld>
+</p:sld>
+</file>
+
+<file path=ppt/slides/slide9.xml><?xml version="1.0" encoding="utf-8"?>
+<p:sld xmlns:p="http://schemas.openxmlformats.org/presentationml/2006/main">
+  <p:cSld>
+    <p:bg>
+      <p:bgPr>
+        <a:solidFill xmlns:a="http://schemas.openxmlformats.org/drawingml/2006/main">
+          <a:srgbClr val="F3EFE5"/>
+        </a:solidFill>
+      </p:bgPr>
+    </p:bg>
+    <p:spTree>
+      <p:nvGrpSpPr>
+        <p:cNvPr id="1" name=""/>
+        <p:cNvGrpSpPr/>
+        <p:nvPr/>
+      </p:nvGrpSpPr>
+      <p:grpSpPr>
+        <a:xfrm xmlns:a="http://schemas.openxmlformats.org/drawingml/2006/main"/>
+      </p:grpSpPr>
+      <p:sp>
+        <p:nvSpPr>
+          <p:cNvPr id="23" name="">
+            <a:extLst xmlns:a="http://schemas.openxmlformats.org/drawingml/2006/main">
+              <a:ext uri="{FF2B5EF4-FFF2-40B4-BE49-F238E27FC236}">
+                <a16:creationId xmlns:a16="http://schemas.microsoft.com/office/drawing/2014/main" id="{F595416C-835D-435F-BC12-610E6A00EEB6}"/>
+              </a:ext>
+            </a:extLst>
+          </p:cNvPr>
+          <p:cNvSpPr>
+            <a:spLocks xmlns:a="http://schemas.openxmlformats.org/drawingml/2006/main" noGrp="1"/>
+          </p:cNvSpPr>
+          <p:nvPr/>
+        </p:nvSpPr>
+        <p:spPr>
+          <a:xfrm xmlns:a="http://schemas.openxmlformats.org/drawingml/2006/main">
+            <a:off x="685800" y="457200"/>
+            <a:ext cx="514350" cy="266700"/>
+          </a:xfrm>
+          <a:prstGeom xmlns:a="http://schemas.openxmlformats.org/drawingml/2006/main" prst="rect">
+            <a:avLst/>
+          </a:prstGeom>
+          <a:noFill xmlns:a="http://schemas.openxmlformats.org/drawingml/2006/main"/>
+          <a:ln xmlns:a="http://schemas.openxmlformats.org/drawingml/2006/main" w="0">
+            <a:noFill/>
+            <a:prstDash val="solid"/>
+          </a:ln>
+        </p:spPr>
+        <p:txBody>
+          <a:bodyPr xmlns:a="http://schemas.openxmlformats.org/drawingml/2006/main"/>
+          <a:lstStyle xmlns:a="http://schemas.openxmlformats.org/drawingml/2006/main"/>
+          <a:p xmlns:a="http://schemas.openxmlformats.org/drawingml/2006/main">
+            <a:pPr algn="l">
+              <a:buNone/>
+              <a:defRPr sz="975" b="1">
+                <a:solidFill>
+                  <a:srgbClr val="8F7BFF"/>
+                </a:solidFill>
+              </a:defRPr>
+            </a:pPr>
+            <a:r>
+              <a:rPr sz="975" b="1">
+                <a:solidFill>
+                  <a:srgbClr val="8F7BFF"/>
+                </a:solidFill>
+              </a:rPr>
+              <a:t>07</a:t>
+            </a:r>
+          </a:p>
+        </p:txBody>
+      </p:sp>
+      <p:sp>
+        <p:nvSpPr>
+          <p:cNvPr id="2" name="">
+            <a:extLst xmlns:a="http://schemas.openxmlformats.org/drawingml/2006/main">
+              <a:ext uri="{FF2B5EF4-FFF2-40B4-BE49-F238E27FC236}">
+                <a16:creationId xmlns:a16="http://schemas.microsoft.com/office/drawing/2014/main" id="{D1C0A470-81CC-4128-A843-C3A698DE5035}"/>
+              </a:ext>
+            </a:extLst>
+          </p:cNvPr>
+          <p:cNvSpPr>
+            <a:spLocks xmlns:a="http://schemas.openxmlformats.org/drawingml/2006/main" noGrp="1"/>
+          </p:cNvSpPr>
+          <p:nvPr/>
+        </p:nvSpPr>
+        <p:spPr>
+          <a:xfrm xmlns:a="http://schemas.openxmlformats.org/drawingml/2006/main">
+            <a:off x="1219200" y="457200"/>
+            <a:ext cx="4762500" cy="266700"/>
+          </a:xfrm>
+          <a:prstGeom xmlns:a="http://schemas.openxmlformats.org/drawingml/2006/main" prst="rect">
+            <a:avLst/>
+          </a:prstGeom>
+          <a:noFill xmlns:a="http://schemas.openxmlformats.org/drawingml/2006/main"/>
+          <a:ln xmlns:a="http://schemas.openxmlformats.org/drawingml/2006/main" w="0">
+            <a:noFill/>
+            <a:prstDash val="solid"/>
+          </a:ln>
+        </p:spPr>
+        <p:txBody>
+          <a:bodyPr xmlns:a="http://schemas.openxmlformats.org/drawingml/2006/main"/>
+          <a:lstStyle xmlns:a="http://schemas.openxmlformats.org/drawingml/2006/main"/>
+          <a:p xmlns:a="http://schemas.openxmlformats.org/drawingml/2006/main">
+            <a:pPr algn="l">
+              <a:buNone/>
+              <a:defRPr sz="975" b="1">
+                <a:solidFill>
+                  <a:srgbClr val="152015"/>
+                </a:solidFill>
+              </a:defRPr>
+            </a:pPr>
+            <a:r>
+              <a:rPr sz="975" b="1">
+                <a:solidFill>
+                  <a:srgbClr val="152015"/>
+                </a:solidFill>
+              </a:rPr>
+              <a:t>PHASE 2 · OPERATING MODEL</a:t>
+            </a:r>
+          </a:p>
+        </p:txBody>
+      </p:sp>
+      <p:sp>
+        <p:nvSpPr>
+          <p:cNvPr id="3" name="">
+            <a:extLst xmlns:a="http://schemas.openxmlformats.org/drawingml/2006/main">
+              <a:ext uri="{FF2B5EF4-FFF2-40B4-BE49-F238E27FC236}">
+                <a16:creationId xmlns:a16="http://schemas.microsoft.com/office/drawing/2014/main" id="{55822932-EF21-468D-8B02-B71F4C482449}"/>
+              </a:ext>
+            </a:extLst>
+          </p:cNvPr>
+          <p:cNvSpPr>
+            <a:spLocks xmlns:a="http://schemas.openxmlformats.org/drawingml/2006/main" noGrp="1"/>
+          </p:cNvSpPr>
+          <p:nvPr/>
+        </p:nvSpPr>
+        <p:spPr>
+          <a:xfrm xmlns:a="http://schemas.openxmlformats.org/drawingml/2006/main">
+            <a:off x="685800" y="781050"/>
+            <a:ext cx="10820400" cy="19050"/>
+          </a:xfrm>
+          <a:prstGeom xmlns:a="http://schemas.openxmlformats.org/drawingml/2006/main" prst="rect">
+            <a:avLst/>
+          </a:prstGeom>
+          <a:solidFill xmlns:a="http://schemas.openxmlformats.org/drawingml/2006/main">
+            <a:srgbClr val="CDD0C8"/>
+          </a:solidFill>
+          <a:ln xmlns:a="http://schemas.openxmlformats.org/drawingml/2006/main" w="0">
+            <a:noFill/>
+            <a:prstDash val="solid"/>
+          </a:ln>
+        </p:spPr>
+      </p:sp>
+      <p:sp>
+        <p:nvSpPr>
+          <p:cNvPr id="4" name="">
+            <a:extLst xmlns:a="http://schemas.openxmlformats.org/drawingml/2006/main">
+              <a:ext uri="{FF2B5EF4-FFF2-40B4-BE49-F238E27FC236}">
+                <a16:creationId xmlns:a16="http://schemas.microsoft.com/office/drawing/2014/main" id="{0A5A30F2-A980-4F8E-901F-F23233E02BEF}"/>
+              </a:ext>
+            </a:extLst>
+          </p:cNvPr>
+          <p:cNvSpPr>
+            <a:spLocks xmlns:a="http://schemas.openxmlformats.org/drawingml/2006/main" noGrp="1"/>
+          </p:cNvSpPr>
+          <p:nvPr/>
+        </p:nvSpPr>
+        <p:spPr>
+          <a:xfrm xmlns:a="http://schemas.openxmlformats.org/drawingml/2006/main">
+            <a:off x="685800" y="1123950"/>
+            <a:ext cx="7429500" cy="1028700"/>
+          </a:xfrm>
+          <a:prstGeom xmlns:a="http://schemas.openxmlformats.org/drawingml/2006/main" prst="rect">
+            <a:avLst/>
+          </a:prstGeom>
+          <a:noFill xmlns:a="http://schemas.openxmlformats.org/drawingml/2006/main"/>
+          <a:ln xmlns:a="http://schemas.openxmlformats.org/drawingml/2006/main" w="0">
+            <a:noFill/>
+            <a:prstDash val="solid"/>
+          </a:ln>
+        </p:spPr>
+        <p:txBody>
+          <a:bodyPr xmlns:a="http://schemas.openxmlformats.org/drawingml/2006/main"/>
+          <a:lstStyle xmlns:a="http://schemas.openxmlformats.org/drawingml/2006/main"/>
+          <a:p xmlns:a="http://schemas.openxmlformats.org/drawingml/2006/main">
+            <a:pPr algn="l">
+              <a:buNone/>
+              <a:defRPr sz="3300" b="1">
+                <a:solidFill>
+                  <a:srgbClr val="152015"/>
+                </a:solidFill>
+              </a:defRPr>
+            </a:pPr>
+            <a:r>
+              <a:rPr sz="3300" b="1">
+                <a:solidFill>
+                  <a:srgbClr val="152015"/>
+                </a:solidFill>
+              </a:rPr>
+              <a:t>One brief becomes a controlled</a:t>
+            </a:r>
+          </a:p>
+          <a:p xmlns:a="http://schemas.openxmlformats.org/drawingml/2006/main">
+            <a:pPr algn="l">
+              <a:buNone/>
+              <a:defRPr sz="3300" b="1">
+                <a:solidFill>
+                  <a:srgbClr val="152015"/>
+                </a:solidFill>
+              </a:defRPr>
+            </a:pPr>
+            <a:r>
+              <a:rPr sz="3300" b="1">
+                <a:solidFill>
+                  <a:srgbClr val="152015"/>
+                </a:solidFill>
+              </a:rPr>
+              <a:t>provider comparison.</a:t>
+            </a:r>
+          </a:p>
+        </p:txBody>
+      </p:sp>
+      <p:sp>
+        <p:nvSpPr>
+          <p:cNvPr id="5" name="">
+            <a:extLst xmlns:a="http://schemas.openxmlformats.org/drawingml/2006/main">
+              <a:ext uri="{FF2B5EF4-FFF2-40B4-BE49-F238E27FC236}">
+                <a16:creationId xmlns:a16="http://schemas.microsoft.com/office/drawing/2014/main" id="{C76F5C34-5E74-4C1C-8437-2F1389791FA5}"/>
+              </a:ext>
+            </a:extLst>
+          </p:cNvPr>
+          <p:cNvSpPr>
+            <a:spLocks xmlns:a="http://schemas.openxmlformats.org/drawingml/2006/main" noGrp="1"/>
+          </p:cNvSpPr>
+          <p:nvPr/>
+        </p:nvSpPr>
+        <p:spPr>
+          <a:xfrm xmlns:a="http://schemas.openxmlformats.org/drawingml/2006/main">
+            <a:off x="685800" y="2857500"/>
+            <a:ext cx="3048000" cy="2266950"/>
+          </a:xfrm>
+          <a:prstGeom xmlns:a="http://schemas.openxmlformats.org/drawingml/2006/main" prst="roundRect">
+            <a:avLst>
+              <a:gd name="adj" fmla="val 8403"/>
+            </a:avLst>
+          </a:prstGeom>
+          <a:solidFill xmlns:a="http://schemas.openxmlformats.org/drawingml/2006/main">
+            <a:srgbClr val="FFFFFF"/>
+          </a:solidFill>
+          <a:ln xmlns:a="http://schemas.openxmlformats.org/drawingml/2006/main" w="9525">
+            <a:solidFill>
+              <a:srgbClr val="CDD0C8"/>
+            </a:solidFill>
+            <a:prstDash val="solid"/>
+          </a:ln>
+        </p:spPr>
+      </p:sp>
+      <p:sp>
+        <p:nvSpPr>
+          <p:cNvPr id="6" name="">
+            <a:extLst xmlns:a="http://schemas.openxmlformats.org/drawingml/2006/main">
+              <a:ext uri="{FF2B5EF4-FFF2-40B4-BE49-F238E27FC236}">
+                <a16:creationId xmlns:a16="http://schemas.microsoft.com/office/drawing/2014/main" id="{FA4374CB-4474-4B5A-AC33-B973B5BD8692}"/>
+              </a:ext>
+            </a:extLst>
+          </p:cNvPr>
+          <p:cNvSpPr>
+            <a:spLocks xmlns:a="http://schemas.openxmlformats.org/drawingml/2006/main" noGrp="1"/>
+          </p:cNvSpPr>
+          <p:nvPr/>
+        </p:nvSpPr>
+        <p:spPr>
+          <a:xfrm xmlns:a="http://schemas.openxmlformats.org/drawingml/2006/main">
+            <a:off x="914400" y="3095625"/>
+            <a:ext cx="438150" cy="438150"/>
+          </a:xfrm>
+          <a:prstGeom xmlns:a="http://schemas.openxmlformats.org/drawingml/2006/main" prst="roundRect">
+            <a:avLst>
+              <a:gd name="adj" fmla="val 50000"/>
+            </a:avLst>
+          </a:prstGeom>
+          <a:solidFill xmlns:a="http://schemas.openxmlformats.org/drawingml/2006/main">
+            <a:srgbClr val="D8FF55"/>
+          </a:solidFill>
+          <a:ln xmlns:a="http://schemas.openxmlformats.org/drawingml/2006/main" w="0">
+            <a:noFill/>
+            <a:prstDash val="solid"/>
+          </a:ln>
+        </p:spPr>
+      </p:sp>
+      <p:sp>
+        <p:nvSpPr>
+          <p:cNvPr id="7" name="">
+            <a:extLst xmlns:a="http://schemas.openxmlformats.org/drawingml/2006/main">
+              <a:ext uri="{FF2B5EF4-FFF2-40B4-BE49-F238E27FC236}">
+                <a16:creationId xmlns:a16="http://schemas.microsoft.com/office/drawing/2014/main" id="{46ECE422-DC44-47CC-8F1A-D4DA4C4D48A0}"/>
+              </a:ext>
+            </a:extLst>
+          </p:cNvPr>
+          <p:cNvSpPr>
+            <a:spLocks xmlns:a="http://schemas.openxmlformats.org/drawingml/2006/main" noGrp="1"/>
+          </p:cNvSpPr>
+          <p:nvPr/>
+        </p:nvSpPr>
+        <p:spPr>
+          <a:xfrm xmlns:a="http://schemas.openxmlformats.org/drawingml/2006/main">
+            <a:off x="914400" y="3171825"/>
+            <a:ext cx="438150" cy="228600"/>
+          </a:xfrm>
+          <a:prstGeom xmlns:a="http://schemas.openxmlformats.org/drawingml/2006/main" prst="rect">
+            <a:avLst/>
+          </a:prstGeom>
+          <a:noFill xmlns:a="http://schemas.openxmlformats.org/drawingml/2006/main"/>
+          <a:ln xmlns:a="http://schemas.openxmlformats.org/drawingml/2006/main" w="0">
+            <a:noFill/>
+            <a:prstDash val="solid"/>
+          </a:ln>
+        </p:spPr>
+        <p:txBody>
+          <a:bodyPr xmlns:a="http://schemas.openxmlformats.org/drawingml/2006/main"/>
+          <a:lstStyle xmlns:a="http://schemas.openxmlformats.org/drawingml/2006/main"/>
+          <a:p xmlns:a="http://schemas.openxmlformats.org/drawingml/2006/main">
+            <a:pPr algn="ctr">
+              <a:buNone/>
+              <a:defRPr sz="1200" b="1">
+                <a:solidFill>
+                  <a:srgbClr val="152015"/>
+                </a:solidFill>
+              </a:defRPr>
+            </a:pPr>
+            <a:r>
+              <a:rPr sz="1200" b="1">
+                <a:solidFill>
+                  <a:srgbClr val="152015"/>
+                </a:solidFill>
+              </a:rPr>
+              <a:t>1</a:t>
+            </a:r>
+          </a:p>
+        </p:txBody>
+      </p:sp>
+      <p:sp>
+        <p:nvSpPr>
+          <p:cNvPr id="8" name="">
+            <a:extLst xmlns:a="http://schemas.openxmlformats.org/drawingml/2006/main">
+              <a:ext uri="{FF2B5EF4-FFF2-40B4-BE49-F238E27FC236}">
+                <a16:creationId xmlns:a16="http://schemas.microsoft.com/office/drawing/2014/main" id="{3167DCDE-8D59-4BEB-B3AB-6992467AFC2A}"/>
+              </a:ext>
+            </a:extLst>
+          </p:cNvPr>
+          <p:cNvSpPr>
+            <a:spLocks xmlns:a="http://schemas.openxmlformats.org/drawingml/2006/main" noGrp="1"/>
+          </p:cNvSpPr>
+          <p:nvPr/>
+        </p:nvSpPr>
+        <p:spPr>
+          <a:xfrm xmlns:a="http://schemas.openxmlformats.org/drawingml/2006/main">
+            <a:off x="914400" y="3781425"/>
+            <a:ext cx="2286000" cy="266700"/>
+          </a:xfrm>
+          <a:prstGeom xmlns:a="http://schemas.openxmlformats.org/drawingml/2006/main" prst="rect">
+            <a:avLst/>
+          </a:prstGeom>
+          <a:noFill xmlns:a="http://schemas.openxmlformats.org/drawingml/2006/main"/>
+          <a:ln xmlns:a="http://schemas.openxmlformats.org/drawingml/2006/main" w="0">
+            <a:noFill/>
+            <a:prstDash val="solid"/>
+          </a:ln>
+        </p:spPr>
+        <p:txBody>
+          <a:bodyPr xmlns:a="http://schemas.openxmlformats.org/drawingml/2006/main"/>
+          <a:lstStyle xmlns:a="http://schemas.openxmlformats.org/drawingml/2006/main"/>
+          <a:p xmlns:a="http://schemas.openxmlformats.org/drawingml/2006/main">
+            <a:pPr algn="l">
+              <a:buNone/>
+              <a:defRPr sz="1125" b="1">
+                <a:solidFill>
+                  <a:srgbClr val="8F7BFF"/>
+                </a:solidFill>
+              </a:defRPr>
+            </a:pPr>
+            <a:r>
+              <a:rPr sz="1125" b="1">
+                <a:solidFill>
+                  <a:srgbClr val="8F7BFF"/>
+                </a:solidFill>
+              </a:rPr>
+              <a:t>CONTROL</a:t>
+            </a:r>
+          </a:p>
+        </p:txBody>
+      </p:sp>
+      <p:sp>
+        <p:nvSpPr>
+          <p:cNvPr id="9" name="">
+            <a:extLst xmlns:a="http://schemas.openxmlformats.org/drawingml/2006/main">
+              <a:ext uri="{FF2B5EF4-FFF2-40B4-BE49-F238E27FC236}">
+                <a16:creationId xmlns:a16="http://schemas.microsoft.com/office/drawing/2014/main" id="{81CF3EF3-74C5-4C07-A253-896873C4989E}"/>
+              </a:ext>
+            </a:extLst>
+          </p:cNvPr>
+          <p:cNvSpPr>
+            <a:spLocks xmlns:a="http://schemas.openxmlformats.org/drawingml/2006/main" noGrp="1"/>
+          </p:cNvSpPr>
+          <p:nvPr/>
+        </p:nvSpPr>
+        <p:spPr>
+          <a:xfrm xmlns:a="http://schemas.openxmlformats.org/drawingml/2006/main">
+            <a:off x="914400" y="4238625"/>
+            <a:ext cx="2571750" cy="800100"/>
+          </a:xfrm>
+          <a:prstGeom xmlns:a="http://schemas.openxmlformats.org/drawingml/2006/main" prst="rect">
+            <a:avLst/>
+          </a:prstGeom>
+          <a:noFill xmlns:a="http://schemas.openxmlformats.org/drawingml/2006/main"/>
+          <a:ln xmlns:a="http://schemas.openxmlformats.org/drawingml/2006/main" w="0">
+            <a:noFill/>
+            <a:prstDash val="solid"/>
+          </a:ln>
+        </p:spPr>
+        <p:txBody>
+          <a:bodyPr xmlns:a="http://schemas.openxmlformats.org/drawingml/2006/main"/>
+          <a:lstStyle xmlns:a="http://schemas.openxmlformats.org/drawingml/2006/main"/>
+          <a:p xmlns:a="http://schemas.openxmlformats.org/drawingml/2006/main">
+            <a:pPr algn="l">
+              <a:buNone/>
+              <a:defRPr sz="1425" b="0">
+                <a:solidFill>
+                  <a:srgbClr val="152015"/>
+                </a:solidFill>
+              </a:defRPr>
+            </a:pPr>
+            <a:r>
+              <a:rPr sz="1425" b="0">
+                <a:solidFill>
+                  <a:srgbClr val="152015"/>
+                </a:solidFill>
+              </a:rPr>
+              <a:t>Freeze the confirmed workload, formats, risk, and spend limit.</a:t>
+            </a:r>
+          </a:p>
+        </p:txBody>
+      </p:sp>
+      <p:sp>
+        <p:nvSpPr>
+          <p:cNvPr id="10" name="">
+            <a:extLst xmlns:a="http://schemas.openxmlformats.org/drawingml/2006/main">
+              <a:ext uri="{FF2B5EF4-FFF2-40B4-BE49-F238E27FC236}">
+                <a16:creationId xmlns:a16="http://schemas.microsoft.com/office/drawing/2014/main" id="{9675C56A-026E-439E-93C7-3AC237103AAA}"/>
+              </a:ext>
+            </a:extLst>
+          </p:cNvPr>
+          <p:cNvSpPr>
+            <a:spLocks xmlns:a="http://schemas.openxmlformats.org/drawingml/2006/main" noGrp="1"/>
+          </p:cNvSpPr>
+          <p:nvPr/>
+        </p:nvSpPr>
+        <p:spPr>
+          <a:xfrm xmlns:a="http://schemas.openxmlformats.org/drawingml/2006/main">
+            <a:off x="4276725" y="2857500"/>
+            <a:ext cx="3048000" cy="2266950"/>
+          </a:xfrm>
+          <a:prstGeom xmlns:a="http://schemas.openxmlformats.org/drawingml/2006/main" prst="roundRect">
+            <a:avLst>
+              <a:gd name="adj" fmla="val 8403"/>
+            </a:avLst>
+          </a:prstGeom>
+          <a:solidFill xmlns:a="http://schemas.openxmlformats.org/drawingml/2006/main">
+            <a:srgbClr val="152015"/>
+          </a:solidFill>
+          <a:ln xmlns:a="http://schemas.openxmlformats.org/drawingml/2006/main" w="0">
+            <a:noFill/>
+            <a:prstDash val="solid"/>
+          </a:ln>
+        </p:spPr>
+      </p:sp>
+      <p:sp>
+        <p:nvSpPr>
+          <p:cNvPr id="11" name="">
+            <a:extLst xmlns:a="http://schemas.openxmlformats.org/drawingml/2006/main">
+              <a:ext uri="{FF2B5EF4-FFF2-40B4-BE49-F238E27FC236}">
+                <a16:creationId xmlns:a16="http://schemas.microsoft.com/office/drawing/2014/main" id="{B1E67260-98F0-4F3C-80A5-3D31811DDCFD}"/>
+              </a:ext>
+            </a:extLst>
+          </p:cNvPr>
+          <p:cNvSpPr>
+            <a:spLocks xmlns:a="http://schemas.openxmlformats.org/drawingml/2006/main" noGrp="1"/>
+          </p:cNvSpPr>
+          <p:nvPr/>
+        </p:nvSpPr>
+        <p:spPr>
+          <a:xfrm xmlns:a="http://schemas.openxmlformats.org/drawingml/2006/main">
+            <a:off x="4505325" y="3095625"/>
+            <a:ext cx="438150" cy="438150"/>
+          </a:xfrm>
+          <a:prstGeom xmlns:a="http://schemas.openxmlformats.org/drawingml/2006/main" prst="roundRect">
+            <a:avLst>
+              <a:gd name="adj" fmla="val 50000"/>
+            </a:avLst>
+          </a:prstGeom>
+          <a:solidFill xmlns:a="http://schemas.openxmlformats.org/drawingml/2006/main">
+            <a:srgbClr val="8F7BFF"/>
+          </a:solidFill>
+          <a:ln xmlns:a="http://schemas.openxmlformats.org/drawingml/2006/main" w="0">
+            <a:noFill/>
+            <a:prstDash val="solid"/>
+          </a:ln>
+        </p:spPr>
+      </p:sp>
+      <p:sp>
+        <p:nvSpPr>
+          <p:cNvPr id="12" name="">
+            <a:extLst xmlns:a="http://schemas.openxmlformats.org/drawingml/2006/main">
+              <a:ext uri="{FF2B5EF4-FFF2-40B4-BE49-F238E27FC236}">
+                <a16:creationId xmlns:a16="http://schemas.microsoft.com/office/drawing/2014/main" id="{166A3942-AAD4-48E2-9026-A29FC8EF509D}"/>
+              </a:ext>
+            </a:extLst>
+          </p:cNvPr>
+          <p:cNvSpPr>
+            <a:spLocks xmlns:a="http://schemas.openxmlformats.org/drawingml/2006/main" noGrp="1"/>
+          </p:cNvSpPr>
+          <p:nvPr/>
+        </p:nvSpPr>
+        <p:spPr>
+          <a:xfrm xmlns:a="http://schemas.openxmlformats.org/drawingml/2006/main">
+            <a:off x="4505325" y="3171825"/>
+            <a:ext cx="438150" cy="228600"/>
+          </a:xfrm>
+          <a:prstGeom xmlns:a="http://schemas.openxmlformats.org/drawingml/2006/main" prst="rect">
+            <a:avLst/>
+          </a:prstGeom>
+          <a:noFill xmlns:a="http://schemas.openxmlformats.org/drawingml/2006/main"/>
+          <a:ln xmlns:a="http://schemas.openxmlformats.org/drawingml/2006/main" w="0">
+            <a:noFill/>
+            <a:prstDash val="solid"/>
+          </a:ln>
+        </p:spPr>
+        <p:txBody>
+          <a:bodyPr xmlns:a="http://schemas.openxmlformats.org/drawingml/2006/main"/>
+          <a:lstStyle xmlns:a="http://schemas.openxmlformats.org/drawingml/2006/main"/>
+          <a:p xmlns:a="http://schemas.openxmlformats.org/drawingml/2006/main">
+            <a:pPr algn="ctr">
+              <a:buNone/>
+              <a:defRPr sz="1200" b="1">
+                <a:solidFill>
+                  <a:srgbClr val="152015"/>
+                </a:solidFill>
+              </a:defRPr>
+            </a:pPr>
+            <a:r>
+              <a:rPr sz="1200" b="1">
+                <a:solidFill>
+                  <a:srgbClr val="152015"/>
+                </a:solidFill>
+              </a:rPr>
+              <a:t>2</a:t>
+            </a:r>
+          </a:p>
+        </p:txBody>
+      </p:sp>
+      <p:sp>
+        <p:nvSpPr>
+          <p:cNvPr id="13" name="">
+            <a:extLst xmlns:a="http://schemas.openxmlformats.org/drawingml/2006/main">
+              <a:ext uri="{FF2B5EF4-FFF2-40B4-BE49-F238E27FC236}">
+                <a16:creationId xmlns:a16="http://schemas.microsoft.com/office/drawing/2014/main" id="{D6C8AC39-F317-42D8-A4D9-4108B789B5B7}"/>
+              </a:ext>
+            </a:extLst>
+          </p:cNvPr>
+          <p:cNvSpPr>
+            <a:spLocks xmlns:a="http://schemas.openxmlformats.org/drawingml/2006/main" noGrp="1"/>
+          </p:cNvSpPr>
+          <p:nvPr/>
+        </p:nvSpPr>
+        <p:spPr>
+          <a:xfrm xmlns:a="http://schemas.openxmlformats.org/drawingml/2006/main">
+            <a:off x="4505325" y="3781425"/>
+            <a:ext cx="2286000" cy="266700"/>
+          </a:xfrm>
+          <a:prstGeom xmlns:a="http://schemas.openxmlformats.org/drawingml/2006/main" prst="rect">
+            <a:avLst/>
+          </a:prstGeom>
+          <a:noFill xmlns:a="http://schemas.openxmlformats.org/drawingml/2006/main"/>
+          <a:ln xmlns:a="http://schemas.openxmlformats.org/drawingml/2006/main" w="0">
+            <a:noFill/>
+            <a:prstDash val="solid"/>
+          </a:ln>
+        </p:spPr>
+        <p:txBody>
+          <a:bodyPr xmlns:a="http://schemas.openxmlformats.org/drawingml/2006/main"/>
+          <a:lstStyle xmlns:a="http://schemas.openxmlformats.org/drawingml/2006/main"/>
+          <a:p xmlns:a="http://schemas.openxmlformats.org/drawingml/2006/main">
+            <a:pPr algn="l">
+              <a:buNone/>
+              <a:defRPr sz="1125" b="1">
+                <a:solidFill>
+                  <a:srgbClr val="D8FF55"/>
+                </a:solidFill>
+              </a:defRPr>
+            </a:pPr>
+            <a:r>
+              <a:rPr sz="1125" b="1">
+                <a:solidFill>
+                  <a:srgbClr val="D8FF55"/>
+                </a:solidFill>
+              </a:rPr>
+              <a:t>RUN</a:t>
+            </a:r>
+          </a:p>
+        </p:txBody>
+      </p:sp>
+      <p:sp>
+        <p:nvSpPr>
+          <p:cNvPr id="14" name="">
+            <a:extLst xmlns:a="http://schemas.openxmlformats.org/drawingml/2006/main">
+              <a:ext uri="{FF2B5EF4-FFF2-40B4-BE49-F238E27FC236}">
+                <a16:creationId xmlns:a16="http://schemas.microsoft.com/office/drawing/2014/main" id="{65D36F35-26C8-447A-B870-E786D4BC8409}"/>
+              </a:ext>
+            </a:extLst>
+          </p:cNvPr>
+          <p:cNvSpPr>
+            <a:spLocks xmlns:a="http://schemas.openxmlformats.org/drawingml/2006/main" noGrp="1"/>
+          </p:cNvSpPr>
+          <p:nvPr/>
+        </p:nvSpPr>
+        <p:spPr>
+          <a:xfrm xmlns:a="http://schemas.openxmlformats.org/drawingml/2006/main">
+            <a:off x="4505325" y="4238625"/>
+            <a:ext cx="2571750" cy="800100"/>
+          </a:xfrm>
+          <a:prstGeom xmlns:a="http://schemas.openxmlformats.org/drawingml/2006/main" prst="rect">
+            <a:avLst/>
+          </a:prstGeom>
+          <a:noFill xmlns:a="http://schemas.openxmlformats.org/drawingml/2006/main"/>
+          <a:ln xmlns:a="http://schemas.openxmlformats.org/drawingml/2006/main" w="0">
+            <a:noFill/>
+            <a:prstDash val="solid"/>
+          </a:ln>
+        </p:spPr>
+        <p:txBody>
+          <a:bodyPr xmlns:a="http://schemas.openxmlformats.org/drawingml/2006/main"/>
+          <a:lstStyle xmlns:a="http://schemas.openxmlformats.org/drawingml/2006/main"/>
+          <a:p xmlns:a="http://schemas.openxmlformats.org/drawingml/2006/main">
+            <a:pPr algn="l">
+              <a:buNone/>
+              <a:defRPr sz="1425" b="0">
+                <a:solidFill>
+                  <a:srgbClr val="FFFFFF"/>
+                </a:solidFill>
+              </a:defRPr>
+            </a:pPr>
+            <a:r>
+              <a:rPr sz="1425" b="0">
+                <a:solidFill>
+                  <a:srgbClr val="FFFFFF"/>
+                </a:solidFill>
+              </a:rPr>
+              <a:t>Provider runners use the same sealed case—only after approval.</a:t>
+            </a:r>
+          </a:p>
+        </p:txBody>
+      </p:sp>
+      <p:sp>
+        <p:nvSpPr>
+          <p:cNvPr id="15" name="">
+            <a:extLst xmlns:a="http://schemas.openxmlformats.org/drawingml/2006/main">
+              <a:ext uri="{FF2B5EF4-FFF2-40B4-BE49-F238E27FC236}">
+                <a16:creationId xmlns:a16="http://schemas.microsoft.com/office/drawing/2014/main" id="{D99E029B-5297-4AE3-82DA-6975A2A91EB1}"/>
+              </a:ext>
+            </a:extLst>
+          </p:cNvPr>
+          <p:cNvSpPr>
+            <a:spLocks xmlns:a="http://schemas.openxmlformats.org/drawingml/2006/main" noGrp="1"/>
+          </p:cNvSpPr>
+          <p:nvPr/>
+        </p:nvSpPr>
+        <p:spPr>
+          <a:xfrm xmlns:a="http://schemas.openxmlformats.org/drawingml/2006/main">
+            <a:off x="7867650" y="2857500"/>
+            <a:ext cx="3048000" cy="2266950"/>
+          </a:xfrm>
+          <a:prstGeom xmlns:a="http://schemas.openxmlformats.org/drawingml/2006/main" prst="roundRect">
+            <a:avLst>
+              <a:gd name="adj" fmla="val 8403"/>
+            </a:avLst>
+          </a:prstGeom>
+          <a:solidFill xmlns:a="http://schemas.openxmlformats.org/drawingml/2006/main">
+            <a:srgbClr val="FFFFFF"/>
+          </a:solidFill>
+          <a:ln xmlns:a="http://schemas.openxmlformats.org/drawingml/2006/main" w="9525">
+            <a:solidFill>
+              <a:srgbClr val="CDD0C8"/>
+            </a:solidFill>
+            <a:prstDash val="solid"/>
+          </a:ln>
+        </p:spPr>
+      </p:sp>
+      <p:sp>
+        <p:nvSpPr>
+          <p:cNvPr id="16" name="">
+            <a:extLst xmlns:a="http://schemas.openxmlformats.org/drawingml/2006/main">
+              <a:ext uri="{FF2B5EF4-FFF2-40B4-BE49-F238E27FC236}">
+                <a16:creationId xmlns:a16="http://schemas.microsoft.com/office/drawing/2014/main" id="{8C241CF8-2770-4B71-9566-A38260E96F28}"/>
+              </a:ext>
+            </a:extLst>
+          </p:cNvPr>
+          <p:cNvSpPr>
+            <a:spLocks xmlns:a="http://schemas.openxmlformats.org/drawingml/2006/main" noGrp="1"/>
+          </p:cNvSpPr>
+          <p:nvPr/>
+        </p:nvSpPr>
+        <p:spPr>
+          <a:xfrm xmlns:a="http://schemas.openxmlformats.org/drawingml/2006/main">
+            <a:off x="8096250" y="3095625"/>
+            <a:ext cx="438150" cy="438150"/>
+          </a:xfrm>
+          <a:prstGeom xmlns:a="http://schemas.openxmlformats.org/drawingml/2006/main" prst="roundRect">
+            <a:avLst>
+              <a:gd name="adj" fmla="val 50000"/>
+            </a:avLst>
+          </a:prstGeom>
+          <a:solidFill xmlns:a="http://schemas.openxmlformats.org/drawingml/2006/main">
+            <a:srgbClr val="FF8159"/>
+          </a:solidFill>
+          <a:ln xmlns:a="http://schemas.openxmlformats.org/drawingml/2006/main" w="0">
+            <a:noFill/>
+            <a:prstDash val="solid"/>
+          </a:ln>
+        </p:spPr>
+      </p:sp>
+      <p:sp>
+        <p:nvSpPr>
+          <p:cNvPr id="17" name="">
+            <a:extLst xmlns:a="http://schemas.openxmlformats.org/drawingml/2006/main">
+              <a:ext uri="{FF2B5EF4-FFF2-40B4-BE49-F238E27FC236}">
+                <a16:creationId xmlns:a16="http://schemas.microsoft.com/office/drawing/2014/main" id="{4FAB3E40-36FD-4532-A9F4-A2ACBDB3D262}"/>
+              </a:ext>
+            </a:extLst>
+          </p:cNvPr>
+          <p:cNvSpPr>
+            <a:spLocks xmlns:a="http://schemas.openxmlformats.org/drawingml/2006/main" noGrp="1"/>
+          </p:cNvSpPr>
+          <p:nvPr/>
+        </p:nvSpPr>
+        <p:spPr>
+          <a:xfrm xmlns:a="http://schemas.openxmlformats.org/drawingml/2006/main">
+            <a:off x="8096250" y="3171825"/>
+            <a:ext cx="438150" cy="228600"/>
+          </a:xfrm>
+          <a:prstGeom xmlns:a="http://schemas.openxmlformats.org/drawingml/2006/main" prst="rect">
+            <a:avLst/>
+          </a:prstGeom>
+          <a:noFill xmlns:a="http://schemas.openxmlformats.org/drawingml/2006/main"/>
+          <a:ln xmlns:a="http://schemas.openxmlformats.org/drawingml/2006/main" w="0">
+            <a:noFill/>
+            <a:prstDash val="solid"/>
+          </a:ln>
+        </p:spPr>
+        <p:txBody>
+          <a:bodyPr xmlns:a="http://schemas.openxmlformats.org/drawingml/2006/main"/>
+          <a:lstStyle xmlns:a="http://schemas.openxmlformats.org/drawingml/2006/main"/>
+          <a:p xmlns:a="http://schemas.openxmlformats.org/drawingml/2006/main">
+            <a:pPr algn="ctr">
+              <a:buNone/>
+              <a:defRPr sz="1200" b="1">
+                <a:solidFill>
+                  <a:srgbClr val="152015"/>
+                </a:solidFill>
+              </a:defRPr>
+            </a:pPr>
+            <a:r>
+              <a:rPr sz="1200" b="1">
+                <a:solidFill>
+                  <a:srgbClr val="152015"/>
+                </a:solidFill>
+              </a:rPr>
+              <a:t>3</a:t>
+            </a:r>
+          </a:p>
+        </p:txBody>
+      </p:sp>
+      <p:sp>
+        <p:nvSpPr>
+          <p:cNvPr id="18" name="">
+            <a:extLst xmlns:a="http://schemas.openxmlformats.org/drawingml/2006/main">
+              <a:ext uri="{FF2B5EF4-FFF2-40B4-BE49-F238E27FC236}">
+                <a16:creationId xmlns:a16="http://schemas.microsoft.com/office/drawing/2014/main" id="{0A220EAC-9F7A-42E1-B85A-70646B175116}"/>
+              </a:ext>
+            </a:extLst>
+          </p:cNvPr>
+          <p:cNvSpPr>
+            <a:spLocks xmlns:a="http://schemas.openxmlformats.org/drawingml/2006/main" noGrp="1"/>
+          </p:cNvSpPr>
+          <p:nvPr/>
+        </p:nvSpPr>
+        <p:spPr>
+          <a:xfrm xmlns:a="http://schemas.openxmlformats.org/drawingml/2006/main">
+            <a:off x="8096250" y="3781425"/>
+            <a:ext cx="2286000" cy="266700"/>
+          </a:xfrm>
+          <a:prstGeom xmlns:a="http://schemas.openxmlformats.org/drawingml/2006/main" prst="rect">
+            <a:avLst/>
+          </a:prstGeom>
+          <a:noFill xmlns:a="http://schemas.openxmlformats.org/drawingml/2006/main"/>
+          <a:ln xmlns:a="http://schemas.openxmlformats.org/drawingml/2006/main" w="0">
+            <a:noFill/>
+            <a:prstDash val="solid"/>
+          </a:ln>
+        </p:spPr>
+        <p:txBody>
+          <a:bodyPr xmlns:a="http://schemas.openxmlformats.org/drawingml/2006/main"/>
+          <a:lstStyle xmlns:a="http://schemas.openxmlformats.org/drawingml/2006/main"/>
+          <a:p xmlns:a="http://schemas.openxmlformats.org/drawingml/2006/main">
+            <a:pPr algn="l">
+              <a:buNone/>
+              <a:defRPr sz="1125" b="1">
+                <a:solidFill>
+                  <a:srgbClr val="8F7BFF"/>
+                </a:solidFill>
+              </a:defRPr>
+            </a:pPr>
+            <a:r>
+              <a:rPr sz="1125" b="1">
+                <a:solidFill>
+                  <a:srgbClr val="8F7BFF"/>
+                </a:solidFill>
+              </a:rPr>
+              <a:t>PROVE</a:t>
+            </a:r>
+          </a:p>
+        </p:txBody>
+      </p:sp>
+      <p:sp>
+        <p:nvSpPr>
+          <p:cNvPr id="19" name="">
+            <a:extLst xmlns:a="http://schemas.openxmlformats.org/drawingml/2006/main">
+              <a:ext uri="{FF2B5EF4-FFF2-40B4-BE49-F238E27FC236}">
+                <a16:creationId xmlns:a16="http://schemas.microsoft.com/office/drawing/2014/main" id="{1EAE9D48-9B74-4383-9D45-B7361AF48861}"/>
+              </a:ext>
+            </a:extLst>
+          </p:cNvPr>
+          <p:cNvSpPr>
+            <a:spLocks xmlns:a="http://schemas.openxmlformats.org/drawingml/2006/main" noGrp="1"/>
+          </p:cNvSpPr>
+          <p:nvPr/>
+        </p:nvSpPr>
+        <p:spPr>
+          <a:xfrm xmlns:a="http://schemas.openxmlformats.org/drawingml/2006/main">
+            <a:off x="8096250" y="4238625"/>
+            <a:ext cx="2571750" cy="800100"/>
+          </a:xfrm>
+          <a:prstGeom xmlns:a="http://schemas.openxmlformats.org/drawingml/2006/main" prst="rect">
+            <a:avLst/>
+          </a:prstGeom>
+          <a:noFill xmlns:a="http://schemas.openxmlformats.org/drawingml/2006/main"/>
+          <a:ln xmlns:a="http://schemas.openxmlformats.org/drawingml/2006/main" w="0">
+            <a:noFill/>
+            <a:prstDash val="solid"/>
+          </a:ln>
+        </p:spPr>
+        <p:txBody>
+          <a:bodyPr xmlns:a="http://schemas.openxmlformats.org/drawingml/2006/main"/>
+          <a:lstStyle xmlns:a="http://schemas.openxmlformats.org/drawingml/2006/main"/>
+          <a:p xmlns:a="http://schemas.openxmlformats.org/drawingml/2006/main">
+            <a:pPr algn="l">
+              <a:buNone/>
+              <a:defRPr sz="1425" b="0">
+                <a:solidFill>
+                  <a:srgbClr val="152015"/>
+                </a:solidFill>
+              </a:defRPr>
+            </a:pPr>
+            <a:r>
+              <a:rPr sz="1425" b="0">
+                <a:solidFill>
+                  <a:srgbClr val="152015"/>
+                </a:solidFill>
+              </a:rPr>
+              <a:t>Blind scoring, governance, and a point-in-time report make differences visible.</a:t>
+            </a:r>
+          </a:p>
+        </p:txBody>
+      </p:sp>
+      <p:sp>
+        <p:nvSpPr>
+          <p:cNvPr id="20" name="">
+            <a:extLst xmlns:a="http://schemas.openxmlformats.org/drawingml/2006/main">
+              <a:ext uri="{FF2B5EF4-FFF2-40B4-BE49-F238E27FC236}">
+                <a16:creationId xmlns:a16="http://schemas.microsoft.com/office/drawing/2014/main" id="{5027562A-2C6A-4CB9-9D99-BE48BB8FDDBC}"/>
+              </a:ext>
+            </a:extLst>
+          </p:cNvPr>
+          <p:cNvSpPr>
+            <a:spLocks xmlns:a="http://schemas.openxmlformats.org/drawingml/2006/main" noGrp="1"/>
+          </p:cNvSpPr>
+          <p:nvPr/>
+        </p:nvSpPr>
+        <p:spPr>
+          <a:xfrm xmlns:a="http://schemas.openxmlformats.org/drawingml/2006/main">
+            <a:off x="685800" y="5581650"/>
+            <a:ext cx="8953500" cy="323850"/>
+          </a:xfrm>
+          <a:prstGeom xmlns:a="http://schemas.openxmlformats.org/drawingml/2006/main" prst="rect">
+            <a:avLst/>
+          </a:prstGeom>
+          <a:noFill xmlns:a="http://schemas.openxmlformats.org/drawingml/2006/main"/>
+          <a:ln xmlns:a="http://schemas.openxmlformats.org/drawingml/2006/main" w="0">
+            <a:noFill/>
+            <a:prstDash val="solid"/>
+          </a:ln>
+        </p:spPr>
+        <p:txBody>
+          <a:bodyPr xmlns:a="http://schemas.openxmlformats.org/drawingml/2006/main"/>
+          <a:lstStyle xmlns:a="http://schemas.openxmlformats.org/drawingml/2006/main"/>
+          <a:p xmlns:a="http://schemas.openxmlformats.org/drawingml/2006/main">
+            <a:pPr algn="l">
+              <a:buNone/>
+              <a:defRPr sz="1800" b="1">
+                <a:solidFill>
+                  <a:srgbClr val="8F7BFF"/>
+                </a:solidFill>
+              </a:defRPr>
+            </a:pPr>
+            <a:r>
+              <a:rPr sz="1800" b="1">
+                <a:solidFill>
+                  <a:srgbClr val="8F7BFF"/>
+                </a:solidFill>
+              </a:rPr>
+              <a:t>One workload. Multiple controlled runs. One report to export—or delete.</a:t>
+            </a:r>
+          </a:p>
+        </p:txBody>
+      </p:sp>
+      <p:sp>
+        <p:nvSpPr>
+          <p:cNvPr id="21" name="">
+            <a:extLst xmlns:a="http://schemas.openxmlformats.org/drawingml/2006/main">
+              <a:ext uri="{FF2B5EF4-FFF2-40B4-BE49-F238E27FC236}">
+                <a16:creationId xmlns:a16="http://schemas.microsoft.com/office/drawing/2014/main" id="{1EFBFCAD-AC5E-4D43-8F56-8311CE364574}"/>
+              </a:ext>
+            </a:extLst>
+          </p:cNvPr>
+          <p:cNvSpPr>
+            <a:spLocks xmlns:a="http://schemas.openxmlformats.org/drawingml/2006/main" noGrp="1"/>
+          </p:cNvSpPr>
+          <p:nvPr/>
+        </p:nvSpPr>
+        <p:spPr>
+          <a:xfrm xmlns:a="http://schemas.openxmlformats.org/drawingml/2006/main">
+            <a:off x="685800" y="6496050"/>
+            <a:ext cx="4000500" cy="171450"/>
+          </a:xfrm>
+          <a:prstGeom xmlns:a="http://schemas.openxmlformats.org/drawingml/2006/main" prst="rect">
+            <a:avLst/>
+          </a:prstGeom>
+          <a:noFill xmlns:a="http://schemas.openxmlformats.org/drawingml/2006/main"/>
+          <a:ln xmlns:a="http://schemas.openxmlformats.org/drawingml/2006/main" w="0">
+            <a:noFill/>
+            <a:prstDash val="solid"/>
+          </a:ln>
+        </p:spPr>
+        <p:txBody>
+          <a:bodyPr xmlns:a="http://schemas.openxmlformats.org/drawingml/2006/main"/>
+          <a:lstStyle xmlns:a="http://schemas.openxmlformats.org/drawingml/2006/main"/>
+          <a:p xmlns:a="http://schemas.openxmlformats.org/drawingml/2006/main">
+            <a:pPr algn="l">
+              <a:buNone/>
+              <a:defRPr sz="825" b="1">
+                <a:solidFill>
+                  <a:srgbClr val="687068"/>
+                </a:solidFill>
+              </a:defRPr>
+            </a:pPr>
+            <a:r>
+              <a:rPr sz="825" b="1">
+                <a:solidFill>
+                  <a:srgbClr val="687068"/>
+                </a:solidFill>
+              </a:rPr>
+              <a:t>AI BUILD CREW · BADLABZ.COM</a:t>
+            </a:r>
+          </a:p>
+        </p:txBody>
+      </p:sp>
+      <p:sp>
+        <p:nvSpPr>
+          <p:cNvPr id="22" name="">
+            <a:extLst xmlns:a="http://schemas.openxmlformats.org/drawingml/2006/main">
+              <a:ext uri="{FF2B5EF4-FFF2-40B4-BE49-F238E27FC236}">
+                <a16:creationId xmlns:a16="http://schemas.microsoft.com/office/drawing/2014/main" id="{0E78C71B-E1E9-4CCE-AD87-856072D44A76}"/>
+              </a:ext>
+            </a:extLst>
+          </p:cNvPr>
+          <p:cNvSpPr>
+            <a:spLocks xmlns:a="http://schemas.openxmlformats.org/drawingml/2006/main" noGrp="1"/>
+          </p:cNvSpPr>
+          <p:nvPr/>
+        </p:nvSpPr>
+        <p:spPr>
+          <a:xfrm xmlns:a="http://schemas.openxmlformats.org/drawingml/2006/main">
+            <a:off x="10858500" y="6496050"/>
+            <a:ext cx="647700" cy="171450"/>
+          </a:xfrm>
+          <a:prstGeom xmlns:a="http://schemas.openxmlformats.org/drawingml/2006/main" prst="rect">
+            <a:avLst/>
+          </a:prstGeom>
+          <a:noFill xmlns:a="http://schemas.openxmlformats.org/drawingml/2006/main"/>
+          <a:ln xmlns:a="http://schemas.openxmlformats.org/drawingml/2006/main" w="0">
+            <a:noFill/>
+            <a:prstDash val="solid"/>
+          </a:ln>
+        </p:spPr>
+        <p:txBody>
+          <a:bodyPr xmlns:a="http://schemas.openxmlformats.org/drawingml/2006/main"/>
+          <a:lstStyle xmlns:a="http://schemas.openxmlformats.org/drawingml/2006/main"/>
+          <a:p xmlns:a="http://schemas.openxmlformats.org/drawingml/2006/main">
+            <a:pPr algn="r">
+              <a:buNone/>
+              <a:defRPr sz="825" b="1">
+                <a:solidFill>
+                  <a:srgbClr val="8F7BFF"/>
+                </a:solidFill>
+              </a:defRPr>
+            </a:pPr>
+            <a:r>
+              <a:rPr sz="825" b="1">
+                <a:solidFill>
+                  <a:srgbClr val="8F7BFF"/>
+                </a:solidFill>
+              </a:rPr>
+              <a:t>09</a:t>
+            </a:r>
+          </a:p>
+        </p:txBody>
+      </p:sp>
+    </p:spTree>
+    <p:extLst>
+      <p:ext uri="{BB962C8B-B14F-4D97-AF65-F5344CB8AC3E}">
+        <p14:creationId xmlns:p14="http://schemas.microsoft.com/office/powerpoint/2010/main" val="1488857310"/>
       </p:ext>
     </p:extLst>
   </p:cSld>

</xml_diff>

<commit_message>
Finalize recording deck and guided demo
</commit_message>
<xml_diff>
--- a/artifacts/AI_BUILD_CREW_COST_CONTRACT_VIDEO_REVIEW.pptx
+++ b/artifacts/AI_BUILD_CREW_COST_CONTRACT_VIDEO_REVIEW.pptx
@@ -2,23 +2,24 @@
 <file path=ppt/presentation.xml><?xml version="1.0" encoding="utf-8"?>
 <p:presentation xmlns:p="http://schemas.openxmlformats.org/presentationml/2006/main">
   <p:sldMasterIdLst>
-    <p:sldMasterId xmlns:r="http://schemas.openxmlformats.org/officeDocument/2006/relationships" id="2147483648" r:id="Rda68c6c13e124e89"/>
+    <p:sldMasterId xmlns:r="http://schemas.openxmlformats.org/officeDocument/2006/relationships" id="2147483648" r:id="Rc65c6fcb9fe94bc1"/>
   </p:sldMasterIdLst>
   <p:notesMasterIdLst>
-    <p:notesMasterId xmlns:r="http://schemas.openxmlformats.org/officeDocument/2006/relationships" r:id="R31ca0785941a497e"/>
+    <p:notesMasterId xmlns:r="http://schemas.openxmlformats.org/officeDocument/2006/relationships" r:id="R6cb18e7f26574c2b"/>
   </p:notesMasterIdLst>
   <p:sldIdLst>
-    <p:sldId xmlns:r="http://schemas.openxmlformats.org/officeDocument/2006/relationships" id="256" r:id="R98b373e1cfab4d58"/>
-    <p:sldId xmlns:r="http://schemas.openxmlformats.org/officeDocument/2006/relationships" id="257" r:id="R764d1e5b88594da0"/>
-    <p:sldId xmlns:r="http://schemas.openxmlformats.org/officeDocument/2006/relationships" id="258" r:id="R474d42d2be4245db"/>
-    <p:sldId xmlns:r="http://schemas.openxmlformats.org/officeDocument/2006/relationships" id="259" r:id="R4020a1a900b84cd5"/>
-    <p:sldId xmlns:r="http://schemas.openxmlformats.org/officeDocument/2006/relationships" id="260" r:id="Rf5bb74ee6080499a"/>
-    <p:sldId xmlns:r="http://schemas.openxmlformats.org/officeDocument/2006/relationships" id="261" r:id="Rc7eee5b5d4314140"/>
-    <p:sldId xmlns:r="http://schemas.openxmlformats.org/officeDocument/2006/relationships" id="262" r:id="R87bffd3a20024a28"/>
-    <p:sldId xmlns:r="http://schemas.openxmlformats.org/officeDocument/2006/relationships" id="263" r:id="R6ee581eff5df4f67"/>
-    <p:sldId xmlns:r="http://schemas.openxmlformats.org/officeDocument/2006/relationships" id="264" r:id="R2f065474507d488b"/>
-    <p:sldId xmlns:r="http://schemas.openxmlformats.org/officeDocument/2006/relationships" id="265" r:id="R540eb597b6034f20"/>
-    <p:sldId xmlns:r="http://schemas.openxmlformats.org/officeDocument/2006/relationships" id="266" r:id="R33fe81211eec4dff"/>
+    <p:sldId xmlns:r="http://schemas.openxmlformats.org/officeDocument/2006/relationships" id="256" r:id="R9f7862ddd57f46e4"/>
+    <p:sldId xmlns:r="http://schemas.openxmlformats.org/officeDocument/2006/relationships" id="257" r:id="R2eebec415ebe449d"/>
+    <p:sldId xmlns:r="http://schemas.openxmlformats.org/officeDocument/2006/relationships" id="258" r:id="Rcbe97d1b3a5246cf"/>
+    <p:sldId xmlns:r="http://schemas.openxmlformats.org/officeDocument/2006/relationships" id="259" r:id="R285ad29349ea4946"/>
+    <p:sldId xmlns:r="http://schemas.openxmlformats.org/officeDocument/2006/relationships" id="260" r:id="R3f7392ca04424b96"/>
+    <p:sldId xmlns:r="http://schemas.openxmlformats.org/officeDocument/2006/relationships" id="261" r:id="Red3891b08e584162"/>
+    <p:sldId xmlns:r="http://schemas.openxmlformats.org/officeDocument/2006/relationships" id="262" r:id="R634e7273648b4676"/>
+    <p:sldId xmlns:r="http://schemas.openxmlformats.org/officeDocument/2006/relationships" id="263" r:id="Rdf06b0e0d62647ff"/>
+    <p:sldId xmlns:r="http://schemas.openxmlformats.org/officeDocument/2006/relationships" id="264" r:id="R14e7c4cdf89645af"/>
+    <p:sldId xmlns:r="http://schemas.openxmlformats.org/officeDocument/2006/relationships" id="265" r:id="Rc4d0d74ed8f44384"/>
+    <p:sldId xmlns:r="http://schemas.openxmlformats.org/officeDocument/2006/relationships" id="266" r:id="R60a2dd1dd6924203"/>
+    <p:sldId xmlns:r="http://schemas.openxmlformats.org/officeDocument/2006/relationships" id="267" r:id="Rb0141ccdac4541d7"/>
   </p:sldIdLst>
   <p:sldSz cx="12192000" cy="6858000"/>
   <p:notesSz cx="6858000" cy="9144000"/>
@@ -547,7 +548,7 @@
           <a:lstStyle xmlns:a="http://schemas.openxmlformats.org/drawingml/2006/main"/>
           <a:p xmlns:a="http://schemas.openxmlformats.org/drawingml/2006/main">
             <a:r>
-              <a:t>The six handoffs are intentionally hard-bordered: brief, freeze, provider run, blinded scoring, governance, and report. Catalog-only comparison makes no provider calls and has zero model-token cost. Live comparison begins only after the user sees a maximum spend and explicitly approves it. Every provider receives the same frozen case; runners cannot choose models, raise budgets, score themselves, or change policy.</a:t>
+              <a:t>The current estimator becomes the deterministic control plane. The Workload Architect can propose stages, but the user confirms them. The orchestrator then sends one frozen case to controlled OpenAI, Gemini, Claude, and Bedrock runners. Their results are frozen before blinded evaluation. Cost and governance rules run after scoring, and the output is a point-in-time comparative report. No provider can change the prompt, score itself, set the budget, calculate its own price, or approve the decision.</a:t>
             </a:r>
           </a:p>
           <a:p xmlns:a="http://schemas.openxmlformats.org/drawingml/2006/main">
@@ -562,27 +563,17 @@
           </a:p>
           <a:p xmlns:a="http://schemas.openxmlformats.org/drawingml/2006/main">
             <a:r>
-              <a:t>- AI Build Crew Multi-Agent Provider Platform Plan, August 9, 2026</a:t>
-            </a:r>
-          </a:p>
-          <a:p xmlns:a="http://schemas.openxmlformats.org/drawingml/2006/main">
-            <a:r>
-              <a:t>- https://ai.google.dev/gemini-api/docs/pricing</a:t>
-            </a:r>
-          </a:p>
-          <a:p xmlns:a="http://schemas.openxmlformats.org/drawingml/2006/main">
-            <a:r>
-              <a:t>- https://ai.google.dev/api/models</a:t>
-            </a:r>
-          </a:p>
-          <a:p xmlns:a="http://schemas.openxmlformats.org/drawingml/2006/main">
-            <a:r>
-              <a:t>- https://platform.claude.com/docs/en/api/beta/models/list</a:t>
-            </a:r>
-          </a:p>
-          <a:p xmlns:a="http://schemas.openxmlformats.org/drawingml/2006/main">
-            <a:r>
-              <a:t>- https://developers.openai.com/api/reference/resources/evals</a:t>
+              <a:t>- AI Build Crew Multi-Agent Provider Platform Plan, “The right architecture,” August 9, 2026</a:t>
+            </a:r>
+          </a:p>
+          <a:p xmlns:a="http://schemas.openxmlformats.org/drawingml/2006/main">
+            <a:r>
+              <a:t>- https://kroki.io/</a:t>
+            </a:r>
+          </a:p>
+          <a:p xmlns:a="http://schemas.openxmlformats.org/drawingml/2006/main">
+            <a:r>
+              <a:t>- https://mermaid.js.org/</a:t>
             </a:r>
           </a:p>
         </p:txBody>
@@ -652,6 +643,111 @@
           <a:lstStyle xmlns:a="http://schemas.openxmlformats.org/drawingml/2006/main"/>
           <a:p xmlns:a="http://schemas.openxmlformats.org/drawingml/2006/main">
             <a:r>
+              <a:t>The six handoffs are intentionally hard-bordered: brief, freeze, provider run, blinded scoring, governance, and report. Catalog-only comparison makes no provider calls and has zero model-token cost. Live comparison begins only after the user sees a maximum spend and explicitly approves it. Every provider receives the same frozen case; runners cannot choose models, raise budgets, score themselves, or change policy.</a:t>
+            </a:r>
+          </a:p>
+          <a:p xmlns:a="http://schemas.openxmlformats.org/drawingml/2006/main">
+            <a:r>
+              <a:t/>
+            </a:r>
+          </a:p>
+          <a:p xmlns:a="http://schemas.openxmlformats.org/drawingml/2006/main">
+            <a:r>
+              <a:t>[Sources]</a:t>
+            </a:r>
+          </a:p>
+          <a:p xmlns:a="http://schemas.openxmlformats.org/drawingml/2006/main">
+            <a:r>
+              <a:t>- AI Build Crew Multi-Agent Provider Platform Plan, August 9, 2026</a:t>
+            </a:r>
+          </a:p>
+          <a:p xmlns:a="http://schemas.openxmlformats.org/drawingml/2006/main">
+            <a:r>
+              <a:t>- https://ai.google.dev/gemini-api/docs/pricing</a:t>
+            </a:r>
+          </a:p>
+          <a:p xmlns:a="http://schemas.openxmlformats.org/drawingml/2006/main">
+            <a:r>
+              <a:t>- https://ai.google.dev/api/models</a:t>
+            </a:r>
+          </a:p>
+          <a:p xmlns:a="http://schemas.openxmlformats.org/drawingml/2006/main">
+            <a:r>
+              <a:t>- https://platform.claude.com/docs/en/api/beta/models/list</a:t>
+            </a:r>
+          </a:p>
+          <a:p xmlns:a="http://schemas.openxmlformats.org/drawingml/2006/main">
+            <a:r>
+              <a:t>- https://developers.openai.com/api/reference/resources/evals</a:t>
+            </a:r>
+          </a:p>
+        </p:txBody>
+      </p:sp>
+      <p:sp>
+        <p:nvSpPr>
+          <p:cNvPr id="4" name="Slide Number Placeholder 3"/>
+          <p:cNvSpPr>
+            <a:spLocks xmlns:a="http://schemas.openxmlformats.org/drawingml/2006/main" noGrp="1"/>
+          </p:cNvSpPr>
+          <p:nvPr>
+            <p:ph type="sldNum" idx="5"/>
+          </p:nvPr>
+        </p:nvSpPr>
+        <p:spPr/>
+        <p:txBody>
+          <a:bodyPr xmlns:a="http://schemas.openxmlformats.org/drawingml/2006/main"/>
+          <a:lstStyle xmlns:a="http://schemas.openxmlformats.org/drawingml/2006/main"/>
+          <a:p xmlns:a="http://schemas.openxmlformats.org/drawingml/2006/main"/>
+        </p:txBody>
+      </p:sp>
+    </p:spTree>
+  </p:cSld>
+  <p:clrMapOvr>
+    <a:masterClrMapping xmlns:a="http://schemas.openxmlformats.org/drawingml/2006/main"/>
+  </p:clrMapOvr>
+</p:notes>
+</file>
+
+<file path=ppt/notesSlides/notesSlide12.xml><?xml version="1.0" encoding="utf-8"?>
+<p:notes xmlns:p="http://schemas.openxmlformats.org/presentationml/2006/main">
+  <p:cSld>
+    <p:spTree>
+      <p:nvGrpSpPr>
+        <p:cNvPr id="1" name=""/>
+        <p:cNvGrpSpPr/>
+        <p:nvPr/>
+      </p:nvGrpSpPr>
+      <p:grpSpPr>
+        <a:xfrm xmlns:a="http://schemas.openxmlformats.org/drawingml/2006/main"/>
+      </p:grpSpPr>
+      <p:sp>
+        <p:nvSpPr>
+          <p:cNvPr id="2" name="Slide Image Placeholder 1"/>
+          <p:cNvSpPr>
+            <a:spLocks xmlns:a="http://schemas.openxmlformats.org/drawingml/2006/main" noGrp="1"/>
+          </p:cNvSpPr>
+          <p:nvPr>
+            <p:ph type="sldImg" idx="0"/>
+          </p:nvPr>
+        </p:nvSpPr>
+        <p:spPr/>
+      </p:sp>
+      <p:sp>
+        <p:nvSpPr>
+          <p:cNvPr id="3" name="Notes Placeholder 2"/>
+          <p:cNvSpPr>
+            <a:spLocks xmlns:a="http://schemas.openxmlformats.org/drawingml/2006/main" noGrp="1"/>
+          </p:cNvSpPr>
+          <p:nvPr>
+            <p:ph type="body" idx="1"/>
+          </p:nvPr>
+        </p:nvSpPr>
+        <p:spPr/>
+        <p:txBody>
+          <a:bodyPr xmlns:a="http://schemas.openxmlformats.org/drawingml/2006/main"/>
+          <a:lstStyle xmlns:a="http://schemas.openxmlformats.org/drawingml/2006/main"/>
+          <a:p xmlns:a="http://schemas.openxmlformats.org/drawingml/2006/main">
+            <a:r>
               <a:t>AWS is the Phase 2 evidence foundation, not a requirement for the current estimator. S3 holds versioned source snapshots and run artifacts; DynamoDB holds project metadata, budgets, and report history; Secrets Manager protects provider credentials used by server-side runners. Retrieval-augmented generation can ground source summaries, model evidence, and report explanations. It cannot calculate cost, alter eligibility, rewrite policy, or approve a decision. Privacy defaults remain no raw prompt retention, synthetic cases first, and user-controlled export or deletion.</a:t>
             </a:r>
           </a:p>
@@ -1212,7 +1308,7 @@
           <a:lstStyle xmlns:a="http://schemas.openxmlformats.org/drawingml/2006/main"/>
           <a:p xmlns:a="http://schemas.openxmlformats.org/drawingml/2006/main">
             <a:r>
-              <a:t>Eighteen automated checks pass. They cover COST-001 through COST-006, model-owned output profiles, retry and checker inclusion, deliberate ledger corruption, governance failure propagation, multi-format requirements, unknown-step workflow recommendations, Luna/Terra/Sol tier changes, deterministic output, fail-closed safety, stable ranking, and rendered-page smoke. Build and lint pass. Zero generative calls can change the decision path. This proves the decision contract—not measured model quality or first-time-user comprehension.</a:t>
+              <a:t>Twenty-two automated cases pass. They cover deterministic repeatability; ordered low, likely, and high model-behavior scenarios; rejection of user-authored output tokens; retries and checker steps; deliberate ledger corruption; governance propagation; high-risk and unknown fail-closed behavior; unsupported and multi-format blocking; the four-format inventory case; workflow-step recommendations; model-tier switching; stale pricing; visible assumptions; loop limits; candidate-order stability; point-in-time report output; blocked-report behavior; rendered-page coverage; and guided intake format scope. This proves the decision contract—not measured provider quality or first-time-user comprehension.</a:t>
             </a:r>
           </a:p>
           <a:p xmlns:a="http://schemas.openxmlformats.org/drawingml/2006/main">
@@ -1227,12 +1323,12 @@
           </a:p>
           <a:p xmlns:a="http://schemas.openxmlformats.org/drawingml/2006/main">
             <a:r>
-              <a:t>- AI Build Crew automated test suite, decision engine v1.4.0</a:t>
-            </a:r>
-          </a:p>
-          <a:p xmlns:a="http://schemas.openxmlformats.org/drawingml/2006/main">
-            <a:r>
-              <a:t>- AI Build Crew Evaluation report, August 9, 2026</a:t>
+              <a:t>- AI Build Crew automated test suite, 22 passing cases, August 9, 2026</a:t>
+            </a:r>
+          </a:p>
+          <a:p xmlns:a="http://schemas.openxmlformats.org/drawingml/2006/main">
+            <a:r>
+              <a:t>- AI Build Crew decision engine v1.4.0</a:t>
             </a:r>
           </a:p>
           <a:p xmlns:a="http://schemas.openxmlformats.org/drawingml/2006/main">
@@ -1500,7 +1596,7 @@
   </p:cSld>
   <p:clrMap bg1="lt1" tx1="dk1" bg2="lt2" tx2="dk2" accent1="accent1" accent2="accent2" accent3="accent3" accent4="accent4" accent5="accent5" accent6="accent6" hlink="hlink" folHlink="folHlink"/>
   <p:sldLayoutIdLst>
-    <p:sldLayoutId xmlns:r="http://schemas.openxmlformats.org/officeDocument/2006/relationships" id="2147483649" r:id="R06a3eae344364870"/>
+    <p:sldLayoutId xmlns:r="http://schemas.openxmlformats.org/officeDocument/2006/relationships" id="2147483649" r:id="R5b95318c16744dd0"/>
   </p:sldLayoutIdLst>
   <p:txStyles>
     <p:titleStyle>
@@ -2193,7 +2289,7 @@
           <p:nvPr/>
         </p:nvPicPr>
         <p:blipFill>
-          <a:blip xmlns:r="http://schemas.openxmlformats.org/officeDocument/2006/relationships" xmlns:a="http://schemas.openxmlformats.org/drawingml/2006/main" r:embed="R27cbb2583a0a490e"/>
+          <a:blip xmlns:r="http://schemas.openxmlformats.org/officeDocument/2006/relationships" xmlns:a="http://schemas.openxmlformats.org/drawingml/2006/main" r:embed="R807127871ffd40f2"/>
           <a:srcRect xmlns:a="http://schemas.openxmlformats.org/drawingml/2006/main" l="0" t="27" r="0" b="27"/>
           <a:stretch xmlns:a="http://schemas.openxmlformats.org/drawingml/2006/main">
             <a:fillRect l="0" t="0" r="0" b="0"/>
@@ -2542,6 +2638,443 @@
 </file>
 
 <file path=ppt/slides/slide10.xml><?xml version="1.0" encoding="utf-8"?>
+<p:sld xmlns:p="http://schemas.openxmlformats.org/presentationml/2006/main">
+  <p:cSld>
+    <p:bg>
+      <p:bgPr>
+        <a:solidFill xmlns:a="http://schemas.openxmlformats.org/drawingml/2006/main">
+          <a:srgbClr val="F3EFE5"/>
+        </a:solidFill>
+      </p:bgPr>
+    </p:bg>
+    <p:spTree>
+      <p:nvGrpSpPr>
+        <p:cNvPr id="1" name=""/>
+        <p:cNvGrpSpPr/>
+        <p:nvPr/>
+      </p:nvGrpSpPr>
+      <p:grpSpPr>
+        <a:xfrm xmlns:a="http://schemas.openxmlformats.org/drawingml/2006/main"/>
+      </p:grpSpPr>
+      <p:sp>
+        <p:nvSpPr>
+          <p:cNvPr id="21" name="">
+            <a:extLst xmlns:a="http://schemas.openxmlformats.org/drawingml/2006/main">
+              <a:ext uri="{FF2B5EF4-FFF2-40B4-BE49-F238E27FC236}">
+                <a16:creationId xmlns:a16="http://schemas.microsoft.com/office/drawing/2014/main" id="{3B66254D-BA81-43B0-A173-40DA05518F60}"/>
+              </a:ext>
+            </a:extLst>
+          </p:cNvPr>
+          <p:cNvSpPr>
+            <a:spLocks xmlns:a="http://schemas.openxmlformats.org/drawingml/2006/main" noGrp="1"/>
+          </p:cNvSpPr>
+          <p:nvPr/>
+        </p:nvSpPr>
+        <p:spPr>
+          <a:xfrm xmlns:a="http://schemas.openxmlformats.org/drawingml/2006/main">
+            <a:off x="685800" y="457200"/>
+            <a:ext cx="514350" cy="266700"/>
+          </a:xfrm>
+          <a:prstGeom xmlns:a="http://schemas.openxmlformats.org/drawingml/2006/main" prst="rect">
+            <a:avLst/>
+          </a:prstGeom>
+          <a:noFill xmlns:a="http://schemas.openxmlformats.org/drawingml/2006/main"/>
+          <a:ln xmlns:a="http://schemas.openxmlformats.org/drawingml/2006/main" w="0">
+            <a:noFill/>
+            <a:prstDash val="solid"/>
+          </a:ln>
+        </p:spPr>
+        <p:txBody>
+          <a:bodyPr xmlns:a="http://schemas.openxmlformats.org/drawingml/2006/main"/>
+          <a:lstStyle xmlns:a="http://schemas.openxmlformats.org/drawingml/2006/main"/>
+          <a:p xmlns:a="http://schemas.openxmlformats.org/drawingml/2006/main">
+            <a:pPr algn="l">
+              <a:buNone/>
+              <a:defRPr sz="975" b="1">
+                <a:solidFill>
+                  <a:srgbClr val="8F7BFF"/>
+                </a:solidFill>
+              </a:defRPr>
+            </a:pPr>
+            <a:r>
+              <a:rPr sz="975" b="1">
+                <a:solidFill>
+                  <a:srgbClr val="8F7BFF"/>
+                </a:solidFill>
+              </a:rPr>
+              <a:t>08</a:t>
+            </a:r>
+          </a:p>
+        </p:txBody>
+      </p:sp>
+      <p:sp>
+        <p:nvSpPr>
+          <p:cNvPr id="2" name="">
+            <a:extLst xmlns:a="http://schemas.openxmlformats.org/drawingml/2006/main">
+              <a:ext uri="{FF2B5EF4-FFF2-40B4-BE49-F238E27FC236}">
+                <a16:creationId xmlns:a16="http://schemas.microsoft.com/office/drawing/2014/main" id="{AEECD96B-D96E-4E52-9E61-B75EEDC2F693}"/>
+              </a:ext>
+            </a:extLst>
+          </p:cNvPr>
+          <p:cNvSpPr>
+            <a:spLocks xmlns:a="http://schemas.openxmlformats.org/drawingml/2006/main" noGrp="1"/>
+          </p:cNvSpPr>
+          <p:nvPr/>
+        </p:nvSpPr>
+        <p:spPr>
+          <a:xfrm xmlns:a="http://schemas.openxmlformats.org/drawingml/2006/main">
+            <a:off x="1219200" y="457200"/>
+            <a:ext cx="4762500" cy="266700"/>
+          </a:xfrm>
+          <a:prstGeom xmlns:a="http://schemas.openxmlformats.org/drawingml/2006/main" prst="rect">
+            <a:avLst/>
+          </a:prstGeom>
+          <a:noFill xmlns:a="http://schemas.openxmlformats.org/drawingml/2006/main"/>
+          <a:ln xmlns:a="http://schemas.openxmlformats.org/drawingml/2006/main" w="0">
+            <a:noFill/>
+            <a:prstDash val="solid"/>
+          </a:ln>
+        </p:spPr>
+        <p:txBody>
+          <a:bodyPr xmlns:a="http://schemas.openxmlformats.org/drawingml/2006/main"/>
+          <a:lstStyle xmlns:a="http://schemas.openxmlformats.org/drawingml/2006/main"/>
+          <a:p xmlns:a="http://schemas.openxmlformats.org/drawingml/2006/main">
+            <a:pPr algn="l">
+              <a:buNone/>
+              <a:defRPr sz="975" b="1">
+                <a:solidFill>
+                  <a:srgbClr val="152015"/>
+                </a:solidFill>
+              </a:defRPr>
+            </a:pPr>
+            <a:r>
+              <a:rPr sz="975" b="1">
+                <a:solidFill>
+                  <a:srgbClr val="152015"/>
+                </a:solidFill>
+              </a:rPr>
+              <a:t>PHASE 2 · THE RIGHT ARCHITECTURE</a:t>
+            </a:r>
+          </a:p>
+        </p:txBody>
+      </p:sp>
+      <p:sp>
+        <p:nvSpPr>
+          <p:cNvPr id="3" name="">
+            <a:extLst xmlns:a="http://schemas.openxmlformats.org/drawingml/2006/main">
+              <a:ext uri="{FF2B5EF4-FFF2-40B4-BE49-F238E27FC236}">
+                <a16:creationId xmlns:a16="http://schemas.microsoft.com/office/drawing/2014/main" id="{C57488F2-36F9-43D6-8D83-5FFAFE4AD0B5}"/>
+              </a:ext>
+            </a:extLst>
+          </p:cNvPr>
+          <p:cNvSpPr>
+            <a:spLocks xmlns:a="http://schemas.openxmlformats.org/drawingml/2006/main" noGrp="1"/>
+          </p:cNvSpPr>
+          <p:nvPr/>
+        </p:nvSpPr>
+        <p:spPr>
+          <a:xfrm xmlns:a="http://schemas.openxmlformats.org/drawingml/2006/main">
+            <a:off x="685800" y="781050"/>
+            <a:ext cx="10820400" cy="19050"/>
+          </a:xfrm>
+          <a:prstGeom xmlns:a="http://schemas.openxmlformats.org/drawingml/2006/main" prst="rect">
+            <a:avLst/>
+          </a:prstGeom>
+          <a:solidFill xmlns:a="http://schemas.openxmlformats.org/drawingml/2006/main">
+            <a:srgbClr val="CDD0C8"/>
+          </a:solidFill>
+          <a:ln xmlns:a="http://schemas.openxmlformats.org/drawingml/2006/main" w="0">
+            <a:noFill/>
+            <a:prstDash val="solid"/>
+          </a:ln>
+        </p:spPr>
+      </p:sp>
+      <p:sp>
+        <p:nvSpPr>
+          <p:cNvPr id="4" name="">
+            <a:extLst xmlns:a="http://schemas.openxmlformats.org/drawingml/2006/main">
+              <a:ext uri="{FF2B5EF4-FFF2-40B4-BE49-F238E27FC236}">
+                <a16:creationId xmlns:a16="http://schemas.microsoft.com/office/drawing/2014/main" id="{AC5C84C1-6575-4D95-AE41-C4CA0B56BC8E}"/>
+              </a:ext>
+            </a:extLst>
+          </p:cNvPr>
+          <p:cNvSpPr>
+            <a:spLocks xmlns:a="http://schemas.openxmlformats.org/drawingml/2006/main" noGrp="1"/>
+          </p:cNvSpPr>
+          <p:nvPr/>
+        </p:nvSpPr>
+        <p:spPr>
+          <a:xfrm xmlns:a="http://schemas.openxmlformats.org/drawingml/2006/main">
+            <a:off x="685800" y="1123950"/>
+            <a:ext cx="6858000" cy="990600"/>
+          </a:xfrm>
+          <a:prstGeom xmlns:a="http://schemas.openxmlformats.org/drawingml/2006/main" prst="rect">
+            <a:avLst/>
+          </a:prstGeom>
+          <a:noFill xmlns:a="http://schemas.openxmlformats.org/drawingml/2006/main"/>
+          <a:ln xmlns:a="http://schemas.openxmlformats.org/drawingml/2006/main" w="0">
+            <a:noFill/>
+            <a:prstDash val="solid"/>
+          </a:ln>
+        </p:spPr>
+        <p:txBody>
+          <a:bodyPr xmlns:a="http://schemas.openxmlformats.org/drawingml/2006/main"/>
+          <a:lstStyle xmlns:a="http://schemas.openxmlformats.org/drawingml/2006/main"/>
+          <a:p xmlns:a="http://schemas.openxmlformats.org/drawingml/2006/main">
+            <a:pPr algn="l">
+              <a:buNone/>
+              <a:defRPr sz="3375" b="1">
+                <a:solidFill>
+                  <a:srgbClr val="152015"/>
+                </a:solidFill>
+              </a:defRPr>
+            </a:pPr>
+            <a:r>
+              <a:rPr sz="3375" b="1">
+                <a:solidFill>
+                  <a:srgbClr val="152015"/>
+                </a:solidFill>
+              </a:rPr>
+              <a:t>The right architecture keeps</a:t>
+            </a:r>
+          </a:p>
+          <a:p xmlns:a="http://schemas.openxmlformats.org/drawingml/2006/main">
+            <a:pPr algn="l">
+              <a:buNone/>
+              <a:defRPr sz="3375" b="1">
+                <a:solidFill>
+                  <a:srgbClr val="152015"/>
+                </a:solidFill>
+              </a:defRPr>
+            </a:pPr>
+            <a:r>
+              <a:rPr sz="3375" b="1">
+                <a:solidFill>
+                  <a:srgbClr val="152015"/>
+                </a:solidFill>
+              </a:rPr>
+              <a:t>agents inside the rules.</a:t>
+            </a:r>
+          </a:p>
+        </p:txBody>
+      </p:sp>
+      <p:sp>
+        <p:nvSpPr>
+          <p:cNvPr id="17" name="">
+            <a:extLst xmlns:a="http://schemas.openxmlformats.org/drawingml/2006/main">
+              <a:ext uri="{FF2B5EF4-FFF2-40B4-BE49-F238E27FC236}">
+                <a16:creationId xmlns:a16="http://schemas.microsoft.com/office/drawing/2014/main" id="{138D78AB-16CC-4403-B9F2-A992A34228A2}"/>
+              </a:ext>
+            </a:extLst>
+          </p:cNvPr>
+          <p:cNvSpPr>
+            <a:spLocks xmlns:a="http://schemas.openxmlformats.org/drawingml/2006/main" noGrp="1"/>
+          </p:cNvSpPr>
+          <p:nvPr/>
+        </p:nvSpPr>
+        <p:spPr>
+          <a:xfrm xmlns:a="http://schemas.openxmlformats.org/drawingml/2006/main">
+            <a:off x="685800" y="5657850"/>
+            <a:ext cx="10820400" cy="19050"/>
+          </a:xfrm>
+          <a:prstGeom xmlns:a="http://schemas.openxmlformats.org/drawingml/2006/main" prst="rect">
+            <a:avLst/>
+          </a:prstGeom>
+          <a:solidFill xmlns:a="http://schemas.openxmlformats.org/drawingml/2006/main">
+            <a:srgbClr val="CDD0C8"/>
+          </a:solidFill>
+          <a:ln xmlns:a="http://schemas.openxmlformats.org/drawingml/2006/main" w="0">
+            <a:noFill/>
+            <a:prstDash val="solid"/>
+          </a:ln>
+        </p:spPr>
+      </p:sp>
+      <p:sp>
+        <p:nvSpPr>
+          <p:cNvPr id="18" name="">
+            <a:extLst xmlns:a="http://schemas.openxmlformats.org/drawingml/2006/main">
+              <a:ext uri="{FF2B5EF4-FFF2-40B4-BE49-F238E27FC236}">
+                <a16:creationId xmlns:a16="http://schemas.microsoft.com/office/drawing/2014/main" id="{0AD073E4-4E78-4C57-964D-07C5F68E62E3}"/>
+              </a:ext>
+            </a:extLst>
+          </p:cNvPr>
+          <p:cNvSpPr>
+            <a:spLocks xmlns:a="http://schemas.openxmlformats.org/drawingml/2006/main" noGrp="1"/>
+          </p:cNvSpPr>
+          <p:nvPr/>
+        </p:nvSpPr>
+        <p:spPr>
+          <a:xfrm xmlns:a="http://schemas.openxmlformats.org/drawingml/2006/main">
+            <a:off x="685800" y="5867400"/>
+            <a:ext cx="10572750" cy="304800"/>
+          </a:xfrm>
+          <a:prstGeom xmlns:a="http://schemas.openxmlformats.org/drawingml/2006/main" prst="rect">
+            <a:avLst/>
+          </a:prstGeom>
+          <a:noFill xmlns:a="http://schemas.openxmlformats.org/drawingml/2006/main"/>
+          <a:ln xmlns:a="http://schemas.openxmlformats.org/drawingml/2006/main" w="0">
+            <a:noFill/>
+            <a:prstDash val="solid"/>
+          </a:ln>
+        </p:spPr>
+        <p:txBody>
+          <a:bodyPr xmlns:a="http://schemas.openxmlformats.org/drawingml/2006/main"/>
+          <a:lstStyle xmlns:a="http://schemas.openxmlformats.org/drawingml/2006/main"/>
+          <a:p xmlns:a="http://schemas.openxmlformats.org/drawingml/2006/main">
+            <a:pPr algn="l">
+              <a:buNone/>
+              <a:defRPr sz="1200" b="1">
+                <a:solidFill>
+                  <a:srgbClr val="FF8159"/>
+                </a:solidFill>
+              </a:defRPr>
+            </a:pPr>
+            <a:r>
+              <a:rPr sz="1200" b="1">
+                <a:solidFill>
+                  <a:srgbClr val="FF8159"/>
+                </a:solidFill>
+              </a:rPr>
+              <a:t>One frozen case. Provider runners cannot change prompts, scoring, budgets, or policy.</a:t>
+            </a:r>
+          </a:p>
+        </p:txBody>
+      </p:sp>
+      <p:sp>
+        <p:nvSpPr>
+          <p:cNvPr id="19" name="">
+            <a:extLst xmlns:a="http://schemas.openxmlformats.org/drawingml/2006/main">
+              <a:ext uri="{FF2B5EF4-FFF2-40B4-BE49-F238E27FC236}">
+                <a16:creationId xmlns:a16="http://schemas.microsoft.com/office/drawing/2014/main" id="{6BEB2435-DD99-4D36-A74C-7BA05B65E0EE}"/>
+              </a:ext>
+            </a:extLst>
+          </p:cNvPr>
+          <p:cNvSpPr>
+            <a:spLocks xmlns:a="http://schemas.openxmlformats.org/drawingml/2006/main" noGrp="1"/>
+          </p:cNvSpPr>
+          <p:nvPr/>
+        </p:nvSpPr>
+        <p:spPr>
+          <a:xfrm xmlns:a="http://schemas.openxmlformats.org/drawingml/2006/main">
+            <a:off x="685800" y="6496050"/>
+            <a:ext cx="4000500" cy="171450"/>
+          </a:xfrm>
+          <a:prstGeom xmlns:a="http://schemas.openxmlformats.org/drawingml/2006/main" prst="rect">
+            <a:avLst/>
+          </a:prstGeom>
+          <a:noFill xmlns:a="http://schemas.openxmlformats.org/drawingml/2006/main"/>
+          <a:ln xmlns:a="http://schemas.openxmlformats.org/drawingml/2006/main" w="0">
+            <a:noFill/>
+            <a:prstDash val="solid"/>
+          </a:ln>
+        </p:spPr>
+        <p:txBody>
+          <a:bodyPr xmlns:a="http://schemas.openxmlformats.org/drawingml/2006/main"/>
+          <a:lstStyle xmlns:a="http://schemas.openxmlformats.org/drawingml/2006/main"/>
+          <a:p xmlns:a="http://schemas.openxmlformats.org/drawingml/2006/main">
+            <a:pPr algn="l">
+              <a:buNone/>
+              <a:defRPr sz="825" b="1">
+                <a:solidFill>
+                  <a:srgbClr val="687068"/>
+                </a:solidFill>
+              </a:defRPr>
+            </a:pPr>
+            <a:r>
+              <a:rPr sz="825" b="1">
+                <a:solidFill>
+                  <a:srgbClr val="687068"/>
+                </a:solidFill>
+              </a:rPr>
+              <a:t>AI BUILD CREW · BADLABZ.COM</a:t>
+            </a:r>
+          </a:p>
+        </p:txBody>
+      </p:sp>
+      <p:sp>
+        <p:nvSpPr>
+          <p:cNvPr id="20" name="">
+            <a:extLst xmlns:a="http://schemas.openxmlformats.org/drawingml/2006/main">
+              <a:ext uri="{FF2B5EF4-FFF2-40B4-BE49-F238E27FC236}">
+                <a16:creationId xmlns:a16="http://schemas.microsoft.com/office/drawing/2014/main" id="{779176EB-F656-4A73-A2D1-14A8AE4A3DC7}"/>
+              </a:ext>
+            </a:extLst>
+          </p:cNvPr>
+          <p:cNvSpPr>
+            <a:spLocks xmlns:a="http://schemas.openxmlformats.org/drawingml/2006/main" noGrp="1"/>
+          </p:cNvSpPr>
+          <p:nvPr/>
+        </p:nvSpPr>
+        <p:spPr>
+          <a:xfrm xmlns:a="http://schemas.openxmlformats.org/drawingml/2006/main">
+            <a:off x="10858500" y="6496050"/>
+            <a:ext cx="647700" cy="171450"/>
+          </a:xfrm>
+          <a:prstGeom xmlns:a="http://schemas.openxmlformats.org/drawingml/2006/main" prst="rect">
+            <a:avLst/>
+          </a:prstGeom>
+          <a:noFill xmlns:a="http://schemas.openxmlformats.org/drawingml/2006/main"/>
+          <a:ln xmlns:a="http://schemas.openxmlformats.org/drawingml/2006/main" w="0">
+            <a:noFill/>
+            <a:prstDash val="solid"/>
+          </a:ln>
+        </p:spPr>
+        <p:txBody>
+          <a:bodyPr xmlns:a="http://schemas.openxmlformats.org/drawingml/2006/main"/>
+          <a:lstStyle xmlns:a="http://schemas.openxmlformats.org/drawingml/2006/main"/>
+          <a:p xmlns:a="http://schemas.openxmlformats.org/drawingml/2006/main">
+            <a:pPr algn="r">
+              <a:buNone/>
+              <a:defRPr sz="825" b="1">
+                <a:solidFill>
+                  <a:srgbClr val="8F7BFF"/>
+                </a:solidFill>
+              </a:defRPr>
+            </a:pPr>
+            <a:r>
+              <a:rPr sz="825" b="1">
+                <a:solidFill>
+                  <a:srgbClr val="8F7BFF"/>
+                </a:solidFill>
+              </a:rPr>
+              <a:t>10</a:t>
+            </a:r>
+          </a:p>
+        </p:txBody>
+      </p:sp>
+      <p:pic>
+        <p:nvPicPr>
+          <p:cNvPr id="31" name=""/>
+          <p:cNvPicPr>
+            <a:picLocks xmlns:a="http://schemas.openxmlformats.org/drawingml/2006/main" noChangeAspect="1"/>
+          </p:cNvPicPr>
+          <p:nvPr/>
+        </p:nvPicPr>
+        <p:blipFill>
+          <a:blip xmlns:r="http://schemas.openxmlformats.org/officeDocument/2006/relationships" xmlns:a="http://schemas.openxmlformats.org/drawingml/2006/main" r:embed="R662522c8bf19470e"/>
+          <a:stretch xmlns:a="http://schemas.openxmlformats.org/drawingml/2006/main"/>
+        </p:blipFill>
+        <p:spPr>
+          <a:xfrm xmlns:a="http://schemas.openxmlformats.org/drawingml/2006/main">
+            <a:off x="342900" y="2866391"/>
+            <a:ext cx="11506200" cy="1315717"/>
+          </a:xfrm>
+          <a:prstGeom xmlns:a="http://schemas.openxmlformats.org/drawingml/2006/main" prst="rect">
+            <a:avLst/>
+          </a:prstGeom>
+        </p:spPr>
+      </p:pic>
+    </p:spTree>
+    <p:extLst>
+      <p:ext uri="{BB962C8B-B14F-4D97-AF65-F5344CB8AC3E}">
+        <p14:creationId xmlns:p14="http://schemas.microsoft.com/office/powerpoint/2010/main" val="442973976"/>
+      </p:ext>
+    </p:extLst>
+  </p:cSld>
+</p:sld>
+</file>
+
+<file path=ppt/slides/slide11.xml><?xml version="1.0" encoding="utf-8"?>
 <p:sld xmlns:p="http://schemas.openxmlformats.org/presentationml/2006/main">
   <p:cSld>
     <p:bg>
@@ -2606,7 +3139,7 @@
                   <a:srgbClr val="D8FF55"/>
                 </a:solidFill>
               </a:rPr>
-              <a:t>08</a:t>
+              <a:t>09</a:t>
             </a:r>
           </a:p>
         </p:txBody>
@@ -4036,7 +4569,7 @@
                   <a:srgbClr val="D8FF55"/>
                 </a:solidFill>
               </a:rPr>
-              <a:t>10</a:t>
+              <a:t>11</a:t>
             </a:r>
           </a:p>
         </p:txBody>
@@ -4051,7 +4584,7 @@
 </p:sld>
 </file>
 
-<file path=ppt/slides/slide11.xml><?xml version="1.0" encoding="utf-8"?>
+<file path=ppt/slides/slide12.xml><?xml version="1.0" encoding="utf-8"?>
 <p:sld xmlns:p="http://schemas.openxmlformats.org/presentationml/2006/main">
   <p:cSld>
     <p:spTree>
@@ -4072,7 +4605,7 @@
           <p:nvPr/>
         </p:nvPicPr>
         <p:blipFill>
-          <a:blip xmlns:r="http://schemas.openxmlformats.org/officeDocument/2006/relationships" xmlns:a="http://schemas.openxmlformats.org/drawingml/2006/main" r:embed="R97fdd1ca7be34a35"/>
+          <a:blip xmlns:r="http://schemas.openxmlformats.org/officeDocument/2006/relationships" xmlns:a="http://schemas.openxmlformats.org/drawingml/2006/main" r:embed="Rde6fd65d06b2470b"/>
           <a:srcRect xmlns:a="http://schemas.openxmlformats.org/drawingml/2006/main" l="0" t="27" r="0" b="27"/>
           <a:stretch xmlns:a="http://schemas.openxmlformats.org/drawingml/2006/main">
             <a:fillRect l="0" t="0" r="0" b="0"/>
@@ -7600,7 +8133,7 @@
         </p:xfrm>
         <a:graphic xmlns:a="http://schemas.openxmlformats.org/drawingml/2006/main">
           <a:graphicData uri="http://schemas.openxmlformats.org/drawingml/2006/chart">
-            <c:chart xmlns:r="http://schemas.openxmlformats.org/officeDocument/2006/relationships" xmlns:c="http://schemas.openxmlformats.org/drawingml/2006/chart" r:id="R04c1eac78a3c480b"/>
+            <c:chart xmlns:r="http://schemas.openxmlformats.org/officeDocument/2006/relationships" xmlns:c="http://schemas.openxmlformats.org/drawingml/2006/chart" r:id="Rf4ffb299f9ae4797"/>
           </a:graphicData>
         </a:graphic>
       </p:graphicFrame>
@@ -9799,7 +10332,7 @@
                   <a:srgbClr val="8F7BFF"/>
                 </a:solidFill>
               </a:rPr>
-              <a:t>18</a:t>
+              <a:t>22</a:t>
             </a:r>
           </a:p>
         </p:txBody>
@@ -10580,7 +11113,7 @@
           <p:nvPr/>
         </p:nvPicPr>
         <p:blipFill>
-          <a:blip xmlns:r="http://schemas.openxmlformats.org/officeDocument/2006/relationships" xmlns:a="http://schemas.openxmlformats.org/drawingml/2006/main" r:embed="R1fa3f6720400422f"/>
+          <a:blip xmlns:r="http://schemas.openxmlformats.org/officeDocument/2006/relationships" xmlns:a="http://schemas.openxmlformats.org/drawingml/2006/main" r:embed="R577ec5e9ca8e478b"/>
           <a:srcRect xmlns:a="http://schemas.openxmlformats.org/drawingml/2006/main" l="0" t="27" r="0" b="27"/>
           <a:stretch xmlns:a="http://schemas.openxmlformats.org/drawingml/2006/main">
             <a:fillRect l="0" t="0" r="0" b="0"/>

</xml_diff>